<commit_message>
dashboard: 2026-09-13 05:13 刷新
</commit_message>
<xml_diff>
--- a/media/figstudio/bzso_roadmap/roadmap_bazn2si2o7_editable.pptx
+++ b/media/figstudio/bzso_roadmap/roadmap_bazn2si2o7_editable.pptx
@@ -7,7 +7,7 @@
   <p:sldIdLst>
     <p:sldId id="256" r:id="rId7"/>
   </p:sldIdLst>
-  <p:sldSz cx="12191999" cy="8127999" type="screen4x3"/>
+  <p:sldSz cx="12191999" cy="4063999" type="screen4x3"/>
   <p:notesSz cx="6858000" cy="9144000"/>
   <p:defaultTextStyle>
     <a:defPPr>
@@ -502,7 +502,7 @@
           <a:lstStyle/>
           <a:p>
             <a:r>
-              <a:t>BaZn2Si2O7 综述路线图（super_teaser S5 F02 → super_img2ppt 重建）</a:t>
+              <a:t>BaZn2Si2O7 综述路线图（super_teaser 第二轮 F03 → super_img2ppt 重建）</a:t>
             </a:r>
           </a:p>
         </p:txBody>
@@ -3524,20 +3524,20 @@
         </p:nvSpPr>
         <p:spPr>
           <a:xfrm>
-            <a:off x="269874" y="912812"/>
-            <a:ext cx="2611437" cy="1984374"/>
+            <a:off x="230143" y="875668"/>
+            <a:ext cx="1358408" cy="2194784"/>
           </a:xfrm>
           <a:prstGeom prst="roundRect">
             <a:avLst>
-              <a:gd name="adj" fmla="val 7199"/>
+              <a:gd name="adj" fmla="val 5785"/>
             </a:avLst>
           </a:prstGeom>
           <a:solidFill>
-            <a:srgbClr val="F3F5F6"/>
+            <a:srgbClr val="FFFFFF"/>
           </a:solidFill>
-          <a:ln w="23812">
+          <a:ln w="14033">
             <a:solidFill>
-              <a:srgbClr val="C9CFD4"/>
+              <a:srgbClr val="4A5158"/>
             </a:solidFill>
           </a:ln>
           <a:effectLst/>
@@ -3566,14 +3566,14 @@
       </p:sp>
       <p:sp>
         <p:nvSpPr>
-          <p:cNvPr id="3" name="n1_t" descr="Editable text; source id n1_t"/>
+          <p:cNvPr id="3" name="n1_n" descr="Editable text; source id n1_n"/>
           <p:cNvSpPr txBox="1"/>
           <p:nvPr/>
         </p:nvSpPr>
         <p:spPr>
           <a:xfrm>
-            <a:off x="380999" y="1325562"/>
-            <a:ext cx="2389187" cy="523874"/>
+            <a:off x="319955" y="943027"/>
+            <a:ext cx="392928" cy="190850"/>
           </a:xfrm>
           <a:prstGeom prst="rect">
             <a:avLst/>
@@ -3587,9 +3587,9 @@
           </a:bodyPr>
           <a:lstStyle/>
           <a:p>
-            <a:pPr algn="ctr" fontAlgn="base">
+            <a:pPr algn="l" fontAlgn="base">
               <a:lnSpc>
-                <a:spcPts val="4093"/>
+                <a:spcPts val="1138"/>
               </a:lnSpc>
               <a:spcBef>
                 <a:spcPts val="0"/>
@@ -3597,39 +3597,39 @@
               <a:spcAft>
                 <a:spcPts val="0"/>
               </a:spcAft>
-              <a:defRPr sz="2821" b="1" i="0" lang="zh-CN" dirty="0">
-                <a:solidFill>
-                  <a:srgbClr val="2B2F33"/>
-                </a:solidFill>
-                <a:latin typeface="Noto Sans CJK SC"/>
-                <a:ea typeface="Noto Sans CJK SC"/>
-                <a:cs typeface="Noto Sans CJK SC"/>
+              <a:defRPr sz="972" b="1" i="0" lang="zh-CN" dirty="0">
+                <a:solidFill>
+                  <a:srgbClr val="8A9199"/>
+                </a:solidFill>
+                <a:latin typeface="DejaVu Sans"/>
+                <a:ea typeface="DejaVu Sans"/>
+                <a:cs typeface="DejaVu Sans"/>
               </a:defRPr>
             </a:pPr>
             <a:r>
-              <a:rPr sz="2821" b="1" i="0" lang="zh-CN" dirty="0">
-                <a:solidFill>
-                  <a:srgbClr val="2B2F33"/>
-                </a:solidFill>
-                <a:latin typeface="Noto Sans CJK SC"/>
-                <a:ea typeface="Noto Sans CJK SC"/>
-                <a:cs typeface="Noto Sans CJK SC"/>
+              <a:rPr sz="972" b="1" i="0" lang="zh-CN" dirty="0">
+                <a:solidFill>
+                  <a:srgbClr val="8A9199"/>
+                </a:solidFill>
+                <a:latin typeface="DejaVu Sans"/>
+                <a:ea typeface="DejaVu Sans"/>
+                <a:cs typeface="DejaVu Sans"/>
               </a:rPr>
-              <a:t>结构基础</a:t>
-            </a:r>
-          </a:p>
-        </p:txBody>
-      </p:sp>
-      <p:sp>
-        <p:nvSpPr>
-          <p:cNvPr id="4" name="n1_s" descr="Editable text; source id n1_s"/>
+              <a:t>01</a:t>
+            </a:r>
+          </a:p>
+        </p:txBody>
+      </p:sp>
+      <p:sp>
+        <p:nvSpPr>
+          <p:cNvPr id="4" name="n1_t" descr="Editable text; source id n1_t"/>
           <p:cNvSpPr txBox="1"/>
           <p:nvPr/>
         </p:nvSpPr>
         <p:spPr>
           <a:xfrm>
-            <a:off x="380999" y="1928812"/>
-            <a:ext cx="2389187" cy="380999"/>
+            <a:off x="286276" y="1279823"/>
+            <a:ext cx="1246143" cy="336795"/>
           </a:xfrm>
           <a:prstGeom prst="rect">
             <a:avLst/>
@@ -3645,7 +3645,7 @@
           <a:p>
             <a:pPr algn="ctr" fontAlgn="base">
               <a:lnSpc>
-                <a:spcPts val="2734"/>
+                <a:spcPts val="2574"/>
               </a:lnSpc>
               <a:spcBef>
                 <a:spcPts val="0"/>
@@ -3653,9 +3653,9 @@
               <a:spcAft>
                 <a:spcPts val="0"/>
               </a:spcAft>
-              <a:defRPr sz="1874" b="0" i="0" lang="zh-CN" dirty="0">
-                <a:solidFill>
-                  <a:srgbClr val="3A4046"/>
+              <a:defRPr sz="1767" b="1" i="0" lang="zh-CN" dirty="0">
+                <a:solidFill>
+                  <a:srgbClr val="1F2326"/>
                 </a:solidFill>
                 <a:latin typeface="Noto Sans CJK SC"/>
                 <a:ea typeface="Noto Sans CJK SC"/>
@@ -3663,7 +3663,63 @@
               </a:defRPr>
             </a:pPr>
             <a:r>
-              <a:rPr sz="1874" b="0" i="0" lang="zh-CN" dirty="0">
+              <a:rPr sz="1767" b="1" i="0" lang="zh-CN" dirty="0">
+                <a:solidFill>
+                  <a:srgbClr val="1F2326"/>
+                </a:solidFill>
+                <a:latin typeface="Noto Sans CJK SC"/>
+                <a:ea typeface="Noto Sans CJK SC"/>
+                <a:cs typeface="Noto Sans CJK SC"/>
+              </a:rPr>
+              <a:t>结构基础</a:t>
+            </a:r>
+          </a:p>
+        </p:txBody>
+      </p:sp>
+      <p:sp>
+        <p:nvSpPr>
+          <p:cNvPr id="5" name="n1_s" descr="Editable text; source id n1_s"/>
+          <p:cNvSpPr txBox="1"/>
+          <p:nvPr/>
+        </p:nvSpPr>
+        <p:spPr>
+          <a:xfrm>
+            <a:off x="275049" y="1661524"/>
+            <a:ext cx="1268596" cy="224530"/>
+          </a:xfrm>
+          <a:prstGeom prst="rect">
+            <a:avLst/>
+          </a:prstGeom>
+          <a:noFill/>
+          <a:effectLst/>
+        </p:spPr>
+        <p:txBody>
+          <a:bodyPr wrap="none" anchor="ctr" tIns="0" rIns="0" bIns="0" lIns="0" anchorCtr="0" vertOverflow="overflow">
+            <a:noAutofit/>
+          </a:bodyPr>
+          <a:lstStyle/>
+          <a:p>
+            <a:pPr algn="ctr" fontAlgn="base">
+              <a:lnSpc>
+                <a:spcPts val="1546"/>
+              </a:lnSpc>
+              <a:spcBef>
+                <a:spcPts val="0"/>
+              </a:spcBef>
+              <a:spcAft>
+                <a:spcPts val="0"/>
+              </a:spcAft>
+              <a:defRPr sz="1063" b="0" i="0" lang="zh-CN" dirty="0">
+                <a:solidFill>
+                  <a:srgbClr val="3A4046"/>
+                </a:solidFill>
+                <a:latin typeface="Noto Sans CJK SC"/>
+                <a:ea typeface="Noto Sans CJK SC"/>
+                <a:cs typeface="Noto Sans CJK SC"/>
+              </a:defRPr>
+            </a:pPr>
+            <a:r>
+              <a:rPr sz="1063" b="0" i="0" lang="zh-CN" dirty="0">
                 <a:solidFill>
                   <a:srgbClr val="3A4046"/>
                 </a:solidFill>
@@ -3676,28 +3732,53 @@
           </a:p>
         </p:txBody>
       </p:sp>
-      <p:sp>
-        <p:nvSpPr>
-          <p:cNvPr id="5" name="n2" descr="Editable shape; source id n2"/>
+      <p:pic>
+        <p:nvPicPr>
+          <p:cNvPr id="6" name="n1_i" descr="exact crop of source page_001 (monochrome line motif)"/>
+          <p:cNvPicPr>
+            <a:picLocks noChangeAspect="1"/>
+          </p:cNvPicPr>
+          <p:nvPr/>
+        </p:nvPicPr>
+        <p:blipFill>
+          <a:blip r:embed="rId2"/>
+          <a:stretch>
+            <a:fillRect/>
+          </a:stretch>
+        </p:blipFill>
+        <p:spPr>
+          <a:xfrm>
+            <a:off x="336795" y="2104972"/>
+            <a:ext cx="1178784" cy="813922"/>
+          </a:xfrm>
+          <a:prstGeom prst="rect">
+            <a:avLst/>
+          </a:prstGeom>
+          <a:effectLst/>
+        </p:spPr>
+      </p:pic>
+      <p:sp>
+        <p:nvSpPr>
+          <p:cNvPr id="7" name="n2" descr="Editable shape; source id n2"/>
           <p:cNvSpPr/>
           <p:nvPr/>
         </p:nvSpPr>
         <p:spPr>
           <a:xfrm>
-            <a:off x="4357687" y="912812"/>
-            <a:ext cx="2619374" cy="1984374"/>
+            <a:off x="2234077" y="875668"/>
+            <a:ext cx="1414541" cy="2194784"/>
           </a:xfrm>
           <a:prstGeom prst="roundRect">
             <a:avLst>
-              <a:gd name="adj" fmla="val 7199"/>
+              <a:gd name="adj" fmla="val 5555"/>
             </a:avLst>
           </a:prstGeom>
           <a:solidFill>
-            <a:srgbClr val="F3F5F6"/>
+            <a:srgbClr val="FFFFFF"/>
           </a:solidFill>
-          <a:ln w="23812">
+          <a:ln w="14033">
             <a:solidFill>
-              <a:srgbClr val="C9CFD4"/>
+              <a:srgbClr val="4A5158"/>
             </a:solidFill>
           </a:ln>
           <a:effectLst/>
@@ -3726,14 +3807,14 @@
       </p:sp>
       <p:sp>
         <p:nvSpPr>
-          <p:cNvPr id="6" name="n2_t" descr="Editable text; source id n2_t"/>
+          <p:cNvPr id="8" name="n2_n" descr="Editable text; source id n2_n"/>
           <p:cNvSpPr txBox="1"/>
           <p:nvPr/>
         </p:nvSpPr>
         <p:spPr>
           <a:xfrm>
-            <a:off x="4468812" y="1325562"/>
-            <a:ext cx="2397124" cy="523874"/>
+            <a:off x="2323889" y="943027"/>
+            <a:ext cx="392928" cy="190850"/>
           </a:xfrm>
           <a:prstGeom prst="rect">
             <a:avLst/>
@@ -3747,9 +3828,9 @@
           </a:bodyPr>
           <a:lstStyle/>
           <a:p>
-            <a:pPr algn="ctr" fontAlgn="base">
+            <a:pPr algn="l" fontAlgn="base">
               <a:lnSpc>
-                <a:spcPts val="4093"/>
+                <a:spcPts val="1138"/>
               </a:lnSpc>
               <a:spcBef>
                 <a:spcPts val="0"/>
@@ -3757,39 +3838,39 @@
               <a:spcAft>
                 <a:spcPts val="0"/>
               </a:spcAft>
-              <a:defRPr sz="2821" b="1" i="0" lang="zh-CN" dirty="0">
-                <a:solidFill>
-                  <a:srgbClr val="2B2F33"/>
-                </a:solidFill>
-                <a:latin typeface="Noto Sans CJK SC"/>
-                <a:ea typeface="Noto Sans CJK SC"/>
-                <a:cs typeface="Noto Sans CJK SC"/>
+              <a:defRPr sz="972" b="1" i="0" lang="zh-CN" dirty="0">
+                <a:solidFill>
+                  <a:srgbClr val="8A9199"/>
+                </a:solidFill>
+                <a:latin typeface="DejaVu Sans"/>
+                <a:ea typeface="DejaVu Sans"/>
+                <a:cs typeface="DejaVu Sans"/>
               </a:defRPr>
             </a:pPr>
             <a:r>
-              <a:rPr sz="2821" b="1" i="0" lang="zh-CN" dirty="0">
-                <a:solidFill>
-                  <a:srgbClr val="2B2F33"/>
-                </a:solidFill>
-                <a:latin typeface="Noto Sans CJK SC"/>
-                <a:ea typeface="Noto Sans CJK SC"/>
-                <a:cs typeface="Noto Sans CJK SC"/>
+              <a:rPr sz="972" b="1" i="0" lang="zh-CN" dirty="0">
+                <a:solidFill>
+                  <a:srgbClr val="8A9199"/>
+                </a:solidFill>
+                <a:latin typeface="DejaVu Sans"/>
+                <a:ea typeface="DejaVu Sans"/>
+                <a:cs typeface="DejaVu Sans"/>
               </a:rPr>
-              <a:t>合成路线</a:t>
-            </a:r>
-          </a:p>
-        </p:txBody>
-      </p:sp>
-      <p:sp>
-        <p:nvSpPr>
-          <p:cNvPr id="7" name="n2_s" descr="Editable text; source id n2_s"/>
+              <a:t>02</a:t>
+            </a:r>
+          </a:p>
+        </p:txBody>
+      </p:sp>
+      <p:sp>
+        <p:nvSpPr>
+          <p:cNvPr id="9" name="n2_t" descr="Editable text; source id n2_t"/>
           <p:cNvSpPr txBox="1"/>
           <p:nvPr/>
         </p:nvSpPr>
         <p:spPr>
           <a:xfrm>
-            <a:off x="4468812" y="1928812"/>
-            <a:ext cx="2397124" cy="380999"/>
+            <a:off x="2290209" y="1279823"/>
+            <a:ext cx="1302276" cy="336795"/>
           </a:xfrm>
           <a:prstGeom prst="rect">
             <a:avLst/>
@@ -3805,7 +3886,7 @@
           <a:p>
             <a:pPr algn="ctr" fontAlgn="base">
               <a:lnSpc>
-                <a:spcPts val="2734"/>
+                <a:spcPts val="2574"/>
               </a:lnSpc>
               <a:spcBef>
                 <a:spcPts val="0"/>
@@ -3813,9 +3894,9 @@
               <a:spcAft>
                 <a:spcPts val="0"/>
               </a:spcAft>
-              <a:defRPr sz="1874" b="0" i="0" lang="zh-CN" dirty="0">
-                <a:solidFill>
-                  <a:srgbClr val="3A4046"/>
+              <a:defRPr sz="1767" b="1" i="0" lang="zh-CN" dirty="0">
+                <a:solidFill>
+                  <a:srgbClr val="1F2326"/>
                 </a:solidFill>
                 <a:latin typeface="Noto Sans CJK SC"/>
                 <a:ea typeface="Noto Sans CJK SC"/>
@@ -3823,7 +3904,63 @@
               </a:defRPr>
             </a:pPr>
             <a:r>
-              <a:rPr sz="1874" b="0" i="0" lang="zh-CN" dirty="0">
+              <a:rPr sz="1767" b="1" i="0" lang="zh-CN" dirty="0">
+                <a:solidFill>
+                  <a:srgbClr val="1F2326"/>
+                </a:solidFill>
+                <a:latin typeface="Noto Sans CJK SC"/>
+                <a:ea typeface="Noto Sans CJK SC"/>
+                <a:cs typeface="Noto Sans CJK SC"/>
+              </a:rPr>
+              <a:t>合成路线</a:t>
+            </a:r>
+          </a:p>
+        </p:txBody>
+      </p:sp>
+      <p:sp>
+        <p:nvSpPr>
+          <p:cNvPr id="10" name="n2_s" descr="Editable text; source id n2_s"/>
+          <p:cNvSpPr txBox="1"/>
+          <p:nvPr/>
+        </p:nvSpPr>
+        <p:spPr>
+          <a:xfrm>
+            <a:off x="2278983" y="1661524"/>
+            <a:ext cx="1324729" cy="224530"/>
+          </a:xfrm>
+          <a:prstGeom prst="rect">
+            <a:avLst/>
+          </a:prstGeom>
+          <a:noFill/>
+          <a:effectLst/>
+        </p:spPr>
+        <p:txBody>
+          <a:bodyPr wrap="none" anchor="ctr" tIns="0" rIns="0" bIns="0" lIns="0" anchorCtr="0" vertOverflow="overflow">
+            <a:noAutofit/>
+          </a:bodyPr>
+          <a:lstStyle/>
+          <a:p>
+            <a:pPr algn="ctr" fontAlgn="base">
+              <a:lnSpc>
+                <a:spcPts val="1546"/>
+              </a:lnSpc>
+              <a:spcBef>
+                <a:spcPts val="0"/>
+              </a:spcBef>
+              <a:spcAft>
+                <a:spcPts val="0"/>
+              </a:spcAft>
+              <a:defRPr sz="1063" b="0" i="0" lang="zh-CN" dirty="0">
+                <a:solidFill>
+                  <a:srgbClr val="3A4046"/>
+                </a:solidFill>
+                <a:latin typeface="Noto Sans CJK SC"/>
+                <a:ea typeface="Noto Sans CJK SC"/>
+                <a:cs typeface="Noto Sans CJK SC"/>
+              </a:defRPr>
+            </a:pPr>
+            <a:r>
+              <a:rPr sz="1063" b="0" i="0" lang="zh-CN" dirty="0">
                 <a:solidFill>
                   <a:srgbClr val="3A4046"/>
                 </a:solidFill>
@@ -3834,7 +3971,7 @@
               <a:t>固相</a:t>
             </a:r>
             <a:r>
-              <a:rPr sz="1874" b="0" i="0" lang="zh-CN" dirty="0">
+              <a:rPr sz="1063" b="0" i="0" lang="zh-CN" dirty="0">
                 <a:solidFill>
                   <a:srgbClr val="3A4046"/>
                 </a:solidFill>
@@ -3845,7 +3982,7 @@
               <a:t> · </a:t>
             </a:r>
             <a:r>
-              <a:rPr sz="1874" b="0" i="0" lang="zh-CN" dirty="0">
+              <a:rPr sz="1063" b="0" i="0" lang="zh-CN" dirty="0">
                 <a:solidFill>
                   <a:srgbClr val="3A4046"/>
                 </a:solidFill>
@@ -3856,7 +3993,7 @@
               <a:t>溶胶</a:t>
             </a:r>
             <a:r>
-              <a:rPr sz="1874" b="0" i="0" lang="zh-CN" dirty="0">
+              <a:rPr sz="1063" b="0" i="0" lang="zh-CN" dirty="0">
                 <a:solidFill>
                   <a:srgbClr val="3A4046"/>
                 </a:solidFill>
@@ -3867,7 +4004,7 @@
               <a:t>—</a:t>
             </a:r>
             <a:r>
-              <a:rPr sz="1874" b="0" i="0" lang="zh-CN" dirty="0">
+              <a:rPr sz="1063" b="0" i="0" lang="zh-CN" dirty="0">
                 <a:solidFill>
                   <a:srgbClr val="3A4046"/>
                 </a:solidFill>
@@ -3880,28 +4017,53 @@
           </a:p>
         </p:txBody>
       </p:sp>
-      <p:sp>
-        <p:nvSpPr>
-          <p:cNvPr id="8" name="n3" descr="Editable shape; source id n3"/>
+      <p:pic>
+        <p:nvPicPr>
+          <p:cNvPr id="11" name="n2_i" descr="exact crop of source page_001 (monochrome line motif)"/>
+          <p:cNvPicPr>
+            <a:picLocks noChangeAspect="1"/>
+          </p:cNvPicPr>
+          <p:nvPr/>
+        </p:nvPicPr>
+        <p:blipFill>
+          <a:blip r:embed="rId3"/>
+          <a:stretch>
+            <a:fillRect/>
+          </a:stretch>
+        </p:blipFill>
+        <p:spPr>
+          <a:xfrm>
+            <a:off x="2554033" y="2172331"/>
+            <a:ext cx="785856" cy="757790"/>
+          </a:xfrm>
+          <a:prstGeom prst="rect">
+            <a:avLst/>
+          </a:prstGeom>
+          <a:effectLst/>
+        </p:spPr>
+      </p:pic>
+      <p:sp>
+        <p:nvSpPr>
+          <p:cNvPr id="12" name="n3" descr="Editable shape; source id n3"/>
           <p:cNvSpPr/>
           <p:nvPr/>
         </p:nvSpPr>
         <p:spPr>
           <a:xfrm>
-            <a:off x="8389937" y="912812"/>
-            <a:ext cx="2579687" cy="1976437"/>
+            <a:off x="4294143" y="875668"/>
+            <a:ext cx="1403314" cy="2194784"/>
           </a:xfrm>
           <a:prstGeom prst="roundRect">
             <a:avLst>
-              <a:gd name="adj" fmla="val 7228"/>
+              <a:gd name="adj" fmla="val 5600"/>
             </a:avLst>
           </a:prstGeom>
           <a:solidFill>
-            <a:srgbClr val="F3F5F6"/>
+            <a:srgbClr val="FFFFFF"/>
           </a:solidFill>
-          <a:ln w="23812">
+          <a:ln w="14033">
             <a:solidFill>
-              <a:srgbClr val="C9CFD4"/>
+              <a:srgbClr val="4A5158"/>
             </a:solidFill>
           </a:ln>
           <a:effectLst/>
@@ -3930,14 +4092,14 @@
       </p:sp>
       <p:sp>
         <p:nvSpPr>
-          <p:cNvPr id="9" name="n3_t" descr="Editable text; source id n3_t"/>
+          <p:cNvPr id="13" name="n3_n" descr="Editable text; source id n3_n"/>
           <p:cNvSpPr txBox="1"/>
           <p:nvPr/>
         </p:nvSpPr>
         <p:spPr>
           <a:xfrm>
-            <a:off x="8501062" y="1325562"/>
-            <a:ext cx="2357437" cy="523874"/>
+            <a:off x="4383955" y="943027"/>
+            <a:ext cx="392928" cy="190850"/>
           </a:xfrm>
           <a:prstGeom prst="rect">
             <a:avLst/>
@@ -3951,9 +4113,9 @@
           </a:bodyPr>
           <a:lstStyle/>
           <a:p>
-            <a:pPr algn="ctr" fontAlgn="base">
+            <a:pPr algn="l" fontAlgn="base">
               <a:lnSpc>
-                <a:spcPts val="4093"/>
+                <a:spcPts val="1138"/>
               </a:lnSpc>
               <a:spcBef>
                 <a:spcPts val="0"/>
@@ -3961,39 +4123,39 @@
               <a:spcAft>
                 <a:spcPts val="0"/>
               </a:spcAft>
-              <a:defRPr sz="2821" b="1" i="0" lang="zh-CN" dirty="0">
-                <a:solidFill>
-                  <a:srgbClr val="2B2F33"/>
-                </a:solidFill>
-                <a:latin typeface="Noto Sans CJK SC"/>
-                <a:ea typeface="Noto Sans CJK SC"/>
-                <a:cs typeface="Noto Sans CJK SC"/>
+              <a:defRPr sz="972" b="1" i="0" lang="zh-CN" dirty="0">
+                <a:solidFill>
+                  <a:srgbClr val="8A9199"/>
+                </a:solidFill>
+                <a:latin typeface="DejaVu Sans"/>
+                <a:ea typeface="DejaVu Sans"/>
+                <a:cs typeface="DejaVu Sans"/>
               </a:defRPr>
             </a:pPr>
             <a:r>
-              <a:rPr sz="2821" b="1" i="0" lang="zh-CN" dirty="0">
-                <a:solidFill>
-                  <a:srgbClr val="2B2F33"/>
-                </a:solidFill>
-                <a:latin typeface="Noto Sans CJK SC"/>
-                <a:ea typeface="Noto Sans CJK SC"/>
-                <a:cs typeface="Noto Sans CJK SC"/>
+              <a:rPr sz="972" b="1" i="0" lang="zh-CN" dirty="0">
+                <a:solidFill>
+                  <a:srgbClr val="8A9199"/>
+                </a:solidFill>
+                <a:latin typeface="DejaVu Sans"/>
+                <a:ea typeface="DejaVu Sans"/>
+                <a:cs typeface="DejaVu Sans"/>
               </a:rPr>
-              <a:t>相控制</a:t>
-            </a:r>
-          </a:p>
-        </p:txBody>
-      </p:sp>
-      <p:sp>
-        <p:nvSpPr>
-          <p:cNvPr id="10" name="n3_s" descr="Editable text; source id n3_s"/>
+              <a:t>03</a:t>
+            </a:r>
+          </a:p>
+        </p:txBody>
+      </p:sp>
+      <p:sp>
+        <p:nvSpPr>
+          <p:cNvPr id="14" name="n3_t" descr="Editable text; source id n3_t"/>
           <p:cNvSpPr txBox="1"/>
           <p:nvPr/>
         </p:nvSpPr>
         <p:spPr>
           <a:xfrm>
-            <a:off x="8501062" y="1928812"/>
-            <a:ext cx="2357437" cy="380999"/>
+            <a:off x="4350276" y="1279823"/>
+            <a:ext cx="1291049" cy="336795"/>
           </a:xfrm>
           <a:prstGeom prst="rect">
             <a:avLst/>
@@ -4009,7 +4171,7 @@
           <a:p>
             <a:pPr algn="ctr" fontAlgn="base">
               <a:lnSpc>
-                <a:spcPts val="2734"/>
+                <a:spcPts val="2574"/>
               </a:lnSpc>
               <a:spcBef>
                 <a:spcPts val="0"/>
@@ -4017,9 +4179,9 @@
               <a:spcAft>
                 <a:spcPts val="0"/>
               </a:spcAft>
-              <a:defRPr sz="1874" b="0" i="0" lang="zh-CN" dirty="0">
-                <a:solidFill>
-                  <a:srgbClr val="3A4046"/>
+              <a:defRPr sz="1767" b="1" i="0" lang="zh-CN" dirty="0">
+                <a:solidFill>
+                  <a:srgbClr val="1F2326"/>
                 </a:solidFill>
                 <a:latin typeface="Noto Sans CJK SC"/>
                 <a:ea typeface="Noto Sans CJK SC"/>
@@ -4027,7 +4189,63 @@
               </a:defRPr>
             </a:pPr>
             <a:r>
-              <a:rPr sz="1874" b="0" i="0" lang="zh-CN" dirty="0">
+              <a:rPr sz="1767" b="1" i="0" lang="zh-CN" dirty="0">
+                <a:solidFill>
+                  <a:srgbClr val="1F2326"/>
+                </a:solidFill>
+                <a:latin typeface="Noto Sans CJK SC"/>
+                <a:ea typeface="Noto Sans CJK SC"/>
+                <a:cs typeface="Noto Sans CJK SC"/>
+              </a:rPr>
+              <a:t>相控制</a:t>
+            </a:r>
+          </a:p>
+        </p:txBody>
+      </p:sp>
+      <p:sp>
+        <p:nvSpPr>
+          <p:cNvPr id="15" name="n3_s" descr="Editable text; source id n3_s"/>
+          <p:cNvSpPr txBox="1"/>
+          <p:nvPr/>
+        </p:nvSpPr>
+        <p:spPr>
+          <a:xfrm>
+            <a:off x="4339049" y="1661524"/>
+            <a:ext cx="1313502" cy="224530"/>
+          </a:xfrm>
+          <a:prstGeom prst="rect">
+            <a:avLst/>
+          </a:prstGeom>
+          <a:noFill/>
+          <a:effectLst/>
+        </p:spPr>
+        <p:txBody>
+          <a:bodyPr wrap="none" anchor="ctr" tIns="0" rIns="0" bIns="0" lIns="0" anchorCtr="0" vertOverflow="overflow">
+            <a:noAutofit/>
+          </a:bodyPr>
+          <a:lstStyle/>
+          <a:p>
+            <a:pPr algn="ctr" fontAlgn="base">
+              <a:lnSpc>
+                <a:spcPts val="1546"/>
+              </a:lnSpc>
+              <a:spcBef>
+                <a:spcPts val="0"/>
+              </a:spcBef>
+              <a:spcAft>
+                <a:spcPts val="0"/>
+              </a:spcAft>
+              <a:defRPr sz="1063" b="0" i="0" lang="zh-CN" dirty="0">
+                <a:solidFill>
+                  <a:srgbClr val="3A4046"/>
+                </a:solidFill>
+                <a:latin typeface="Noto Sans CJK SC"/>
+                <a:ea typeface="Noto Sans CJK SC"/>
+                <a:cs typeface="Noto Sans CJK SC"/>
+              </a:defRPr>
+            </a:pPr>
+            <a:r>
+              <a:rPr sz="1063" b="0" i="0" lang="zh-CN" dirty="0">
                 <a:solidFill>
                   <a:srgbClr val="3A4046"/>
                 </a:solidFill>
@@ -4038,7 +4256,7 @@
               <a:t>组成</a:t>
             </a:r>
             <a:r>
-              <a:rPr sz="1874" b="0" i="0" lang="zh-CN" dirty="0">
+              <a:rPr sz="1063" b="0" i="0" lang="zh-CN" dirty="0">
                 <a:solidFill>
                   <a:srgbClr val="3A4046"/>
                 </a:solidFill>
@@ -4049,7 +4267,7 @@
               <a:t> · </a:t>
             </a:r>
             <a:r>
-              <a:rPr sz="1874" b="0" i="0" lang="zh-CN" dirty="0">
+              <a:rPr sz="1063" b="0" i="0" lang="zh-CN" dirty="0">
                 <a:solidFill>
                   <a:srgbClr val="3A4046"/>
                 </a:solidFill>
@@ -4062,28 +4280,53 @@
           </a:p>
         </p:txBody>
       </p:sp>
-      <p:sp>
-        <p:nvSpPr>
-          <p:cNvPr id="11" name="n4" descr="Editable shape; source id n4"/>
+      <p:pic>
+        <p:nvPicPr>
+          <p:cNvPr id="16" name="n3_i" descr="exact crop of source page_001 (monochrome line motif)"/>
+          <p:cNvPicPr>
+            <a:picLocks noChangeAspect="1"/>
+          </p:cNvPicPr>
+          <p:nvPr/>
+        </p:nvPicPr>
+        <p:blipFill>
+          <a:blip r:embed="rId4"/>
+          <a:stretch>
+            <a:fillRect/>
+          </a:stretch>
+        </p:blipFill>
+        <p:spPr>
+          <a:xfrm>
+            <a:off x="4473767" y="2060066"/>
+            <a:ext cx="1044066" cy="886895"/>
+          </a:xfrm>
+          <a:prstGeom prst="rect">
+            <a:avLst/>
+          </a:prstGeom>
+          <a:effectLst/>
+        </p:spPr>
+      </p:pic>
+      <p:sp>
+        <p:nvSpPr>
+          <p:cNvPr id="17" name="n4" descr="Editable shape; source id n4"/>
           <p:cNvSpPr/>
           <p:nvPr/>
         </p:nvSpPr>
         <p:spPr>
           <a:xfrm>
-            <a:off x="8508999" y="5127624"/>
-            <a:ext cx="2659062" cy="1936749"/>
+            <a:off x="6382276" y="875668"/>
+            <a:ext cx="1392088" cy="2194784"/>
           </a:xfrm>
           <a:prstGeom prst="roundRect">
             <a:avLst>
-              <a:gd name="adj" fmla="val 7377"/>
+              <a:gd name="adj" fmla="val 5645"/>
             </a:avLst>
           </a:prstGeom>
           <a:solidFill>
-            <a:srgbClr val="F3F5F6"/>
+            <a:srgbClr val="FFFFFF"/>
           </a:solidFill>
-          <a:ln w="23812">
+          <a:ln w="14033">
             <a:solidFill>
-              <a:srgbClr val="C9CFD4"/>
+              <a:srgbClr val="4A5158"/>
             </a:solidFill>
           </a:ln>
           <a:effectLst/>
@@ -4112,14 +4355,14 @@
       </p:sp>
       <p:sp>
         <p:nvSpPr>
-          <p:cNvPr id="12" name="n4_t" descr="Editable text; source id n4_t"/>
+          <p:cNvPr id="18" name="n4_n" descr="Editable text; source id n4_n"/>
           <p:cNvSpPr txBox="1"/>
           <p:nvPr/>
         </p:nvSpPr>
         <p:spPr>
           <a:xfrm>
-            <a:off x="8620124" y="5540374"/>
-            <a:ext cx="2436812" cy="523874"/>
+            <a:off x="6472088" y="943027"/>
+            <a:ext cx="392928" cy="190850"/>
           </a:xfrm>
           <a:prstGeom prst="rect">
             <a:avLst/>
@@ -4133,9 +4376,9 @@
           </a:bodyPr>
           <a:lstStyle/>
           <a:p>
-            <a:pPr algn="ctr" fontAlgn="base">
+            <a:pPr algn="l" fontAlgn="base">
               <a:lnSpc>
-                <a:spcPts val="4093"/>
+                <a:spcPts val="1138"/>
               </a:lnSpc>
               <a:spcBef>
                 <a:spcPts val="0"/>
@@ -4143,39 +4386,39 @@
               <a:spcAft>
                 <a:spcPts val="0"/>
               </a:spcAft>
-              <a:defRPr sz="2821" b="1" i="0" lang="zh-CN" dirty="0">
-                <a:solidFill>
-                  <a:srgbClr val="2B2F33"/>
-                </a:solidFill>
-                <a:latin typeface="Noto Sans CJK SC"/>
-                <a:ea typeface="Noto Sans CJK SC"/>
-                <a:cs typeface="Noto Sans CJK SC"/>
+              <a:defRPr sz="972" b="1" i="0" lang="zh-CN" dirty="0">
+                <a:solidFill>
+                  <a:srgbClr val="8A9199"/>
+                </a:solidFill>
+                <a:latin typeface="DejaVu Sans"/>
+                <a:ea typeface="DejaVu Sans"/>
+                <a:cs typeface="DejaVu Sans"/>
               </a:defRPr>
             </a:pPr>
             <a:r>
-              <a:rPr sz="2821" b="1" i="0" lang="zh-CN" dirty="0">
-                <a:solidFill>
-                  <a:srgbClr val="2B2F33"/>
-                </a:solidFill>
-                <a:latin typeface="Noto Sans CJK SC"/>
-                <a:ea typeface="Noto Sans CJK SC"/>
-                <a:cs typeface="Noto Sans CJK SC"/>
+              <a:rPr sz="972" b="1" i="0" lang="zh-CN" dirty="0">
+                <a:solidFill>
+                  <a:srgbClr val="8A9199"/>
+                </a:solidFill>
+                <a:latin typeface="DejaVu Sans"/>
+                <a:ea typeface="DejaVu Sans"/>
+                <a:cs typeface="DejaVu Sans"/>
               </a:rPr>
-              <a:t>近邻体系</a:t>
-            </a:r>
-          </a:p>
-        </p:txBody>
-      </p:sp>
-      <p:sp>
-        <p:nvSpPr>
-          <p:cNvPr id="13" name="n4_s" descr="Editable text; source id n4_s"/>
+              <a:t>04</a:t>
+            </a:r>
+          </a:p>
+        </p:txBody>
+      </p:sp>
+      <p:sp>
+        <p:nvSpPr>
+          <p:cNvPr id="19" name="n4_t" descr="Editable text; source id n4_t"/>
           <p:cNvSpPr txBox="1"/>
           <p:nvPr/>
         </p:nvSpPr>
         <p:spPr>
           <a:xfrm>
-            <a:off x="8620124" y="6143624"/>
-            <a:ext cx="2436812" cy="380999"/>
+            <a:off x="6438408" y="1279823"/>
+            <a:ext cx="1279823" cy="336795"/>
           </a:xfrm>
           <a:prstGeom prst="rect">
             <a:avLst/>
@@ -4191,7 +4434,7 @@
           <a:p>
             <a:pPr algn="ctr" fontAlgn="base">
               <a:lnSpc>
-                <a:spcPts val="2203"/>
+                <a:spcPts val="2574"/>
               </a:lnSpc>
               <a:spcBef>
                 <a:spcPts val="0"/>
@@ -4199,7 +4442,63 @@
               <a:spcAft>
                 <a:spcPts val="0"/>
               </a:spcAft>
-              <a:defRPr sz="1874" b="0" i="0" lang="zh-CN" dirty="0">
+              <a:defRPr sz="1767" b="1" i="0" lang="zh-CN" dirty="0">
+                <a:solidFill>
+                  <a:srgbClr val="1F2326"/>
+                </a:solidFill>
+                <a:latin typeface="Noto Sans CJK SC"/>
+                <a:ea typeface="Noto Sans CJK SC"/>
+                <a:cs typeface="Noto Sans CJK SC"/>
+              </a:defRPr>
+            </a:pPr>
+            <a:r>
+              <a:rPr sz="1767" b="1" i="0" lang="zh-CN" dirty="0">
+                <a:solidFill>
+                  <a:srgbClr val="1F2326"/>
+                </a:solidFill>
+                <a:latin typeface="Noto Sans CJK SC"/>
+                <a:ea typeface="Noto Sans CJK SC"/>
+                <a:cs typeface="Noto Sans CJK SC"/>
+              </a:rPr>
+              <a:t>近邻体系</a:t>
+            </a:r>
+          </a:p>
+        </p:txBody>
+      </p:sp>
+      <p:sp>
+        <p:nvSpPr>
+          <p:cNvPr id="20" name="n4_s" descr="Editable text; source id n4_s"/>
+          <p:cNvSpPr txBox="1"/>
+          <p:nvPr/>
+        </p:nvSpPr>
+        <p:spPr>
+          <a:xfrm>
+            <a:off x="6427182" y="1661524"/>
+            <a:ext cx="1302276" cy="224530"/>
+          </a:xfrm>
+          <a:prstGeom prst="rect">
+            <a:avLst/>
+          </a:prstGeom>
+          <a:noFill/>
+          <a:effectLst/>
+        </p:spPr>
+        <p:txBody>
+          <a:bodyPr wrap="none" anchor="ctr" tIns="0" rIns="0" bIns="0" lIns="0" anchorCtr="0" vertOverflow="overflow">
+            <a:noAutofit/>
+          </a:bodyPr>
+          <a:lstStyle/>
+          <a:p>
+            <a:pPr algn="ctr" fontAlgn="base">
+              <a:lnSpc>
+                <a:spcPts val="1248"/>
+              </a:lnSpc>
+              <a:spcBef>
+                <a:spcPts val="0"/>
+              </a:spcBef>
+              <a:spcAft>
+                <a:spcPts val="0"/>
+              </a:spcAft>
+              <a:defRPr sz="1063" b="0" i="0" lang="zh-CN" dirty="0">
                 <a:solidFill>
                   <a:srgbClr val="3A4046"/>
                 </a:solidFill>
@@ -4209,7 +4508,7 @@
               </a:defRPr>
             </a:pPr>
             <a:r>
-              <a:rPr sz="1874" b="0" i="0" lang="zh-CN" dirty="0">
+              <a:rPr sz="1063" b="0" i="0" lang="zh-CN" dirty="0">
                 <a:solidFill>
                   <a:srgbClr val="3A4046"/>
                 </a:solidFill>
@@ -4222,26 +4521,51 @@
           </a:p>
         </p:txBody>
       </p:sp>
-      <p:sp>
-        <p:nvSpPr>
-          <p:cNvPr id="14" name="n5" descr="Editable shape; source id n5"/>
+      <p:pic>
+        <p:nvPicPr>
+          <p:cNvPr id="21" name="n4_i" descr="exact crop of source page_001 (monochrome line motif)"/>
+          <p:cNvPicPr>
+            <a:picLocks noChangeAspect="1"/>
+          </p:cNvPicPr>
+          <p:nvPr/>
+        </p:nvPicPr>
+        <p:blipFill>
+          <a:blip r:embed="rId5"/>
+          <a:stretch>
+            <a:fillRect/>
+          </a:stretch>
+        </p:blipFill>
+        <p:spPr>
+          <a:xfrm>
+            <a:off x="6657325" y="2104972"/>
+            <a:ext cx="853215" cy="785856"/>
+          </a:xfrm>
+          <a:prstGeom prst="rect">
+            <a:avLst/>
+          </a:prstGeom>
+          <a:effectLst/>
+        </p:spPr>
+      </p:pic>
+      <p:sp>
+        <p:nvSpPr>
+          <p:cNvPr id="22" name="n5" descr="Editable shape; source id n5"/>
           <p:cNvSpPr/>
           <p:nvPr/>
         </p:nvSpPr>
         <p:spPr>
           <a:xfrm>
-            <a:off x="4349749" y="5127624"/>
-            <a:ext cx="2754312" cy="1936749"/>
+            <a:off x="8414276" y="875668"/>
+            <a:ext cx="1504353" cy="2194784"/>
           </a:xfrm>
           <a:prstGeom prst="roundRect">
             <a:avLst>
-              <a:gd name="adj" fmla="val 7377"/>
+              <a:gd name="adj" fmla="val 5223"/>
             </a:avLst>
           </a:prstGeom>
           <a:solidFill>
-            <a:srgbClr val="FBF3E3"/>
+            <a:srgbClr val="FFFFFF"/>
           </a:solidFill>
-          <a:ln w="23812">
+          <a:ln w="14033">
             <a:solidFill>
               <a:srgbClr val="B8862B"/>
             </a:solidFill>
@@ -4272,14 +4596,14 @@
       </p:sp>
       <p:sp>
         <p:nvSpPr>
-          <p:cNvPr id="15" name="n5_t" descr="Editable text; source id n5_t"/>
+          <p:cNvPr id="23" name="n5_n" descr="Editable text; source id n5_n"/>
           <p:cNvSpPr txBox="1"/>
           <p:nvPr/>
         </p:nvSpPr>
         <p:spPr>
           <a:xfrm>
-            <a:off x="4460874" y="5540374"/>
-            <a:ext cx="2532062" cy="523874"/>
+            <a:off x="8504088" y="943027"/>
+            <a:ext cx="392928" cy="190850"/>
           </a:xfrm>
           <a:prstGeom prst="rect">
             <a:avLst/>
@@ -4293,9 +4617,9 @@
           </a:bodyPr>
           <a:lstStyle/>
           <a:p>
-            <a:pPr algn="ctr" fontAlgn="base">
+            <a:pPr algn="l" fontAlgn="base">
               <a:lnSpc>
-                <a:spcPts val="4093"/>
+                <a:spcPts val="1138"/>
               </a:lnSpc>
               <a:spcBef>
                 <a:spcPts val="0"/>
@@ -4303,39 +4627,39 @@
               <a:spcAft>
                 <a:spcPts val="0"/>
               </a:spcAft>
-              <a:defRPr sz="2821" b="1" i="0" lang="zh-CN" dirty="0">
-                <a:solidFill>
-                  <a:srgbClr val="2B2F33"/>
-                </a:solidFill>
-                <a:latin typeface="Noto Sans CJK SC"/>
-                <a:ea typeface="Noto Sans CJK SC"/>
-                <a:cs typeface="Noto Sans CJK SC"/>
+              <a:defRPr sz="972" b="1" i="0" lang="zh-CN" dirty="0">
+                <a:solidFill>
+                  <a:srgbClr val="8A9199"/>
+                </a:solidFill>
+                <a:latin typeface="DejaVu Sans"/>
+                <a:ea typeface="DejaVu Sans"/>
+                <a:cs typeface="DejaVu Sans"/>
               </a:defRPr>
             </a:pPr>
             <a:r>
-              <a:rPr sz="2821" b="1" i="0" lang="zh-CN" dirty="0">
-                <a:solidFill>
-                  <a:srgbClr val="2B2F33"/>
-                </a:solidFill>
-                <a:latin typeface="Noto Sans CJK SC"/>
-                <a:ea typeface="Noto Sans CJK SC"/>
-                <a:cs typeface="Noto Sans CJK SC"/>
+              <a:rPr sz="972" b="1" i="0" lang="zh-CN" dirty="0">
+                <a:solidFill>
+                  <a:srgbClr val="8A9199"/>
+                </a:solidFill>
+                <a:latin typeface="DejaVu Sans"/>
+                <a:ea typeface="DejaVu Sans"/>
+                <a:cs typeface="DejaVu Sans"/>
               </a:rPr>
-              <a:t>类似物判据</a:t>
-            </a:r>
-          </a:p>
-        </p:txBody>
-      </p:sp>
-      <p:sp>
-        <p:nvSpPr>
-          <p:cNvPr id="16" name="n5_s" descr="Editable text; source id n5_s"/>
+              <a:t>05</a:t>
+            </a:r>
+          </a:p>
+        </p:txBody>
+      </p:sp>
+      <p:sp>
+        <p:nvSpPr>
+          <p:cNvPr id="24" name="n5_t" descr="Editable text; source id n5_t"/>
           <p:cNvSpPr txBox="1"/>
           <p:nvPr/>
         </p:nvSpPr>
         <p:spPr>
           <a:xfrm>
-            <a:off x="4460874" y="6143624"/>
-            <a:ext cx="2532062" cy="380999"/>
+            <a:off x="8470408" y="1279823"/>
+            <a:ext cx="1392088" cy="336795"/>
           </a:xfrm>
           <a:prstGeom prst="rect">
             <a:avLst/>
@@ -4351,7 +4675,7 @@
           <a:p>
             <a:pPr algn="ctr" fontAlgn="base">
               <a:lnSpc>
-                <a:spcPts val="2203"/>
+                <a:spcPts val="2574"/>
               </a:lnSpc>
               <a:spcBef>
                 <a:spcPts val="0"/>
@@ -4359,7 +4683,63 @@
               <a:spcAft>
                 <a:spcPts val="0"/>
               </a:spcAft>
-              <a:defRPr sz="1874" b="0" i="0" lang="zh-CN" dirty="0">
+              <a:defRPr sz="1767" b="1" i="0" lang="zh-CN" dirty="0">
+                <a:solidFill>
+                  <a:srgbClr val="1F2326"/>
+                </a:solidFill>
+                <a:latin typeface="Noto Sans CJK SC"/>
+                <a:ea typeface="Noto Sans CJK SC"/>
+                <a:cs typeface="Noto Sans CJK SC"/>
+              </a:defRPr>
+            </a:pPr>
+            <a:r>
+              <a:rPr sz="1767" b="1" i="0" lang="zh-CN" dirty="0">
+                <a:solidFill>
+                  <a:srgbClr val="1F2326"/>
+                </a:solidFill>
+                <a:latin typeface="Noto Sans CJK SC"/>
+                <a:ea typeface="Noto Sans CJK SC"/>
+                <a:cs typeface="Noto Sans CJK SC"/>
+              </a:rPr>
+              <a:t>类似物判据</a:t>
+            </a:r>
+          </a:p>
+        </p:txBody>
+      </p:sp>
+      <p:sp>
+        <p:nvSpPr>
+          <p:cNvPr id="25" name="n5_s" descr="Editable text; source id n5_s"/>
+          <p:cNvSpPr txBox="1"/>
+          <p:nvPr/>
+        </p:nvSpPr>
+        <p:spPr>
+          <a:xfrm>
+            <a:off x="8459182" y="1661524"/>
+            <a:ext cx="1414541" cy="224530"/>
+          </a:xfrm>
+          <a:prstGeom prst="rect">
+            <a:avLst/>
+          </a:prstGeom>
+          <a:noFill/>
+          <a:effectLst/>
+        </p:spPr>
+        <p:txBody>
+          <a:bodyPr wrap="none" anchor="ctr" tIns="0" rIns="0" bIns="0" lIns="0" anchorCtr="0" vertOverflow="overflow">
+            <a:noAutofit/>
+          </a:bodyPr>
+          <a:lstStyle/>
+          <a:p>
+            <a:pPr algn="ctr" fontAlgn="base">
+              <a:lnSpc>
+                <a:spcPts val="1248"/>
+              </a:lnSpc>
+              <a:spcBef>
+                <a:spcPts val="0"/>
+              </a:spcBef>
+              <a:spcAft>
+                <a:spcPts val="0"/>
+              </a:spcAft>
+              <a:defRPr sz="1063" b="0" i="0" lang="zh-CN" dirty="0">
                 <a:solidFill>
                   <a:srgbClr val="3A4046"/>
                 </a:solidFill>
@@ -4369,7 +4749,7 @@
               </a:defRPr>
             </a:pPr>
             <a:r>
-              <a:rPr sz="1874" b="0" i="0" lang="zh-CN" dirty="0">
+              <a:rPr sz="1063" b="0" i="0" lang="zh-CN" dirty="0">
                 <a:solidFill>
                   <a:srgbClr val="3A4046"/>
                 </a:solidFill>
@@ -4382,28 +4762,53 @@
           </a:p>
         </p:txBody>
       </p:sp>
-      <p:sp>
-        <p:nvSpPr>
-          <p:cNvPr id="17" name="n6" descr="Editable shape; source id n6"/>
+      <p:pic>
+        <p:nvPicPr>
+          <p:cNvPr id="26" name="n5_i" descr="exact crop of source page_001 (monochrome line motif)"/>
+          <p:cNvPicPr>
+            <a:picLocks noChangeAspect="1"/>
+          </p:cNvPicPr>
+          <p:nvPr/>
+        </p:nvPicPr>
+        <p:blipFill>
+          <a:blip r:embed="rId6"/>
+          <a:stretch>
+            <a:fillRect/>
+          </a:stretch>
+        </p:blipFill>
+        <p:spPr>
+          <a:xfrm>
+            <a:off x="8661259" y="2093745"/>
+            <a:ext cx="1027226" cy="853215"/>
+          </a:xfrm>
+          <a:prstGeom prst="rect">
+            <a:avLst/>
+          </a:prstGeom>
+          <a:effectLst/>
+        </p:spPr>
+      </p:pic>
+      <p:sp>
+        <p:nvSpPr>
+          <p:cNvPr id="27" name="n6" descr="Editable shape; source id n6"/>
           <p:cNvSpPr/>
           <p:nvPr/>
         </p:nvSpPr>
         <p:spPr>
           <a:xfrm>
-            <a:off x="269874" y="5135562"/>
-            <a:ext cx="2659062" cy="1928812"/>
+            <a:off x="10564154" y="875668"/>
+            <a:ext cx="1408928" cy="2194784"/>
           </a:xfrm>
           <a:prstGeom prst="roundRect">
             <a:avLst>
-              <a:gd name="adj" fmla="val 7407"/>
+              <a:gd name="adj" fmla="val 5577"/>
             </a:avLst>
           </a:prstGeom>
           <a:solidFill>
-            <a:srgbClr val="F3F5F6"/>
+            <a:srgbClr val="FFFFFF"/>
           </a:solidFill>
-          <a:ln w="23812">
+          <a:ln w="14033">
             <a:solidFill>
-              <a:srgbClr val="C9CFD4"/>
+              <a:srgbClr val="4A5158"/>
             </a:solidFill>
           </a:ln>
           <a:effectLst/>
@@ -4432,14 +4837,14 @@
       </p:sp>
       <p:sp>
         <p:nvSpPr>
-          <p:cNvPr id="18" name="n6_t" descr="Editable text; source id n6_t"/>
+          <p:cNvPr id="28" name="n6_n" descr="Editable text; source id n6_n"/>
           <p:cNvSpPr txBox="1"/>
           <p:nvPr/>
         </p:nvSpPr>
         <p:spPr>
           <a:xfrm>
-            <a:off x="380999" y="5548312"/>
-            <a:ext cx="2436812" cy="523874"/>
+            <a:off x="10653966" y="943027"/>
+            <a:ext cx="392928" cy="190850"/>
           </a:xfrm>
           <a:prstGeom prst="rect">
             <a:avLst/>
@@ -4453,9 +4858,9 @@
           </a:bodyPr>
           <a:lstStyle/>
           <a:p>
-            <a:pPr algn="ctr" fontAlgn="base">
+            <a:pPr algn="l" fontAlgn="base">
               <a:lnSpc>
-                <a:spcPts val="4093"/>
+                <a:spcPts val="1138"/>
               </a:lnSpc>
               <a:spcBef>
                 <a:spcPts val="0"/>
@@ -4463,39 +4868,39 @@
               <a:spcAft>
                 <a:spcPts val="0"/>
               </a:spcAft>
-              <a:defRPr sz="2821" b="1" i="0" lang="zh-CN" dirty="0">
-                <a:solidFill>
-                  <a:srgbClr val="2B2F33"/>
-                </a:solidFill>
-                <a:latin typeface="Noto Sans CJK SC"/>
-                <a:ea typeface="Noto Sans CJK SC"/>
-                <a:cs typeface="Noto Sans CJK SC"/>
+              <a:defRPr sz="972" b="1" i="0" lang="zh-CN" dirty="0">
+                <a:solidFill>
+                  <a:srgbClr val="8A9199"/>
+                </a:solidFill>
+                <a:latin typeface="DejaVu Sans"/>
+                <a:ea typeface="DejaVu Sans"/>
+                <a:cs typeface="DejaVu Sans"/>
               </a:defRPr>
             </a:pPr>
             <a:r>
-              <a:rPr sz="2821" b="1" i="0" lang="zh-CN" dirty="0">
-                <a:solidFill>
-                  <a:srgbClr val="2B2F33"/>
-                </a:solidFill>
-                <a:latin typeface="Noto Sans CJK SC"/>
-                <a:ea typeface="Noto Sans CJK SC"/>
-                <a:cs typeface="Noto Sans CJK SC"/>
+              <a:rPr sz="972" b="1" i="0" lang="zh-CN" dirty="0">
+                <a:solidFill>
+                  <a:srgbClr val="8A9199"/>
+                </a:solidFill>
+                <a:latin typeface="DejaVu Sans"/>
+                <a:ea typeface="DejaVu Sans"/>
+                <a:cs typeface="DejaVu Sans"/>
               </a:rPr>
-              <a:t>实验优先级</a:t>
-            </a:r>
-          </a:p>
-        </p:txBody>
-      </p:sp>
-      <p:sp>
-        <p:nvSpPr>
-          <p:cNvPr id="19" name="n6_s" descr="Editable text; source id n6_s"/>
+              <a:t>06</a:t>
+            </a:r>
+          </a:p>
+        </p:txBody>
+      </p:sp>
+      <p:sp>
+        <p:nvSpPr>
+          <p:cNvPr id="29" name="n6_t" descr="Editable text; source id n6_t"/>
           <p:cNvSpPr txBox="1"/>
           <p:nvPr/>
         </p:nvSpPr>
         <p:spPr>
           <a:xfrm>
-            <a:off x="380999" y="6151562"/>
-            <a:ext cx="2436812" cy="380999"/>
+            <a:off x="10620287" y="1279823"/>
+            <a:ext cx="1296662" cy="336795"/>
           </a:xfrm>
           <a:prstGeom prst="rect">
             <a:avLst/>
@@ -4511,7 +4916,7 @@
           <a:p>
             <a:pPr algn="ctr" fontAlgn="base">
               <a:lnSpc>
-                <a:spcPts val="2734"/>
+                <a:spcPts val="2574"/>
               </a:lnSpc>
               <a:spcBef>
                 <a:spcPts val="0"/>
@@ -4519,9 +4924,9 @@
               <a:spcAft>
                 <a:spcPts val="0"/>
               </a:spcAft>
-              <a:defRPr sz="1874" b="0" i="0" lang="zh-CN" dirty="0">
-                <a:solidFill>
-                  <a:srgbClr val="3A4046"/>
+              <a:defRPr sz="1767" b="1" i="0" lang="zh-CN" dirty="0">
+                <a:solidFill>
+                  <a:srgbClr val="1F2326"/>
                 </a:solidFill>
                 <a:latin typeface="Noto Sans CJK SC"/>
                 <a:ea typeface="Noto Sans CJK SC"/>
@@ -4529,7 +4934,63 @@
               </a:defRPr>
             </a:pPr>
             <a:r>
-              <a:rPr sz="1874" b="0" i="0" lang="zh-CN" dirty="0">
+              <a:rPr sz="1767" b="1" i="0" lang="zh-CN" dirty="0">
+                <a:solidFill>
+                  <a:srgbClr val="1F2326"/>
+                </a:solidFill>
+                <a:latin typeface="Noto Sans CJK SC"/>
+                <a:ea typeface="Noto Sans CJK SC"/>
+                <a:cs typeface="Noto Sans CJK SC"/>
+              </a:rPr>
+              <a:t>实验优先级</a:t>
+            </a:r>
+          </a:p>
+        </p:txBody>
+      </p:sp>
+      <p:sp>
+        <p:nvSpPr>
+          <p:cNvPr id="30" name="n6_s" descr="Editable text; source id n6_s"/>
+          <p:cNvSpPr txBox="1"/>
+          <p:nvPr/>
+        </p:nvSpPr>
+        <p:spPr>
+          <a:xfrm>
+            <a:off x="10609060" y="1661524"/>
+            <a:ext cx="1319115" cy="224530"/>
+          </a:xfrm>
+          <a:prstGeom prst="rect">
+            <a:avLst/>
+          </a:prstGeom>
+          <a:noFill/>
+          <a:effectLst/>
+        </p:spPr>
+        <p:txBody>
+          <a:bodyPr wrap="none" anchor="ctr" tIns="0" rIns="0" bIns="0" lIns="0" anchorCtr="0" vertOverflow="overflow">
+            <a:noAutofit/>
+          </a:bodyPr>
+          <a:lstStyle/>
+          <a:p>
+            <a:pPr algn="ctr" fontAlgn="base">
+              <a:lnSpc>
+                <a:spcPts val="1546"/>
+              </a:lnSpc>
+              <a:spcBef>
+                <a:spcPts val="0"/>
+              </a:spcBef>
+              <a:spcAft>
+                <a:spcPts val="0"/>
+              </a:spcAft>
+              <a:defRPr sz="1063" b="0" i="0" lang="zh-CN" dirty="0">
+                <a:solidFill>
+                  <a:srgbClr val="3A4046"/>
+                </a:solidFill>
+                <a:latin typeface="Noto Sans CJK SC"/>
+                <a:ea typeface="Noto Sans CJK SC"/>
+                <a:cs typeface="Noto Sans CJK SC"/>
+              </a:defRPr>
+            </a:pPr>
+            <a:r>
+              <a:rPr sz="1063" b="0" i="0" lang="zh-CN" dirty="0">
                 <a:solidFill>
                   <a:srgbClr val="3A4046"/>
                 </a:solidFill>
@@ -4540,7 +5001,7 @@
               <a:t>相图</a:t>
             </a:r>
             <a:r>
-              <a:rPr sz="1874" b="0" i="0" lang="zh-CN" dirty="0">
+              <a:rPr sz="1063" b="0" i="0" lang="zh-CN" dirty="0">
                 <a:solidFill>
                   <a:srgbClr val="3A4046"/>
                 </a:solidFill>
@@ -4551,7 +5012,7 @@
               <a:t> · </a:t>
             </a:r>
             <a:r>
-              <a:rPr sz="1874" b="0" i="0" lang="zh-CN" dirty="0">
+              <a:rPr sz="1063" b="0" i="0" lang="zh-CN" dirty="0">
                 <a:solidFill>
                   <a:srgbClr val="3A4046"/>
                 </a:solidFill>
@@ -4562,7 +5023,7 @@
               <a:t>结构</a:t>
             </a:r>
             <a:r>
-              <a:rPr sz="1874" b="0" i="0" lang="zh-CN" dirty="0">
+              <a:rPr sz="1063" b="0" i="0" lang="zh-CN" dirty="0">
                 <a:solidFill>
                   <a:srgbClr val="3A4046"/>
                 </a:solidFill>
@@ -4573,7 +5034,7 @@
               <a:t> · </a:t>
             </a:r>
             <a:r>
-              <a:rPr sz="1874" b="0" i="0" lang="zh-CN" dirty="0">
+              <a:rPr sz="1063" b="0" i="0" lang="zh-CN" dirty="0">
                 <a:solidFill>
                   <a:srgbClr val="3A4046"/>
                 </a:solidFill>
@@ -4586,23 +5047,698 @@
           </a:p>
         </p:txBody>
       </p:sp>
+      <p:pic>
+        <p:nvPicPr>
+          <p:cNvPr id="31" name="n6_i" descr="exact crop of source page_001 (monochrome line motif)"/>
+          <p:cNvPicPr>
+            <a:picLocks noChangeAspect="1"/>
+          </p:cNvPicPr>
+          <p:nvPr/>
+        </p:nvPicPr>
+        <p:blipFill>
+          <a:blip r:embed="rId7"/>
+          <a:stretch>
+            <a:fillRect/>
+          </a:stretch>
+        </p:blipFill>
+        <p:spPr>
+          <a:xfrm>
+            <a:off x="10811137" y="2093745"/>
+            <a:ext cx="1066519" cy="841988"/>
+          </a:xfrm>
+          <a:prstGeom prst="rect">
+            <a:avLst/>
+          </a:prstGeom>
+          <a:effectLst/>
+        </p:spPr>
+      </p:pic>
+      <p:sp>
+        <p:nvSpPr>
+          <p:cNvPr id="32" name="e0" descr="Editable line; source id e0"/>
+          <p:cNvSpPr/>
+          <p:nvPr/>
+        </p:nvSpPr>
+        <p:spPr>
+          <a:xfrm>
+            <a:off x="1644685" y="1813083"/>
+            <a:ext cx="533260" cy="101039"/>
+          </a:xfrm>
+          <a:custGeom>
+            <a:avLst/>
+            <a:gdLst/>
+            <a:ahLst/>
+            <a:cxnLst/>
+            <a:rect l="l" t="t" r="r" b="b"/>
+            <a:pathLst>
+              <a:path w="95000" h="18000">
+                <a:moveTo>
+                  <a:pt x="0" y="6500"/>
+                </a:moveTo>
+                <a:lnTo>
+                  <a:pt x="77000" y="6500"/>
+                </a:lnTo>
+                <a:lnTo>
+                  <a:pt x="77000" y="0"/>
+                </a:lnTo>
+                <a:lnTo>
+                  <a:pt x="95000" y="9000"/>
+                </a:lnTo>
+                <a:lnTo>
+                  <a:pt x="77000" y="18000"/>
+                </a:lnTo>
+                <a:lnTo>
+                  <a:pt x="77000" y="11500"/>
+                </a:lnTo>
+                <a:lnTo>
+                  <a:pt x="0" y="11500"/>
+                </a:lnTo>
+                <a:close/>
+              </a:path>
+            </a:pathLst>
+          </a:custGeom>
+          <a:solidFill>
+            <a:srgbClr val="1F6F78"/>
+          </a:solidFill>
+          <a:ln>
+            <a:noFill/>
+          </a:ln>
+          <a:effectLst/>
+        </p:spPr>
+        <p:style>
+          <a:lnRef idx="1">
+            <a:schemeClr val="accent1"/>
+          </a:lnRef>
+          <a:fillRef idx="3">
+            <a:schemeClr val="accent1"/>
+          </a:fillRef>
+          <a:effectRef idx="0">
+            <a:schemeClr val="accent1"/>
+          </a:effectRef>
+          <a:fontRef idx="minor">
+            <a:schemeClr val="lt1"/>
+          </a:fontRef>
+        </p:style>
+        <p:txBody>
+          <a:bodyPr rtlCol="0" anchor="ctr"/>
+          <a:lstStyle/>
+          <a:p>
+            <a:pPr algn="ctr"/>
+          </a:p>
+        </p:txBody>
+      </p:sp>
+      <p:sp>
+        <p:nvSpPr>
+          <p:cNvPr id="33" name="e0_l" descr="Editable text; source id e0_l"/>
+          <p:cNvSpPr txBox="1"/>
+          <p:nvPr/>
+        </p:nvSpPr>
+        <p:spPr>
+          <a:xfrm>
+            <a:off x="1650298" y="1605392"/>
+            <a:ext cx="527646" cy="179624"/>
+          </a:xfrm>
+          <a:prstGeom prst="rect">
+            <a:avLst/>
+          </a:prstGeom>
+          <a:noFill/>
+          <a:effectLst/>
+        </p:spPr>
+        <p:txBody>
+          <a:bodyPr wrap="none" anchor="ctr" tIns="0" rIns="0" bIns="0" lIns="0" anchorCtr="0" vertOverflow="overflow">
+            <a:noAutofit/>
+          </a:bodyPr>
+          <a:lstStyle/>
+          <a:p>
+            <a:pPr algn="ctr" fontAlgn="base">
+              <a:lnSpc>
+                <a:spcPts val="1292"/>
+              </a:lnSpc>
+              <a:spcBef>
+                <a:spcPts val="0"/>
+              </a:spcBef>
+              <a:spcAft>
+                <a:spcPts val="0"/>
+              </a:spcAft>
+              <a:defRPr sz="883" b="0" i="0" lang="zh-CN" dirty="0">
+                <a:solidFill>
+                  <a:srgbClr val="3A4046"/>
+                </a:solidFill>
+                <a:latin typeface="Noto Sans CJK SC"/>
+                <a:ea typeface="Noto Sans CJK SC"/>
+                <a:cs typeface="Noto Sans CJK SC"/>
+              </a:defRPr>
+            </a:pPr>
+            <a:r>
+              <a:rPr sz="883" b="0" i="0" lang="zh-CN" dirty="0">
+                <a:solidFill>
+                  <a:srgbClr val="3A4046"/>
+                </a:solidFill>
+                <a:latin typeface="Noto Sans CJK SC"/>
+                <a:ea typeface="Noto Sans CJK SC"/>
+                <a:cs typeface="Noto Sans CJK SC"/>
+              </a:rPr>
+              <a:t>结构约束</a:t>
+            </a:r>
+          </a:p>
+        </p:txBody>
+      </p:sp>
+      <p:sp>
+        <p:nvSpPr>
+          <p:cNvPr id="34" name="e1" descr="Editable line; source id e1"/>
+          <p:cNvSpPr/>
+          <p:nvPr/>
+        </p:nvSpPr>
+        <p:spPr>
+          <a:xfrm>
+            <a:off x="3704751" y="1813083"/>
+            <a:ext cx="533260" cy="101039"/>
+          </a:xfrm>
+          <a:custGeom>
+            <a:avLst/>
+            <a:gdLst/>
+            <a:ahLst/>
+            <a:cxnLst/>
+            <a:rect l="l" t="t" r="r" b="b"/>
+            <a:pathLst>
+              <a:path w="95000" h="18000">
+                <a:moveTo>
+                  <a:pt x="0" y="6500"/>
+                </a:moveTo>
+                <a:lnTo>
+                  <a:pt x="77000" y="6500"/>
+                </a:lnTo>
+                <a:lnTo>
+                  <a:pt x="77000" y="0"/>
+                </a:lnTo>
+                <a:lnTo>
+                  <a:pt x="95000" y="9000"/>
+                </a:lnTo>
+                <a:lnTo>
+                  <a:pt x="77000" y="18000"/>
+                </a:lnTo>
+                <a:lnTo>
+                  <a:pt x="77000" y="11500"/>
+                </a:lnTo>
+                <a:lnTo>
+                  <a:pt x="0" y="11500"/>
+                </a:lnTo>
+                <a:close/>
+              </a:path>
+            </a:pathLst>
+          </a:custGeom>
+          <a:solidFill>
+            <a:srgbClr val="1F6F78"/>
+          </a:solidFill>
+          <a:ln>
+            <a:noFill/>
+          </a:ln>
+          <a:effectLst/>
+        </p:spPr>
+        <p:style>
+          <a:lnRef idx="1">
+            <a:schemeClr val="accent1"/>
+          </a:lnRef>
+          <a:fillRef idx="3">
+            <a:schemeClr val="accent1"/>
+          </a:fillRef>
+          <a:effectRef idx="0">
+            <a:schemeClr val="accent1"/>
+          </a:effectRef>
+          <a:fontRef idx="minor">
+            <a:schemeClr val="lt1"/>
+          </a:fontRef>
+        </p:style>
+        <p:txBody>
+          <a:bodyPr rtlCol="0" anchor="ctr"/>
+          <a:lstStyle/>
+          <a:p>
+            <a:pPr algn="ctr"/>
+          </a:p>
+        </p:txBody>
+      </p:sp>
+      <p:sp>
+        <p:nvSpPr>
+          <p:cNvPr id="35" name="e1_l" descr="Editable text; source id e1_l"/>
+          <p:cNvSpPr txBox="1"/>
+          <p:nvPr/>
+        </p:nvSpPr>
+        <p:spPr>
+          <a:xfrm>
+            <a:off x="3704751" y="1605392"/>
+            <a:ext cx="527646" cy="179624"/>
+          </a:xfrm>
+          <a:prstGeom prst="rect">
+            <a:avLst/>
+          </a:prstGeom>
+          <a:noFill/>
+          <a:effectLst/>
+        </p:spPr>
+        <p:txBody>
+          <a:bodyPr wrap="none" anchor="ctr" tIns="0" rIns="0" bIns="0" lIns="0" anchorCtr="0" vertOverflow="overflow">
+            <a:noAutofit/>
+          </a:bodyPr>
+          <a:lstStyle/>
+          <a:p>
+            <a:pPr algn="ctr" fontAlgn="base">
+              <a:lnSpc>
+                <a:spcPts val="1292"/>
+              </a:lnSpc>
+              <a:spcBef>
+                <a:spcPts val="0"/>
+              </a:spcBef>
+              <a:spcAft>
+                <a:spcPts val="0"/>
+              </a:spcAft>
+              <a:defRPr sz="883" b="0" i="0" lang="zh-CN" dirty="0">
+                <a:solidFill>
+                  <a:srgbClr val="3A4046"/>
+                </a:solidFill>
+                <a:latin typeface="Noto Sans CJK SC"/>
+                <a:ea typeface="Noto Sans CJK SC"/>
+                <a:cs typeface="Noto Sans CJK SC"/>
+              </a:defRPr>
+            </a:pPr>
+            <a:r>
+              <a:rPr sz="883" b="0" i="0" lang="zh-CN" dirty="0">
+                <a:solidFill>
+                  <a:srgbClr val="3A4046"/>
+                </a:solidFill>
+                <a:latin typeface="Noto Sans CJK SC"/>
+                <a:ea typeface="Noto Sans CJK SC"/>
+                <a:cs typeface="Noto Sans CJK SC"/>
+              </a:rPr>
+              <a:t>条件窗口</a:t>
+            </a:r>
+          </a:p>
+        </p:txBody>
+      </p:sp>
+      <p:sp>
+        <p:nvSpPr>
+          <p:cNvPr id="36" name="e2" descr="Editable line; source id e2"/>
+          <p:cNvSpPr/>
+          <p:nvPr/>
+        </p:nvSpPr>
+        <p:spPr>
+          <a:xfrm>
+            <a:off x="5753591" y="1813083"/>
+            <a:ext cx="572552" cy="101039"/>
+          </a:xfrm>
+          <a:custGeom>
+            <a:avLst/>
+            <a:gdLst/>
+            <a:ahLst/>
+            <a:cxnLst/>
+            <a:rect l="l" t="t" r="r" b="b"/>
+            <a:pathLst>
+              <a:path w="102000" h="18000">
+                <a:moveTo>
+                  <a:pt x="0" y="6500"/>
+                </a:moveTo>
+                <a:lnTo>
+                  <a:pt x="84000" y="6500"/>
+                </a:lnTo>
+                <a:lnTo>
+                  <a:pt x="84000" y="0"/>
+                </a:lnTo>
+                <a:lnTo>
+                  <a:pt x="102000" y="9000"/>
+                </a:lnTo>
+                <a:lnTo>
+                  <a:pt x="84000" y="18000"/>
+                </a:lnTo>
+                <a:lnTo>
+                  <a:pt x="84000" y="11500"/>
+                </a:lnTo>
+                <a:lnTo>
+                  <a:pt x="0" y="11500"/>
+                </a:lnTo>
+                <a:close/>
+              </a:path>
+            </a:pathLst>
+          </a:custGeom>
+          <a:solidFill>
+            <a:srgbClr val="1F6F78"/>
+          </a:solidFill>
+          <a:ln>
+            <a:noFill/>
+          </a:ln>
+          <a:effectLst/>
+        </p:spPr>
+        <p:style>
+          <a:lnRef idx="1">
+            <a:schemeClr val="accent1"/>
+          </a:lnRef>
+          <a:fillRef idx="3">
+            <a:schemeClr val="accent1"/>
+          </a:fillRef>
+          <a:effectRef idx="0">
+            <a:schemeClr val="accent1"/>
+          </a:effectRef>
+          <a:fontRef idx="minor">
+            <a:schemeClr val="lt1"/>
+          </a:fontRef>
+        </p:style>
+        <p:txBody>
+          <a:bodyPr rtlCol="0" anchor="ctr"/>
+          <a:lstStyle/>
+          <a:p>
+            <a:pPr algn="ctr"/>
+          </a:p>
+        </p:txBody>
+      </p:sp>
+      <p:sp>
+        <p:nvSpPr>
+          <p:cNvPr id="37" name="e2_l" descr="Editable text; source id e2_l"/>
+          <p:cNvSpPr txBox="1"/>
+          <p:nvPr/>
+        </p:nvSpPr>
+        <p:spPr>
+          <a:xfrm>
+            <a:off x="5719911" y="1605392"/>
+            <a:ext cx="639911" cy="179624"/>
+          </a:xfrm>
+          <a:prstGeom prst="rect">
+            <a:avLst/>
+          </a:prstGeom>
+          <a:noFill/>
+          <a:effectLst/>
+        </p:spPr>
+        <p:txBody>
+          <a:bodyPr wrap="none" anchor="ctr" tIns="0" rIns="0" bIns="0" lIns="0" anchorCtr="0" vertOverflow="overflow">
+            <a:noAutofit/>
+          </a:bodyPr>
+          <a:lstStyle/>
+          <a:p>
+            <a:pPr algn="ctr" fontAlgn="base">
+              <a:lnSpc>
+                <a:spcPts val="1292"/>
+              </a:lnSpc>
+              <a:spcBef>
+                <a:spcPts val="0"/>
+              </a:spcBef>
+              <a:spcAft>
+                <a:spcPts val="0"/>
+              </a:spcAft>
+              <a:defRPr sz="883" b="0" i="0" lang="zh-CN" dirty="0">
+                <a:solidFill>
+                  <a:srgbClr val="3A4046"/>
+                </a:solidFill>
+                <a:latin typeface="Noto Sans CJK SC"/>
+                <a:ea typeface="Noto Sans CJK SC"/>
+                <a:cs typeface="Noto Sans CJK SC"/>
+              </a:defRPr>
+            </a:pPr>
+            <a:r>
+              <a:rPr sz="883" b="0" i="0" lang="zh-CN" dirty="0">
+                <a:solidFill>
+                  <a:srgbClr val="3A4046"/>
+                </a:solidFill>
+                <a:latin typeface="Noto Sans CJK SC"/>
+                <a:ea typeface="Noto Sans CJK SC"/>
+                <a:cs typeface="Noto Sans CJK SC"/>
+              </a:rPr>
+              <a:t>可迁移变量</a:t>
+            </a:r>
+          </a:p>
+        </p:txBody>
+      </p:sp>
+      <p:sp>
+        <p:nvSpPr>
+          <p:cNvPr id="38" name="e3" descr="Editable line; source id e3"/>
+          <p:cNvSpPr/>
+          <p:nvPr/>
+        </p:nvSpPr>
+        <p:spPr>
+          <a:xfrm>
+            <a:off x="7830497" y="1813083"/>
+            <a:ext cx="527646" cy="101039"/>
+          </a:xfrm>
+          <a:custGeom>
+            <a:avLst/>
+            <a:gdLst/>
+            <a:ahLst/>
+            <a:cxnLst/>
+            <a:rect l="l" t="t" r="r" b="b"/>
+            <a:pathLst>
+              <a:path w="94000" h="18000">
+                <a:moveTo>
+                  <a:pt x="0" y="6500"/>
+                </a:moveTo>
+                <a:lnTo>
+                  <a:pt x="76000" y="6500"/>
+                </a:lnTo>
+                <a:lnTo>
+                  <a:pt x="76000" y="0"/>
+                </a:lnTo>
+                <a:lnTo>
+                  <a:pt x="94000" y="9000"/>
+                </a:lnTo>
+                <a:lnTo>
+                  <a:pt x="76000" y="18000"/>
+                </a:lnTo>
+                <a:lnTo>
+                  <a:pt x="76000" y="11500"/>
+                </a:lnTo>
+                <a:lnTo>
+                  <a:pt x="0" y="11500"/>
+                </a:lnTo>
+                <a:close/>
+              </a:path>
+            </a:pathLst>
+          </a:custGeom>
+          <a:solidFill>
+            <a:srgbClr val="1F6F78"/>
+          </a:solidFill>
+          <a:ln>
+            <a:noFill/>
+          </a:ln>
+          <a:effectLst/>
+        </p:spPr>
+        <p:style>
+          <a:lnRef idx="1">
+            <a:schemeClr val="accent1"/>
+          </a:lnRef>
+          <a:fillRef idx="3">
+            <a:schemeClr val="accent1"/>
+          </a:fillRef>
+          <a:effectRef idx="0">
+            <a:schemeClr val="accent1"/>
+          </a:effectRef>
+          <a:fontRef idx="minor">
+            <a:schemeClr val="lt1"/>
+          </a:fontRef>
+        </p:style>
+        <p:txBody>
+          <a:bodyPr rtlCol="0" anchor="ctr"/>
+          <a:lstStyle/>
+          <a:p>
+            <a:pPr algn="ctr"/>
+          </a:p>
+        </p:txBody>
+      </p:sp>
+      <p:sp>
+        <p:nvSpPr>
+          <p:cNvPr id="39" name="e3_l" descr="Editable text; source id e3_l"/>
+          <p:cNvSpPr txBox="1"/>
+          <p:nvPr/>
+        </p:nvSpPr>
+        <p:spPr>
+          <a:xfrm>
+            <a:off x="7830497" y="1605392"/>
+            <a:ext cx="527646" cy="179624"/>
+          </a:xfrm>
+          <a:prstGeom prst="rect">
+            <a:avLst/>
+          </a:prstGeom>
+          <a:noFill/>
+          <a:effectLst/>
+        </p:spPr>
+        <p:txBody>
+          <a:bodyPr wrap="none" anchor="ctr" tIns="0" rIns="0" bIns="0" lIns="0" anchorCtr="0" vertOverflow="overflow">
+            <a:noAutofit/>
+          </a:bodyPr>
+          <a:lstStyle/>
+          <a:p>
+            <a:pPr algn="ctr" fontAlgn="base">
+              <a:lnSpc>
+                <a:spcPts val="1292"/>
+              </a:lnSpc>
+              <a:spcBef>
+                <a:spcPts val="0"/>
+              </a:spcBef>
+              <a:spcAft>
+                <a:spcPts val="0"/>
+              </a:spcAft>
+              <a:defRPr sz="883" b="0" i="0" lang="zh-CN" dirty="0">
+                <a:solidFill>
+                  <a:srgbClr val="3A4046"/>
+                </a:solidFill>
+                <a:latin typeface="Noto Sans CJK SC"/>
+                <a:ea typeface="Noto Sans CJK SC"/>
+                <a:cs typeface="Noto Sans CJK SC"/>
+              </a:defRPr>
+            </a:pPr>
+            <a:r>
+              <a:rPr sz="883" b="0" i="0" lang="zh-CN" dirty="0">
+                <a:solidFill>
+                  <a:srgbClr val="3A4046"/>
+                </a:solidFill>
+                <a:latin typeface="Noto Sans CJK SC"/>
+                <a:ea typeface="Noto Sans CJK SC"/>
+                <a:cs typeface="Noto Sans CJK SC"/>
+              </a:rPr>
+              <a:t>比较边界</a:t>
+            </a:r>
+          </a:p>
+        </p:txBody>
+      </p:sp>
+      <p:sp>
+        <p:nvSpPr>
+          <p:cNvPr id="40" name="e4" descr="Editable line; source id e4"/>
+          <p:cNvSpPr/>
+          <p:nvPr/>
+        </p:nvSpPr>
+        <p:spPr>
+          <a:xfrm>
+            <a:off x="9974762" y="1813083"/>
+            <a:ext cx="533260" cy="101039"/>
+          </a:xfrm>
+          <a:custGeom>
+            <a:avLst/>
+            <a:gdLst/>
+            <a:ahLst/>
+            <a:cxnLst/>
+            <a:rect l="l" t="t" r="r" b="b"/>
+            <a:pathLst>
+              <a:path w="95000" h="18000">
+                <a:moveTo>
+                  <a:pt x="0" y="6500"/>
+                </a:moveTo>
+                <a:lnTo>
+                  <a:pt x="77000" y="6500"/>
+                </a:lnTo>
+                <a:lnTo>
+                  <a:pt x="77000" y="0"/>
+                </a:lnTo>
+                <a:lnTo>
+                  <a:pt x="95000" y="9000"/>
+                </a:lnTo>
+                <a:lnTo>
+                  <a:pt x="77000" y="18000"/>
+                </a:lnTo>
+                <a:lnTo>
+                  <a:pt x="77000" y="11500"/>
+                </a:lnTo>
+                <a:lnTo>
+                  <a:pt x="0" y="11500"/>
+                </a:lnTo>
+                <a:close/>
+              </a:path>
+            </a:pathLst>
+          </a:custGeom>
+          <a:solidFill>
+            <a:srgbClr val="1F6F78"/>
+          </a:solidFill>
+          <a:ln>
+            <a:noFill/>
+          </a:ln>
+          <a:effectLst/>
+        </p:spPr>
+        <p:style>
+          <a:lnRef idx="1">
+            <a:schemeClr val="accent1"/>
+          </a:lnRef>
+          <a:fillRef idx="3">
+            <a:schemeClr val="accent1"/>
+          </a:fillRef>
+          <a:effectRef idx="0">
+            <a:schemeClr val="accent1"/>
+          </a:effectRef>
+          <a:fontRef idx="minor">
+            <a:schemeClr val="lt1"/>
+          </a:fontRef>
+        </p:style>
+        <p:txBody>
+          <a:bodyPr rtlCol="0" anchor="ctr"/>
+          <a:lstStyle/>
+          <a:p>
+            <a:pPr algn="ctr"/>
+          </a:p>
+        </p:txBody>
+      </p:sp>
+      <p:sp>
+        <p:nvSpPr>
+          <p:cNvPr id="41" name="e4_l" descr="Editable text; source id e4_l"/>
+          <p:cNvSpPr txBox="1"/>
+          <p:nvPr/>
+        </p:nvSpPr>
+        <p:spPr>
+          <a:xfrm>
+            <a:off x="9980375" y="1605392"/>
+            <a:ext cx="527646" cy="179624"/>
+          </a:xfrm>
+          <a:prstGeom prst="rect">
+            <a:avLst/>
+          </a:prstGeom>
+          <a:noFill/>
+          <a:effectLst/>
+        </p:spPr>
+        <p:txBody>
+          <a:bodyPr wrap="none" anchor="ctr" tIns="0" rIns="0" bIns="0" lIns="0" anchorCtr="0" vertOverflow="overflow">
+            <a:noAutofit/>
+          </a:bodyPr>
+          <a:lstStyle/>
+          <a:p>
+            <a:pPr algn="ctr" fontAlgn="base">
+              <a:lnSpc>
+                <a:spcPts val="1292"/>
+              </a:lnSpc>
+              <a:spcBef>
+                <a:spcPts val="0"/>
+              </a:spcBef>
+              <a:spcAft>
+                <a:spcPts val="0"/>
+              </a:spcAft>
+              <a:defRPr sz="883" b="0" i="0" lang="zh-CN" dirty="0">
+                <a:solidFill>
+                  <a:srgbClr val="3A4046"/>
+                </a:solidFill>
+                <a:latin typeface="Noto Sans CJK SC"/>
+                <a:ea typeface="Noto Sans CJK SC"/>
+                <a:cs typeface="Noto Sans CJK SC"/>
+              </a:defRPr>
+            </a:pPr>
+            <a:r>
+              <a:rPr sz="883" b="0" i="0" lang="zh-CN" dirty="0">
+                <a:solidFill>
+                  <a:srgbClr val="3A4046"/>
+                </a:solidFill>
+                <a:latin typeface="Noto Sans CJK SC"/>
+                <a:ea typeface="Noto Sans CJK SC"/>
+                <a:cs typeface="Noto Sans CJK SC"/>
+              </a:rPr>
+              <a:t>缺口驱动</a:t>
+            </a:r>
+          </a:p>
+        </p:txBody>
+      </p:sp>
       <p:cxnSp>
         <p:nvCxnSpPr>
-          <p:cNvPr id="20" name="e1a" descr="Editable line; source id e1a"/>
+          <p:cNvPr id="42" name="base" descr="Editable line; source id base"/>
           <p:cNvCxnSpPr/>
           <p:nvPr/>
         </p:nvCxnSpPr>
         <p:spPr>
           <a:xfrm>
-            <a:off x="2889249" y="1904999"/>
-            <a:ext cx="222250" cy="0"/>
+            <a:off x="207690" y="3210784"/>
+            <a:ext cx="11771005" cy="0"/>
           </a:xfrm>
           <a:prstGeom prst="line">
             <a:avLst/>
           </a:prstGeom>
-          <a:ln w="71437">
+          <a:ln w="22453">
             <a:solidFill>
-              <a:srgbClr val="1F6F78"/>
+              <a:srgbClr val="C9CFD4"/>
             </a:solidFill>
           </a:ln>
           <a:effectLst/>
@@ -4622,1112 +5758,6 @@
           </a:fontRef>
         </p:style>
       </p:cxnSp>
-      <p:sp>
-        <p:nvSpPr>
-          <p:cNvPr id="21" name="e1b" descr="Editable line; source id e1b"/>
-          <p:cNvSpPr/>
-          <p:nvPr/>
-        </p:nvSpPr>
-        <p:spPr>
-          <a:xfrm>
-            <a:off x="4127500" y="1817687"/>
-            <a:ext cx="214312" cy="174625"/>
-          </a:xfrm>
-          <a:custGeom>
-            <a:avLst/>
-            <a:gdLst/>
-            <a:ahLst/>
-            <a:cxnLst/>
-            <a:rect l="l" t="t" r="r" b="b"/>
-            <a:pathLst>
-              <a:path w="27000" h="22000">
-                <a:moveTo>
-                  <a:pt x="0" y="6500"/>
-                </a:moveTo>
-                <a:lnTo>
-                  <a:pt x="9000" y="6500"/>
-                </a:lnTo>
-                <a:lnTo>
-                  <a:pt x="9000" y="0"/>
-                </a:lnTo>
-                <a:lnTo>
-                  <a:pt x="27000" y="11000"/>
-                </a:lnTo>
-                <a:lnTo>
-                  <a:pt x="9000" y="22000"/>
-                </a:lnTo>
-                <a:lnTo>
-                  <a:pt x="9000" y="15500"/>
-                </a:lnTo>
-                <a:lnTo>
-                  <a:pt x="0" y="15500"/>
-                </a:lnTo>
-                <a:close/>
-              </a:path>
-            </a:pathLst>
-          </a:custGeom>
-          <a:solidFill>
-            <a:srgbClr val="1F6F78"/>
-          </a:solidFill>
-          <a:ln>
-            <a:noFill/>
-          </a:ln>
-          <a:effectLst/>
-        </p:spPr>
-        <p:style>
-          <a:lnRef idx="1">
-            <a:schemeClr val="accent1"/>
-          </a:lnRef>
-          <a:fillRef idx="3">
-            <a:schemeClr val="accent1"/>
-          </a:fillRef>
-          <a:effectRef idx="0">
-            <a:schemeClr val="accent1"/>
-          </a:effectRef>
-          <a:fontRef idx="minor">
-            <a:schemeClr val="lt1"/>
-          </a:fontRef>
-        </p:style>
-        <p:txBody>
-          <a:bodyPr rtlCol="0" anchor="ctr"/>
-          <a:lstStyle/>
-          <a:p>
-            <a:pPr algn="ctr"/>
-          </a:p>
-        </p:txBody>
-      </p:sp>
-      <p:sp>
-        <p:nvSpPr>
-          <p:cNvPr id="22" name="e1_p" descr="Editable shape; source id e1_p"/>
-          <p:cNvSpPr/>
-          <p:nvPr/>
-        </p:nvSpPr>
-        <p:spPr>
-          <a:xfrm>
-            <a:off x="3127374" y="1714499"/>
-            <a:ext cx="984249" cy="380999"/>
-          </a:xfrm>
-          <a:prstGeom prst="roundRect">
-            <a:avLst>
-              <a:gd name="adj" fmla="val 50000"/>
-            </a:avLst>
-          </a:prstGeom>
-          <a:solidFill>
-            <a:srgbClr val="FFFFFF"/>
-          </a:solidFill>
-          <a:ln w="19843">
-            <a:solidFill>
-              <a:srgbClr val="1F6F78"/>
-            </a:solidFill>
-          </a:ln>
-          <a:effectLst/>
-        </p:spPr>
-        <p:style>
-          <a:lnRef idx="1">
-            <a:schemeClr val="accent1"/>
-          </a:lnRef>
-          <a:fillRef idx="3">
-            <a:schemeClr val="accent1"/>
-          </a:fillRef>
-          <a:effectRef idx="0">
-            <a:schemeClr val="accent1"/>
-          </a:effectRef>
-          <a:fontRef idx="minor">
-            <a:schemeClr val="lt1"/>
-          </a:fontRef>
-        </p:style>
-        <p:txBody>
-          <a:bodyPr rtlCol="0" anchor="ctr"/>
-          <a:lstStyle/>
-          <a:p>
-            <a:pPr algn="ctr"/>
-          </a:p>
-        </p:txBody>
-      </p:sp>
-      <p:sp>
-        <p:nvSpPr>
-          <p:cNvPr id="23" name="e1_pt" descr="Editable text; source id e1_pt"/>
-          <p:cNvSpPr txBox="1"/>
-          <p:nvPr/>
-        </p:nvSpPr>
-        <p:spPr>
-          <a:xfrm>
-            <a:off x="3190874" y="1746249"/>
-            <a:ext cx="857249" cy="317499"/>
-          </a:xfrm>
-          <a:prstGeom prst="rect">
-            <a:avLst/>
-          </a:prstGeom>
-          <a:noFill/>
-          <a:effectLst/>
-        </p:spPr>
-        <p:txBody>
-          <a:bodyPr wrap="none" anchor="ctr" tIns="0" rIns="0" bIns="0" lIns="0" anchorCtr="0" vertOverflow="overflow">
-            <a:noAutofit/>
-          </a:bodyPr>
-          <a:lstStyle/>
-          <a:p>
-            <a:pPr algn="ctr" fontAlgn="base">
-              <a:lnSpc>
-                <a:spcPts val="2187"/>
-              </a:lnSpc>
-              <a:spcBef>
-                <a:spcPts val="0"/>
-              </a:spcBef>
-              <a:spcAft>
-                <a:spcPts val="0"/>
-              </a:spcAft>
-              <a:defRPr sz="1499" b="1" i="0" lang="zh-CN" dirty="0">
-                <a:solidFill>
-                  <a:srgbClr val="1F6F78"/>
-                </a:solidFill>
-                <a:latin typeface="Noto Sans CJK SC"/>
-                <a:ea typeface="Noto Sans CJK SC"/>
-                <a:cs typeface="Noto Sans CJK SC"/>
-              </a:defRPr>
-            </a:pPr>
-            <a:r>
-              <a:rPr sz="1499" b="1" i="0" lang="zh-CN" dirty="0">
-                <a:solidFill>
-                  <a:srgbClr val="1F6F78"/>
-                </a:solidFill>
-                <a:latin typeface="Noto Sans CJK SC"/>
-                <a:ea typeface="Noto Sans CJK SC"/>
-                <a:cs typeface="Noto Sans CJK SC"/>
-              </a:rPr>
-              <a:t>结构约束</a:t>
-            </a:r>
-          </a:p>
-        </p:txBody>
-      </p:sp>
-      <p:cxnSp>
-        <p:nvCxnSpPr>
-          <p:cNvPr id="24" name="e2a" descr="Editable line; source id e2a"/>
-          <p:cNvCxnSpPr/>
-          <p:nvPr/>
-        </p:nvCxnSpPr>
-        <p:spPr>
-          <a:xfrm>
-            <a:off x="6984999" y="1904999"/>
-            <a:ext cx="190500" cy="0"/>
-          </a:xfrm>
-          <a:prstGeom prst="line">
-            <a:avLst/>
-          </a:prstGeom>
-          <a:ln w="71437">
-            <a:solidFill>
-              <a:srgbClr val="1F6F78"/>
-            </a:solidFill>
-          </a:ln>
-          <a:effectLst/>
-        </p:spPr>
-        <p:style>
-          <a:lnRef idx="2">
-            <a:schemeClr val="accent1"/>
-          </a:lnRef>
-          <a:fillRef idx="0">
-            <a:schemeClr val="accent1"/>
-          </a:fillRef>
-          <a:effectRef idx="0">
-            <a:schemeClr val="accent1"/>
-          </a:effectRef>
-          <a:fontRef idx="minor">
-            <a:schemeClr val="tx1"/>
-          </a:fontRef>
-        </p:style>
-      </p:cxnSp>
-      <p:sp>
-        <p:nvSpPr>
-          <p:cNvPr id="25" name="e2b" descr="Editable line; source id e2b"/>
-          <p:cNvSpPr/>
-          <p:nvPr/>
-        </p:nvSpPr>
-        <p:spPr>
-          <a:xfrm>
-            <a:off x="8191500" y="1817687"/>
-            <a:ext cx="182562" cy="174625"/>
-          </a:xfrm>
-          <a:custGeom>
-            <a:avLst/>
-            <a:gdLst/>
-            <a:ahLst/>
-            <a:cxnLst/>
-            <a:rect l="l" t="t" r="r" b="b"/>
-            <a:pathLst>
-              <a:path w="23000" h="22000">
-                <a:moveTo>
-                  <a:pt x="0" y="6500"/>
-                </a:moveTo>
-                <a:lnTo>
-                  <a:pt x="5000" y="6500"/>
-                </a:lnTo>
-                <a:lnTo>
-                  <a:pt x="5000" y="0"/>
-                </a:lnTo>
-                <a:lnTo>
-                  <a:pt x="23000" y="11000"/>
-                </a:lnTo>
-                <a:lnTo>
-                  <a:pt x="5000" y="22000"/>
-                </a:lnTo>
-                <a:lnTo>
-                  <a:pt x="5000" y="15500"/>
-                </a:lnTo>
-                <a:lnTo>
-                  <a:pt x="0" y="15500"/>
-                </a:lnTo>
-                <a:close/>
-              </a:path>
-            </a:pathLst>
-          </a:custGeom>
-          <a:solidFill>
-            <a:srgbClr val="1F6F78"/>
-          </a:solidFill>
-          <a:ln>
-            <a:noFill/>
-          </a:ln>
-          <a:effectLst/>
-        </p:spPr>
-        <p:style>
-          <a:lnRef idx="1">
-            <a:schemeClr val="accent1"/>
-          </a:lnRef>
-          <a:fillRef idx="3">
-            <a:schemeClr val="accent1"/>
-          </a:fillRef>
-          <a:effectRef idx="0">
-            <a:schemeClr val="accent1"/>
-          </a:effectRef>
-          <a:fontRef idx="minor">
-            <a:schemeClr val="lt1"/>
-          </a:fontRef>
-        </p:style>
-        <p:txBody>
-          <a:bodyPr rtlCol="0" anchor="ctr"/>
-          <a:lstStyle/>
-          <a:p>
-            <a:pPr algn="ctr"/>
-          </a:p>
-        </p:txBody>
-      </p:sp>
-      <p:sp>
-        <p:nvSpPr>
-          <p:cNvPr id="26" name="e2_p" descr="Editable shape; source id e2_p"/>
-          <p:cNvSpPr/>
-          <p:nvPr/>
-        </p:nvSpPr>
-        <p:spPr>
-          <a:xfrm>
-            <a:off x="7191374" y="1714499"/>
-            <a:ext cx="984249" cy="380999"/>
-          </a:xfrm>
-          <a:prstGeom prst="roundRect">
-            <a:avLst>
-              <a:gd name="adj" fmla="val 50000"/>
-            </a:avLst>
-          </a:prstGeom>
-          <a:solidFill>
-            <a:srgbClr val="FFFFFF"/>
-          </a:solidFill>
-          <a:ln w="19843">
-            <a:solidFill>
-              <a:srgbClr val="1F6F78"/>
-            </a:solidFill>
-          </a:ln>
-          <a:effectLst/>
-        </p:spPr>
-        <p:style>
-          <a:lnRef idx="1">
-            <a:schemeClr val="accent1"/>
-          </a:lnRef>
-          <a:fillRef idx="3">
-            <a:schemeClr val="accent1"/>
-          </a:fillRef>
-          <a:effectRef idx="0">
-            <a:schemeClr val="accent1"/>
-          </a:effectRef>
-          <a:fontRef idx="minor">
-            <a:schemeClr val="lt1"/>
-          </a:fontRef>
-        </p:style>
-        <p:txBody>
-          <a:bodyPr rtlCol="0" anchor="ctr"/>
-          <a:lstStyle/>
-          <a:p>
-            <a:pPr algn="ctr"/>
-          </a:p>
-        </p:txBody>
-      </p:sp>
-      <p:sp>
-        <p:nvSpPr>
-          <p:cNvPr id="27" name="e2_pt" descr="Editable text; source id e2_pt"/>
-          <p:cNvSpPr txBox="1"/>
-          <p:nvPr/>
-        </p:nvSpPr>
-        <p:spPr>
-          <a:xfrm>
-            <a:off x="7254874" y="1746249"/>
-            <a:ext cx="857249" cy="317499"/>
-          </a:xfrm>
-          <a:prstGeom prst="rect">
-            <a:avLst/>
-          </a:prstGeom>
-          <a:noFill/>
-          <a:effectLst/>
-        </p:spPr>
-        <p:txBody>
-          <a:bodyPr wrap="none" anchor="ctr" tIns="0" rIns="0" bIns="0" lIns="0" anchorCtr="0" vertOverflow="overflow">
-            <a:noAutofit/>
-          </a:bodyPr>
-          <a:lstStyle/>
-          <a:p>
-            <a:pPr algn="ctr" fontAlgn="base">
-              <a:lnSpc>
-                <a:spcPts val="2187"/>
-              </a:lnSpc>
-              <a:spcBef>
-                <a:spcPts val="0"/>
-              </a:spcBef>
-              <a:spcAft>
-                <a:spcPts val="0"/>
-              </a:spcAft>
-              <a:defRPr sz="1499" b="1" i="0" lang="zh-CN" dirty="0">
-                <a:solidFill>
-                  <a:srgbClr val="1F6F78"/>
-                </a:solidFill>
-                <a:latin typeface="Noto Sans CJK SC"/>
-                <a:ea typeface="Noto Sans CJK SC"/>
-                <a:cs typeface="Noto Sans CJK SC"/>
-              </a:defRPr>
-            </a:pPr>
-            <a:r>
-              <a:rPr sz="1499" b="1" i="0" lang="zh-CN" dirty="0">
-                <a:solidFill>
-                  <a:srgbClr val="1F6F78"/>
-                </a:solidFill>
-                <a:latin typeface="Noto Sans CJK SC"/>
-                <a:ea typeface="Noto Sans CJK SC"/>
-                <a:cs typeface="Noto Sans CJK SC"/>
-              </a:rPr>
-              <a:t>条件窗口</a:t>
-            </a:r>
-          </a:p>
-        </p:txBody>
-      </p:sp>
-      <p:cxnSp>
-        <p:nvCxnSpPr>
-          <p:cNvPr id="28" name="e3a" descr="Editable line; source id e3a"/>
-          <p:cNvCxnSpPr/>
-          <p:nvPr/>
-        </p:nvCxnSpPr>
-        <p:spPr>
-          <a:xfrm>
-            <a:off x="10977562" y="1904999"/>
-            <a:ext cx="452437" cy="0"/>
-          </a:xfrm>
-          <a:prstGeom prst="line">
-            <a:avLst/>
-          </a:prstGeom>
-          <a:ln w="71437">
-            <a:solidFill>
-              <a:srgbClr val="1F6F78"/>
-            </a:solidFill>
-          </a:ln>
-          <a:effectLst/>
-        </p:spPr>
-        <p:style>
-          <a:lnRef idx="2">
-            <a:schemeClr val="accent1"/>
-          </a:lnRef>
-          <a:fillRef idx="0">
-            <a:schemeClr val="accent1"/>
-          </a:fillRef>
-          <a:effectRef idx="0">
-            <a:schemeClr val="accent1"/>
-          </a:effectRef>
-          <a:fontRef idx="minor">
-            <a:schemeClr val="tx1"/>
-          </a:fontRef>
-        </p:style>
-      </p:cxnSp>
-      <p:cxnSp>
-        <p:nvCxnSpPr>
-          <p:cNvPr id="29" name="e3b" descr="Editable line; source id e3b"/>
-          <p:cNvCxnSpPr/>
-          <p:nvPr/>
-        </p:nvCxnSpPr>
-        <p:spPr>
-          <a:xfrm>
-            <a:off x="11429999" y="1904999"/>
-            <a:ext cx="0" cy="1793875"/>
-          </a:xfrm>
-          <a:prstGeom prst="line">
-            <a:avLst/>
-          </a:prstGeom>
-          <a:ln w="71437">
-            <a:solidFill>
-              <a:srgbClr val="1F6F78"/>
-            </a:solidFill>
-          </a:ln>
-          <a:effectLst/>
-        </p:spPr>
-        <p:style>
-          <a:lnRef idx="2">
-            <a:schemeClr val="accent1"/>
-          </a:lnRef>
-          <a:fillRef idx="0">
-            <a:schemeClr val="accent1"/>
-          </a:fillRef>
-          <a:effectRef idx="0">
-            <a:schemeClr val="accent1"/>
-          </a:effectRef>
-          <a:fontRef idx="minor">
-            <a:schemeClr val="tx1"/>
-          </a:fontRef>
-        </p:style>
-      </p:cxnSp>
-      <p:sp>
-        <p:nvSpPr>
-          <p:cNvPr id="30" name="e3_p" descr="Editable shape; source id e3_p"/>
-          <p:cNvSpPr/>
-          <p:nvPr/>
-        </p:nvSpPr>
-        <p:spPr>
-          <a:xfrm>
-            <a:off x="10794999" y="3714749"/>
-            <a:ext cx="1269999" cy="380999"/>
-          </a:xfrm>
-          <a:prstGeom prst="roundRect">
-            <a:avLst>
-              <a:gd name="adj" fmla="val 50000"/>
-            </a:avLst>
-          </a:prstGeom>
-          <a:solidFill>
-            <a:srgbClr val="FFFFFF"/>
-          </a:solidFill>
-          <a:ln w="19843">
-            <a:solidFill>
-              <a:srgbClr val="1F6F78"/>
-            </a:solidFill>
-          </a:ln>
-          <a:effectLst/>
-        </p:spPr>
-        <p:style>
-          <a:lnRef idx="1">
-            <a:schemeClr val="accent1"/>
-          </a:lnRef>
-          <a:fillRef idx="3">
-            <a:schemeClr val="accent1"/>
-          </a:fillRef>
-          <a:effectRef idx="0">
-            <a:schemeClr val="accent1"/>
-          </a:effectRef>
-          <a:fontRef idx="minor">
-            <a:schemeClr val="lt1"/>
-          </a:fontRef>
-        </p:style>
-        <p:txBody>
-          <a:bodyPr rtlCol="0" anchor="ctr"/>
-          <a:lstStyle/>
-          <a:p>
-            <a:pPr algn="ctr"/>
-          </a:p>
-        </p:txBody>
-      </p:sp>
-      <p:sp>
-        <p:nvSpPr>
-          <p:cNvPr id="31" name="e3_pt" descr="Editable text; source id e3_pt"/>
-          <p:cNvSpPr txBox="1"/>
-          <p:nvPr/>
-        </p:nvSpPr>
-        <p:spPr>
-          <a:xfrm>
-            <a:off x="10858499" y="3746499"/>
-            <a:ext cx="1142999" cy="317499"/>
-          </a:xfrm>
-          <a:prstGeom prst="rect">
-            <a:avLst/>
-          </a:prstGeom>
-          <a:noFill/>
-          <a:effectLst/>
-        </p:spPr>
-        <p:txBody>
-          <a:bodyPr wrap="none" anchor="ctr" tIns="0" rIns="0" bIns="0" lIns="0" anchorCtr="0" vertOverflow="overflow">
-            <a:noAutofit/>
-          </a:bodyPr>
-          <a:lstStyle/>
-          <a:p>
-            <a:pPr algn="ctr" fontAlgn="base">
-              <a:lnSpc>
-                <a:spcPts val="2187"/>
-              </a:lnSpc>
-              <a:spcBef>
-                <a:spcPts val="0"/>
-              </a:spcBef>
-              <a:spcAft>
-                <a:spcPts val="0"/>
-              </a:spcAft>
-              <a:defRPr sz="1499" b="1" i="0" lang="zh-CN" dirty="0">
-                <a:solidFill>
-                  <a:srgbClr val="1F6F78"/>
-                </a:solidFill>
-                <a:latin typeface="Noto Sans CJK SC"/>
-                <a:ea typeface="Noto Sans CJK SC"/>
-                <a:cs typeface="Noto Sans CJK SC"/>
-              </a:defRPr>
-            </a:pPr>
-            <a:r>
-              <a:rPr sz="1499" b="1" i="0" lang="zh-CN" dirty="0">
-                <a:solidFill>
-                  <a:srgbClr val="1F6F78"/>
-                </a:solidFill>
-                <a:latin typeface="Noto Sans CJK SC"/>
-                <a:ea typeface="Noto Sans CJK SC"/>
-                <a:cs typeface="Noto Sans CJK SC"/>
-              </a:rPr>
-              <a:t>可迁移变量</a:t>
-            </a:r>
-          </a:p>
-        </p:txBody>
-      </p:sp>
-      <p:cxnSp>
-        <p:nvCxnSpPr>
-          <p:cNvPr id="32" name="e3c" descr="Editable line; source id e3c"/>
-          <p:cNvCxnSpPr/>
-          <p:nvPr/>
-        </p:nvCxnSpPr>
-        <p:spPr>
-          <a:xfrm>
-            <a:off x="11429999" y="4111624"/>
-            <a:ext cx="0" cy="1976438"/>
-          </a:xfrm>
-          <a:prstGeom prst="line">
-            <a:avLst/>
-          </a:prstGeom>
-          <a:ln w="71437">
-            <a:solidFill>
-              <a:srgbClr val="1F6F78"/>
-            </a:solidFill>
-          </a:ln>
-          <a:effectLst/>
-        </p:spPr>
-        <p:style>
-          <a:lnRef idx="2">
-            <a:schemeClr val="accent1"/>
-          </a:lnRef>
-          <a:fillRef idx="0">
-            <a:schemeClr val="accent1"/>
-          </a:fillRef>
-          <a:effectRef idx="0">
-            <a:schemeClr val="accent1"/>
-          </a:effectRef>
-          <a:fontRef idx="minor">
-            <a:schemeClr val="tx1"/>
-          </a:fontRef>
-        </p:style>
-      </p:cxnSp>
-      <p:sp>
-        <p:nvSpPr>
-          <p:cNvPr id="33" name="e3d" descr="Editable line; source id e3d"/>
-          <p:cNvSpPr/>
-          <p:nvPr/>
-        </p:nvSpPr>
-        <p:spPr>
-          <a:xfrm>
-            <a:off x="11183937" y="5992812"/>
-            <a:ext cx="246062" cy="190500"/>
-          </a:xfrm>
-          <a:custGeom>
-            <a:avLst/>
-            <a:gdLst/>
-            <a:ahLst/>
-            <a:cxnLst/>
-            <a:rect l="l" t="t" r="r" b="b"/>
-            <a:pathLst>
-              <a:path w="31000" h="24000">
-                <a:moveTo>
-                  <a:pt x="31000" y="16500"/>
-                </a:moveTo>
-                <a:lnTo>
-                  <a:pt x="22000" y="16500"/>
-                </a:lnTo>
-                <a:lnTo>
-                  <a:pt x="22000" y="24000"/>
-                </a:lnTo>
-                <a:lnTo>
-                  <a:pt x="0" y="12000"/>
-                </a:lnTo>
-                <a:lnTo>
-                  <a:pt x="22000" y="0"/>
-                </a:lnTo>
-                <a:lnTo>
-                  <a:pt x="22000" y="7500"/>
-                </a:lnTo>
-                <a:lnTo>
-                  <a:pt x="31000" y="7500"/>
-                </a:lnTo>
-                <a:close/>
-              </a:path>
-            </a:pathLst>
-          </a:custGeom>
-          <a:solidFill>
-            <a:srgbClr val="1F6F78"/>
-          </a:solidFill>
-          <a:ln>
-            <a:noFill/>
-          </a:ln>
-          <a:effectLst/>
-        </p:spPr>
-        <p:style>
-          <a:lnRef idx="1">
-            <a:schemeClr val="accent1"/>
-          </a:lnRef>
-          <a:fillRef idx="3">
-            <a:schemeClr val="accent1"/>
-          </a:fillRef>
-          <a:effectRef idx="0">
-            <a:schemeClr val="accent1"/>
-          </a:effectRef>
-          <a:fontRef idx="minor">
-            <a:schemeClr val="lt1"/>
-          </a:fontRef>
-        </p:style>
-        <p:txBody>
-          <a:bodyPr rtlCol="0" anchor="ctr"/>
-          <a:lstStyle/>
-          <a:p>
-            <a:pPr algn="ctr"/>
-          </a:p>
-        </p:txBody>
-      </p:sp>
-      <p:cxnSp>
-        <p:nvCxnSpPr>
-          <p:cNvPr id="34" name="e4a" descr="Editable line; source id e4a"/>
-          <p:cNvCxnSpPr/>
-          <p:nvPr/>
-        </p:nvCxnSpPr>
-        <p:spPr>
-          <a:xfrm flipH="1">
-            <a:off x="8310562" y="6088062"/>
-            <a:ext cx="182562" cy="0"/>
-          </a:xfrm>
-          <a:prstGeom prst="line">
-            <a:avLst/>
-          </a:prstGeom>
-          <a:ln w="71437">
-            <a:solidFill>
-              <a:srgbClr val="1F6F78"/>
-            </a:solidFill>
-          </a:ln>
-          <a:effectLst/>
-        </p:spPr>
-        <p:style>
-          <a:lnRef idx="2">
-            <a:schemeClr val="accent1"/>
-          </a:lnRef>
-          <a:fillRef idx="0">
-            <a:schemeClr val="accent1"/>
-          </a:fillRef>
-          <a:effectRef idx="0">
-            <a:schemeClr val="accent1"/>
-          </a:effectRef>
-          <a:fontRef idx="minor">
-            <a:schemeClr val="tx1"/>
-          </a:fontRef>
-        </p:style>
-      </p:cxnSp>
-      <p:sp>
-        <p:nvSpPr>
-          <p:cNvPr id="35" name="e4b" descr="Editable line; source id e4b"/>
-          <p:cNvSpPr/>
-          <p:nvPr/>
-        </p:nvSpPr>
-        <p:spPr>
-          <a:xfrm>
-            <a:off x="7119937" y="6000750"/>
-            <a:ext cx="174625" cy="174625"/>
-          </a:xfrm>
-          <a:custGeom>
-            <a:avLst/>
-            <a:gdLst/>
-            <a:ahLst/>
-            <a:cxnLst/>
-            <a:rect l="l" t="t" r="r" b="b"/>
-            <a:pathLst>
-              <a:path w="22000" h="22000">
-                <a:moveTo>
-                  <a:pt x="22000" y="15500"/>
-                </a:moveTo>
-                <a:lnTo>
-                  <a:pt x="18000" y="15500"/>
-                </a:lnTo>
-                <a:lnTo>
-                  <a:pt x="18000" y="22000"/>
-                </a:lnTo>
-                <a:lnTo>
-                  <a:pt x="0" y="11000"/>
-                </a:lnTo>
-                <a:lnTo>
-                  <a:pt x="18000" y="0"/>
-                </a:lnTo>
-                <a:lnTo>
-                  <a:pt x="18000" y="6500"/>
-                </a:lnTo>
-                <a:lnTo>
-                  <a:pt x="22000" y="6500"/>
-                </a:lnTo>
-                <a:close/>
-              </a:path>
-            </a:pathLst>
-          </a:custGeom>
-          <a:solidFill>
-            <a:srgbClr val="1F6F78"/>
-          </a:solidFill>
-          <a:ln>
-            <a:noFill/>
-          </a:ln>
-          <a:effectLst/>
-        </p:spPr>
-        <p:style>
-          <a:lnRef idx="1">
-            <a:schemeClr val="accent1"/>
-          </a:lnRef>
-          <a:fillRef idx="3">
-            <a:schemeClr val="accent1"/>
-          </a:fillRef>
-          <a:effectRef idx="0">
-            <a:schemeClr val="accent1"/>
-          </a:effectRef>
-          <a:fontRef idx="minor">
-            <a:schemeClr val="lt1"/>
-          </a:fontRef>
-        </p:style>
-        <p:txBody>
-          <a:bodyPr rtlCol="0" anchor="ctr"/>
-          <a:lstStyle/>
-          <a:p>
-            <a:pPr algn="ctr"/>
-          </a:p>
-        </p:txBody>
-      </p:sp>
-      <p:sp>
-        <p:nvSpPr>
-          <p:cNvPr id="36" name="e4_p" descr="Editable shape; source id e4_p"/>
-          <p:cNvSpPr/>
-          <p:nvPr/>
-        </p:nvSpPr>
-        <p:spPr>
-          <a:xfrm>
-            <a:off x="7310437" y="5897562"/>
-            <a:ext cx="984249" cy="380999"/>
-          </a:xfrm>
-          <a:prstGeom prst="roundRect">
-            <a:avLst>
-              <a:gd name="adj" fmla="val 50000"/>
-            </a:avLst>
-          </a:prstGeom>
-          <a:solidFill>
-            <a:srgbClr val="FFFFFF"/>
-          </a:solidFill>
-          <a:ln w="19843">
-            <a:solidFill>
-              <a:srgbClr val="1F6F78"/>
-            </a:solidFill>
-          </a:ln>
-          <a:effectLst/>
-        </p:spPr>
-        <p:style>
-          <a:lnRef idx="1">
-            <a:schemeClr val="accent1"/>
-          </a:lnRef>
-          <a:fillRef idx="3">
-            <a:schemeClr val="accent1"/>
-          </a:fillRef>
-          <a:effectRef idx="0">
-            <a:schemeClr val="accent1"/>
-          </a:effectRef>
-          <a:fontRef idx="minor">
-            <a:schemeClr val="lt1"/>
-          </a:fontRef>
-        </p:style>
-        <p:txBody>
-          <a:bodyPr rtlCol="0" anchor="ctr"/>
-          <a:lstStyle/>
-          <a:p>
-            <a:pPr algn="ctr"/>
-          </a:p>
-        </p:txBody>
-      </p:sp>
-      <p:sp>
-        <p:nvSpPr>
-          <p:cNvPr id="37" name="e4_pt" descr="Editable text; source id e4_pt"/>
-          <p:cNvSpPr txBox="1"/>
-          <p:nvPr/>
-        </p:nvSpPr>
-        <p:spPr>
-          <a:xfrm>
-            <a:off x="7373937" y="5929312"/>
-            <a:ext cx="857249" cy="317499"/>
-          </a:xfrm>
-          <a:prstGeom prst="rect">
-            <a:avLst/>
-          </a:prstGeom>
-          <a:noFill/>
-          <a:effectLst/>
-        </p:spPr>
-        <p:txBody>
-          <a:bodyPr wrap="none" anchor="ctr" tIns="0" rIns="0" bIns="0" lIns="0" anchorCtr="0" vertOverflow="overflow">
-            <a:noAutofit/>
-          </a:bodyPr>
-          <a:lstStyle/>
-          <a:p>
-            <a:pPr algn="ctr" fontAlgn="base">
-              <a:lnSpc>
-                <a:spcPts val="2187"/>
-              </a:lnSpc>
-              <a:spcBef>
-                <a:spcPts val="0"/>
-              </a:spcBef>
-              <a:spcAft>
-                <a:spcPts val="0"/>
-              </a:spcAft>
-              <a:defRPr sz="1499" b="1" i="0" lang="zh-CN" dirty="0">
-                <a:solidFill>
-                  <a:srgbClr val="1F6F78"/>
-                </a:solidFill>
-                <a:latin typeface="Noto Sans CJK SC"/>
-                <a:ea typeface="Noto Sans CJK SC"/>
-                <a:cs typeface="Noto Sans CJK SC"/>
-              </a:defRPr>
-            </a:pPr>
-            <a:r>
-              <a:rPr sz="1499" b="1" i="0" lang="zh-CN" dirty="0">
-                <a:solidFill>
-                  <a:srgbClr val="1F6F78"/>
-                </a:solidFill>
-                <a:latin typeface="Noto Sans CJK SC"/>
-                <a:ea typeface="Noto Sans CJK SC"/>
-                <a:cs typeface="Noto Sans CJK SC"/>
-              </a:rPr>
-              <a:t>比较边界</a:t>
-            </a:r>
-          </a:p>
-        </p:txBody>
-      </p:sp>
-      <p:cxnSp>
-        <p:nvCxnSpPr>
-          <p:cNvPr id="38" name="e5a" descr="Editable line; source id e5a"/>
-          <p:cNvCxnSpPr/>
-          <p:nvPr/>
-        </p:nvCxnSpPr>
-        <p:spPr>
-          <a:xfrm flipH="1">
-            <a:off x="4143374" y="6088062"/>
-            <a:ext cx="190500" cy="0"/>
-          </a:xfrm>
-          <a:prstGeom prst="line">
-            <a:avLst/>
-          </a:prstGeom>
-          <a:ln w="71437">
-            <a:solidFill>
-              <a:srgbClr val="1F6F78"/>
-            </a:solidFill>
-          </a:ln>
-          <a:effectLst/>
-        </p:spPr>
-        <p:style>
-          <a:lnRef idx="2">
-            <a:schemeClr val="accent1"/>
-          </a:lnRef>
-          <a:fillRef idx="0">
-            <a:schemeClr val="accent1"/>
-          </a:fillRef>
-          <a:effectRef idx="0">
-            <a:schemeClr val="accent1"/>
-          </a:effectRef>
-          <a:fontRef idx="minor">
-            <a:schemeClr val="tx1"/>
-          </a:fontRef>
-        </p:style>
-      </p:cxnSp>
-      <p:sp>
-        <p:nvSpPr>
-          <p:cNvPr id="39" name="e5b" descr="Editable line; source id e5b"/>
-          <p:cNvSpPr/>
-          <p:nvPr/>
-        </p:nvSpPr>
-        <p:spPr>
-          <a:xfrm>
-            <a:off x="2944812" y="6000750"/>
-            <a:ext cx="182562" cy="174625"/>
-          </a:xfrm>
-          <a:custGeom>
-            <a:avLst/>
-            <a:gdLst/>
-            <a:ahLst/>
-            <a:cxnLst/>
-            <a:rect l="l" t="t" r="r" b="b"/>
-            <a:pathLst>
-              <a:path w="23000" h="22000">
-                <a:moveTo>
-                  <a:pt x="23000" y="15500"/>
-                </a:moveTo>
-                <a:lnTo>
-                  <a:pt x="18000" y="15500"/>
-                </a:lnTo>
-                <a:lnTo>
-                  <a:pt x="18000" y="22000"/>
-                </a:lnTo>
-                <a:lnTo>
-                  <a:pt x="0" y="11000"/>
-                </a:lnTo>
-                <a:lnTo>
-                  <a:pt x="18000" y="0"/>
-                </a:lnTo>
-                <a:lnTo>
-                  <a:pt x="18000" y="6500"/>
-                </a:lnTo>
-                <a:lnTo>
-                  <a:pt x="23000" y="6500"/>
-                </a:lnTo>
-                <a:close/>
-              </a:path>
-            </a:pathLst>
-          </a:custGeom>
-          <a:solidFill>
-            <a:srgbClr val="1F6F78"/>
-          </a:solidFill>
-          <a:ln>
-            <a:noFill/>
-          </a:ln>
-          <a:effectLst/>
-        </p:spPr>
-        <p:style>
-          <a:lnRef idx="1">
-            <a:schemeClr val="accent1"/>
-          </a:lnRef>
-          <a:fillRef idx="3">
-            <a:schemeClr val="accent1"/>
-          </a:fillRef>
-          <a:effectRef idx="0">
-            <a:schemeClr val="accent1"/>
-          </a:effectRef>
-          <a:fontRef idx="minor">
-            <a:schemeClr val="lt1"/>
-          </a:fontRef>
-        </p:style>
-        <p:txBody>
-          <a:bodyPr rtlCol="0" anchor="ctr"/>
-          <a:lstStyle/>
-          <a:p>
-            <a:pPr algn="ctr"/>
-          </a:p>
-        </p:txBody>
-      </p:sp>
-      <p:sp>
-        <p:nvSpPr>
-          <p:cNvPr id="40" name="e5_p" descr="Editable shape; source id e5_p"/>
-          <p:cNvSpPr/>
-          <p:nvPr/>
-        </p:nvSpPr>
-        <p:spPr>
-          <a:xfrm>
-            <a:off x="3143249" y="5897562"/>
-            <a:ext cx="984249" cy="380999"/>
-          </a:xfrm>
-          <a:prstGeom prst="roundRect">
-            <a:avLst>
-              <a:gd name="adj" fmla="val 50000"/>
-            </a:avLst>
-          </a:prstGeom>
-          <a:solidFill>
-            <a:srgbClr val="FFFFFF"/>
-          </a:solidFill>
-          <a:ln w="19843">
-            <a:solidFill>
-              <a:srgbClr val="1F6F78"/>
-            </a:solidFill>
-          </a:ln>
-          <a:effectLst/>
-        </p:spPr>
-        <p:style>
-          <a:lnRef idx="1">
-            <a:schemeClr val="accent1"/>
-          </a:lnRef>
-          <a:fillRef idx="3">
-            <a:schemeClr val="accent1"/>
-          </a:fillRef>
-          <a:effectRef idx="0">
-            <a:schemeClr val="accent1"/>
-          </a:effectRef>
-          <a:fontRef idx="minor">
-            <a:schemeClr val="lt1"/>
-          </a:fontRef>
-        </p:style>
-        <p:txBody>
-          <a:bodyPr rtlCol="0" anchor="ctr"/>
-          <a:lstStyle/>
-          <a:p>
-            <a:pPr algn="ctr"/>
-          </a:p>
-        </p:txBody>
-      </p:sp>
-      <p:sp>
-        <p:nvSpPr>
-          <p:cNvPr id="41" name="e5_pt" descr="Editable text; source id e5_pt"/>
-          <p:cNvSpPr txBox="1"/>
-          <p:nvPr/>
-        </p:nvSpPr>
-        <p:spPr>
-          <a:xfrm>
-            <a:off x="3206749" y="5929312"/>
-            <a:ext cx="857249" cy="317499"/>
-          </a:xfrm>
-          <a:prstGeom prst="rect">
-            <a:avLst/>
-          </a:prstGeom>
-          <a:noFill/>
-          <a:effectLst/>
-        </p:spPr>
-        <p:txBody>
-          <a:bodyPr wrap="none" anchor="ctr" tIns="0" rIns="0" bIns="0" lIns="0" anchorCtr="0" vertOverflow="overflow">
-            <a:noAutofit/>
-          </a:bodyPr>
-          <a:lstStyle/>
-          <a:p>
-            <a:pPr algn="ctr" fontAlgn="base">
-              <a:lnSpc>
-                <a:spcPts val="2187"/>
-              </a:lnSpc>
-              <a:spcBef>
-                <a:spcPts val="0"/>
-              </a:spcBef>
-              <a:spcAft>
-                <a:spcPts val="0"/>
-              </a:spcAft>
-              <a:defRPr sz="1499" b="1" i="0" lang="zh-CN" dirty="0">
-                <a:solidFill>
-                  <a:srgbClr val="1F6F78"/>
-                </a:solidFill>
-                <a:latin typeface="Noto Sans CJK SC"/>
-                <a:ea typeface="Noto Sans CJK SC"/>
-                <a:cs typeface="Noto Sans CJK SC"/>
-              </a:defRPr>
-            </a:pPr>
-            <a:r>
-              <a:rPr sz="1499" b="1" i="0" lang="zh-CN" dirty="0">
-                <a:solidFill>
-                  <a:srgbClr val="1F6F78"/>
-                </a:solidFill>
-                <a:latin typeface="Noto Sans CJK SC"/>
-                <a:ea typeface="Noto Sans CJK SC"/>
-                <a:cs typeface="Noto Sans CJK SC"/>
-              </a:rPr>
-              <a:t>缺口驱动</a:t>
-            </a:r>
-          </a:p>
-        </p:txBody>
-      </p:sp>
     </p:spTree>
   </p:cSld>
   <p:clrMapOvr>

</xml_diff>

<commit_message>
dashboard: 2026-09-13 18:41 刷新
</commit_message>
<xml_diff>
--- a/media/figstudio/bzso_roadmap/roadmap_bazn2si2o7_editable.pptx
+++ b/media/figstudio/bzso_roadmap/roadmap_bazn2si2o7_editable.pptx
@@ -7,7 +7,7 @@
   <p:sldIdLst>
     <p:sldId id="256" r:id="rId7"/>
   </p:sldIdLst>
-  <p:sldSz cx="12191999" cy="4063999" type="screen4x3"/>
+  <p:sldSz cx="12191999" cy="4536420" type="screen4x3"/>
   <p:notesSz cx="6858000" cy="9144000"/>
   <p:defaultTextStyle>
     <a:defPPr>
@@ -502,7 +502,7 @@
           <a:lstStyle/>
           <a:p>
             <a:r>
-              <a:t>BaZn2Si2O7 综述路线图（super_teaser 第二轮 F03 → super_img2ppt 重建）</a:t>
+              <a:t>BaZn2Si2O7 综述路线图（super_teaser 第三轮 R01 → super_img2ppt 重建）</a:t>
             </a:r>
           </a:p>
         </p:txBody>
@@ -3518,26 +3518,26 @@
       <p:grpSpPr/>
       <p:sp>
         <p:nvSpPr>
-          <p:cNvPr id="2" name="n1" descr="Editable shape; source id n1"/>
+          <p:cNvPr id="2" name="zA" descr="Editable shape; source id zA"/>
           <p:cNvSpPr/>
           <p:nvPr/>
         </p:nvSpPr>
         <p:spPr>
           <a:xfrm>
-            <a:off x="230143" y="875668"/>
-            <a:ext cx="1358408" cy="2194784"/>
+            <a:off x="237198" y="664155"/>
+            <a:ext cx="5811361" cy="3231828"/>
           </a:xfrm>
           <a:prstGeom prst="roundRect">
             <a:avLst>
-              <a:gd name="adj" fmla="val 5785"/>
+              <a:gd name="adj" fmla="val 2935"/>
             </a:avLst>
           </a:prstGeom>
           <a:solidFill>
-            <a:srgbClr val="FFFFFF"/>
+            <a:srgbClr val="EEF2F7"/>
           </a:solidFill>
-          <a:ln w="14033">
+          <a:ln w="8894">
             <a:solidFill>
-              <a:srgbClr val="4A5158"/>
+              <a:srgbClr val="5B7592"/>
             </a:solidFill>
           </a:ln>
           <a:effectLst/>
@@ -3566,14 +3566,14 @@
       </p:sp>
       <p:sp>
         <p:nvSpPr>
-          <p:cNvPr id="3" name="n1_n" descr="Editable text; source id n1_n"/>
+          <p:cNvPr id="3" name="zA_l" descr="Editable text; source id zA_l"/>
           <p:cNvSpPr txBox="1"/>
           <p:nvPr/>
         </p:nvSpPr>
         <p:spPr>
           <a:xfrm>
-            <a:off x="319955" y="943027"/>
-            <a:ext cx="392928" cy="190850"/>
+            <a:off x="343937" y="735315"/>
+            <a:ext cx="592996" cy="195688"/>
           </a:xfrm>
           <a:prstGeom prst="rect">
             <a:avLst/>
@@ -3589,7 +3589,7 @@
           <a:p>
             <a:pPr algn="l" fontAlgn="base">
               <a:lnSpc>
-                <a:spcPts val="1138"/>
+                <a:spcPts val="1505"/>
               </a:lnSpc>
               <a:spcBef>
                 <a:spcPts val="0"/>
@@ -3597,39 +3597,87 @@
               <a:spcAft>
                 <a:spcPts val="0"/>
               </a:spcAft>
-              <a:defRPr sz="972" b="1" i="0" lang="zh-CN" dirty="0">
-                <a:solidFill>
-                  <a:srgbClr val="8A9199"/>
-                </a:solidFill>
-                <a:latin typeface="DejaVu Sans"/>
-                <a:ea typeface="DejaVu Sans"/>
-                <a:cs typeface="DejaVu Sans"/>
+              <a:defRPr sz="1027" b="1" i="0" lang="zh-CN" dirty="0">
+                <a:solidFill>
+                  <a:srgbClr val="2B3E57"/>
+                </a:solidFill>
+                <a:latin typeface="Noto Sans CJK SC"/>
+                <a:ea typeface="Noto Sans CJK SC"/>
+                <a:cs typeface="Noto Sans CJK SC"/>
               </a:defRPr>
             </a:pPr>
             <a:r>
-              <a:rPr sz="972" b="1" i="0" lang="zh-CN" dirty="0">
-                <a:solidFill>
-                  <a:srgbClr val="8A9199"/>
-                </a:solidFill>
-                <a:latin typeface="DejaVu Sans"/>
-                <a:ea typeface="DejaVu Sans"/>
-                <a:cs typeface="DejaVu Sans"/>
+              <a:rPr sz="1027" b="1" i="0" lang="zh-CN" dirty="0">
+                <a:solidFill>
+                  <a:srgbClr val="2B3E57"/>
+                </a:solidFill>
+                <a:latin typeface="Noto Sans CJK SC"/>
+                <a:ea typeface="Noto Sans CJK SC"/>
+                <a:cs typeface="Noto Sans CJK SC"/>
               </a:rPr>
-              <a:t>01</a:t>
-            </a:r>
-          </a:p>
-        </p:txBody>
-      </p:sp>
-      <p:sp>
-        <p:nvSpPr>
-          <p:cNvPr id="4" name="n1_t" descr="Editable text; source id n1_t"/>
+              <a:t>文献证据</a:t>
+            </a:r>
+          </a:p>
+        </p:txBody>
+      </p:sp>
+      <p:sp>
+        <p:nvSpPr>
+          <p:cNvPr id="4" name="zB" descr="Editable shape; source id zB"/>
+          <p:cNvSpPr/>
+          <p:nvPr/>
+        </p:nvSpPr>
+        <p:spPr>
+          <a:xfrm>
+            <a:off x="6190879" y="664155"/>
+            <a:ext cx="5811361" cy="3231828"/>
+          </a:xfrm>
+          <a:prstGeom prst="roundRect">
+            <a:avLst>
+              <a:gd name="adj" fmla="val 2935"/>
+            </a:avLst>
+          </a:prstGeom>
+          <a:solidFill>
+            <a:srgbClr val="E6F2F3"/>
+          </a:solidFill>
+          <a:ln w="8894">
+            <a:solidFill>
+              <a:srgbClr val="1F7F8C"/>
+            </a:solidFill>
+          </a:ln>
+          <a:effectLst/>
+        </p:spPr>
+        <p:style>
+          <a:lnRef idx="1">
+            <a:schemeClr val="accent1"/>
+          </a:lnRef>
+          <a:fillRef idx="3">
+            <a:schemeClr val="accent1"/>
+          </a:fillRef>
+          <a:effectRef idx="0">
+            <a:schemeClr val="accent1"/>
+          </a:effectRef>
+          <a:fontRef idx="minor">
+            <a:schemeClr val="lt1"/>
+          </a:fontRef>
+        </p:style>
+        <p:txBody>
+          <a:bodyPr rtlCol="0" anchor="ctr"/>
+          <a:lstStyle/>
+          <a:p>
+            <a:pPr algn="ctr"/>
+          </a:p>
+        </p:txBody>
+      </p:sp>
+      <p:sp>
+        <p:nvSpPr>
+          <p:cNvPr id="5" name="zB_l" descr="Editable text; source id zB_l"/>
           <p:cNvSpPr txBox="1"/>
           <p:nvPr/>
         </p:nvSpPr>
         <p:spPr>
           <a:xfrm>
-            <a:off x="286276" y="1279823"/>
-            <a:ext cx="1246143" cy="336795"/>
+            <a:off x="6297618" y="735315"/>
+            <a:ext cx="592996" cy="195688"/>
           </a:xfrm>
           <a:prstGeom prst="rect">
             <a:avLst/>
@@ -3643,9 +3691,9 @@
           </a:bodyPr>
           <a:lstStyle/>
           <a:p>
-            <a:pPr algn="ctr" fontAlgn="base">
+            <a:pPr algn="l" fontAlgn="base">
               <a:lnSpc>
-                <a:spcPts val="2574"/>
+                <a:spcPts val="1505"/>
               </a:lnSpc>
               <a:spcBef>
                 <a:spcPts val="0"/>
@@ -3653,9 +3701,9 @@
               <a:spcAft>
                 <a:spcPts val="0"/>
               </a:spcAft>
-              <a:defRPr sz="1767" b="1" i="0" lang="zh-CN" dirty="0">
-                <a:solidFill>
-                  <a:srgbClr val="1F2326"/>
+              <a:defRPr sz="1027" b="1" i="0" lang="zh-CN" dirty="0">
+                <a:solidFill>
+                  <a:srgbClr val="0F4F58"/>
                 </a:solidFill>
                 <a:latin typeface="Noto Sans CJK SC"/>
                 <a:ea typeface="Noto Sans CJK SC"/>
@@ -3663,29 +3711,123 @@
               </a:defRPr>
             </a:pPr>
             <a:r>
-              <a:rPr sz="1767" b="1" i="0" lang="zh-CN" dirty="0">
-                <a:solidFill>
-                  <a:srgbClr val="1F2326"/>
+              <a:rPr sz="1027" b="1" i="0" lang="zh-CN" dirty="0">
+                <a:solidFill>
+                  <a:srgbClr val="0F4F58"/>
                 </a:solidFill>
                 <a:latin typeface="Noto Sans CJK SC"/>
                 <a:ea typeface="Noto Sans CJK SC"/>
                 <a:cs typeface="Noto Sans CJK SC"/>
               </a:rPr>
-              <a:t>结构基础</a:t>
-            </a:r>
-          </a:p>
-        </p:txBody>
-      </p:sp>
-      <p:sp>
-        <p:nvSpPr>
-          <p:cNvPr id="5" name="n1_s" descr="Editable text; source id n1_s"/>
+              <a:t>实验方法</a:t>
+            </a:r>
+          </a:p>
+        </p:txBody>
+      </p:sp>
+      <p:sp>
+        <p:nvSpPr>
+          <p:cNvPr id="6" name="n1" descr="Editable shape; source id n1"/>
+          <p:cNvSpPr/>
+          <p:nvPr/>
+        </p:nvSpPr>
+        <p:spPr>
+          <a:xfrm>
+            <a:off x="415097" y="1126692"/>
+            <a:ext cx="1269011" cy="2490583"/>
+          </a:xfrm>
+          <a:prstGeom prst="roundRect">
+            <a:avLst>
+              <a:gd name="adj" fmla="val 4672"/>
+            </a:avLst>
+          </a:prstGeom>
+          <a:solidFill>
+            <a:srgbClr val="FFFFFF"/>
+          </a:solidFill>
+          <a:ln w="8894">
+            <a:solidFill>
+              <a:srgbClr val="5B7592"/>
+            </a:solidFill>
+          </a:ln>
+          <a:effectLst/>
+        </p:spPr>
+        <p:style>
+          <a:lnRef idx="1">
+            <a:schemeClr val="accent1"/>
+          </a:lnRef>
+          <a:fillRef idx="3">
+            <a:schemeClr val="accent1"/>
+          </a:fillRef>
+          <a:effectRef idx="0">
+            <a:schemeClr val="accent1"/>
+          </a:effectRef>
+          <a:fontRef idx="minor">
+            <a:schemeClr val="lt1"/>
+          </a:fontRef>
+        </p:style>
+        <p:txBody>
+          <a:bodyPr rtlCol="0" anchor="ctr"/>
+          <a:lstStyle/>
+          <a:p>
+            <a:pPr algn="ctr"/>
+          </a:p>
+        </p:txBody>
+      </p:sp>
+      <p:sp>
+        <p:nvSpPr>
+          <p:cNvPr id="7" name="n1_s" descr="Editable shape; source id n1_s"/>
+          <p:cNvSpPr/>
+          <p:nvPr/>
+        </p:nvSpPr>
+        <p:spPr>
+          <a:xfrm>
+            <a:off x="415097" y="1126692"/>
+            <a:ext cx="1269011" cy="47439"/>
+          </a:xfrm>
+          <a:prstGeom prst="roundRect">
+            <a:avLst>
+              <a:gd name="adj" fmla="val 50000"/>
+            </a:avLst>
+          </a:prstGeom>
+          <a:solidFill>
+            <a:srgbClr val="5B7592"/>
+          </a:solidFill>
+          <a:ln>
+            <a:noFill/>
+          </a:ln>
+          <a:effectLst/>
+        </p:spPr>
+        <p:style>
+          <a:lnRef idx="1">
+            <a:schemeClr val="accent1"/>
+          </a:lnRef>
+          <a:fillRef idx="3">
+            <a:schemeClr val="accent1"/>
+          </a:fillRef>
+          <a:effectRef idx="0">
+            <a:schemeClr val="accent1"/>
+          </a:effectRef>
+          <a:fontRef idx="minor">
+            <a:schemeClr val="lt1"/>
+          </a:fontRef>
+        </p:style>
+        <p:txBody>
+          <a:bodyPr rtlCol="0" anchor="ctr"/>
+          <a:lstStyle/>
+          <a:p>
+            <a:pPr algn="ctr"/>
+          </a:p>
+        </p:txBody>
+      </p:sp>
+      <p:sp>
+        <p:nvSpPr>
+          <p:cNvPr id="8" name="n1_t" descr="Editable text; source id n1_t"/>
           <p:cNvSpPr txBox="1"/>
           <p:nvPr/>
         </p:nvSpPr>
         <p:spPr>
           <a:xfrm>
-            <a:off x="275049" y="1661524"/>
-            <a:ext cx="1268596" cy="224530"/>
+            <a:off x="498116" y="1482490"/>
+            <a:ext cx="1102972" cy="219408"/>
           </a:xfrm>
           <a:prstGeom prst="rect">
             <a:avLst/>
@@ -3699,9 +3841,9 @@
           </a:bodyPr>
           <a:lstStyle/>
           <a:p>
-            <a:pPr algn="ctr" fontAlgn="base">
+            <a:pPr algn="l" fontAlgn="base">
               <a:lnSpc>
-                <a:spcPts val="1546"/>
+                <a:spcPts val="1692"/>
               </a:lnSpc>
               <a:spcBef>
                 <a:spcPts val="0"/>
@@ -3709,9 +3851,9 @@
               <a:spcAft>
                 <a:spcPts val="0"/>
               </a:spcAft>
-              <a:defRPr sz="1063" b="0" i="0" lang="zh-CN" dirty="0">
-                <a:solidFill>
-                  <a:srgbClr val="3A4046"/>
+              <a:defRPr sz="1167" b="1" i="0" lang="zh-CN" dirty="0">
+                <a:solidFill>
+                  <a:srgbClr val="2B3E57"/>
                 </a:solidFill>
                 <a:latin typeface="Noto Sans CJK SC"/>
                 <a:ea typeface="Noto Sans CJK SC"/>
@@ -3719,9 +3861,65 @@
               </a:defRPr>
             </a:pPr>
             <a:r>
-              <a:rPr sz="1063" b="0" i="0" lang="zh-CN" dirty="0">
-                <a:solidFill>
-                  <a:srgbClr val="3A4046"/>
+              <a:rPr sz="1167" b="1" i="0" lang="zh-CN" dirty="0">
+                <a:solidFill>
+                  <a:srgbClr val="2B3E57"/>
+                </a:solidFill>
+                <a:latin typeface="Noto Sans CJK SC"/>
+                <a:ea typeface="Noto Sans CJK SC"/>
+                <a:cs typeface="Noto Sans CJK SC"/>
+              </a:rPr>
+              <a:t>结构基础</a:t>
+            </a:r>
+          </a:p>
+        </p:txBody>
+      </p:sp>
+      <p:sp>
+        <p:nvSpPr>
+          <p:cNvPr id="9" name="n1_k0" descr="Editable text; source id n1_k0"/>
+          <p:cNvSpPr txBox="1"/>
+          <p:nvPr/>
+        </p:nvSpPr>
+        <p:spPr>
+          <a:xfrm>
+            <a:off x="498116" y="1749338"/>
+            <a:ext cx="1102972" cy="171968"/>
+          </a:xfrm>
+          <a:prstGeom prst="rect">
+            <a:avLst/>
+          </a:prstGeom>
+          <a:noFill/>
+          <a:effectLst/>
+        </p:spPr>
+        <p:txBody>
+          <a:bodyPr wrap="none" anchor="ctr" tIns="0" rIns="0" bIns="0" lIns="0" anchorCtr="0" vertOverflow="overflow">
+            <a:noAutofit/>
+          </a:bodyPr>
+          <a:lstStyle/>
+          <a:p>
+            <a:pPr algn="l" fontAlgn="base">
+              <a:lnSpc>
+                <a:spcPts val="1214"/>
+              </a:lnSpc>
+              <a:spcBef>
+                <a:spcPts val="0"/>
+              </a:spcBef>
+              <a:spcAft>
+                <a:spcPts val="0"/>
+              </a:spcAft>
+              <a:defRPr sz="828" b="0" i="0" lang="zh-CN" dirty="0">
+                <a:solidFill>
+                  <a:srgbClr val="3F4854"/>
+                </a:solidFill>
+                <a:latin typeface="Noto Sans CJK SC"/>
+                <a:ea typeface="Noto Sans CJK SC"/>
+                <a:cs typeface="Noto Sans CJK SC"/>
+              </a:defRPr>
+            </a:pPr>
+            <a:r>
+              <a:rPr sz="828" b="0" i="0" lang="zh-CN" dirty="0">
+                <a:solidFill>
+                  <a:srgbClr val="3F4854"/>
                 </a:solidFill>
                 <a:latin typeface="Noto Sans CJK SC"/>
                 <a:ea typeface="Noto Sans CJK SC"/>
@@ -3732,9 +3930,65 @@
           </a:p>
         </p:txBody>
       </p:sp>
+      <p:sp>
+        <p:nvSpPr>
+          <p:cNvPr id="10" name="n1_n" descr="Editable text; source id n1_n"/>
+          <p:cNvSpPr txBox="1"/>
+          <p:nvPr/>
+        </p:nvSpPr>
+        <p:spPr>
+          <a:xfrm>
+            <a:off x="509976" y="1233431"/>
+            <a:ext cx="332077" cy="166038"/>
+          </a:xfrm>
+          <a:prstGeom prst="rect">
+            <a:avLst/>
+          </a:prstGeom>
+          <a:noFill/>
+          <a:effectLst/>
+        </p:spPr>
+        <p:txBody>
+          <a:bodyPr wrap="none" anchor="ctr" tIns="0" rIns="0" bIns="0" lIns="0" anchorCtr="0" vertOverflow="overflow">
+            <a:noAutofit/>
+          </a:bodyPr>
+          <a:lstStyle/>
+          <a:p>
+            <a:pPr algn="l" fontAlgn="base">
+              <a:lnSpc>
+                <a:spcPts val="1038"/>
+              </a:lnSpc>
+              <a:spcBef>
+                <a:spcPts val="0"/>
+              </a:spcBef>
+              <a:spcAft>
+                <a:spcPts val="0"/>
+              </a:spcAft>
+              <a:defRPr sz="887" b="1" i="0" lang="zh-CN" dirty="0">
+                <a:solidFill>
+                  <a:srgbClr val="8A9199"/>
+                </a:solidFill>
+                <a:latin typeface="DejaVu Sans"/>
+                <a:ea typeface="DejaVu Sans"/>
+                <a:cs typeface="DejaVu Sans"/>
+              </a:defRPr>
+            </a:pPr>
+            <a:r>
+              <a:rPr sz="887" b="1" i="0" lang="zh-CN" dirty="0">
+                <a:solidFill>
+                  <a:srgbClr val="8A9199"/>
+                </a:solidFill>
+                <a:latin typeface="DejaVu Sans"/>
+                <a:ea typeface="DejaVu Sans"/>
+                <a:cs typeface="DejaVu Sans"/>
+              </a:rPr>
+              <a:t>01</a:t>
+            </a:r>
+          </a:p>
+        </p:txBody>
+      </p:sp>
       <p:pic>
         <p:nvPicPr>
-          <p:cNvPr id="6" name="n1_i" descr="exact crop of source page_001 (monochrome line motif)"/>
+          <p:cNvPr id="11" name="n1_ic" descr="exact crop of the generated raster (line motif)"/>
           <p:cNvPicPr>
             <a:picLocks noChangeAspect="1"/>
           </p:cNvPicPr>
@@ -3748,8 +4002,8 @@
         </p:blipFill>
         <p:spPr>
           <a:xfrm>
-            <a:off x="336795" y="2104972"/>
-            <a:ext cx="1178784" cy="813922"/>
+            <a:off x="699735" y="2729092"/>
+            <a:ext cx="699735" cy="412475"/>
           </a:xfrm>
           <a:prstGeom prst="rect">
             <a:avLst/>
@@ -3759,26 +4013,26 @@
       </p:pic>
       <p:sp>
         <p:nvSpPr>
-          <p:cNvPr id="7" name="n2" descr="Editable shape; source id n2"/>
+          <p:cNvPr id="12" name="n2" descr="Editable shape; source id n2"/>
           <p:cNvSpPr/>
           <p:nvPr/>
         </p:nvSpPr>
         <p:spPr>
           <a:xfrm>
-            <a:off x="2234077" y="875668"/>
-            <a:ext cx="1414541" cy="2194784"/>
+            <a:off x="2508373" y="1126692"/>
+            <a:ext cx="1269011" cy="2490583"/>
           </a:xfrm>
           <a:prstGeom prst="roundRect">
             <a:avLst>
-              <a:gd name="adj" fmla="val 5555"/>
+              <a:gd name="adj" fmla="val 4672"/>
             </a:avLst>
           </a:prstGeom>
           <a:solidFill>
             <a:srgbClr val="FFFFFF"/>
           </a:solidFill>
-          <a:ln w="14033">
+          <a:ln w="8894">
             <a:solidFill>
-              <a:srgbClr val="4A5158"/>
+              <a:srgbClr val="5B7592"/>
             </a:solidFill>
           </a:ln>
           <a:effectLst/>
@@ -3807,14 +4061,60 @@
       </p:sp>
       <p:sp>
         <p:nvSpPr>
-          <p:cNvPr id="8" name="n2_n" descr="Editable text; source id n2_n"/>
+          <p:cNvPr id="13" name="n2_s" descr="Editable shape; source id n2_s"/>
+          <p:cNvSpPr/>
+          <p:nvPr/>
+        </p:nvSpPr>
+        <p:spPr>
+          <a:xfrm>
+            <a:off x="2508373" y="1126692"/>
+            <a:ext cx="1269011" cy="47439"/>
+          </a:xfrm>
+          <a:prstGeom prst="roundRect">
+            <a:avLst>
+              <a:gd name="adj" fmla="val 50000"/>
+            </a:avLst>
+          </a:prstGeom>
+          <a:solidFill>
+            <a:srgbClr val="5B7592"/>
+          </a:solidFill>
+          <a:ln>
+            <a:noFill/>
+          </a:ln>
+          <a:effectLst/>
+        </p:spPr>
+        <p:style>
+          <a:lnRef idx="1">
+            <a:schemeClr val="accent1"/>
+          </a:lnRef>
+          <a:fillRef idx="3">
+            <a:schemeClr val="accent1"/>
+          </a:fillRef>
+          <a:effectRef idx="0">
+            <a:schemeClr val="accent1"/>
+          </a:effectRef>
+          <a:fontRef idx="minor">
+            <a:schemeClr val="lt1"/>
+          </a:fontRef>
+        </p:style>
+        <p:txBody>
+          <a:bodyPr rtlCol="0" anchor="ctr"/>
+          <a:lstStyle/>
+          <a:p>
+            <a:pPr algn="ctr"/>
+          </a:p>
+        </p:txBody>
+      </p:sp>
+      <p:sp>
+        <p:nvSpPr>
+          <p:cNvPr id="14" name="n2_t" descr="Editable text; source id n2_t"/>
           <p:cNvSpPr txBox="1"/>
           <p:nvPr/>
         </p:nvSpPr>
         <p:spPr>
           <a:xfrm>
-            <a:off x="2323889" y="943027"/>
-            <a:ext cx="392928" cy="190850"/>
+            <a:off x="2591392" y="1482490"/>
+            <a:ext cx="1102972" cy="219408"/>
           </a:xfrm>
           <a:prstGeom prst="rect">
             <a:avLst/>
@@ -3830,7 +4130,7 @@
           <a:p>
             <a:pPr algn="l" fontAlgn="base">
               <a:lnSpc>
-                <a:spcPts val="1138"/>
+                <a:spcPts val="1692"/>
               </a:lnSpc>
               <a:spcBef>
                 <a:spcPts val="0"/>
@@ -3838,39 +4138,39 @@
               <a:spcAft>
                 <a:spcPts val="0"/>
               </a:spcAft>
-              <a:defRPr sz="972" b="1" i="0" lang="zh-CN" dirty="0">
-                <a:solidFill>
-                  <a:srgbClr val="8A9199"/>
-                </a:solidFill>
-                <a:latin typeface="DejaVu Sans"/>
-                <a:ea typeface="DejaVu Sans"/>
-                <a:cs typeface="DejaVu Sans"/>
+              <a:defRPr sz="1167" b="1" i="0" lang="zh-CN" dirty="0">
+                <a:solidFill>
+                  <a:srgbClr val="2B3E57"/>
+                </a:solidFill>
+                <a:latin typeface="Noto Sans CJK SC"/>
+                <a:ea typeface="Noto Sans CJK SC"/>
+                <a:cs typeface="Noto Sans CJK SC"/>
               </a:defRPr>
             </a:pPr>
             <a:r>
-              <a:rPr sz="972" b="1" i="0" lang="zh-CN" dirty="0">
-                <a:solidFill>
-                  <a:srgbClr val="8A9199"/>
-                </a:solidFill>
-                <a:latin typeface="DejaVu Sans"/>
-                <a:ea typeface="DejaVu Sans"/>
-                <a:cs typeface="DejaVu Sans"/>
+              <a:rPr sz="1167" b="1" i="0" lang="zh-CN" dirty="0">
+                <a:solidFill>
+                  <a:srgbClr val="2B3E57"/>
+                </a:solidFill>
+                <a:latin typeface="Noto Sans CJK SC"/>
+                <a:ea typeface="Noto Sans CJK SC"/>
+                <a:cs typeface="Noto Sans CJK SC"/>
               </a:rPr>
-              <a:t>02</a:t>
-            </a:r>
-          </a:p>
-        </p:txBody>
-      </p:sp>
-      <p:sp>
-        <p:nvSpPr>
-          <p:cNvPr id="9" name="n2_t" descr="Editable text; source id n2_t"/>
+              <a:t>合成路线</a:t>
+            </a:r>
+          </a:p>
+        </p:txBody>
+      </p:sp>
+      <p:sp>
+        <p:nvSpPr>
+          <p:cNvPr id="15" name="n2_k0" descr="Editable text; source id n2_k0"/>
           <p:cNvSpPr txBox="1"/>
           <p:nvPr/>
         </p:nvSpPr>
         <p:spPr>
           <a:xfrm>
-            <a:off x="2290209" y="1279823"/>
-            <a:ext cx="1302276" cy="336795"/>
+            <a:off x="2591392" y="1749338"/>
+            <a:ext cx="1102972" cy="171968"/>
           </a:xfrm>
           <a:prstGeom prst="rect">
             <a:avLst/>
@@ -3884,9 +4184,9 @@
           </a:bodyPr>
           <a:lstStyle/>
           <a:p>
-            <a:pPr algn="ctr" fontAlgn="base">
+            <a:pPr algn="l" fontAlgn="base">
               <a:lnSpc>
-                <a:spcPts val="2574"/>
+                <a:spcPts val="1214"/>
               </a:lnSpc>
               <a:spcBef>
                 <a:spcPts val="0"/>
@@ -3894,9 +4194,9 @@
               <a:spcAft>
                 <a:spcPts val="0"/>
               </a:spcAft>
-              <a:defRPr sz="1767" b="1" i="0" lang="zh-CN" dirty="0">
-                <a:solidFill>
-                  <a:srgbClr val="1F2326"/>
+              <a:defRPr sz="828" b="0" i="0" lang="zh-CN" dirty="0">
+                <a:solidFill>
+                  <a:srgbClr val="3F4854"/>
                 </a:solidFill>
                 <a:latin typeface="Noto Sans CJK SC"/>
                 <a:ea typeface="Noto Sans CJK SC"/>
@@ -3904,29 +4204,73 @@
               </a:defRPr>
             </a:pPr>
             <a:r>
-              <a:rPr sz="1767" b="1" i="0" lang="zh-CN" dirty="0">
-                <a:solidFill>
-                  <a:srgbClr val="1F2326"/>
+              <a:rPr sz="828" b="0" i="0" lang="zh-CN" dirty="0">
+                <a:solidFill>
+                  <a:srgbClr val="3F4854"/>
                 </a:solidFill>
                 <a:latin typeface="Noto Sans CJK SC"/>
                 <a:ea typeface="Noto Sans CJK SC"/>
                 <a:cs typeface="Noto Sans CJK SC"/>
               </a:rPr>
-              <a:t>合成路线</a:t>
-            </a:r>
-          </a:p>
-        </p:txBody>
-      </p:sp>
-      <p:sp>
-        <p:nvSpPr>
-          <p:cNvPr id="10" name="n2_s" descr="Editable text; source id n2_s"/>
+              <a:t>固相</a:t>
+            </a:r>
+            <a:r>
+              <a:rPr sz="828" b="0" i="0" lang="zh-CN" dirty="0">
+                <a:solidFill>
+                  <a:srgbClr val="3F4854"/>
+                </a:solidFill>
+                <a:latin typeface="DejaVu Sans"/>
+                <a:ea typeface="DejaVu Sans"/>
+                <a:cs typeface="DejaVu Sans"/>
+              </a:rPr>
+              <a:t> · </a:t>
+            </a:r>
+            <a:r>
+              <a:rPr sz="828" b="0" i="0" lang="zh-CN" dirty="0">
+                <a:solidFill>
+                  <a:srgbClr val="3F4854"/>
+                </a:solidFill>
+                <a:latin typeface="Noto Sans CJK SC"/>
+                <a:ea typeface="Noto Sans CJK SC"/>
+                <a:cs typeface="Noto Sans CJK SC"/>
+              </a:rPr>
+              <a:t>溶胶</a:t>
+            </a:r>
+            <a:r>
+              <a:rPr sz="828" b="0" i="0" lang="zh-CN" dirty="0">
+                <a:solidFill>
+                  <a:srgbClr val="3F4854"/>
+                </a:solidFill>
+                <a:latin typeface="DejaVu Sans"/>
+                <a:ea typeface="DejaVu Sans"/>
+                <a:cs typeface="DejaVu Sans"/>
+              </a:rPr>
+              <a:t>—</a:t>
+            </a:r>
+            <a:r>
+              <a:rPr sz="828" b="0" i="0" lang="zh-CN" dirty="0">
+                <a:solidFill>
+                  <a:srgbClr val="3F4854"/>
+                </a:solidFill>
+                <a:latin typeface="Noto Sans CJK SC"/>
+                <a:ea typeface="Noto Sans CJK SC"/>
+                <a:cs typeface="Noto Sans CJK SC"/>
+              </a:rPr>
+              <a:t>凝胶</a:t>
+            </a:r>
+          </a:p>
+        </p:txBody>
+      </p:sp>
+      <p:sp>
+        <p:nvSpPr>
+          <p:cNvPr id="16" name="n2_n" descr="Editable text; source id n2_n"/>
           <p:cNvSpPr txBox="1"/>
           <p:nvPr/>
         </p:nvSpPr>
         <p:spPr>
           <a:xfrm>
-            <a:off x="2278983" y="1661524"/>
-            <a:ext cx="1324729" cy="224530"/>
+            <a:off x="2603252" y="1233431"/>
+            <a:ext cx="332077" cy="166038"/>
           </a:xfrm>
           <a:prstGeom prst="rect">
             <a:avLst/>
@@ -3940,9 +4284,9 @@
           </a:bodyPr>
           <a:lstStyle/>
           <a:p>
-            <a:pPr algn="ctr" fontAlgn="base">
+            <a:pPr algn="l" fontAlgn="base">
               <a:lnSpc>
-                <a:spcPts val="1546"/>
+                <a:spcPts val="1038"/>
               </a:lnSpc>
               <a:spcBef>
                 <a:spcPts val="0"/>
@@ -3950,76 +4294,32 @@
               <a:spcAft>
                 <a:spcPts val="0"/>
               </a:spcAft>
-              <a:defRPr sz="1063" b="0" i="0" lang="zh-CN" dirty="0">
-                <a:solidFill>
-                  <a:srgbClr val="3A4046"/>
-                </a:solidFill>
-                <a:latin typeface="Noto Sans CJK SC"/>
-                <a:ea typeface="Noto Sans CJK SC"/>
-                <a:cs typeface="Noto Sans CJK SC"/>
+              <a:defRPr sz="887" b="1" i="0" lang="zh-CN" dirty="0">
+                <a:solidFill>
+                  <a:srgbClr val="8A9199"/>
+                </a:solidFill>
+                <a:latin typeface="DejaVu Sans"/>
+                <a:ea typeface="DejaVu Sans"/>
+                <a:cs typeface="DejaVu Sans"/>
               </a:defRPr>
             </a:pPr>
             <a:r>
-              <a:rPr sz="1063" b="0" i="0" lang="zh-CN" dirty="0">
-                <a:solidFill>
-                  <a:srgbClr val="3A4046"/>
-                </a:solidFill>
-                <a:latin typeface="Noto Sans CJK SC"/>
-                <a:ea typeface="Noto Sans CJK SC"/>
-                <a:cs typeface="Noto Sans CJK SC"/>
-              </a:rPr>
-              <a:t>固相</a:t>
-            </a:r>
-            <a:r>
-              <a:rPr sz="1063" b="0" i="0" lang="zh-CN" dirty="0">
-                <a:solidFill>
-                  <a:srgbClr val="3A4046"/>
+              <a:rPr sz="887" b="1" i="0" lang="zh-CN" dirty="0">
+                <a:solidFill>
+                  <a:srgbClr val="8A9199"/>
                 </a:solidFill>
                 <a:latin typeface="DejaVu Sans"/>
                 <a:ea typeface="DejaVu Sans"/>
                 <a:cs typeface="DejaVu Sans"/>
               </a:rPr>
-              <a:t> · </a:t>
-            </a:r>
-            <a:r>
-              <a:rPr sz="1063" b="0" i="0" lang="zh-CN" dirty="0">
-                <a:solidFill>
-                  <a:srgbClr val="3A4046"/>
-                </a:solidFill>
-                <a:latin typeface="Noto Sans CJK SC"/>
-                <a:ea typeface="Noto Sans CJK SC"/>
-                <a:cs typeface="Noto Sans CJK SC"/>
-              </a:rPr>
-              <a:t>溶胶</a:t>
-            </a:r>
-            <a:r>
-              <a:rPr sz="1063" b="0" i="0" lang="zh-CN" dirty="0">
-                <a:solidFill>
-                  <a:srgbClr val="3A4046"/>
-                </a:solidFill>
-                <a:latin typeface="DejaVu Sans"/>
-                <a:ea typeface="DejaVu Sans"/>
-                <a:cs typeface="DejaVu Sans"/>
-              </a:rPr>
-              <a:t>—</a:t>
-            </a:r>
-            <a:r>
-              <a:rPr sz="1063" b="0" i="0" lang="zh-CN" dirty="0">
-                <a:solidFill>
-                  <a:srgbClr val="3A4046"/>
-                </a:solidFill>
-                <a:latin typeface="Noto Sans CJK SC"/>
-                <a:ea typeface="Noto Sans CJK SC"/>
-                <a:cs typeface="Noto Sans CJK SC"/>
-              </a:rPr>
-              <a:t>凝胶</a:t>
+              <a:t>02</a:t>
             </a:r>
           </a:p>
         </p:txBody>
       </p:sp>
       <p:pic>
         <p:nvPicPr>
-          <p:cNvPr id="11" name="n2_i" descr="exact crop of source page_001 (monochrome line motif)"/>
+          <p:cNvPr id="17" name="n2_ic" descr="exact crop of the generated raster (line motif)"/>
           <p:cNvPicPr>
             <a:picLocks noChangeAspect="1"/>
           </p:cNvPicPr>
@@ -4033,8 +4333,8 @@
         </p:blipFill>
         <p:spPr>
           <a:xfrm>
-            <a:off x="2554033" y="2172331"/>
-            <a:ext cx="785856" cy="757790"/>
+            <a:off x="2793011" y="2619104"/>
+            <a:ext cx="699735" cy="632453"/>
           </a:xfrm>
           <a:prstGeom prst="rect">
             <a:avLst/>
@@ -4044,26 +4344,26 @@
       </p:pic>
       <p:sp>
         <p:nvSpPr>
-          <p:cNvPr id="12" name="n3" descr="Editable shape; source id n3"/>
+          <p:cNvPr id="18" name="n3" descr="Editable shape; source id n3"/>
           <p:cNvSpPr/>
           <p:nvPr/>
         </p:nvSpPr>
         <p:spPr>
           <a:xfrm>
-            <a:off x="4294143" y="875668"/>
-            <a:ext cx="1403314" cy="2194784"/>
+            <a:off x="4601649" y="1126692"/>
+            <a:ext cx="1269011" cy="2490583"/>
           </a:xfrm>
           <a:prstGeom prst="roundRect">
             <a:avLst>
-              <a:gd name="adj" fmla="val 5600"/>
+              <a:gd name="adj" fmla="val 4672"/>
             </a:avLst>
           </a:prstGeom>
           <a:solidFill>
             <a:srgbClr val="FFFFFF"/>
           </a:solidFill>
-          <a:ln w="14033">
+          <a:ln w="8894">
             <a:solidFill>
-              <a:srgbClr val="4A5158"/>
+              <a:srgbClr val="5B7592"/>
             </a:solidFill>
           </a:ln>
           <a:effectLst/>
@@ -4092,14 +4392,60 @@
       </p:sp>
       <p:sp>
         <p:nvSpPr>
-          <p:cNvPr id="13" name="n3_n" descr="Editable text; source id n3_n"/>
+          <p:cNvPr id="19" name="n3_s" descr="Editable shape; source id n3_s"/>
+          <p:cNvSpPr/>
+          <p:nvPr/>
+        </p:nvSpPr>
+        <p:spPr>
+          <a:xfrm>
+            <a:off x="4601649" y="1126692"/>
+            <a:ext cx="1269011" cy="47439"/>
+          </a:xfrm>
+          <a:prstGeom prst="roundRect">
+            <a:avLst>
+              <a:gd name="adj" fmla="val 50000"/>
+            </a:avLst>
+          </a:prstGeom>
+          <a:solidFill>
+            <a:srgbClr val="5B7592"/>
+          </a:solidFill>
+          <a:ln>
+            <a:noFill/>
+          </a:ln>
+          <a:effectLst/>
+        </p:spPr>
+        <p:style>
+          <a:lnRef idx="1">
+            <a:schemeClr val="accent1"/>
+          </a:lnRef>
+          <a:fillRef idx="3">
+            <a:schemeClr val="accent1"/>
+          </a:fillRef>
+          <a:effectRef idx="0">
+            <a:schemeClr val="accent1"/>
+          </a:effectRef>
+          <a:fontRef idx="minor">
+            <a:schemeClr val="lt1"/>
+          </a:fontRef>
+        </p:style>
+        <p:txBody>
+          <a:bodyPr rtlCol="0" anchor="ctr"/>
+          <a:lstStyle/>
+          <a:p>
+            <a:pPr algn="ctr"/>
+          </a:p>
+        </p:txBody>
+      </p:sp>
+      <p:sp>
+        <p:nvSpPr>
+          <p:cNvPr id="20" name="n3_t" descr="Editable text; source id n3_t"/>
           <p:cNvSpPr txBox="1"/>
           <p:nvPr/>
         </p:nvSpPr>
         <p:spPr>
           <a:xfrm>
-            <a:off x="4383955" y="943027"/>
-            <a:ext cx="392928" cy="190850"/>
+            <a:off x="4684669" y="1482490"/>
+            <a:ext cx="1102972" cy="219408"/>
           </a:xfrm>
           <a:prstGeom prst="rect">
             <a:avLst/>
@@ -4115,7 +4461,7 @@
           <a:p>
             <a:pPr algn="l" fontAlgn="base">
               <a:lnSpc>
-                <a:spcPts val="1138"/>
+                <a:spcPts val="1692"/>
               </a:lnSpc>
               <a:spcBef>
                 <a:spcPts val="0"/>
@@ -4123,39 +4469,39 @@
               <a:spcAft>
                 <a:spcPts val="0"/>
               </a:spcAft>
-              <a:defRPr sz="972" b="1" i="0" lang="zh-CN" dirty="0">
-                <a:solidFill>
-                  <a:srgbClr val="8A9199"/>
-                </a:solidFill>
-                <a:latin typeface="DejaVu Sans"/>
-                <a:ea typeface="DejaVu Sans"/>
-                <a:cs typeface="DejaVu Sans"/>
+              <a:defRPr sz="1167" b="1" i="0" lang="zh-CN" dirty="0">
+                <a:solidFill>
+                  <a:srgbClr val="2B3E57"/>
+                </a:solidFill>
+                <a:latin typeface="Noto Sans CJK SC"/>
+                <a:ea typeface="Noto Sans CJK SC"/>
+                <a:cs typeface="Noto Sans CJK SC"/>
               </a:defRPr>
             </a:pPr>
             <a:r>
-              <a:rPr sz="972" b="1" i="0" lang="zh-CN" dirty="0">
-                <a:solidFill>
-                  <a:srgbClr val="8A9199"/>
-                </a:solidFill>
-                <a:latin typeface="DejaVu Sans"/>
-                <a:ea typeface="DejaVu Sans"/>
-                <a:cs typeface="DejaVu Sans"/>
+              <a:rPr sz="1167" b="1" i="0" lang="zh-CN" dirty="0">
+                <a:solidFill>
+                  <a:srgbClr val="2B3E57"/>
+                </a:solidFill>
+                <a:latin typeface="Noto Sans CJK SC"/>
+                <a:ea typeface="Noto Sans CJK SC"/>
+                <a:cs typeface="Noto Sans CJK SC"/>
               </a:rPr>
-              <a:t>03</a:t>
-            </a:r>
-          </a:p>
-        </p:txBody>
-      </p:sp>
-      <p:sp>
-        <p:nvSpPr>
-          <p:cNvPr id="14" name="n3_t" descr="Editable text; source id n3_t"/>
+              <a:t>相控制</a:t>
+            </a:r>
+          </a:p>
+        </p:txBody>
+      </p:sp>
+      <p:sp>
+        <p:nvSpPr>
+          <p:cNvPr id="21" name="n3_k0" descr="Editable text; source id n3_k0"/>
           <p:cNvSpPr txBox="1"/>
           <p:nvPr/>
         </p:nvSpPr>
         <p:spPr>
           <a:xfrm>
-            <a:off x="4350276" y="1279823"/>
-            <a:ext cx="1291049" cy="336795"/>
+            <a:off x="4684669" y="1749338"/>
+            <a:ext cx="1102972" cy="171968"/>
           </a:xfrm>
           <a:prstGeom prst="rect">
             <a:avLst/>
@@ -4169,9 +4515,9 @@
           </a:bodyPr>
           <a:lstStyle/>
           <a:p>
-            <a:pPr algn="ctr" fontAlgn="base">
+            <a:pPr algn="l" fontAlgn="base">
               <a:lnSpc>
-                <a:spcPts val="2574"/>
+                <a:spcPts val="1214"/>
               </a:lnSpc>
               <a:spcBef>
                 <a:spcPts val="0"/>
@@ -4179,9 +4525,9 @@
               <a:spcAft>
                 <a:spcPts val="0"/>
               </a:spcAft>
-              <a:defRPr sz="1767" b="1" i="0" lang="zh-CN" dirty="0">
-                <a:solidFill>
-                  <a:srgbClr val="1F2326"/>
+              <a:defRPr sz="828" b="0" i="0" lang="zh-CN" dirty="0">
+                <a:solidFill>
+                  <a:srgbClr val="3F4854"/>
                 </a:solidFill>
                 <a:latin typeface="Noto Sans CJK SC"/>
                 <a:ea typeface="Noto Sans CJK SC"/>
@@ -4189,29 +4535,51 @@
               </a:defRPr>
             </a:pPr>
             <a:r>
-              <a:rPr sz="1767" b="1" i="0" lang="zh-CN" dirty="0">
-                <a:solidFill>
-                  <a:srgbClr val="1F2326"/>
+              <a:rPr sz="828" b="0" i="0" lang="zh-CN" dirty="0">
+                <a:solidFill>
+                  <a:srgbClr val="3F4854"/>
                 </a:solidFill>
                 <a:latin typeface="Noto Sans CJK SC"/>
                 <a:ea typeface="Noto Sans CJK SC"/>
                 <a:cs typeface="Noto Sans CJK SC"/>
               </a:rPr>
-              <a:t>相控制</a:t>
-            </a:r>
-          </a:p>
-        </p:txBody>
-      </p:sp>
-      <p:sp>
-        <p:nvSpPr>
-          <p:cNvPr id="15" name="n3_s" descr="Editable text; source id n3_s"/>
+              <a:t>组成</a:t>
+            </a:r>
+            <a:r>
+              <a:rPr sz="828" b="0" i="0" lang="zh-CN" dirty="0">
+                <a:solidFill>
+                  <a:srgbClr val="3F4854"/>
+                </a:solidFill>
+                <a:latin typeface="DejaVu Sans"/>
+                <a:ea typeface="DejaVu Sans"/>
+                <a:cs typeface="DejaVu Sans"/>
+              </a:rPr>
+              <a:t> · </a:t>
+            </a:r>
+            <a:r>
+              <a:rPr sz="828" b="0" i="0" lang="zh-CN" dirty="0">
+                <a:solidFill>
+                  <a:srgbClr val="3F4854"/>
+                </a:solidFill>
+                <a:latin typeface="Noto Sans CJK SC"/>
+                <a:ea typeface="Noto Sans CJK SC"/>
+                <a:cs typeface="Noto Sans CJK SC"/>
+              </a:rPr>
+              <a:t>热处理</a:t>
+            </a:r>
+          </a:p>
+        </p:txBody>
+      </p:sp>
+      <p:sp>
+        <p:nvSpPr>
+          <p:cNvPr id="22" name="n3_n" descr="Editable text; source id n3_n"/>
           <p:cNvSpPr txBox="1"/>
           <p:nvPr/>
         </p:nvSpPr>
         <p:spPr>
           <a:xfrm>
-            <a:off x="4339049" y="1661524"/>
-            <a:ext cx="1313502" cy="224530"/>
+            <a:off x="4696529" y="1233431"/>
+            <a:ext cx="332077" cy="166038"/>
           </a:xfrm>
           <a:prstGeom prst="rect">
             <a:avLst/>
@@ -4225,9 +4593,9 @@
           </a:bodyPr>
           <a:lstStyle/>
           <a:p>
-            <a:pPr algn="ctr" fontAlgn="base">
+            <a:pPr algn="l" fontAlgn="base">
               <a:lnSpc>
-                <a:spcPts val="1546"/>
+                <a:spcPts val="1038"/>
               </a:lnSpc>
               <a:spcBef>
                 <a:spcPts val="0"/>
@@ -4235,54 +4603,32 @@
               <a:spcAft>
                 <a:spcPts val="0"/>
               </a:spcAft>
-              <a:defRPr sz="1063" b="0" i="0" lang="zh-CN" dirty="0">
-                <a:solidFill>
-                  <a:srgbClr val="3A4046"/>
-                </a:solidFill>
-                <a:latin typeface="Noto Sans CJK SC"/>
-                <a:ea typeface="Noto Sans CJK SC"/>
-                <a:cs typeface="Noto Sans CJK SC"/>
+              <a:defRPr sz="887" b="1" i="0" lang="zh-CN" dirty="0">
+                <a:solidFill>
+                  <a:srgbClr val="8A9199"/>
+                </a:solidFill>
+                <a:latin typeface="DejaVu Sans"/>
+                <a:ea typeface="DejaVu Sans"/>
+                <a:cs typeface="DejaVu Sans"/>
               </a:defRPr>
             </a:pPr>
             <a:r>
-              <a:rPr sz="1063" b="0" i="0" lang="zh-CN" dirty="0">
-                <a:solidFill>
-                  <a:srgbClr val="3A4046"/>
-                </a:solidFill>
-                <a:latin typeface="Noto Sans CJK SC"/>
-                <a:ea typeface="Noto Sans CJK SC"/>
-                <a:cs typeface="Noto Sans CJK SC"/>
-              </a:rPr>
-              <a:t>组成</a:t>
-            </a:r>
-            <a:r>
-              <a:rPr sz="1063" b="0" i="0" lang="zh-CN" dirty="0">
-                <a:solidFill>
-                  <a:srgbClr val="3A4046"/>
+              <a:rPr sz="887" b="1" i="0" lang="zh-CN" dirty="0">
+                <a:solidFill>
+                  <a:srgbClr val="8A9199"/>
                 </a:solidFill>
                 <a:latin typeface="DejaVu Sans"/>
                 <a:ea typeface="DejaVu Sans"/>
                 <a:cs typeface="DejaVu Sans"/>
               </a:rPr>
-              <a:t> · </a:t>
-            </a:r>
-            <a:r>
-              <a:rPr sz="1063" b="0" i="0" lang="zh-CN" dirty="0">
-                <a:solidFill>
-                  <a:srgbClr val="3A4046"/>
-                </a:solidFill>
-                <a:latin typeface="Noto Sans CJK SC"/>
-                <a:ea typeface="Noto Sans CJK SC"/>
-                <a:cs typeface="Noto Sans CJK SC"/>
-              </a:rPr>
-              <a:t>热处理</a:t>
+              <a:t>03</a:t>
             </a:r>
           </a:p>
         </p:txBody>
       </p:sp>
       <p:pic>
         <p:nvPicPr>
-          <p:cNvPr id="16" name="n3_i" descr="exact crop of source page_001 (monochrome line motif)"/>
+          <p:cNvPr id="23" name="n3_ic" descr="exact crop of the generated raster (line motif)"/>
           <p:cNvPicPr>
             <a:picLocks noChangeAspect="1"/>
           </p:cNvPicPr>
@@ -4296,8 +4642,8 @@
         </p:blipFill>
         <p:spPr>
           <a:xfrm>
-            <a:off x="4473767" y="2060066"/>
-            <a:ext cx="1044066" cy="886895"/>
+            <a:off x="4886287" y="2632460"/>
+            <a:ext cx="699735" cy="605741"/>
           </a:xfrm>
           <a:prstGeom prst="rect">
             <a:avLst/>
@@ -4307,26 +4653,26 @@
       </p:pic>
       <p:sp>
         <p:nvSpPr>
-          <p:cNvPr id="17" name="n4" descr="Editable shape; source id n4"/>
+          <p:cNvPr id="24" name="n4" descr="Editable shape; source id n4"/>
           <p:cNvSpPr/>
           <p:nvPr/>
         </p:nvSpPr>
         <p:spPr>
           <a:xfrm>
-            <a:off x="6382276" y="875668"/>
-            <a:ext cx="1392088" cy="2194784"/>
+            <a:off x="6368778" y="1126692"/>
+            <a:ext cx="1269011" cy="2490583"/>
           </a:xfrm>
           <a:prstGeom prst="roundRect">
             <a:avLst>
-              <a:gd name="adj" fmla="val 5645"/>
+              <a:gd name="adj" fmla="val 4672"/>
             </a:avLst>
           </a:prstGeom>
           <a:solidFill>
             <a:srgbClr val="FFFFFF"/>
           </a:solidFill>
-          <a:ln w="14033">
+          <a:ln w="8894">
             <a:solidFill>
-              <a:srgbClr val="4A5158"/>
+              <a:srgbClr val="1F7F8C"/>
             </a:solidFill>
           </a:ln>
           <a:effectLst/>
@@ -4355,14 +4701,60 @@
       </p:sp>
       <p:sp>
         <p:nvSpPr>
-          <p:cNvPr id="18" name="n4_n" descr="Editable text; source id n4_n"/>
+          <p:cNvPr id="25" name="n4_s" descr="Editable shape; source id n4_s"/>
+          <p:cNvSpPr/>
+          <p:nvPr/>
+        </p:nvSpPr>
+        <p:spPr>
+          <a:xfrm>
+            <a:off x="6368778" y="1126692"/>
+            <a:ext cx="1269011" cy="47439"/>
+          </a:xfrm>
+          <a:prstGeom prst="roundRect">
+            <a:avLst>
+              <a:gd name="adj" fmla="val 50000"/>
+            </a:avLst>
+          </a:prstGeom>
+          <a:solidFill>
+            <a:srgbClr val="1F7F8C"/>
+          </a:solidFill>
+          <a:ln>
+            <a:noFill/>
+          </a:ln>
+          <a:effectLst/>
+        </p:spPr>
+        <p:style>
+          <a:lnRef idx="1">
+            <a:schemeClr val="accent1"/>
+          </a:lnRef>
+          <a:fillRef idx="3">
+            <a:schemeClr val="accent1"/>
+          </a:fillRef>
+          <a:effectRef idx="0">
+            <a:schemeClr val="accent1"/>
+          </a:effectRef>
+          <a:fontRef idx="minor">
+            <a:schemeClr val="lt1"/>
+          </a:fontRef>
+        </p:style>
+        <p:txBody>
+          <a:bodyPr rtlCol="0" anchor="ctr"/>
+          <a:lstStyle/>
+          <a:p>
+            <a:pPr algn="ctr"/>
+          </a:p>
+        </p:txBody>
+      </p:sp>
+      <p:sp>
+        <p:nvSpPr>
+          <p:cNvPr id="26" name="n4_t" descr="Editable text; source id n4_t"/>
           <p:cNvSpPr txBox="1"/>
           <p:nvPr/>
         </p:nvSpPr>
         <p:spPr>
           <a:xfrm>
-            <a:off x="6472088" y="943027"/>
-            <a:ext cx="392928" cy="190850"/>
+            <a:off x="6451797" y="1482490"/>
+            <a:ext cx="1102972" cy="219408"/>
           </a:xfrm>
           <a:prstGeom prst="rect">
             <a:avLst/>
@@ -4378,7 +4770,7 @@
           <a:p>
             <a:pPr algn="l" fontAlgn="base">
               <a:lnSpc>
-                <a:spcPts val="1138"/>
+                <a:spcPts val="1692"/>
               </a:lnSpc>
               <a:spcBef>
                 <a:spcPts val="0"/>
@@ -4386,39 +4778,39 @@
               <a:spcAft>
                 <a:spcPts val="0"/>
               </a:spcAft>
-              <a:defRPr sz="972" b="1" i="0" lang="zh-CN" dirty="0">
-                <a:solidFill>
-                  <a:srgbClr val="8A9199"/>
-                </a:solidFill>
-                <a:latin typeface="DejaVu Sans"/>
-                <a:ea typeface="DejaVu Sans"/>
-                <a:cs typeface="DejaVu Sans"/>
+              <a:defRPr sz="1167" b="1" i="0" lang="zh-CN" dirty="0">
+                <a:solidFill>
+                  <a:srgbClr val="0F4F58"/>
+                </a:solidFill>
+                <a:latin typeface="Noto Sans CJK SC"/>
+                <a:ea typeface="Noto Sans CJK SC"/>
+                <a:cs typeface="Noto Sans CJK SC"/>
               </a:defRPr>
             </a:pPr>
             <a:r>
-              <a:rPr sz="972" b="1" i="0" lang="zh-CN" dirty="0">
-                <a:solidFill>
-                  <a:srgbClr val="8A9199"/>
-                </a:solidFill>
-                <a:latin typeface="DejaVu Sans"/>
-                <a:ea typeface="DejaVu Sans"/>
-                <a:cs typeface="DejaVu Sans"/>
+              <a:rPr sz="1167" b="1" i="0" lang="zh-CN" dirty="0">
+                <a:solidFill>
+                  <a:srgbClr val="0F4F58"/>
+                </a:solidFill>
+                <a:latin typeface="Noto Sans CJK SC"/>
+                <a:ea typeface="Noto Sans CJK SC"/>
+                <a:cs typeface="Noto Sans CJK SC"/>
               </a:rPr>
-              <a:t>04</a:t>
-            </a:r>
-          </a:p>
-        </p:txBody>
-      </p:sp>
-      <p:sp>
-        <p:nvSpPr>
-          <p:cNvPr id="19" name="n4_t" descr="Editable text; source id n4_t"/>
+              <a:t>近邻体系</a:t>
+            </a:r>
+          </a:p>
+        </p:txBody>
+      </p:sp>
+      <p:sp>
+        <p:nvSpPr>
+          <p:cNvPr id="27" name="n4_k0" descr="Editable text; source id n4_k0"/>
           <p:cNvSpPr txBox="1"/>
           <p:nvPr/>
         </p:nvSpPr>
         <p:spPr>
           <a:xfrm>
-            <a:off x="6438408" y="1279823"/>
-            <a:ext cx="1279823" cy="336795"/>
+            <a:off x="6451797" y="1749338"/>
+            <a:ext cx="1102972" cy="171968"/>
           </a:xfrm>
           <a:prstGeom prst="rect">
             <a:avLst/>
@@ -4432,9 +4824,9 @@
           </a:bodyPr>
           <a:lstStyle/>
           <a:p>
-            <a:pPr algn="ctr" fontAlgn="base">
+            <a:pPr algn="l" fontAlgn="base">
               <a:lnSpc>
-                <a:spcPts val="2574"/>
+                <a:spcPts val="968"/>
               </a:lnSpc>
               <a:spcBef>
                 <a:spcPts val="0"/>
@@ -4442,39 +4834,39 @@
               <a:spcAft>
                 <a:spcPts val="0"/>
               </a:spcAft>
-              <a:defRPr sz="1767" b="1" i="0" lang="zh-CN" dirty="0">
-                <a:solidFill>
-                  <a:srgbClr val="1F2326"/>
-                </a:solidFill>
-                <a:latin typeface="Noto Sans CJK SC"/>
-                <a:ea typeface="Noto Sans CJK SC"/>
-                <a:cs typeface="Noto Sans CJK SC"/>
+              <a:defRPr sz="828" b="0" i="0" lang="zh-CN" dirty="0">
+                <a:solidFill>
+                  <a:srgbClr val="3F4854"/>
+                </a:solidFill>
+                <a:latin typeface="DejaVu Sans"/>
+                <a:ea typeface="DejaVu Sans"/>
+                <a:cs typeface="DejaVu Sans"/>
               </a:defRPr>
             </a:pPr>
             <a:r>
-              <a:rPr sz="1767" b="1" i="0" lang="zh-CN" dirty="0">
-                <a:solidFill>
-                  <a:srgbClr val="1F2326"/>
-                </a:solidFill>
-                <a:latin typeface="Noto Sans CJK SC"/>
-                <a:ea typeface="Noto Sans CJK SC"/>
-                <a:cs typeface="Noto Sans CJK SC"/>
+              <a:rPr sz="828" b="0" i="0" lang="zh-CN" dirty="0">
+                <a:solidFill>
+                  <a:srgbClr val="3F4854"/>
+                </a:solidFill>
+                <a:latin typeface="DejaVu Sans"/>
+                <a:ea typeface="DejaVu Sans"/>
+                <a:cs typeface="DejaVu Sans"/>
               </a:rPr>
-              <a:t>近邻体系</a:t>
-            </a:r>
-          </a:p>
-        </p:txBody>
-      </p:sp>
-      <p:sp>
-        <p:nvSpPr>
-          <p:cNvPr id="20" name="n4_s" descr="Editable text; source id n4_s"/>
+              <a:t>Ba–Sr–Zn–Si</a:t>
+            </a:r>
+          </a:p>
+        </p:txBody>
+      </p:sp>
+      <p:sp>
+        <p:nvSpPr>
+          <p:cNvPr id="28" name="n4_n" descr="Editable text; source id n4_n"/>
           <p:cNvSpPr txBox="1"/>
           <p:nvPr/>
         </p:nvSpPr>
         <p:spPr>
           <a:xfrm>
-            <a:off x="6427182" y="1661524"/>
-            <a:ext cx="1302276" cy="224530"/>
+            <a:off x="6463657" y="1233431"/>
+            <a:ext cx="332077" cy="166038"/>
           </a:xfrm>
           <a:prstGeom prst="rect">
             <a:avLst/>
@@ -4488,9 +4880,9 @@
           </a:bodyPr>
           <a:lstStyle/>
           <a:p>
-            <a:pPr algn="ctr" fontAlgn="base">
+            <a:pPr algn="l" fontAlgn="base">
               <a:lnSpc>
-                <a:spcPts val="1248"/>
+                <a:spcPts val="1038"/>
               </a:lnSpc>
               <a:spcBef>
                 <a:spcPts val="0"/>
@@ -4498,9 +4890,9 @@
               <a:spcAft>
                 <a:spcPts val="0"/>
               </a:spcAft>
-              <a:defRPr sz="1063" b="0" i="0" lang="zh-CN" dirty="0">
-                <a:solidFill>
-                  <a:srgbClr val="3A4046"/>
+              <a:defRPr sz="887" b="1" i="0" lang="zh-CN" dirty="0">
+                <a:solidFill>
+                  <a:srgbClr val="8A9199"/>
                 </a:solidFill>
                 <a:latin typeface="DejaVu Sans"/>
                 <a:ea typeface="DejaVu Sans"/>
@@ -4508,22 +4900,22 @@
               </a:defRPr>
             </a:pPr>
             <a:r>
-              <a:rPr sz="1063" b="0" i="0" lang="zh-CN" dirty="0">
-                <a:solidFill>
-                  <a:srgbClr val="3A4046"/>
+              <a:rPr sz="887" b="1" i="0" lang="zh-CN" dirty="0">
+                <a:solidFill>
+                  <a:srgbClr val="8A9199"/>
                 </a:solidFill>
                 <a:latin typeface="DejaVu Sans"/>
                 <a:ea typeface="DejaVu Sans"/>
                 <a:cs typeface="DejaVu Sans"/>
               </a:rPr>
-              <a:t>Ba–Sr–Zn–Si</a:t>
+              <a:t>04</a:t>
             </a:r>
           </a:p>
         </p:txBody>
       </p:sp>
       <p:pic>
         <p:nvPicPr>
-          <p:cNvPr id="21" name="n4_i" descr="exact crop of source page_001 (monochrome line motif)"/>
+          <p:cNvPr id="29" name="n4_ic" descr="exact crop of the generated raster (line motif)"/>
           <p:cNvPicPr>
             <a:picLocks noChangeAspect="1"/>
           </p:cNvPicPr>
@@ -4537,8 +4929,8 @@
         </p:blipFill>
         <p:spPr>
           <a:xfrm>
-            <a:off x="6657325" y="2104972"/>
-            <a:ext cx="853215" cy="785856"/>
+            <a:off x="6653416" y="2596934"/>
+            <a:ext cx="699735" cy="676793"/>
           </a:xfrm>
           <a:prstGeom prst="rect">
             <a:avLst/>
@@ -4548,26 +4940,26 @@
       </p:pic>
       <p:sp>
         <p:nvSpPr>
-          <p:cNvPr id="22" name="n5" descr="Editable shape; source id n5"/>
+          <p:cNvPr id="30" name="n5" descr="Editable shape; source id n5"/>
           <p:cNvSpPr/>
           <p:nvPr/>
         </p:nvSpPr>
         <p:spPr>
           <a:xfrm>
-            <a:off x="8414276" y="875668"/>
-            <a:ext cx="1504353" cy="2194784"/>
+            <a:off x="8462054" y="1126692"/>
+            <a:ext cx="1269011" cy="2490583"/>
           </a:xfrm>
           <a:prstGeom prst="roundRect">
             <a:avLst>
-              <a:gd name="adj" fmla="val 5223"/>
+              <a:gd name="adj" fmla="val 4672"/>
             </a:avLst>
           </a:prstGeom>
           <a:solidFill>
             <a:srgbClr val="FFFFFF"/>
           </a:solidFill>
-          <a:ln w="14033">
+          <a:ln w="8894">
             <a:solidFill>
-              <a:srgbClr val="B8862B"/>
+              <a:srgbClr val="C48A24"/>
             </a:solidFill>
           </a:ln>
           <a:effectLst/>
@@ -4596,14 +4988,60 @@
       </p:sp>
       <p:sp>
         <p:nvSpPr>
-          <p:cNvPr id="23" name="n5_n" descr="Editable text; source id n5_n"/>
+          <p:cNvPr id="31" name="n5_s" descr="Editable shape; source id n5_s"/>
+          <p:cNvSpPr/>
+          <p:nvPr/>
+        </p:nvSpPr>
+        <p:spPr>
+          <a:xfrm>
+            <a:off x="8462054" y="1126692"/>
+            <a:ext cx="1269011" cy="47439"/>
+          </a:xfrm>
+          <a:prstGeom prst="roundRect">
+            <a:avLst>
+              <a:gd name="adj" fmla="val 50000"/>
+            </a:avLst>
+          </a:prstGeom>
+          <a:solidFill>
+            <a:srgbClr val="C48A24"/>
+          </a:solidFill>
+          <a:ln>
+            <a:noFill/>
+          </a:ln>
+          <a:effectLst/>
+        </p:spPr>
+        <p:style>
+          <a:lnRef idx="1">
+            <a:schemeClr val="accent1"/>
+          </a:lnRef>
+          <a:fillRef idx="3">
+            <a:schemeClr val="accent1"/>
+          </a:fillRef>
+          <a:effectRef idx="0">
+            <a:schemeClr val="accent1"/>
+          </a:effectRef>
+          <a:fontRef idx="minor">
+            <a:schemeClr val="lt1"/>
+          </a:fontRef>
+        </p:style>
+        <p:txBody>
+          <a:bodyPr rtlCol="0" anchor="ctr"/>
+          <a:lstStyle/>
+          <a:p>
+            <a:pPr algn="ctr"/>
+          </a:p>
+        </p:txBody>
+      </p:sp>
+      <p:sp>
+        <p:nvSpPr>
+          <p:cNvPr id="32" name="n5_t" descr="Editable text; source id n5_t"/>
           <p:cNvSpPr txBox="1"/>
           <p:nvPr/>
         </p:nvSpPr>
         <p:spPr>
           <a:xfrm>
-            <a:off x="8504088" y="943027"/>
-            <a:ext cx="392928" cy="190850"/>
+            <a:off x="8545073" y="1482490"/>
+            <a:ext cx="1102972" cy="219408"/>
           </a:xfrm>
           <a:prstGeom prst="rect">
             <a:avLst/>
@@ -4619,7 +5057,7 @@
           <a:p>
             <a:pPr algn="l" fontAlgn="base">
               <a:lnSpc>
-                <a:spcPts val="1138"/>
+                <a:spcPts val="1692"/>
               </a:lnSpc>
               <a:spcBef>
                 <a:spcPts val="0"/>
@@ -4627,39 +5065,39 @@
               <a:spcAft>
                 <a:spcPts val="0"/>
               </a:spcAft>
-              <a:defRPr sz="972" b="1" i="0" lang="zh-CN" dirty="0">
-                <a:solidFill>
-                  <a:srgbClr val="8A9199"/>
-                </a:solidFill>
-                <a:latin typeface="DejaVu Sans"/>
-                <a:ea typeface="DejaVu Sans"/>
-                <a:cs typeface="DejaVu Sans"/>
+              <a:defRPr sz="1167" b="1" i="0" lang="zh-CN" dirty="0">
+                <a:solidFill>
+                  <a:srgbClr val="7A5410"/>
+                </a:solidFill>
+                <a:latin typeface="Noto Sans CJK SC"/>
+                <a:ea typeface="Noto Sans CJK SC"/>
+                <a:cs typeface="Noto Sans CJK SC"/>
               </a:defRPr>
             </a:pPr>
             <a:r>
-              <a:rPr sz="972" b="1" i="0" lang="zh-CN" dirty="0">
-                <a:solidFill>
-                  <a:srgbClr val="8A9199"/>
-                </a:solidFill>
-                <a:latin typeface="DejaVu Sans"/>
-                <a:ea typeface="DejaVu Sans"/>
-                <a:cs typeface="DejaVu Sans"/>
+              <a:rPr sz="1167" b="1" i="0" lang="zh-CN" dirty="0">
+                <a:solidFill>
+                  <a:srgbClr val="7A5410"/>
+                </a:solidFill>
+                <a:latin typeface="Noto Sans CJK SC"/>
+                <a:ea typeface="Noto Sans CJK SC"/>
+                <a:cs typeface="Noto Sans CJK SC"/>
               </a:rPr>
-              <a:t>05</a:t>
-            </a:r>
-          </a:p>
-        </p:txBody>
-      </p:sp>
-      <p:sp>
-        <p:nvSpPr>
-          <p:cNvPr id="24" name="n5_t" descr="Editable text; source id n5_t"/>
+              <a:t>类似物判据</a:t>
+            </a:r>
+          </a:p>
+        </p:txBody>
+      </p:sp>
+      <p:sp>
+        <p:nvSpPr>
+          <p:cNvPr id="33" name="n5_k0" descr="Editable text; source id n5_k0"/>
           <p:cNvSpPr txBox="1"/>
           <p:nvPr/>
         </p:nvSpPr>
         <p:spPr>
           <a:xfrm>
-            <a:off x="8470408" y="1279823"/>
-            <a:ext cx="1392088" cy="336795"/>
+            <a:off x="8545073" y="1749338"/>
+            <a:ext cx="1102972" cy="171968"/>
           </a:xfrm>
           <a:prstGeom prst="rect">
             <a:avLst/>
@@ -4673,9 +5111,9 @@
           </a:bodyPr>
           <a:lstStyle/>
           <a:p>
-            <a:pPr algn="ctr" fontAlgn="base">
+            <a:pPr algn="l" fontAlgn="base">
               <a:lnSpc>
-                <a:spcPts val="2574"/>
+                <a:spcPts val="968"/>
               </a:lnSpc>
               <a:spcBef>
                 <a:spcPts val="0"/>
@@ -4683,39 +5121,39 @@
               <a:spcAft>
                 <a:spcPts val="0"/>
               </a:spcAft>
-              <a:defRPr sz="1767" b="1" i="0" lang="zh-CN" dirty="0">
-                <a:solidFill>
-                  <a:srgbClr val="1F2326"/>
-                </a:solidFill>
-                <a:latin typeface="Noto Sans CJK SC"/>
-                <a:ea typeface="Noto Sans CJK SC"/>
-                <a:cs typeface="Noto Sans CJK SC"/>
+              <a:defRPr sz="828" b="0" i="0" lang="zh-CN" dirty="0">
+                <a:solidFill>
+                  <a:srgbClr val="3F4854"/>
+                </a:solidFill>
+                <a:latin typeface="DejaVu Sans"/>
+                <a:ea typeface="DejaVu Sans"/>
+                <a:cs typeface="DejaVu Sans"/>
               </a:defRPr>
             </a:pPr>
             <a:r>
-              <a:rPr sz="1767" b="1" i="0" lang="zh-CN" dirty="0">
-                <a:solidFill>
-                  <a:srgbClr val="1F2326"/>
-                </a:solidFill>
-                <a:latin typeface="Noto Sans CJK SC"/>
-                <a:ea typeface="Noto Sans CJK SC"/>
-                <a:cs typeface="Noto Sans CJK SC"/>
+              <a:rPr sz="828" b="0" i="0" lang="zh-CN" dirty="0">
+                <a:solidFill>
+                  <a:srgbClr val="3F4854"/>
+                </a:solidFill>
+                <a:latin typeface="DejaVu Sans"/>
+                <a:ea typeface="DejaVu Sans"/>
+                <a:cs typeface="DejaVu Sans"/>
               </a:rPr>
-              <a:t>类似物判据</a:t>
-            </a:r>
-          </a:p>
-        </p:txBody>
-      </p:sp>
-      <p:sp>
-        <p:nvSpPr>
-          <p:cNvPr id="25" name="n5_s" descr="Editable text; source id n5_s"/>
+              <a:t>Ba5Y12Zn[O(SiO4)]8</a:t>
+            </a:r>
+          </a:p>
+        </p:txBody>
+      </p:sp>
+      <p:sp>
+        <p:nvSpPr>
+          <p:cNvPr id="34" name="n5_n" descr="Editable text; source id n5_n"/>
           <p:cNvSpPr txBox="1"/>
           <p:nvPr/>
         </p:nvSpPr>
         <p:spPr>
           <a:xfrm>
-            <a:off x="8459182" y="1661524"/>
-            <a:ext cx="1414541" cy="224530"/>
+            <a:off x="8556933" y="1233431"/>
+            <a:ext cx="332077" cy="166038"/>
           </a:xfrm>
           <a:prstGeom prst="rect">
             <a:avLst/>
@@ -4729,9 +5167,9 @@
           </a:bodyPr>
           <a:lstStyle/>
           <a:p>
-            <a:pPr algn="ctr" fontAlgn="base">
+            <a:pPr algn="l" fontAlgn="base">
               <a:lnSpc>
-                <a:spcPts val="1248"/>
+                <a:spcPts val="1038"/>
               </a:lnSpc>
               <a:spcBef>
                 <a:spcPts val="0"/>
@@ -4739,9 +5177,9 @@
               <a:spcAft>
                 <a:spcPts val="0"/>
               </a:spcAft>
-              <a:defRPr sz="1063" b="0" i="0" lang="zh-CN" dirty="0">
-                <a:solidFill>
-                  <a:srgbClr val="3A4046"/>
+              <a:defRPr sz="887" b="1" i="0" lang="zh-CN" dirty="0">
+                <a:solidFill>
+                  <a:srgbClr val="8A9199"/>
                 </a:solidFill>
                 <a:latin typeface="DejaVu Sans"/>
                 <a:ea typeface="DejaVu Sans"/>
@@ -4749,22 +5187,22 @@
               </a:defRPr>
             </a:pPr>
             <a:r>
-              <a:rPr sz="1063" b="0" i="0" lang="zh-CN" dirty="0">
-                <a:solidFill>
-                  <a:srgbClr val="3A4046"/>
+              <a:rPr sz="887" b="1" i="0" lang="zh-CN" dirty="0">
+                <a:solidFill>
+                  <a:srgbClr val="8A9199"/>
                 </a:solidFill>
                 <a:latin typeface="DejaVu Sans"/>
                 <a:ea typeface="DejaVu Sans"/>
                 <a:cs typeface="DejaVu Sans"/>
               </a:rPr>
-              <a:t>Ba5Y12Zn[O(SiO4)]8</a:t>
+              <a:t>05</a:t>
             </a:r>
           </a:p>
         </p:txBody>
       </p:sp>
       <p:pic>
         <p:nvPicPr>
-          <p:cNvPr id="26" name="n5_i" descr="exact crop of source page_001 (monochrome line motif)"/>
+          <p:cNvPr id="35" name="n5_ic" descr="exact crop of the generated raster (line motif)"/>
           <p:cNvPicPr>
             <a:picLocks noChangeAspect="1"/>
           </p:cNvPicPr>
@@ -4778,8 +5216,8 @@
         </p:blipFill>
         <p:spPr>
           <a:xfrm>
-            <a:off x="8661259" y="2093745"/>
-            <a:ext cx="1027226" cy="853215"/>
+            <a:off x="8746692" y="2602392"/>
+            <a:ext cx="699735" cy="665877"/>
           </a:xfrm>
           <a:prstGeom prst="rect">
             <a:avLst/>
@@ -4789,26 +5227,26 @@
       </p:pic>
       <p:sp>
         <p:nvSpPr>
-          <p:cNvPr id="27" name="n6" descr="Editable shape; source id n6"/>
+          <p:cNvPr id="36" name="n6" descr="Editable shape; source id n6"/>
           <p:cNvSpPr/>
           <p:nvPr/>
         </p:nvSpPr>
         <p:spPr>
           <a:xfrm>
-            <a:off x="10564154" y="875668"/>
-            <a:ext cx="1408928" cy="2194784"/>
+            <a:off x="10555330" y="1126692"/>
+            <a:ext cx="1269011" cy="2490583"/>
           </a:xfrm>
           <a:prstGeom prst="roundRect">
             <a:avLst>
-              <a:gd name="adj" fmla="val 5577"/>
+              <a:gd name="adj" fmla="val 4672"/>
             </a:avLst>
           </a:prstGeom>
           <a:solidFill>
             <a:srgbClr val="FFFFFF"/>
           </a:solidFill>
-          <a:ln w="14033">
+          <a:ln w="8894">
             <a:solidFill>
-              <a:srgbClr val="4A5158"/>
+              <a:srgbClr val="1F7F8C"/>
             </a:solidFill>
           </a:ln>
           <a:effectLst/>
@@ -4837,14 +5275,60 @@
       </p:sp>
       <p:sp>
         <p:nvSpPr>
-          <p:cNvPr id="28" name="n6_n" descr="Editable text; source id n6_n"/>
+          <p:cNvPr id="37" name="n6_s" descr="Editable shape; source id n6_s"/>
+          <p:cNvSpPr/>
+          <p:nvPr/>
+        </p:nvSpPr>
+        <p:spPr>
+          <a:xfrm>
+            <a:off x="10555330" y="1126692"/>
+            <a:ext cx="1269011" cy="47439"/>
+          </a:xfrm>
+          <a:prstGeom prst="roundRect">
+            <a:avLst>
+              <a:gd name="adj" fmla="val 50000"/>
+            </a:avLst>
+          </a:prstGeom>
+          <a:solidFill>
+            <a:srgbClr val="1F7F8C"/>
+          </a:solidFill>
+          <a:ln>
+            <a:noFill/>
+          </a:ln>
+          <a:effectLst/>
+        </p:spPr>
+        <p:style>
+          <a:lnRef idx="1">
+            <a:schemeClr val="accent1"/>
+          </a:lnRef>
+          <a:fillRef idx="3">
+            <a:schemeClr val="accent1"/>
+          </a:fillRef>
+          <a:effectRef idx="0">
+            <a:schemeClr val="accent1"/>
+          </a:effectRef>
+          <a:fontRef idx="minor">
+            <a:schemeClr val="lt1"/>
+          </a:fontRef>
+        </p:style>
+        <p:txBody>
+          <a:bodyPr rtlCol="0" anchor="ctr"/>
+          <a:lstStyle/>
+          <a:p>
+            <a:pPr algn="ctr"/>
+          </a:p>
+        </p:txBody>
+      </p:sp>
+      <p:sp>
+        <p:nvSpPr>
+          <p:cNvPr id="38" name="n6_t" descr="Editable text; source id n6_t"/>
           <p:cNvSpPr txBox="1"/>
           <p:nvPr/>
         </p:nvSpPr>
         <p:spPr>
           <a:xfrm>
-            <a:off x="10653966" y="943027"/>
-            <a:ext cx="392928" cy="190850"/>
+            <a:off x="10638349" y="1482490"/>
+            <a:ext cx="1102972" cy="219408"/>
           </a:xfrm>
           <a:prstGeom prst="rect">
             <a:avLst/>
@@ -4860,7 +5344,7 @@
           <a:p>
             <a:pPr algn="l" fontAlgn="base">
               <a:lnSpc>
-                <a:spcPts val="1138"/>
+                <a:spcPts val="1692"/>
               </a:lnSpc>
               <a:spcBef>
                 <a:spcPts val="0"/>
@@ -4868,39 +5352,39 @@
               <a:spcAft>
                 <a:spcPts val="0"/>
               </a:spcAft>
-              <a:defRPr sz="972" b="1" i="0" lang="zh-CN" dirty="0">
-                <a:solidFill>
-                  <a:srgbClr val="8A9199"/>
-                </a:solidFill>
-                <a:latin typeface="DejaVu Sans"/>
-                <a:ea typeface="DejaVu Sans"/>
-                <a:cs typeface="DejaVu Sans"/>
+              <a:defRPr sz="1167" b="1" i="0" lang="zh-CN" dirty="0">
+                <a:solidFill>
+                  <a:srgbClr val="0F4F58"/>
+                </a:solidFill>
+                <a:latin typeface="Noto Sans CJK SC"/>
+                <a:ea typeface="Noto Sans CJK SC"/>
+                <a:cs typeface="Noto Sans CJK SC"/>
               </a:defRPr>
             </a:pPr>
             <a:r>
-              <a:rPr sz="972" b="1" i="0" lang="zh-CN" dirty="0">
-                <a:solidFill>
-                  <a:srgbClr val="8A9199"/>
-                </a:solidFill>
-                <a:latin typeface="DejaVu Sans"/>
-                <a:ea typeface="DejaVu Sans"/>
-                <a:cs typeface="DejaVu Sans"/>
+              <a:rPr sz="1167" b="1" i="0" lang="zh-CN" dirty="0">
+                <a:solidFill>
+                  <a:srgbClr val="0F4F58"/>
+                </a:solidFill>
+                <a:latin typeface="Noto Sans CJK SC"/>
+                <a:ea typeface="Noto Sans CJK SC"/>
+                <a:cs typeface="Noto Sans CJK SC"/>
               </a:rPr>
-              <a:t>06</a:t>
-            </a:r>
-          </a:p>
-        </p:txBody>
-      </p:sp>
-      <p:sp>
-        <p:nvSpPr>
-          <p:cNvPr id="29" name="n6_t" descr="Editable text; source id n6_t"/>
+              <a:t>实验优先级</a:t>
+            </a:r>
+          </a:p>
+        </p:txBody>
+      </p:sp>
+      <p:sp>
+        <p:nvSpPr>
+          <p:cNvPr id="39" name="n6_k0" descr="Editable text; source id n6_k0"/>
           <p:cNvSpPr txBox="1"/>
           <p:nvPr/>
         </p:nvSpPr>
         <p:spPr>
           <a:xfrm>
-            <a:off x="10620287" y="1279823"/>
-            <a:ext cx="1296662" cy="336795"/>
+            <a:off x="10638349" y="1749338"/>
+            <a:ext cx="1102972" cy="171968"/>
           </a:xfrm>
           <a:prstGeom prst="rect">
             <a:avLst/>
@@ -4914,9 +5398,9 @@
           </a:bodyPr>
           <a:lstStyle/>
           <a:p>
-            <a:pPr algn="ctr" fontAlgn="base">
+            <a:pPr algn="l" fontAlgn="base">
               <a:lnSpc>
-                <a:spcPts val="2574"/>
+                <a:spcPts val="1214"/>
               </a:lnSpc>
               <a:spcBef>
                 <a:spcPts val="0"/>
@@ -4924,9 +5408,9 @@
               <a:spcAft>
                 <a:spcPts val="0"/>
               </a:spcAft>
-              <a:defRPr sz="1767" b="1" i="0" lang="zh-CN" dirty="0">
-                <a:solidFill>
-                  <a:srgbClr val="1F2326"/>
+              <a:defRPr sz="828" b="0" i="0" lang="zh-CN" dirty="0">
+                <a:solidFill>
+                  <a:srgbClr val="3F4854"/>
                 </a:solidFill>
                 <a:latin typeface="Noto Sans CJK SC"/>
                 <a:ea typeface="Noto Sans CJK SC"/>
@@ -4934,29 +5418,73 @@
               </a:defRPr>
             </a:pPr>
             <a:r>
-              <a:rPr sz="1767" b="1" i="0" lang="zh-CN" dirty="0">
-                <a:solidFill>
-                  <a:srgbClr val="1F2326"/>
+              <a:rPr sz="828" b="0" i="0" lang="zh-CN" dirty="0">
+                <a:solidFill>
+                  <a:srgbClr val="3F4854"/>
                 </a:solidFill>
                 <a:latin typeface="Noto Sans CJK SC"/>
                 <a:ea typeface="Noto Sans CJK SC"/>
                 <a:cs typeface="Noto Sans CJK SC"/>
               </a:rPr>
-              <a:t>实验优先级</a:t>
-            </a:r>
-          </a:p>
-        </p:txBody>
-      </p:sp>
-      <p:sp>
-        <p:nvSpPr>
-          <p:cNvPr id="30" name="n6_s" descr="Editable text; source id n6_s"/>
+              <a:t>相图</a:t>
+            </a:r>
+            <a:r>
+              <a:rPr sz="828" b="0" i="0" lang="zh-CN" dirty="0">
+                <a:solidFill>
+                  <a:srgbClr val="3F4854"/>
+                </a:solidFill>
+                <a:latin typeface="DejaVu Sans"/>
+                <a:ea typeface="DejaVu Sans"/>
+                <a:cs typeface="DejaVu Sans"/>
+              </a:rPr>
+              <a:t> · </a:t>
+            </a:r>
+            <a:r>
+              <a:rPr sz="828" b="0" i="0" lang="zh-CN" dirty="0">
+                <a:solidFill>
+                  <a:srgbClr val="3F4854"/>
+                </a:solidFill>
+                <a:latin typeface="Noto Sans CJK SC"/>
+                <a:ea typeface="Noto Sans CJK SC"/>
+                <a:cs typeface="Noto Sans CJK SC"/>
+              </a:rPr>
+              <a:t>结构</a:t>
+            </a:r>
+            <a:r>
+              <a:rPr sz="828" b="0" i="0" lang="zh-CN" dirty="0">
+                <a:solidFill>
+                  <a:srgbClr val="3F4854"/>
+                </a:solidFill>
+                <a:latin typeface="DejaVu Sans"/>
+                <a:ea typeface="DejaVu Sans"/>
+                <a:cs typeface="DejaVu Sans"/>
+              </a:rPr>
+              <a:t> · </a:t>
+            </a:r>
+            <a:r>
+              <a:rPr sz="828" b="0" i="0" lang="zh-CN" dirty="0">
+                <a:solidFill>
+                  <a:srgbClr val="3F4854"/>
+                </a:solidFill>
+                <a:latin typeface="Noto Sans CJK SC"/>
+                <a:ea typeface="Noto Sans CJK SC"/>
+                <a:cs typeface="Noto Sans CJK SC"/>
+              </a:rPr>
+              <a:t>热力学</a:t>
+            </a:r>
+          </a:p>
+        </p:txBody>
+      </p:sp>
+      <p:sp>
+        <p:nvSpPr>
+          <p:cNvPr id="40" name="n6_n" descr="Editable text; source id n6_n"/>
           <p:cNvSpPr txBox="1"/>
           <p:nvPr/>
         </p:nvSpPr>
         <p:spPr>
           <a:xfrm>
-            <a:off x="10609060" y="1661524"/>
-            <a:ext cx="1319115" cy="224530"/>
+            <a:off x="10650209" y="1233431"/>
+            <a:ext cx="332077" cy="166038"/>
           </a:xfrm>
           <a:prstGeom prst="rect">
             <a:avLst/>
@@ -4970,9 +5498,9 @@
           </a:bodyPr>
           <a:lstStyle/>
           <a:p>
-            <a:pPr algn="ctr" fontAlgn="base">
+            <a:pPr algn="l" fontAlgn="base">
               <a:lnSpc>
-                <a:spcPts val="1546"/>
+                <a:spcPts val="1038"/>
               </a:lnSpc>
               <a:spcBef>
                 <a:spcPts val="0"/>
@@ -4980,76 +5508,32 @@
               <a:spcAft>
                 <a:spcPts val="0"/>
               </a:spcAft>
-              <a:defRPr sz="1063" b="0" i="0" lang="zh-CN" dirty="0">
-                <a:solidFill>
-                  <a:srgbClr val="3A4046"/>
-                </a:solidFill>
-                <a:latin typeface="Noto Sans CJK SC"/>
-                <a:ea typeface="Noto Sans CJK SC"/>
-                <a:cs typeface="Noto Sans CJK SC"/>
+              <a:defRPr sz="887" b="1" i="0" lang="zh-CN" dirty="0">
+                <a:solidFill>
+                  <a:srgbClr val="8A9199"/>
+                </a:solidFill>
+                <a:latin typeface="DejaVu Sans"/>
+                <a:ea typeface="DejaVu Sans"/>
+                <a:cs typeface="DejaVu Sans"/>
               </a:defRPr>
             </a:pPr>
             <a:r>
-              <a:rPr sz="1063" b="0" i="0" lang="zh-CN" dirty="0">
-                <a:solidFill>
-                  <a:srgbClr val="3A4046"/>
-                </a:solidFill>
-                <a:latin typeface="Noto Sans CJK SC"/>
-                <a:ea typeface="Noto Sans CJK SC"/>
-                <a:cs typeface="Noto Sans CJK SC"/>
-              </a:rPr>
-              <a:t>相图</a:t>
-            </a:r>
-            <a:r>
-              <a:rPr sz="1063" b="0" i="0" lang="zh-CN" dirty="0">
-                <a:solidFill>
-                  <a:srgbClr val="3A4046"/>
+              <a:rPr sz="887" b="1" i="0" lang="zh-CN" dirty="0">
+                <a:solidFill>
+                  <a:srgbClr val="8A9199"/>
                 </a:solidFill>
                 <a:latin typeface="DejaVu Sans"/>
                 <a:ea typeface="DejaVu Sans"/>
                 <a:cs typeface="DejaVu Sans"/>
               </a:rPr>
-              <a:t> · </a:t>
-            </a:r>
-            <a:r>
-              <a:rPr sz="1063" b="0" i="0" lang="zh-CN" dirty="0">
-                <a:solidFill>
-                  <a:srgbClr val="3A4046"/>
-                </a:solidFill>
-                <a:latin typeface="Noto Sans CJK SC"/>
-                <a:ea typeface="Noto Sans CJK SC"/>
-                <a:cs typeface="Noto Sans CJK SC"/>
-              </a:rPr>
-              <a:t>结构</a:t>
-            </a:r>
-            <a:r>
-              <a:rPr sz="1063" b="0" i="0" lang="zh-CN" dirty="0">
-                <a:solidFill>
-                  <a:srgbClr val="3A4046"/>
-                </a:solidFill>
-                <a:latin typeface="DejaVu Sans"/>
-                <a:ea typeface="DejaVu Sans"/>
-                <a:cs typeface="DejaVu Sans"/>
-              </a:rPr>
-              <a:t> · </a:t>
-            </a:r>
-            <a:r>
-              <a:rPr sz="1063" b="0" i="0" lang="zh-CN" dirty="0">
-                <a:solidFill>
-                  <a:srgbClr val="3A4046"/>
-                </a:solidFill>
-                <a:latin typeface="Noto Sans CJK SC"/>
-                <a:ea typeface="Noto Sans CJK SC"/>
-                <a:cs typeface="Noto Sans CJK SC"/>
-              </a:rPr>
-              <a:t>热力学</a:t>
+              <a:t>06</a:t>
             </a:r>
           </a:p>
         </p:txBody>
       </p:sp>
       <p:pic>
         <p:nvPicPr>
-          <p:cNvPr id="31" name="n6_i" descr="exact crop of source page_001 (monochrome line motif)"/>
+          <p:cNvPr id="41" name="n6_ic" descr="exact crop of the generated raster (line motif)"/>
           <p:cNvPicPr>
             <a:picLocks noChangeAspect="1"/>
           </p:cNvPicPr>
@@ -5063,8 +5547,8 @@
         </p:blipFill>
         <p:spPr>
           <a:xfrm>
-            <a:off x="10811137" y="2093745"/>
-            <a:ext cx="1066519" cy="841988"/>
+            <a:off x="10839968" y="2522486"/>
+            <a:ext cx="699735" cy="825687"/>
           </a:xfrm>
           <a:prstGeom prst="rect">
             <a:avLst/>
@@ -5074,14 +5558,118 @@
       </p:pic>
       <p:sp>
         <p:nvSpPr>
-          <p:cNvPr id="32" name="e0" descr="Editable line; source id e0"/>
+          <p:cNvPr id="42" name="e0_p" descr="Editable shape; source id e0_p"/>
           <p:cNvSpPr/>
           <p:nvPr/>
         </p:nvSpPr>
         <p:spPr>
           <a:xfrm>
-            <a:off x="1644685" y="1813083"/>
-            <a:ext cx="533260" cy="101039"/>
+            <a:off x="1767128" y="2253385"/>
+            <a:ext cx="664155" cy="243128"/>
+          </a:xfrm>
+          <a:prstGeom prst="roundRect">
+            <a:avLst>
+              <a:gd name="adj" fmla="val 50000"/>
+            </a:avLst>
+          </a:prstGeom>
+          <a:solidFill>
+            <a:srgbClr val="FFFFFF"/>
+          </a:solidFill>
+          <a:ln w="7115">
+            <a:solidFill>
+              <a:srgbClr val="C6CCD1"/>
+            </a:solidFill>
+          </a:ln>
+          <a:effectLst/>
+        </p:spPr>
+        <p:style>
+          <a:lnRef idx="1">
+            <a:schemeClr val="accent1"/>
+          </a:lnRef>
+          <a:fillRef idx="3">
+            <a:schemeClr val="accent1"/>
+          </a:fillRef>
+          <a:effectRef idx="0">
+            <a:schemeClr val="accent1"/>
+          </a:effectRef>
+          <a:fontRef idx="minor">
+            <a:schemeClr val="lt1"/>
+          </a:fontRef>
+        </p:style>
+        <p:txBody>
+          <a:bodyPr rtlCol="0" anchor="ctr"/>
+          <a:lstStyle/>
+          <a:p>
+            <a:pPr algn="ctr"/>
+          </a:p>
+        </p:txBody>
+      </p:sp>
+      <p:sp>
+        <p:nvSpPr>
+          <p:cNvPr id="43" name="e0_p_t" descr="Editable text; source id e0_p_t"/>
+          <p:cNvSpPr txBox="1"/>
+          <p:nvPr/>
+        </p:nvSpPr>
+        <p:spPr>
+          <a:xfrm>
+            <a:off x="1838287" y="2277105"/>
+            <a:ext cx="521836" cy="183828"/>
+          </a:xfrm>
+          <a:prstGeom prst="rect">
+            <a:avLst/>
+          </a:prstGeom>
+          <a:noFill/>
+          <a:effectLst/>
+        </p:spPr>
+        <p:txBody>
+          <a:bodyPr wrap="none" anchor="ctr" tIns="0" rIns="0" bIns="0" lIns="0" anchorCtr="0" vertOverflow="overflow">
+            <a:noAutofit/>
+          </a:bodyPr>
+          <a:lstStyle/>
+          <a:p>
+            <a:pPr algn="ctr" fontAlgn="base">
+              <a:lnSpc>
+                <a:spcPts val="1225"/>
+              </a:lnSpc>
+              <a:spcBef>
+                <a:spcPts val="0"/>
+              </a:spcBef>
+              <a:spcAft>
+                <a:spcPts val="0"/>
+              </a:spcAft>
+              <a:defRPr sz="840" b="0" i="0" lang="zh-CN" dirty="0">
+                <a:solidFill>
+                  <a:srgbClr val="3F4854"/>
+                </a:solidFill>
+                <a:latin typeface="Noto Sans CJK SC"/>
+                <a:ea typeface="Noto Sans CJK SC"/>
+                <a:cs typeface="Noto Sans CJK SC"/>
+              </a:defRPr>
+            </a:pPr>
+            <a:r>
+              <a:rPr sz="840" b="0" i="0" lang="zh-CN" dirty="0">
+                <a:solidFill>
+                  <a:srgbClr val="3F4854"/>
+                </a:solidFill>
+                <a:latin typeface="Noto Sans CJK SC"/>
+                <a:ea typeface="Noto Sans CJK SC"/>
+                <a:cs typeface="Noto Sans CJK SC"/>
+              </a:rPr>
+              <a:t>结构约束</a:t>
+            </a:r>
+          </a:p>
+        </p:txBody>
+      </p:sp>
+      <p:sp>
+        <p:nvSpPr>
+          <p:cNvPr id="44" name="e0_0" descr="Editable line; source id e0_0"/>
+          <p:cNvSpPr/>
+          <p:nvPr/>
+        </p:nvSpPr>
+        <p:spPr>
+          <a:xfrm>
+            <a:off x="1707829" y="2339370"/>
+            <a:ext cx="776825" cy="65230"/>
           </a:xfrm>
           <a:custGeom>
             <a:avLst/>
@@ -5090,34 +5678,34 @@
             <a:cxnLst/>
             <a:rect l="l" t="t" r="r" b="b"/>
             <a:pathLst>
-              <a:path w="95000" h="18000">
+              <a:path w="131000" h="11000">
                 <a:moveTo>
-                  <a:pt x="0" y="6500"/>
+                  <a:pt x="0" y="4500"/>
                 </a:moveTo>
                 <a:lnTo>
-                  <a:pt x="77000" y="6500"/>
+                  <a:pt x="118000" y="4500"/>
                 </a:lnTo>
                 <a:lnTo>
-                  <a:pt x="77000" y="0"/>
+                  <a:pt x="118000" y="0"/>
                 </a:lnTo>
                 <a:lnTo>
-                  <a:pt x="95000" y="9000"/>
+                  <a:pt x="131000" y="5500"/>
                 </a:lnTo>
                 <a:lnTo>
-                  <a:pt x="77000" y="18000"/>
+                  <a:pt x="118000" y="11000"/>
                 </a:lnTo>
                 <a:lnTo>
-                  <a:pt x="77000" y="11500"/>
+                  <a:pt x="118000" y="6500"/>
                 </a:lnTo>
                 <a:lnTo>
-                  <a:pt x="0" y="11500"/>
+                  <a:pt x="0" y="6500"/>
                 </a:lnTo>
                 <a:close/>
               </a:path>
             </a:pathLst>
           </a:custGeom>
           <a:solidFill>
-            <a:srgbClr val="1F6F78"/>
+            <a:srgbClr val="4B5563"/>
           </a:solidFill>
           <a:ln>
             <a:noFill/>
@@ -5148,14 +5736,62 @@
       </p:sp>
       <p:sp>
         <p:nvSpPr>
-          <p:cNvPr id="33" name="e0_l" descr="Editable text; source id e0_l"/>
+          <p:cNvPr id="45" name="e1_p" descr="Editable shape; source id e1_p"/>
+          <p:cNvSpPr/>
+          <p:nvPr/>
+        </p:nvSpPr>
+        <p:spPr>
+          <a:xfrm>
+            <a:off x="3854474" y="2253385"/>
+            <a:ext cx="664155" cy="243128"/>
+          </a:xfrm>
+          <a:prstGeom prst="roundRect">
+            <a:avLst>
+              <a:gd name="adj" fmla="val 50000"/>
+            </a:avLst>
+          </a:prstGeom>
+          <a:solidFill>
+            <a:srgbClr val="FFFFFF"/>
+          </a:solidFill>
+          <a:ln w="7115">
+            <a:solidFill>
+              <a:srgbClr val="C6CCD1"/>
+            </a:solidFill>
+          </a:ln>
+          <a:effectLst/>
+        </p:spPr>
+        <p:style>
+          <a:lnRef idx="1">
+            <a:schemeClr val="accent1"/>
+          </a:lnRef>
+          <a:fillRef idx="3">
+            <a:schemeClr val="accent1"/>
+          </a:fillRef>
+          <a:effectRef idx="0">
+            <a:schemeClr val="accent1"/>
+          </a:effectRef>
+          <a:fontRef idx="minor">
+            <a:schemeClr val="lt1"/>
+          </a:fontRef>
+        </p:style>
+        <p:txBody>
+          <a:bodyPr rtlCol="0" anchor="ctr"/>
+          <a:lstStyle/>
+          <a:p>
+            <a:pPr algn="ctr"/>
+          </a:p>
+        </p:txBody>
+      </p:sp>
+      <p:sp>
+        <p:nvSpPr>
+          <p:cNvPr id="46" name="e1_p_t" descr="Editable text; source id e1_p_t"/>
           <p:cNvSpPr txBox="1"/>
           <p:nvPr/>
         </p:nvSpPr>
         <p:spPr>
           <a:xfrm>
-            <a:off x="1650298" y="1605392"/>
-            <a:ext cx="527646" cy="179624"/>
+            <a:off x="3925634" y="2277105"/>
+            <a:ext cx="521836" cy="183828"/>
           </a:xfrm>
           <a:prstGeom prst="rect">
             <a:avLst/>
@@ -5171,7 +5807,7 @@
           <a:p>
             <a:pPr algn="ctr" fontAlgn="base">
               <a:lnSpc>
-                <a:spcPts val="1292"/>
+                <a:spcPts val="1225"/>
               </a:lnSpc>
               <a:spcBef>
                 <a:spcPts val="0"/>
@@ -5179,9 +5815,9 @@
               <a:spcAft>
                 <a:spcPts val="0"/>
               </a:spcAft>
-              <a:defRPr sz="883" b="0" i="0" lang="zh-CN" dirty="0">
-                <a:solidFill>
-                  <a:srgbClr val="3A4046"/>
+              <a:defRPr sz="840" b="0" i="0" lang="zh-CN" dirty="0">
+                <a:solidFill>
+                  <a:srgbClr val="3F4854"/>
                 </a:solidFill>
                 <a:latin typeface="Noto Sans CJK SC"/>
                 <a:ea typeface="Noto Sans CJK SC"/>
@@ -5189,29 +5825,29 @@
               </a:defRPr>
             </a:pPr>
             <a:r>
-              <a:rPr sz="883" b="0" i="0" lang="zh-CN" dirty="0">
-                <a:solidFill>
-                  <a:srgbClr val="3A4046"/>
+              <a:rPr sz="840" b="0" i="0" lang="zh-CN" dirty="0">
+                <a:solidFill>
+                  <a:srgbClr val="3F4854"/>
                 </a:solidFill>
                 <a:latin typeface="Noto Sans CJK SC"/>
                 <a:ea typeface="Noto Sans CJK SC"/>
                 <a:cs typeface="Noto Sans CJK SC"/>
               </a:rPr>
-              <a:t>结构约束</a:t>
-            </a:r>
-          </a:p>
-        </p:txBody>
-      </p:sp>
-      <p:sp>
-        <p:nvSpPr>
-          <p:cNvPr id="34" name="e1" descr="Editable line; source id e1"/>
+              <a:t>条件窗口</a:t>
+            </a:r>
+          </a:p>
+        </p:txBody>
+      </p:sp>
+      <p:sp>
+        <p:nvSpPr>
+          <p:cNvPr id="47" name="e1_0" descr="Editable line; source id e1_0"/>
           <p:cNvSpPr/>
           <p:nvPr/>
         </p:nvSpPr>
         <p:spPr>
           <a:xfrm>
-            <a:off x="3704751" y="1813083"/>
-            <a:ext cx="533260" cy="101039"/>
+            <a:off x="3801105" y="2339370"/>
+            <a:ext cx="776825" cy="65230"/>
           </a:xfrm>
           <a:custGeom>
             <a:avLst/>
@@ -5220,34 +5856,34 @@
             <a:cxnLst/>
             <a:rect l="l" t="t" r="r" b="b"/>
             <a:pathLst>
-              <a:path w="95000" h="18000">
+              <a:path w="131000" h="11000">
                 <a:moveTo>
-                  <a:pt x="0" y="6500"/>
+                  <a:pt x="0" y="4500"/>
                 </a:moveTo>
                 <a:lnTo>
-                  <a:pt x="77000" y="6500"/>
+                  <a:pt x="118000" y="4500"/>
                 </a:lnTo>
                 <a:lnTo>
-                  <a:pt x="77000" y="0"/>
+                  <a:pt x="118000" y="0"/>
                 </a:lnTo>
                 <a:lnTo>
-                  <a:pt x="95000" y="9000"/>
+                  <a:pt x="131000" y="5500"/>
                 </a:lnTo>
                 <a:lnTo>
-                  <a:pt x="77000" y="18000"/>
+                  <a:pt x="118000" y="11000"/>
                 </a:lnTo>
                 <a:lnTo>
-                  <a:pt x="77000" y="11500"/>
+                  <a:pt x="118000" y="6500"/>
                 </a:lnTo>
                 <a:lnTo>
-                  <a:pt x="0" y="11500"/>
+                  <a:pt x="0" y="6500"/>
                 </a:lnTo>
                 <a:close/>
               </a:path>
             </a:pathLst>
           </a:custGeom>
           <a:solidFill>
-            <a:srgbClr val="1F6F78"/>
+            <a:srgbClr val="4B5563"/>
           </a:solidFill>
           <a:ln>
             <a:noFill/>
@@ -5278,14 +5914,62 @@
       </p:sp>
       <p:sp>
         <p:nvSpPr>
-          <p:cNvPr id="35" name="e1_l" descr="Editable text; source id e1_l"/>
+          <p:cNvPr id="48" name="e2_p" descr="Editable shape; source id e2_p"/>
+          <p:cNvSpPr/>
+          <p:nvPr/>
+        </p:nvSpPr>
+        <p:spPr>
+          <a:xfrm>
+            <a:off x="5734272" y="2253385"/>
+            <a:ext cx="770894" cy="243128"/>
+          </a:xfrm>
+          <a:prstGeom prst="roundRect">
+            <a:avLst>
+              <a:gd name="adj" fmla="val 50000"/>
+            </a:avLst>
+          </a:prstGeom>
+          <a:solidFill>
+            <a:srgbClr val="FFFFFF"/>
+          </a:solidFill>
+          <a:ln w="7115">
+            <a:solidFill>
+              <a:srgbClr val="C6CCD1"/>
+            </a:solidFill>
+          </a:ln>
+          <a:effectLst/>
+        </p:spPr>
+        <p:style>
+          <a:lnRef idx="1">
+            <a:schemeClr val="accent1"/>
+          </a:lnRef>
+          <a:fillRef idx="3">
+            <a:schemeClr val="accent1"/>
+          </a:fillRef>
+          <a:effectRef idx="0">
+            <a:schemeClr val="accent1"/>
+          </a:effectRef>
+          <a:fontRef idx="minor">
+            <a:schemeClr val="lt1"/>
+          </a:fontRef>
+        </p:style>
+        <p:txBody>
+          <a:bodyPr rtlCol="0" anchor="ctr"/>
+          <a:lstStyle/>
+          <a:p>
+            <a:pPr algn="ctr"/>
+          </a:p>
+        </p:txBody>
+      </p:sp>
+      <p:sp>
+        <p:nvSpPr>
+          <p:cNvPr id="49" name="e2_p_t" descr="Editable text; source id e2_p_t"/>
           <p:cNvSpPr txBox="1"/>
           <p:nvPr/>
         </p:nvSpPr>
         <p:spPr>
           <a:xfrm>
-            <a:off x="3704751" y="1605392"/>
-            <a:ext cx="527646" cy="179624"/>
+            <a:off x="5805431" y="2277105"/>
+            <a:ext cx="628575" cy="183828"/>
           </a:xfrm>
           <a:prstGeom prst="rect">
             <a:avLst/>
@@ -5301,7 +5985,7 @@
           <a:p>
             <a:pPr algn="ctr" fontAlgn="base">
               <a:lnSpc>
-                <a:spcPts val="1292"/>
+                <a:spcPts val="1225"/>
               </a:lnSpc>
               <a:spcBef>
                 <a:spcPts val="0"/>
@@ -5309,9 +5993,9 @@
               <a:spcAft>
                 <a:spcPts val="0"/>
               </a:spcAft>
-              <a:defRPr sz="883" b="0" i="0" lang="zh-CN" dirty="0">
-                <a:solidFill>
-                  <a:srgbClr val="3A4046"/>
+              <a:defRPr sz="840" b="0" i="0" lang="zh-CN" dirty="0">
+                <a:solidFill>
+                  <a:srgbClr val="3F4854"/>
                 </a:solidFill>
                 <a:latin typeface="Noto Sans CJK SC"/>
                 <a:ea typeface="Noto Sans CJK SC"/>
@@ -5319,29 +6003,29 @@
               </a:defRPr>
             </a:pPr>
             <a:r>
-              <a:rPr sz="883" b="0" i="0" lang="zh-CN" dirty="0">
-                <a:solidFill>
-                  <a:srgbClr val="3A4046"/>
+              <a:rPr sz="840" b="0" i="0" lang="zh-CN" dirty="0">
+                <a:solidFill>
+                  <a:srgbClr val="3F4854"/>
                 </a:solidFill>
                 <a:latin typeface="Noto Sans CJK SC"/>
                 <a:ea typeface="Noto Sans CJK SC"/>
                 <a:cs typeface="Noto Sans CJK SC"/>
               </a:rPr>
-              <a:t>条件窗口</a:t>
-            </a:r>
-          </a:p>
-        </p:txBody>
-      </p:sp>
-      <p:sp>
-        <p:nvSpPr>
-          <p:cNvPr id="36" name="e2" descr="Editable line; source id e2"/>
+              <a:t>可迁移变量</a:t>
+            </a:r>
+          </a:p>
+        </p:txBody>
+      </p:sp>
+      <p:sp>
+        <p:nvSpPr>
+          <p:cNvPr id="50" name="e2_0" descr="Editable line; source id e2_0"/>
           <p:cNvSpPr/>
           <p:nvPr/>
         </p:nvSpPr>
         <p:spPr>
           <a:xfrm>
-            <a:off x="5753591" y="1813083"/>
-            <a:ext cx="572552" cy="101039"/>
+            <a:off x="5894381" y="2339370"/>
+            <a:ext cx="450677" cy="65230"/>
           </a:xfrm>
           <a:custGeom>
             <a:avLst/>
@@ -5350,34 +6034,34 @@
             <a:cxnLst/>
             <a:rect l="l" t="t" r="r" b="b"/>
             <a:pathLst>
-              <a:path w="102000" h="18000">
+              <a:path w="76000" h="11000">
                 <a:moveTo>
-                  <a:pt x="0" y="6500"/>
+                  <a:pt x="0" y="4500"/>
                 </a:moveTo>
                 <a:lnTo>
-                  <a:pt x="84000" y="6500"/>
+                  <a:pt x="63000" y="4500"/>
                 </a:lnTo>
                 <a:lnTo>
-                  <a:pt x="84000" y="0"/>
+                  <a:pt x="63000" y="0"/>
                 </a:lnTo>
                 <a:lnTo>
-                  <a:pt x="102000" y="9000"/>
+                  <a:pt x="76000" y="5500"/>
                 </a:lnTo>
                 <a:lnTo>
-                  <a:pt x="84000" y="18000"/>
+                  <a:pt x="63000" y="11000"/>
                 </a:lnTo>
                 <a:lnTo>
-                  <a:pt x="84000" y="11500"/>
+                  <a:pt x="63000" y="6500"/>
                 </a:lnTo>
                 <a:lnTo>
-                  <a:pt x="0" y="11500"/>
+                  <a:pt x="0" y="6500"/>
                 </a:lnTo>
                 <a:close/>
               </a:path>
             </a:pathLst>
           </a:custGeom>
           <a:solidFill>
-            <a:srgbClr val="1F6F78"/>
+            <a:srgbClr val="4B5563"/>
           </a:solidFill>
           <a:ln>
             <a:noFill/>
@@ -5408,14 +6092,62 @@
       </p:sp>
       <p:sp>
         <p:nvSpPr>
-          <p:cNvPr id="37" name="e2_l" descr="Editable text; source id e2_l"/>
+          <p:cNvPr id="51" name="e3_p" descr="Editable shape; source id e3_p"/>
+          <p:cNvSpPr/>
+          <p:nvPr/>
+        </p:nvSpPr>
+        <p:spPr>
+          <a:xfrm>
+            <a:off x="7720809" y="2253385"/>
+            <a:ext cx="664155" cy="243128"/>
+          </a:xfrm>
+          <a:prstGeom prst="roundRect">
+            <a:avLst>
+              <a:gd name="adj" fmla="val 50000"/>
+            </a:avLst>
+          </a:prstGeom>
+          <a:solidFill>
+            <a:srgbClr val="FFFFFF"/>
+          </a:solidFill>
+          <a:ln w="7115">
+            <a:solidFill>
+              <a:srgbClr val="C6CCD1"/>
+            </a:solidFill>
+          </a:ln>
+          <a:effectLst/>
+        </p:spPr>
+        <p:style>
+          <a:lnRef idx="1">
+            <a:schemeClr val="accent1"/>
+          </a:lnRef>
+          <a:fillRef idx="3">
+            <a:schemeClr val="accent1"/>
+          </a:fillRef>
+          <a:effectRef idx="0">
+            <a:schemeClr val="accent1"/>
+          </a:effectRef>
+          <a:fontRef idx="minor">
+            <a:schemeClr val="lt1"/>
+          </a:fontRef>
+        </p:style>
+        <p:txBody>
+          <a:bodyPr rtlCol="0" anchor="ctr"/>
+          <a:lstStyle/>
+          <a:p>
+            <a:pPr algn="ctr"/>
+          </a:p>
+        </p:txBody>
+      </p:sp>
+      <p:sp>
+        <p:nvSpPr>
+          <p:cNvPr id="52" name="e3_p_t" descr="Editable text; source id e3_p_t"/>
           <p:cNvSpPr txBox="1"/>
           <p:nvPr/>
         </p:nvSpPr>
         <p:spPr>
           <a:xfrm>
-            <a:off x="5719911" y="1605392"/>
-            <a:ext cx="639911" cy="179624"/>
+            <a:off x="7791968" y="2277105"/>
+            <a:ext cx="521836" cy="183828"/>
           </a:xfrm>
           <a:prstGeom prst="rect">
             <a:avLst/>
@@ -5431,7 +6163,7 @@
           <a:p>
             <a:pPr algn="ctr" fontAlgn="base">
               <a:lnSpc>
-                <a:spcPts val="1292"/>
+                <a:spcPts val="1225"/>
               </a:lnSpc>
               <a:spcBef>
                 <a:spcPts val="0"/>
@@ -5439,9 +6171,9 @@
               <a:spcAft>
                 <a:spcPts val="0"/>
               </a:spcAft>
-              <a:defRPr sz="883" b="0" i="0" lang="zh-CN" dirty="0">
-                <a:solidFill>
-                  <a:srgbClr val="3A4046"/>
+              <a:defRPr sz="840" b="0" i="0" lang="zh-CN" dirty="0">
+                <a:solidFill>
+                  <a:srgbClr val="3F4854"/>
                 </a:solidFill>
                 <a:latin typeface="Noto Sans CJK SC"/>
                 <a:ea typeface="Noto Sans CJK SC"/>
@@ -5449,29 +6181,29 @@
               </a:defRPr>
             </a:pPr>
             <a:r>
-              <a:rPr sz="883" b="0" i="0" lang="zh-CN" dirty="0">
-                <a:solidFill>
-                  <a:srgbClr val="3A4046"/>
+              <a:rPr sz="840" b="0" i="0" lang="zh-CN" dirty="0">
+                <a:solidFill>
+                  <a:srgbClr val="3F4854"/>
                 </a:solidFill>
                 <a:latin typeface="Noto Sans CJK SC"/>
                 <a:ea typeface="Noto Sans CJK SC"/>
                 <a:cs typeface="Noto Sans CJK SC"/>
               </a:rPr>
-              <a:t>可迁移变量</a:t>
-            </a:r>
-          </a:p>
-        </p:txBody>
-      </p:sp>
-      <p:sp>
-        <p:nvSpPr>
-          <p:cNvPr id="38" name="e3" descr="Editable line; source id e3"/>
+              <a:t>比较边界</a:t>
+            </a:r>
+          </a:p>
+        </p:txBody>
+      </p:sp>
+      <p:sp>
+        <p:nvSpPr>
+          <p:cNvPr id="53" name="e3_0" descr="Editable line; source id e3_0"/>
           <p:cNvSpPr/>
           <p:nvPr/>
         </p:nvSpPr>
         <p:spPr>
           <a:xfrm>
-            <a:off x="7830497" y="1813083"/>
-            <a:ext cx="527646" cy="101039"/>
+            <a:off x="7661510" y="2339370"/>
+            <a:ext cx="776825" cy="65230"/>
           </a:xfrm>
           <a:custGeom>
             <a:avLst/>
@@ -5480,34 +6212,34 @@
             <a:cxnLst/>
             <a:rect l="l" t="t" r="r" b="b"/>
             <a:pathLst>
-              <a:path w="94000" h="18000">
+              <a:path w="131000" h="11000">
                 <a:moveTo>
-                  <a:pt x="0" y="6500"/>
+                  <a:pt x="0" y="4500"/>
                 </a:moveTo>
                 <a:lnTo>
-                  <a:pt x="76000" y="6500"/>
+                  <a:pt x="118000" y="4500"/>
                 </a:lnTo>
                 <a:lnTo>
-                  <a:pt x="76000" y="0"/>
+                  <a:pt x="118000" y="0"/>
                 </a:lnTo>
                 <a:lnTo>
-                  <a:pt x="94000" y="9000"/>
+                  <a:pt x="131000" y="5500"/>
                 </a:lnTo>
                 <a:lnTo>
-                  <a:pt x="76000" y="18000"/>
+                  <a:pt x="118000" y="11000"/>
                 </a:lnTo>
                 <a:lnTo>
-                  <a:pt x="76000" y="11500"/>
+                  <a:pt x="118000" y="6500"/>
                 </a:lnTo>
                 <a:lnTo>
-                  <a:pt x="0" y="11500"/>
+                  <a:pt x="0" y="6500"/>
                 </a:lnTo>
                 <a:close/>
               </a:path>
             </a:pathLst>
           </a:custGeom>
           <a:solidFill>
-            <a:srgbClr val="1F6F78"/>
+            <a:srgbClr val="4B5563"/>
           </a:solidFill>
           <a:ln>
             <a:noFill/>
@@ -5538,14 +6270,62 @@
       </p:sp>
       <p:sp>
         <p:nvSpPr>
-          <p:cNvPr id="39" name="e3_l" descr="Editable text; source id e3_l"/>
+          <p:cNvPr id="54" name="e4_p" descr="Editable shape; source id e4_p"/>
+          <p:cNvSpPr/>
+          <p:nvPr/>
+        </p:nvSpPr>
+        <p:spPr>
+          <a:xfrm>
+            <a:off x="9808155" y="2253385"/>
+            <a:ext cx="664155" cy="243128"/>
+          </a:xfrm>
+          <a:prstGeom prst="roundRect">
+            <a:avLst>
+              <a:gd name="adj" fmla="val 50000"/>
+            </a:avLst>
+          </a:prstGeom>
+          <a:solidFill>
+            <a:srgbClr val="FFFFFF"/>
+          </a:solidFill>
+          <a:ln w="7115">
+            <a:solidFill>
+              <a:srgbClr val="C6CCD1"/>
+            </a:solidFill>
+          </a:ln>
+          <a:effectLst/>
+        </p:spPr>
+        <p:style>
+          <a:lnRef idx="1">
+            <a:schemeClr val="accent1"/>
+          </a:lnRef>
+          <a:fillRef idx="3">
+            <a:schemeClr val="accent1"/>
+          </a:fillRef>
+          <a:effectRef idx="0">
+            <a:schemeClr val="accent1"/>
+          </a:effectRef>
+          <a:fontRef idx="minor">
+            <a:schemeClr val="lt1"/>
+          </a:fontRef>
+        </p:style>
+        <p:txBody>
+          <a:bodyPr rtlCol="0" anchor="ctr"/>
+          <a:lstStyle/>
+          <a:p>
+            <a:pPr algn="ctr"/>
+          </a:p>
+        </p:txBody>
+      </p:sp>
+      <p:sp>
+        <p:nvSpPr>
+          <p:cNvPr id="55" name="e4_p_t" descr="Editable text; source id e4_p_t"/>
           <p:cNvSpPr txBox="1"/>
           <p:nvPr/>
         </p:nvSpPr>
         <p:spPr>
           <a:xfrm>
-            <a:off x="7830497" y="1605392"/>
-            <a:ext cx="527646" cy="179624"/>
+            <a:off x="9879314" y="2277105"/>
+            <a:ext cx="521836" cy="183828"/>
           </a:xfrm>
           <a:prstGeom prst="rect">
             <a:avLst/>
@@ -5561,7 +6341,7 @@
           <a:p>
             <a:pPr algn="ctr" fontAlgn="base">
               <a:lnSpc>
-                <a:spcPts val="1292"/>
+                <a:spcPts val="1225"/>
               </a:lnSpc>
               <a:spcBef>
                 <a:spcPts val="0"/>
@@ -5569,9 +6349,9 @@
               <a:spcAft>
                 <a:spcPts val="0"/>
               </a:spcAft>
-              <a:defRPr sz="883" b="0" i="0" lang="zh-CN" dirty="0">
-                <a:solidFill>
-                  <a:srgbClr val="3A4046"/>
+              <a:defRPr sz="840" b="0" i="0" lang="zh-CN" dirty="0">
+                <a:solidFill>
+                  <a:srgbClr val="3F4854"/>
                 </a:solidFill>
                 <a:latin typeface="Noto Sans CJK SC"/>
                 <a:ea typeface="Noto Sans CJK SC"/>
@@ -5579,29 +6359,29 @@
               </a:defRPr>
             </a:pPr>
             <a:r>
-              <a:rPr sz="883" b="0" i="0" lang="zh-CN" dirty="0">
-                <a:solidFill>
-                  <a:srgbClr val="3A4046"/>
+              <a:rPr sz="840" b="0" i="0" lang="zh-CN" dirty="0">
+                <a:solidFill>
+                  <a:srgbClr val="3F4854"/>
                 </a:solidFill>
                 <a:latin typeface="Noto Sans CJK SC"/>
                 <a:ea typeface="Noto Sans CJK SC"/>
                 <a:cs typeface="Noto Sans CJK SC"/>
               </a:rPr>
-              <a:t>比较边界</a:t>
-            </a:r>
-          </a:p>
-        </p:txBody>
-      </p:sp>
-      <p:sp>
-        <p:nvSpPr>
-          <p:cNvPr id="40" name="e4" descr="Editable line; source id e4"/>
+              <a:t>缺口驱动</a:t>
+            </a:r>
+          </a:p>
+        </p:txBody>
+      </p:sp>
+      <p:sp>
+        <p:nvSpPr>
+          <p:cNvPr id="56" name="e4_0" descr="Editable line; source id e4_0"/>
           <p:cNvSpPr/>
           <p:nvPr/>
         </p:nvSpPr>
         <p:spPr>
           <a:xfrm>
-            <a:off x="9974762" y="1813083"/>
-            <a:ext cx="533260" cy="101039"/>
+            <a:off x="9754786" y="2339370"/>
+            <a:ext cx="776825" cy="65230"/>
           </a:xfrm>
           <a:custGeom>
             <a:avLst/>
@@ -5610,34 +6390,34 @@
             <a:cxnLst/>
             <a:rect l="l" t="t" r="r" b="b"/>
             <a:pathLst>
-              <a:path w="95000" h="18000">
+              <a:path w="131000" h="11000">
                 <a:moveTo>
-                  <a:pt x="0" y="6500"/>
+                  <a:pt x="0" y="4500"/>
                 </a:moveTo>
                 <a:lnTo>
-                  <a:pt x="77000" y="6500"/>
+                  <a:pt x="118000" y="4500"/>
                 </a:lnTo>
                 <a:lnTo>
-                  <a:pt x="77000" y="0"/>
+                  <a:pt x="118000" y="0"/>
                 </a:lnTo>
                 <a:lnTo>
-                  <a:pt x="95000" y="9000"/>
+                  <a:pt x="131000" y="5500"/>
                 </a:lnTo>
                 <a:lnTo>
-                  <a:pt x="77000" y="18000"/>
+                  <a:pt x="118000" y="11000"/>
                 </a:lnTo>
                 <a:lnTo>
-                  <a:pt x="77000" y="11500"/>
+                  <a:pt x="118000" y="6500"/>
                 </a:lnTo>
                 <a:lnTo>
-                  <a:pt x="0" y="11500"/>
+                  <a:pt x="0" y="6500"/>
                 </a:lnTo>
                 <a:close/>
               </a:path>
             </a:pathLst>
           </a:custGeom>
           <a:solidFill>
-            <a:srgbClr val="1F6F78"/>
+            <a:srgbClr val="4B5563"/>
           </a:solidFill>
           <a:ln>
             <a:noFill/>
@@ -5666,98 +6446,6 @@
           </a:p>
         </p:txBody>
       </p:sp>
-      <p:sp>
-        <p:nvSpPr>
-          <p:cNvPr id="41" name="e4_l" descr="Editable text; source id e4_l"/>
-          <p:cNvSpPr txBox="1"/>
-          <p:nvPr/>
-        </p:nvSpPr>
-        <p:spPr>
-          <a:xfrm>
-            <a:off x="9980375" y="1605392"/>
-            <a:ext cx="527646" cy="179624"/>
-          </a:xfrm>
-          <a:prstGeom prst="rect">
-            <a:avLst/>
-          </a:prstGeom>
-          <a:noFill/>
-          <a:effectLst/>
-        </p:spPr>
-        <p:txBody>
-          <a:bodyPr wrap="none" anchor="ctr" tIns="0" rIns="0" bIns="0" lIns="0" anchorCtr="0" vertOverflow="overflow">
-            <a:noAutofit/>
-          </a:bodyPr>
-          <a:lstStyle/>
-          <a:p>
-            <a:pPr algn="ctr" fontAlgn="base">
-              <a:lnSpc>
-                <a:spcPts val="1292"/>
-              </a:lnSpc>
-              <a:spcBef>
-                <a:spcPts val="0"/>
-              </a:spcBef>
-              <a:spcAft>
-                <a:spcPts val="0"/>
-              </a:spcAft>
-              <a:defRPr sz="883" b="0" i="0" lang="zh-CN" dirty="0">
-                <a:solidFill>
-                  <a:srgbClr val="3A4046"/>
-                </a:solidFill>
-                <a:latin typeface="Noto Sans CJK SC"/>
-                <a:ea typeface="Noto Sans CJK SC"/>
-                <a:cs typeface="Noto Sans CJK SC"/>
-              </a:defRPr>
-            </a:pPr>
-            <a:r>
-              <a:rPr sz="883" b="0" i="0" lang="zh-CN" dirty="0">
-                <a:solidFill>
-                  <a:srgbClr val="3A4046"/>
-                </a:solidFill>
-                <a:latin typeface="Noto Sans CJK SC"/>
-                <a:ea typeface="Noto Sans CJK SC"/>
-                <a:cs typeface="Noto Sans CJK SC"/>
-              </a:rPr>
-              <a:t>缺口驱动</a:t>
-            </a:r>
-          </a:p>
-        </p:txBody>
-      </p:sp>
-      <p:cxnSp>
-        <p:nvCxnSpPr>
-          <p:cNvPr id="42" name="base" descr="Editable line; source id base"/>
-          <p:cNvCxnSpPr/>
-          <p:nvPr/>
-        </p:nvCxnSpPr>
-        <p:spPr>
-          <a:xfrm>
-            <a:off x="207690" y="3210784"/>
-            <a:ext cx="11771005" cy="0"/>
-          </a:xfrm>
-          <a:prstGeom prst="line">
-            <a:avLst/>
-          </a:prstGeom>
-          <a:ln w="22453">
-            <a:solidFill>
-              <a:srgbClr val="C9CFD4"/>
-            </a:solidFill>
-          </a:ln>
-          <a:effectLst/>
-        </p:spPr>
-        <p:style>
-          <a:lnRef idx="2">
-            <a:schemeClr val="accent1"/>
-          </a:lnRef>
-          <a:fillRef idx="0">
-            <a:schemeClr val="accent1"/>
-          </a:fillRef>
-          <a:effectRef idx="0">
-            <a:schemeClr val="accent1"/>
-          </a:effectRef>
-          <a:fontRef idx="minor">
-            <a:schemeClr val="tx1"/>
-          </a:fontRef>
-        </p:style>
-      </p:cxnSp>
     </p:spTree>
   </p:cSld>
   <p:clrMapOvr>

</xml_diff>

<commit_message>
dashboard: 2026-09-13 23:35 刷新
</commit_message>
<xml_diff>
--- a/media/figstudio/bzso_roadmap/roadmap_bazn2si2o7_editable.pptx
+++ b/media/figstudio/bzso_roadmap/roadmap_bazn2si2o7_editable.pptx
@@ -7,7 +7,7 @@
   <p:sldIdLst>
     <p:sldId id="256" r:id="rId7"/>
   </p:sldIdLst>
-  <p:sldSz cx="12191999" cy="4063999" type="screen4x3"/>
+  <p:sldSz cx="12191999" cy="7143749" type="screen4x3"/>
   <p:notesSz cx="6858000" cy="9144000"/>
   <p:defaultTextStyle>
     <a:defPPr>
@@ -502,7 +502,7 @@
           <a:lstStyle/>
           <a:p>
             <a:r>
-              <a:t>BaZn2Si2O7 综述路线图（super_teaser 第四轮 R05 → super_img2ppt 重建）</a:t>
+              <a:t>BaZn2Si2O7 综述路线图（super_teaser 第四轮 R05 → super_img2ppt 重建；单行六卡改为 3+3 两行，为的是在 \linewidth 下卡内文字仍可读）</a:t>
             </a:r>
           </a:p>
         </p:txBody>
@@ -3524,18 +3524,18 @@
         </p:nvSpPr>
         <p:spPr>
           <a:xfrm>
-            <a:off x="190850" y="471513"/>
-            <a:ext cx="5759204" cy="3177104"/>
+            <a:off x="238124" y="317499"/>
+            <a:ext cx="11715749" cy="3095624"/>
           </a:xfrm>
           <a:prstGeom prst="roundRect">
             <a:avLst>
-              <a:gd name="adj" fmla="val 2473"/>
+              <a:gd name="adj" fmla="val 3589"/>
             </a:avLst>
           </a:prstGeom>
           <a:solidFill>
             <a:srgbClr val="EEF2F7"/>
           </a:solidFill>
-          <a:ln w="6735">
+          <a:ln w="9524">
             <a:solidFill>
               <a:srgbClr val="5B7592"/>
             </a:solidFill>
@@ -3572,8 +3572,8 @@
         </p:nvSpPr>
         <p:spPr>
           <a:xfrm>
-            <a:off x="291889" y="3384795"/>
-            <a:ext cx="639911" cy="207690"/>
+            <a:off x="380999" y="396874"/>
+            <a:ext cx="968374" cy="317499"/>
           </a:xfrm>
           <a:prstGeom prst="rect">
             <a:avLst/>
@@ -3589,7 +3589,7 @@
           <a:p>
             <a:pPr algn="l" fontAlgn="base">
               <a:lnSpc>
-                <a:spcPts val="1359"/>
+                <a:spcPts val="2093"/>
               </a:lnSpc>
               <a:spcBef>
                 <a:spcPts val="0"/>
@@ -3597,7 +3597,7 @@
               <a:spcAft>
                 <a:spcPts val="0"/>
               </a:spcAft>
-              <a:defRPr sz="928" b="1" i="0" lang="zh-CN" dirty="0">
+              <a:defRPr sz="1437" b="1" i="0" lang="zh-CN" dirty="0">
                 <a:solidFill>
                   <a:srgbClr val="2B3E57"/>
                 </a:solidFill>
@@ -3607,7 +3607,7 @@
               </a:defRPr>
             </a:pPr>
             <a:r>
-              <a:rPr sz="928" b="1" i="0" lang="zh-CN" dirty="0">
+              <a:rPr sz="1437" b="1" i="0" lang="zh-CN" dirty="0">
                 <a:solidFill>
                   <a:srgbClr val="2B3E57"/>
                 </a:solidFill>
@@ -3628,18 +3628,18 @@
         </p:nvSpPr>
         <p:spPr>
           <a:xfrm>
-            <a:off x="6365436" y="471513"/>
-            <a:ext cx="5736751" cy="3177104"/>
+            <a:off x="238124" y="3730624"/>
+            <a:ext cx="11715749" cy="3095624"/>
           </a:xfrm>
           <a:prstGeom prst="roundRect">
             <a:avLst>
-              <a:gd name="adj" fmla="val 2473"/>
+              <a:gd name="adj" fmla="val 3589"/>
             </a:avLst>
           </a:prstGeom>
           <a:solidFill>
             <a:srgbClr val="E6F2F3"/>
           </a:solidFill>
-          <a:ln w="6735">
+          <a:ln w="9524">
             <a:solidFill>
               <a:srgbClr val="1F7F8C"/>
             </a:solidFill>
@@ -3676,8 +3676,8 @@
         </p:nvSpPr>
         <p:spPr>
           <a:xfrm>
-            <a:off x="6466474" y="3384795"/>
-            <a:ext cx="639911" cy="207690"/>
+            <a:off x="380999" y="3809999"/>
+            <a:ext cx="968374" cy="317499"/>
           </a:xfrm>
           <a:prstGeom prst="rect">
             <a:avLst/>
@@ -3693,7 +3693,7 @@
           <a:p>
             <a:pPr algn="l" fontAlgn="base">
               <a:lnSpc>
-                <a:spcPts val="1359"/>
+                <a:spcPts val="2093"/>
               </a:lnSpc>
               <a:spcBef>
                 <a:spcPts val="0"/>
@@ -3701,7 +3701,7 @@
               <a:spcAft>
                 <a:spcPts val="0"/>
               </a:spcAft>
-              <a:defRPr sz="928" b="1" i="0" lang="zh-CN" dirty="0">
+              <a:defRPr sz="1437" b="1" i="0" lang="zh-CN" dirty="0">
                 <a:solidFill>
                   <a:srgbClr val="0F4F58"/>
                 </a:solidFill>
@@ -3711,7 +3711,7 @@
               </a:defRPr>
             </a:pPr>
             <a:r>
-              <a:rPr sz="928" b="1" i="0" lang="zh-CN" dirty="0">
+              <a:rPr sz="1437" b="1" i="0" lang="zh-CN" dirty="0">
                 <a:solidFill>
                   <a:srgbClr val="0F4F58"/>
                 </a:solidFill>
@@ -3732,18 +3732,18 @@
         </p:nvSpPr>
         <p:spPr>
           <a:xfrm>
-            <a:off x="336795" y="819535"/>
-            <a:ext cx="1403314" cy="2469834"/>
+            <a:off x="714374" y="793749"/>
+            <a:ext cx="3016249" cy="2301874"/>
           </a:xfrm>
           <a:prstGeom prst="roundRect">
             <a:avLst>
-              <a:gd name="adj" fmla="val 3599"/>
+              <a:gd name="adj" fmla="val 3103"/>
             </a:avLst>
           </a:prstGeom>
           <a:solidFill>
             <a:srgbClr val="FFFFFF"/>
           </a:solidFill>
-          <a:ln w="7858">
+          <a:ln w="11112">
             <a:solidFill>
               <a:srgbClr val="5B7592"/>
             </a:solidFill>
@@ -3780,8 +3780,8 @@
         </p:nvSpPr>
         <p:spPr>
           <a:xfrm>
-            <a:off x="336795" y="819535"/>
-            <a:ext cx="1403314" cy="33679"/>
+            <a:off x="714374" y="793749"/>
+            <a:ext cx="3016249" cy="47624"/>
           </a:xfrm>
           <a:prstGeom prst="roundRect">
             <a:avLst>
@@ -3826,8 +3826,8 @@
         </p:nvSpPr>
         <p:spPr>
           <a:xfrm>
-            <a:off x="437834" y="1291049"/>
-            <a:ext cx="1201237" cy="218917"/>
+            <a:off x="888999" y="1127124"/>
+            <a:ext cx="2666999" cy="341312"/>
           </a:xfrm>
           <a:prstGeom prst="rect">
             <a:avLst/>
@@ -3843,7 +3843,7 @@
           <a:p>
             <a:pPr algn="ctr" fontAlgn="base">
               <a:lnSpc>
-                <a:spcPts val="1701"/>
+                <a:spcPts val="2656"/>
               </a:lnSpc>
               <a:spcBef>
                 <a:spcPts val="0"/>
@@ -3851,7 +3851,7 @@
               <a:spcAft>
                 <a:spcPts val="0"/>
               </a:spcAft>
-              <a:defRPr sz="1171" b="1" i="0" lang="zh-CN" dirty="0">
+              <a:defRPr sz="1832" b="1" i="0" lang="zh-CN" dirty="0">
                 <a:solidFill>
                   <a:srgbClr val="2B3E57"/>
                 </a:solidFill>
@@ -3861,7 +3861,7 @@
               </a:defRPr>
             </a:pPr>
             <a:r>
-              <a:rPr sz="1171" b="1" i="0" lang="zh-CN" dirty="0">
+              <a:rPr sz="1832" b="1" i="0" lang="zh-CN" dirty="0">
                 <a:solidFill>
                   <a:srgbClr val="2B3E57"/>
                 </a:solidFill>
@@ -3882,8 +3882,8 @@
         </p:nvSpPr>
         <p:spPr>
           <a:xfrm>
-            <a:off x="437834" y="931801"/>
-            <a:ext cx="303116" cy="157171"/>
+            <a:off x="888999" y="904874"/>
+            <a:ext cx="428624" cy="206374"/>
           </a:xfrm>
           <a:prstGeom prst="rect">
             <a:avLst/>
@@ -3899,7 +3899,7 @@
           <a:p>
             <a:pPr algn="l" fontAlgn="base">
               <a:lnSpc>
-                <a:spcPts val="928"/>
+                <a:spcPts val="1468"/>
               </a:lnSpc>
               <a:spcBef>
                 <a:spcPts val="0"/>
@@ -3907,7 +3907,7 @@
               <a:spcAft>
                 <a:spcPts val="0"/>
               </a:spcAft>
-              <a:defRPr sz="795" b="1" i="0" lang="zh-CN" dirty="0">
+              <a:defRPr sz="1249" b="1" i="0" lang="zh-CN" dirty="0">
                 <a:solidFill>
                   <a:srgbClr val="97A3AE"/>
                 </a:solidFill>
@@ -3917,7 +3917,7 @@
               </a:defRPr>
             </a:pPr>
             <a:r>
-              <a:rPr sz="795" b="1" i="0" lang="zh-CN" dirty="0">
+              <a:rPr sz="1249" b="1" i="0" lang="zh-CN" dirty="0">
                 <a:solidFill>
                   <a:srgbClr val="97A3AE"/>
                 </a:solidFill>
@@ -3938,13 +3938,13 @@
         </p:nvCxnSpPr>
         <p:spPr>
           <a:xfrm>
-            <a:off x="1038453" y="1947801"/>
-            <a:ext cx="196464" cy="129105"/>
+            <a:off x="2222499" y="1643062"/>
+            <a:ext cx="293688" cy="190500"/>
           </a:xfrm>
           <a:prstGeom prst="line">
             <a:avLst/>
           </a:prstGeom>
-          <a:ln w="9879">
+          <a:ln w="14604">
             <a:solidFill>
               <a:srgbClr val="1F2937"/>
             </a:solidFill>
@@ -3974,13 +3974,13 @@
         </p:nvCxnSpPr>
         <p:spPr>
           <a:xfrm flipH="1">
-            <a:off x="1145104" y="2076906"/>
-            <a:ext cx="89813" cy="263823"/>
+            <a:off x="2381249" y="1833562"/>
+            <a:ext cx="134938" cy="396875"/>
           </a:xfrm>
           <a:prstGeom prst="line">
             <a:avLst/>
           </a:prstGeom>
-          <a:ln w="9879">
+          <a:ln w="14604">
             <a:solidFill>
               <a:srgbClr val="1F2937"/>
             </a:solidFill>
@@ -4010,13 +4010,13 @@
         </p:nvCxnSpPr>
         <p:spPr>
           <a:xfrm flipH="1">
-            <a:off x="931801" y="2340729"/>
-            <a:ext cx="213303" cy="0"/>
+            <a:off x="2063749" y="2230437"/>
+            <a:ext cx="317500" cy="0"/>
           </a:xfrm>
           <a:prstGeom prst="line">
             <a:avLst/>
           </a:prstGeom>
-          <a:ln w="9879">
+          <a:ln w="14604">
             <a:solidFill>
               <a:srgbClr val="1F2937"/>
             </a:solidFill>
@@ -4046,13 +4046,13 @@
         </p:nvCxnSpPr>
         <p:spPr>
           <a:xfrm flipH="1" flipV="1">
-            <a:off x="841988" y="2076906"/>
-            <a:ext cx="89813" cy="263823"/>
+            <a:off x="1928812" y="1833562"/>
+            <a:ext cx="134937" cy="396875"/>
           </a:xfrm>
           <a:prstGeom prst="line">
             <a:avLst/>
           </a:prstGeom>
-          <a:ln w="9879">
+          <a:ln w="14604">
             <a:solidFill>
               <a:srgbClr val="1F2937"/>
             </a:solidFill>
@@ -4082,13 +4082,13 @@
         </p:nvCxnSpPr>
         <p:spPr>
           <a:xfrm flipV="1">
-            <a:off x="841988" y="1947801"/>
-            <a:ext cx="196465" cy="129105"/>
+            <a:off x="1928812" y="1643062"/>
+            <a:ext cx="293687" cy="190500"/>
           </a:xfrm>
           <a:prstGeom prst="line">
             <a:avLst/>
           </a:prstGeom>
-          <a:ln w="9879">
+          <a:ln w="14604">
             <a:solidFill>
               <a:srgbClr val="1F2937"/>
             </a:solidFill>
@@ -4118,13 +4118,13 @@
         </p:nvCxnSpPr>
         <p:spPr>
           <a:xfrm>
-            <a:off x="1038453" y="1947801"/>
-            <a:ext cx="0" cy="392928"/>
+            <a:off x="2222499" y="1643062"/>
+            <a:ext cx="0" cy="587375"/>
           </a:xfrm>
           <a:prstGeom prst="line">
             <a:avLst/>
           </a:prstGeom>
-          <a:ln w="9879">
+          <a:ln w="14604">
             <a:solidFill>
               <a:srgbClr val="1F2937"/>
             </a:solidFill>
@@ -4154,13 +4154,13 @@
         </p:nvCxnSpPr>
         <p:spPr>
           <a:xfrm>
-            <a:off x="841988" y="2076906"/>
-            <a:ext cx="392929" cy="0"/>
+            <a:off x="1928812" y="1833562"/>
+            <a:ext cx="587375" cy="0"/>
           </a:xfrm>
           <a:prstGeom prst="line">
             <a:avLst/>
           </a:prstGeom>
-          <a:ln w="9879">
+          <a:ln w="14604">
             <a:solidFill>
               <a:srgbClr val="1F2937"/>
             </a:solidFill>
@@ -4190,18 +4190,18 @@
         </p:nvSpPr>
         <p:spPr>
           <a:xfrm>
-            <a:off x="426607" y="2615778"/>
-            <a:ext cx="1223690" cy="370475"/>
+            <a:off x="904874" y="2428874"/>
+            <a:ext cx="2635249" cy="492124"/>
           </a:xfrm>
           <a:prstGeom prst="roundRect">
             <a:avLst>
-              <a:gd name="adj" fmla="val 9090"/>
+              <a:gd name="adj" fmla="val 9677"/>
             </a:avLst>
           </a:prstGeom>
           <a:solidFill>
             <a:srgbClr val="F7F9FB"/>
           </a:solidFill>
-          <a:ln w="6735">
+          <a:ln w="9524">
             <a:solidFill>
               <a:srgbClr val="CBD3DA"/>
             </a:solidFill>
@@ -4238,8 +4238,8 @@
         </p:nvSpPr>
         <p:spPr>
           <a:xfrm>
-            <a:off x="465900" y="2638231"/>
-            <a:ext cx="1145104" cy="325569"/>
+            <a:off x="960437" y="2460624"/>
+            <a:ext cx="2524124" cy="428624"/>
           </a:xfrm>
           <a:prstGeom prst="rect">
             <a:avLst/>
@@ -4255,7 +4255,7 @@
           <a:p>
             <a:pPr algn="ctr" fontAlgn="base">
               <a:lnSpc>
-                <a:spcPts val="1160"/>
+                <a:spcPts val="2015"/>
               </a:lnSpc>
               <a:spcBef>
                 <a:spcPts val="0"/>
@@ -4263,7 +4263,7 @@
               <a:spcAft>
                 <a:spcPts val="0"/>
               </a:spcAft>
-              <a:defRPr sz="795" b="0" i="0" lang="zh-CN" dirty="0">
+              <a:defRPr sz="1374" b="0" i="0" lang="zh-CN" dirty="0">
                 <a:solidFill>
                   <a:srgbClr val="3F4854"/>
                 </a:solidFill>
@@ -4273,7 +4273,7 @@
               </a:defRPr>
             </a:pPr>
             <a:r>
-              <a:rPr sz="795" b="0" i="0" lang="zh-CN" dirty="0">
+              <a:rPr sz="1374" b="0" i="0" lang="zh-CN" dirty="0">
                 <a:solidFill>
                   <a:srgbClr val="3F4854"/>
                 </a:solidFill>
@@ -4294,18 +4294,18 @@
         </p:nvSpPr>
         <p:spPr>
           <a:xfrm>
-            <a:off x="2357569" y="819535"/>
-            <a:ext cx="1403314" cy="2469834"/>
+            <a:off x="4683124" y="793749"/>
+            <a:ext cx="3016249" cy="2301874"/>
           </a:xfrm>
           <a:prstGeom prst="roundRect">
             <a:avLst>
-              <a:gd name="adj" fmla="val 3599"/>
+              <a:gd name="adj" fmla="val 3103"/>
             </a:avLst>
           </a:prstGeom>
           <a:solidFill>
             <a:srgbClr val="FFFFFF"/>
           </a:solidFill>
-          <a:ln w="7858">
+          <a:ln w="11112">
             <a:solidFill>
               <a:srgbClr val="5B7592"/>
             </a:solidFill>
@@ -4342,8 +4342,8 @@
         </p:nvSpPr>
         <p:spPr>
           <a:xfrm>
-            <a:off x="2357569" y="819535"/>
-            <a:ext cx="1403314" cy="33679"/>
+            <a:off x="4683124" y="793749"/>
+            <a:ext cx="3016249" cy="47624"/>
           </a:xfrm>
           <a:prstGeom prst="roundRect">
             <a:avLst>
@@ -4388,8 +4388,8 @@
         </p:nvSpPr>
         <p:spPr>
           <a:xfrm>
-            <a:off x="2458607" y="1291049"/>
-            <a:ext cx="1201237" cy="218917"/>
+            <a:off x="4857749" y="1127124"/>
+            <a:ext cx="2666999" cy="341312"/>
           </a:xfrm>
           <a:prstGeom prst="rect">
             <a:avLst/>
@@ -4405,7 +4405,7 @@
           <a:p>
             <a:pPr algn="ctr" fontAlgn="base">
               <a:lnSpc>
-                <a:spcPts val="1701"/>
+                <a:spcPts val="2656"/>
               </a:lnSpc>
               <a:spcBef>
                 <a:spcPts val="0"/>
@@ -4413,7 +4413,7 @@
               <a:spcAft>
                 <a:spcPts val="0"/>
               </a:spcAft>
-              <a:defRPr sz="1171" b="1" i="0" lang="zh-CN" dirty="0">
+              <a:defRPr sz="1832" b="1" i="0" lang="zh-CN" dirty="0">
                 <a:solidFill>
                   <a:srgbClr val="2B3E57"/>
                 </a:solidFill>
@@ -4423,7 +4423,7 @@
               </a:defRPr>
             </a:pPr>
             <a:r>
-              <a:rPr sz="1171" b="1" i="0" lang="zh-CN" dirty="0">
+              <a:rPr sz="1832" b="1" i="0" lang="zh-CN" dirty="0">
                 <a:solidFill>
                   <a:srgbClr val="2B3E57"/>
                 </a:solidFill>
@@ -4444,8 +4444,8 @@
         </p:nvSpPr>
         <p:spPr>
           <a:xfrm>
-            <a:off x="2458607" y="931801"/>
-            <a:ext cx="303116" cy="157171"/>
+            <a:off x="4857749" y="904874"/>
+            <a:ext cx="428624" cy="206374"/>
           </a:xfrm>
           <a:prstGeom prst="rect">
             <a:avLst/>
@@ -4461,7 +4461,7 @@
           <a:p>
             <a:pPr algn="l" fontAlgn="base">
               <a:lnSpc>
-                <a:spcPts val="928"/>
+                <a:spcPts val="1468"/>
               </a:lnSpc>
               <a:spcBef>
                 <a:spcPts val="0"/>
@@ -4469,7 +4469,7 @@
               <a:spcAft>
                 <a:spcPts val="0"/>
               </a:spcAft>
-              <a:defRPr sz="795" b="1" i="0" lang="zh-CN" dirty="0">
+              <a:defRPr sz="1249" b="1" i="0" lang="zh-CN" dirty="0">
                 <a:solidFill>
                   <a:srgbClr val="97A3AE"/>
                 </a:solidFill>
@@ -4479,7 +4479,7 @@
               </a:defRPr>
             </a:pPr>
             <a:r>
-              <a:rPr sz="795" b="1" i="0" lang="zh-CN" dirty="0">
+              <a:rPr sz="1249" b="1" i="0" lang="zh-CN" dirty="0">
                 <a:solidFill>
                   <a:srgbClr val="97A3AE"/>
                 </a:solidFill>
@@ -4500,13 +4500,13 @@
         </p:nvCxnSpPr>
         <p:spPr>
           <a:xfrm>
-            <a:off x="2918894" y="2054452"/>
-            <a:ext cx="50520" cy="269437"/>
+            <a:off x="5984874" y="1809749"/>
+            <a:ext cx="71438" cy="388938"/>
           </a:xfrm>
           <a:prstGeom prst="line">
             <a:avLst/>
           </a:prstGeom>
-          <a:ln w="9879">
+          <a:ln w="14604">
             <a:solidFill>
               <a:srgbClr val="1F2937"/>
             </a:solidFill>
@@ -4536,13 +4536,13 @@
         </p:nvCxnSpPr>
         <p:spPr>
           <a:xfrm>
-            <a:off x="2969414" y="2323889"/>
-            <a:ext cx="179624" cy="0"/>
+            <a:off x="6056312" y="2198687"/>
+            <a:ext cx="269875" cy="0"/>
           </a:xfrm>
           <a:prstGeom prst="line">
             <a:avLst/>
           </a:prstGeom>
-          <a:ln w="9879">
+          <a:ln w="14604">
             <a:solidFill>
               <a:srgbClr val="1F2937"/>
             </a:solidFill>
@@ -4572,13 +4572,13 @@
         </p:nvCxnSpPr>
         <p:spPr>
           <a:xfrm flipV="1">
-            <a:off x="3149038" y="2054452"/>
-            <a:ext cx="50519" cy="269437"/>
+            <a:off x="6326187" y="1809749"/>
+            <a:ext cx="71437" cy="388938"/>
           </a:xfrm>
           <a:prstGeom prst="line">
             <a:avLst/>
           </a:prstGeom>
-          <a:ln w="9879">
+          <a:ln w="14604">
             <a:solidFill>
               <a:srgbClr val="1F2937"/>
             </a:solidFill>
@@ -4608,13 +4608,13 @@
         </p:nvCxnSpPr>
         <p:spPr>
           <a:xfrm>
-            <a:off x="2890828" y="2054452"/>
-            <a:ext cx="336796" cy="0"/>
+            <a:off x="5945187" y="1809749"/>
+            <a:ext cx="492125" cy="0"/>
           </a:xfrm>
           <a:prstGeom prst="line">
             <a:avLst/>
           </a:prstGeom>
-          <a:ln w="9879">
+          <a:ln w="14604">
             <a:solidFill>
               <a:srgbClr val="1F2937"/>
             </a:solidFill>
@@ -4644,18 +4644,18 @@
         </p:nvSpPr>
         <p:spPr>
           <a:xfrm>
-            <a:off x="2447381" y="2615778"/>
-            <a:ext cx="1223690" cy="370475"/>
+            <a:off x="4873624" y="2428874"/>
+            <a:ext cx="2635249" cy="492124"/>
           </a:xfrm>
           <a:prstGeom prst="roundRect">
             <a:avLst>
-              <a:gd name="adj" fmla="val 9090"/>
+              <a:gd name="adj" fmla="val 9677"/>
             </a:avLst>
           </a:prstGeom>
           <a:solidFill>
             <a:srgbClr val="F7F9FB"/>
           </a:solidFill>
-          <a:ln w="6735">
+          <a:ln w="9524">
             <a:solidFill>
               <a:srgbClr val="CBD3DA"/>
             </a:solidFill>
@@ -4692,8 +4692,8 @@
         </p:nvSpPr>
         <p:spPr>
           <a:xfrm>
-            <a:off x="2486673" y="2638231"/>
-            <a:ext cx="1145104" cy="325569"/>
+            <a:off x="4929187" y="2460624"/>
+            <a:ext cx="2524124" cy="428624"/>
           </a:xfrm>
           <a:prstGeom prst="rect">
             <a:avLst/>
@@ -4709,7 +4709,7 @@
           <a:p>
             <a:pPr algn="ctr" fontAlgn="base">
               <a:lnSpc>
-                <a:spcPts val="1160"/>
+                <a:spcPts val="2015"/>
               </a:lnSpc>
               <a:spcBef>
                 <a:spcPts val="0"/>
@@ -4717,7 +4717,7 @@
               <a:spcAft>
                 <a:spcPts val="0"/>
               </a:spcAft>
-              <a:defRPr sz="795" b="0" i="0" lang="zh-CN" dirty="0">
+              <a:defRPr sz="1374" b="0" i="0" lang="zh-CN" dirty="0">
                 <a:solidFill>
                   <a:srgbClr val="3F4854"/>
                 </a:solidFill>
@@ -4727,7 +4727,7 @@
               </a:defRPr>
             </a:pPr>
             <a:r>
-              <a:rPr sz="795" b="0" i="0" lang="zh-CN" dirty="0">
+              <a:rPr sz="1374" b="0" i="0" lang="zh-CN" dirty="0">
                 <a:solidFill>
                   <a:srgbClr val="3F4854"/>
                 </a:solidFill>
@@ -4738,7 +4738,7 @@
               <a:t>固相</a:t>
             </a:r>
             <a:r>
-              <a:rPr sz="795" b="0" i="0" lang="zh-CN" dirty="0">
+              <a:rPr sz="1374" b="0" i="0" lang="zh-CN" dirty="0">
                 <a:solidFill>
                   <a:srgbClr val="3F4854"/>
                 </a:solidFill>
@@ -4749,7 +4749,7 @@
               <a:t> · </a:t>
             </a:r>
             <a:r>
-              <a:rPr sz="795" b="0" i="0" lang="zh-CN" dirty="0">
+              <a:rPr sz="1374" b="0" i="0" lang="zh-CN" dirty="0">
                 <a:solidFill>
                   <a:srgbClr val="3F4854"/>
                 </a:solidFill>
@@ -4760,7 +4760,7 @@
               <a:t>溶胶</a:t>
             </a:r>
             <a:r>
-              <a:rPr sz="795" b="0" i="0" lang="zh-CN" dirty="0">
+              <a:rPr sz="1374" b="0" i="0" lang="zh-CN" dirty="0">
                 <a:solidFill>
                   <a:srgbClr val="3F4854"/>
                 </a:solidFill>
@@ -4771,7 +4771,7 @@
               <a:t>—</a:t>
             </a:r>
             <a:r>
-              <a:rPr sz="795" b="0" i="0" lang="zh-CN" dirty="0">
+              <a:rPr sz="1374" b="0" i="0" lang="zh-CN" dirty="0">
                 <a:solidFill>
                   <a:srgbClr val="3F4854"/>
                 </a:solidFill>
@@ -4792,18 +4792,18 @@
         </p:nvSpPr>
         <p:spPr>
           <a:xfrm>
-            <a:off x="4378342" y="819535"/>
-            <a:ext cx="1403314" cy="2469834"/>
+            <a:off x="8651874" y="793749"/>
+            <a:ext cx="3016249" cy="2301874"/>
           </a:xfrm>
           <a:prstGeom prst="roundRect">
             <a:avLst>
-              <a:gd name="adj" fmla="val 3599"/>
+              <a:gd name="adj" fmla="val 3103"/>
             </a:avLst>
           </a:prstGeom>
           <a:solidFill>
             <a:srgbClr val="FFFFFF"/>
           </a:solidFill>
-          <a:ln w="7858">
+          <a:ln w="11112">
             <a:solidFill>
               <a:srgbClr val="5B7592"/>
             </a:solidFill>
@@ -4840,8 +4840,8 @@
         </p:nvSpPr>
         <p:spPr>
           <a:xfrm>
-            <a:off x="4378342" y="819535"/>
-            <a:ext cx="1403314" cy="33679"/>
+            <a:off x="8651874" y="793749"/>
+            <a:ext cx="3016249" cy="47624"/>
           </a:xfrm>
           <a:prstGeom prst="roundRect">
             <a:avLst>
@@ -4886,8 +4886,8 @@
         </p:nvSpPr>
         <p:spPr>
           <a:xfrm>
-            <a:off x="4479381" y="1291049"/>
-            <a:ext cx="1201237" cy="218917"/>
+            <a:off x="8826499" y="1127124"/>
+            <a:ext cx="2666999" cy="341312"/>
           </a:xfrm>
           <a:prstGeom prst="rect">
             <a:avLst/>
@@ -4903,7 +4903,7 @@
           <a:p>
             <a:pPr algn="ctr" fontAlgn="base">
               <a:lnSpc>
-                <a:spcPts val="1701"/>
+                <a:spcPts val="2656"/>
               </a:lnSpc>
               <a:spcBef>
                 <a:spcPts val="0"/>
@@ -4911,7 +4911,7 @@
               <a:spcAft>
                 <a:spcPts val="0"/>
               </a:spcAft>
-              <a:defRPr sz="1171" b="1" i="0" lang="zh-CN" dirty="0">
+              <a:defRPr sz="1832" b="1" i="0" lang="zh-CN" dirty="0">
                 <a:solidFill>
                   <a:srgbClr val="2B3E57"/>
                 </a:solidFill>
@@ -4921,7 +4921,7 @@
               </a:defRPr>
             </a:pPr>
             <a:r>
-              <a:rPr sz="1171" b="1" i="0" lang="zh-CN" dirty="0">
+              <a:rPr sz="1832" b="1" i="0" lang="zh-CN" dirty="0">
                 <a:solidFill>
                   <a:srgbClr val="2B3E57"/>
                 </a:solidFill>
@@ -4942,8 +4942,8 @@
         </p:nvSpPr>
         <p:spPr>
           <a:xfrm>
-            <a:off x="4479381" y="931801"/>
-            <a:ext cx="303116" cy="157171"/>
+            <a:off x="8826499" y="904874"/>
+            <a:ext cx="428624" cy="206374"/>
           </a:xfrm>
           <a:prstGeom prst="rect">
             <a:avLst/>
@@ -4959,7 +4959,7 @@
           <a:p>
             <a:pPr algn="l" fontAlgn="base">
               <a:lnSpc>
-                <a:spcPts val="928"/>
+                <a:spcPts val="1468"/>
               </a:lnSpc>
               <a:spcBef>
                 <a:spcPts val="0"/>
@@ -4967,7 +4967,7 @@
               <a:spcAft>
                 <a:spcPts val="0"/>
               </a:spcAft>
-              <a:defRPr sz="795" b="1" i="0" lang="zh-CN" dirty="0">
+              <a:defRPr sz="1249" b="1" i="0" lang="zh-CN" dirty="0">
                 <a:solidFill>
                   <a:srgbClr val="97A3AE"/>
                 </a:solidFill>
@@ -4977,7 +4977,7 @@
               </a:defRPr>
             </a:pPr>
             <a:r>
-              <a:rPr sz="795" b="1" i="0" lang="zh-CN" dirty="0">
+              <a:rPr sz="1249" b="1" i="0" lang="zh-CN" dirty="0">
                 <a:solidFill>
                   <a:srgbClr val="97A3AE"/>
                 </a:solidFill>
@@ -4998,13 +4998,13 @@
         </p:nvCxnSpPr>
         <p:spPr>
           <a:xfrm>
-            <a:off x="5079999" y="1959027"/>
-            <a:ext cx="196464" cy="376088"/>
+            <a:off x="10159999" y="1658937"/>
+            <a:ext cx="293688" cy="555625"/>
           </a:xfrm>
           <a:prstGeom prst="line">
             <a:avLst/>
           </a:prstGeom>
-          <a:ln w="9879">
+          <a:ln w="14604">
             <a:solidFill>
               <a:srgbClr val="1F2937"/>
             </a:solidFill>
@@ -5034,13 +5034,13 @@
         </p:nvCxnSpPr>
         <p:spPr>
           <a:xfrm flipH="1">
-            <a:off x="4883535" y="2335115"/>
-            <a:ext cx="392928" cy="0"/>
+            <a:off x="9866312" y="2214562"/>
+            <a:ext cx="587375" cy="0"/>
           </a:xfrm>
           <a:prstGeom prst="line">
             <a:avLst/>
           </a:prstGeom>
-          <a:ln w="9879">
+          <a:ln w="14604">
             <a:solidFill>
               <a:srgbClr val="1F2937"/>
             </a:solidFill>
@@ -5070,13 +5070,13 @@
         </p:nvCxnSpPr>
         <p:spPr>
           <a:xfrm flipV="1">
-            <a:off x="4883535" y="1959027"/>
-            <a:ext cx="196464" cy="376088"/>
+            <a:off x="9866312" y="1658937"/>
+            <a:ext cx="293687" cy="555625"/>
           </a:xfrm>
           <a:prstGeom prst="line">
             <a:avLst/>
           </a:prstGeom>
-          <a:ln w="9879">
+          <a:ln w="14604">
             <a:solidFill>
               <a:srgbClr val="1F2937"/>
             </a:solidFill>
@@ -5106,13 +5106,13 @@
         </p:nvCxnSpPr>
         <p:spPr>
           <a:xfrm>
-            <a:off x="5079999" y="1959027"/>
-            <a:ext cx="61746" cy="246983"/>
+            <a:off x="10159999" y="1658937"/>
+            <a:ext cx="87313" cy="365125"/>
           </a:xfrm>
           <a:prstGeom prst="line">
             <a:avLst/>
           </a:prstGeom>
-          <a:ln w="9879">
+          <a:ln w="14604">
             <a:solidFill>
               <a:srgbClr val="1F2937"/>
             </a:solidFill>
@@ -5142,13 +5142,13 @@
         </p:nvCxnSpPr>
         <p:spPr>
           <a:xfrm flipH="1">
-            <a:off x="4883535" y="2206010"/>
-            <a:ext cx="258210" cy="129105"/>
+            <a:off x="9866312" y="2024062"/>
+            <a:ext cx="381000" cy="190500"/>
           </a:xfrm>
           <a:prstGeom prst="line">
             <a:avLst/>
           </a:prstGeom>
-          <a:ln w="9879">
+          <a:ln w="14604">
             <a:solidFill>
               <a:srgbClr val="1F2937"/>
             </a:solidFill>
@@ -5178,8 +5178,8 @@
         </p:nvSpPr>
         <p:spPr>
           <a:xfrm>
-            <a:off x="5141745" y="2217237"/>
-            <a:ext cx="61745" cy="61745"/>
+            <a:off x="10247312" y="2039937"/>
+            <a:ext cx="87312" cy="87312"/>
           </a:xfrm>
           <a:prstGeom prst="ellipse">
             <a:avLst/>
@@ -5222,18 +5222,18 @@
         </p:nvSpPr>
         <p:spPr>
           <a:xfrm>
-            <a:off x="4468154" y="2615778"/>
-            <a:ext cx="1223690" cy="370475"/>
+            <a:off x="8842374" y="2428874"/>
+            <a:ext cx="2635249" cy="492124"/>
           </a:xfrm>
           <a:prstGeom prst="roundRect">
             <a:avLst>
-              <a:gd name="adj" fmla="val 9090"/>
+              <a:gd name="adj" fmla="val 9677"/>
             </a:avLst>
           </a:prstGeom>
           <a:solidFill>
             <a:srgbClr val="F7F9FB"/>
           </a:solidFill>
-          <a:ln w="6735">
+          <a:ln w="9524">
             <a:solidFill>
               <a:srgbClr val="CBD3DA"/>
             </a:solidFill>
@@ -5270,8 +5270,8 @@
         </p:nvSpPr>
         <p:spPr>
           <a:xfrm>
-            <a:off x="4507447" y="2638231"/>
-            <a:ext cx="1145104" cy="325569"/>
+            <a:off x="8897937" y="2460624"/>
+            <a:ext cx="2524124" cy="428624"/>
           </a:xfrm>
           <a:prstGeom prst="rect">
             <a:avLst/>
@@ -5287,7 +5287,7 @@
           <a:p>
             <a:pPr algn="ctr" fontAlgn="base">
               <a:lnSpc>
-                <a:spcPts val="1160"/>
+                <a:spcPts val="2015"/>
               </a:lnSpc>
               <a:spcBef>
                 <a:spcPts val="0"/>
@@ -5295,7 +5295,7 @@
               <a:spcAft>
                 <a:spcPts val="0"/>
               </a:spcAft>
-              <a:defRPr sz="795" b="0" i="0" lang="zh-CN" dirty="0">
+              <a:defRPr sz="1374" b="0" i="0" lang="zh-CN" dirty="0">
                 <a:solidFill>
                   <a:srgbClr val="3F4854"/>
                 </a:solidFill>
@@ -5305,7 +5305,7 @@
               </a:defRPr>
             </a:pPr>
             <a:r>
-              <a:rPr sz="795" b="0" i="0" lang="zh-CN" dirty="0">
+              <a:rPr sz="1374" b="0" i="0" lang="zh-CN" dirty="0">
                 <a:solidFill>
                   <a:srgbClr val="3F4854"/>
                 </a:solidFill>
@@ -5316,7 +5316,7 @@
               <a:t>组成</a:t>
             </a:r>
             <a:r>
-              <a:rPr sz="795" b="0" i="0" lang="zh-CN" dirty="0">
+              <a:rPr sz="1374" b="0" i="0" lang="zh-CN" dirty="0">
                 <a:solidFill>
                   <a:srgbClr val="3F4854"/>
                 </a:solidFill>
@@ -5327,7 +5327,7 @@
               <a:t> · </a:t>
             </a:r>
             <a:r>
-              <a:rPr sz="795" b="0" i="0" lang="zh-CN" dirty="0">
+              <a:rPr sz="1374" b="0" i="0" lang="zh-CN" dirty="0">
                 <a:solidFill>
                   <a:srgbClr val="3F4854"/>
                 </a:solidFill>
@@ -5348,18 +5348,18 @@
         </p:nvSpPr>
         <p:spPr>
           <a:xfrm>
-            <a:off x="6511381" y="819535"/>
-            <a:ext cx="1403314" cy="2469834"/>
+            <a:off x="714374" y="4206874"/>
+            <a:ext cx="3016249" cy="2301874"/>
           </a:xfrm>
           <a:prstGeom prst="roundRect">
             <a:avLst>
-              <a:gd name="adj" fmla="val 3599"/>
+              <a:gd name="adj" fmla="val 3103"/>
             </a:avLst>
           </a:prstGeom>
           <a:solidFill>
             <a:srgbClr val="FFFFFF"/>
           </a:solidFill>
-          <a:ln w="7858">
+          <a:ln w="11112">
             <a:solidFill>
               <a:srgbClr val="1F7F8C"/>
             </a:solidFill>
@@ -5396,8 +5396,8 @@
         </p:nvSpPr>
         <p:spPr>
           <a:xfrm>
-            <a:off x="6511381" y="819535"/>
-            <a:ext cx="1403314" cy="33679"/>
+            <a:off x="714374" y="4206874"/>
+            <a:ext cx="3016249" cy="47624"/>
           </a:xfrm>
           <a:prstGeom prst="roundRect">
             <a:avLst>
@@ -5442,8 +5442,8 @@
         </p:nvSpPr>
         <p:spPr>
           <a:xfrm>
-            <a:off x="6612419" y="1291049"/>
-            <a:ext cx="1201237" cy="218917"/>
+            <a:off x="888999" y="4540249"/>
+            <a:ext cx="2666999" cy="341312"/>
           </a:xfrm>
           <a:prstGeom prst="rect">
             <a:avLst/>
@@ -5459,7 +5459,7 @@
           <a:p>
             <a:pPr algn="ctr" fontAlgn="base">
               <a:lnSpc>
-                <a:spcPts val="1701"/>
+                <a:spcPts val="2656"/>
               </a:lnSpc>
               <a:spcBef>
                 <a:spcPts val="0"/>
@@ -5467,7 +5467,7 @@
               <a:spcAft>
                 <a:spcPts val="0"/>
               </a:spcAft>
-              <a:defRPr sz="1171" b="1" i="0" lang="zh-CN" dirty="0">
+              <a:defRPr sz="1832" b="1" i="0" lang="zh-CN" dirty="0">
                 <a:solidFill>
                   <a:srgbClr val="0F4F58"/>
                 </a:solidFill>
@@ -5477,7 +5477,7 @@
               </a:defRPr>
             </a:pPr>
             <a:r>
-              <a:rPr sz="1171" b="1" i="0" lang="zh-CN" dirty="0">
+              <a:rPr sz="1832" b="1" i="0" lang="zh-CN" dirty="0">
                 <a:solidFill>
                   <a:srgbClr val="0F4F58"/>
                 </a:solidFill>
@@ -5498,8 +5498,8 @@
         </p:nvSpPr>
         <p:spPr>
           <a:xfrm>
-            <a:off x="6612419" y="931801"/>
-            <a:ext cx="303116" cy="157171"/>
+            <a:off x="888999" y="4317999"/>
+            <a:ext cx="428624" cy="206374"/>
           </a:xfrm>
           <a:prstGeom prst="rect">
             <a:avLst/>
@@ -5515,7 +5515,7 @@
           <a:p>
             <a:pPr algn="l" fontAlgn="base">
               <a:lnSpc>
-                <a:spcPts val="928"/>
+                <a:spcPts val="1468"/>
               </a:lnSpc>
               <a:spcBef>
                 <a:spcPts val="0"/>
@@ -5523,7 +5523,7 @@
               <a:spcAft>
                 <a:spcPts val="0"/>
               </a:spcAft>
-              <a:defRPr sz="795" b="1" i="0" lang="zh-CN" dirty="0">
+              <a:defRPr sz="1249" b="1" i="0" lang="zh-CN" dirty="0">
                 <a:solidFill>
                   <a:srgbClr val="97A3AE"/>
                 </a:solidFill>
@@ -5533,7 +5533,7 @@
               </a:defRPr>
             </a:pPr>
             <a:r>
-              <a:rPr sz="795" b="1" i="0" lang="zh-CN" dirty="0">
+              <a:rPr sz="1249" b="1" i="0" lang="zh-CN" dirty="0">
                 <a:solidFill>
                   <a:srgbClr val="97A3AE"/>
                 </a:solidFill>
@@ -5554,13 +5554,13 @@
         </p:nvCxnSpPr>
         <p:spPr>
           <a:xfrm>
-            <a:off x="7055867" y="1998320"/>
-            <a:ext cx="314342" cy="0"/>
+            <a:off x="1992312" y="5135562"/>
+            <a:ext cx="460375" cy="0"/>
           </a:xfrm>
           <a:prstGeom prst="line">
             <a:avLst/>
           </a:prstGeom>
-          <a:ln w="9879">
+          <a:ln w="14604">
             <a:solidFill>
               <a:srgbClr val="1F2937"/>
             </a:solidFill>
@@ -5590,13 +5590,13 @@
         </p:nvCxnSpPr>
         <p:spPr>
           <a:xfrm>
-            <a:off x="7055867" y="1998320"/>
-            <a:ext cx="0" cy="314342"/>
+            <a:off x="1992312" y="5135562"/>
+            <a:ext cx="0" cy="460375"/>
           </a:xfrm>
           <a:prstGeom prst="line">
             <a:avLst/>
           </a:prstGeom>
-          <a:ln w="9879">
+          <a:ln w="14604">
             <a:solidFill>
               <a:srgbClr val="1F2937"/>
             </a:solidFill>
@@ -5626,13 +5626,13 @@
         </p:nvCxnSpPr>
         <p:spPr>
           <a:xfrm>
-            <a:off x="7055867" y="2155491"/>
-            <a:ext cx="314342" cy="0"/>
+            <a:off x="1992312" y="5365749"/>
+            <a:ext cx="460375" cy="0"/>
           </a:xfrm>
           <a:prstGeom prst="line">
             <a:avLst/>
           </a:prstGeom>
-          <a:ln w="9879">
+          <a:ln w="14604">
             <a:solidFill>
               <a:srgbClr val="1F2937"/>
             </a:solidFill>
@@ -5662,13 +5662,13 @@
         </p:nvCxnSpPr>
         <p:spPr>
           <a:xfrm>
-            <a:off x="7213038" y="1998320"/>
-            <a:ext cx="0" cy="314342"/>
+            <a:off x="2222499" y="5135562"/>
+            <a:ext cx="0" cy="460375"/>
           </a:xfrm>
           <a:prstGeom prst="line">
             <a:avLst/>
           </a:prstGeom>
-          <a:ln w="9879">
+          <a:ln w="14604">
             <a:solidFill>
               <a:srgbClr val="1F2937"/>
             </a:solidFill>
@@ -5698,13 +5698,13 @@
         </p:nvCxnSpPr>
         <p:spPr>
           <a:xfrm>
-            <a:off x="7055867" y="2312662"/>
-            <a:ext cx="314342" cy="0"/>
+            <a:off x="1992312" y="5595937"/>
+            <a:ext cx="460375" cy="0"/>
           </a:xfrm>
           <a:prstGeom prst="line">
             <a:avLst/>
           </a:prstGeom>
-          <a:ln w="9879">
+          <a:ln w="14604">
             <a:solidFill>
               <a:srgbClr val="1F2937"/>
             </a:solidFill>
@@ -5734,13 +5734,13 @@
         </p:nvCxnSpPr>
         <p:spPr>
           <a:xfrm>
-            <a:off x="7370209" y="1998320"/>
-            <a:ext cx="0" cy="314342"/>
+            <a:off x="2452687" y="5135562"/>
+            <a:ext cx="0" cy="460375"/>
           </a:xfrm>
           <a:prstGeom prst="line">
             <a:avLst/>
           </a:prstGeom>
-          <a:ln w="9879">
+          <a:ln w="14604">
             <a:solidFill>
               <a:srgbClr val="1F2937"/>
             </a:solidFill>
@@ -5770,8 +5770,8 @@
         </p:nvSpPr>
         <p:spPr>
           <a:xfrm>
-            <a:off x="7022187" y="1964640"/>
-            <a:ext cx="67359" cy="67359"/>
+            <a:off x="1936749" y="5079999"/>
+            <a:ext cx="103187" cy="103187"/>
           </a:xfrm>
           <a:prstGeom prst="ellipse">
             <a:avLst/>
@@ -5814,8 +5814,8 @@
         </p:nvSpPr>
         <p:spPr>
           <a:xfrm>
-            <a:off x="7022187" y="2121812"/>
-            <a:ext cx="67359" cy="67359"/>
+            <a:off x="1936749" y="5318124"/>
+            <a:ext cx="103187" cy="103187"/>
           </a:xfrm>
           <a:prstGeom prst="ellipse">
             <a:avLst/>
@@ -5858,8 +5858,8 @@
         </p:nvSpPr>
         <p:spPr>
           <a:xfrm>
-            <a:off x="7022187" y="2278983"/>
-            <a:ext cx="67359" cy="67359"/>
+            <a:off x="1936749" y="5548312"/>
+            <a:ext cx="103187" cy="103187"/>
           </a:xfrm>
           <a:prstGeom prst="ellipse">
             <a:avLst/>
@@ -5902,8 +5902,8 @@
         </p:nvSpPr>
         <p:spPr>
           <a:xfrm>
-            <a:off x="7179358" y="1964640"/>
-            <a:ext cx="67359" cy="67359"/>
+            <a:off x="2174874" y="5079999"/>
+            <a:ext cx="103187" cy="103187"/>
           </a:xfrm>
           <a:prstGeom prst="ellipse">
             <a:avLst/>
@@ -5946,8 +5946,8 @@
         </p:nvSpPr>
         <p:spPr>
           <a:xfrm>
-            <a:off x="7179358" y="2121812"/>
-            <a:ext cx="67359" cy="67359"/>
+            <a:off x="2174874" y="5318124"/>
+            <a:ext cx="103187" cy="103187"/>
           </a:xfrm>
           <a:prstGeom prst="ellipse">
             <a:avLst/>
@@ -5990,8 +5990,8 @@
         </p:nvSpPr>
         <p:spPr>
           <a:xfrm>
-            <a:off x="7179358" y="2278983"/>
-            <a:ext cx="67359" cy="67359"/>
+            <a:off x="2174874" y="5548312"/>
+            <a:ext cx="103187" cy="103187"/>
           </a:xfrm>
           <a:prstGeom prst="ellipse">
             <a:avLst/>
@@ -6034,8 +6034,8 @@
         </p:nvSpPr>
         <p:spPr>
           <a:xfrm>
-            <a:off x="7336530" y="1964640"/>
-            <a:ext cx="67359" cy="67359"/>
+            <a:off x="2405062" y="5079999"/>
+            <a:ext cx="103187" cy="103187"/>
           </a:xfrm>
           <a:prstGeom prst="ellipse">
             <a:avLst/>
@@ -6078,8 +6078,8 @@
         </p:nvSpPr>
         <p:spPr>
           <a:xfrm>
-            <a:off x="7336530" y="2121812"/>
-            <a:ext cx="67359" cy="67359"/>
+            <a:off x="2405062" y="5318124"/>
+            <a:ext cx="103187" cy="103187"/>
           </a:xfrm>
           <a:prstGeom prst="ellipse">
             <a:avLst/>
@@ -6122,8 +6122,8 @@
         </p:nvSpPr>
         <p:spPr>
           <a:xfrm>
-            <a:off x="7336530" y="2278983"/>
-            <a:ext cx="67359" cy="67359"/>
+            <a:off x="2405062" y="5548312"/>
+            <a:ext cx="103187" cy="103187"/>
           </a:xfrm>
           <a:prstGeom prst="ellipse">
             <a:avLst/>
@@ -6166,18 +6166,18 @@
         </p:nvSpPr>
         <p:spPr>
           <a:xfrm>
-            <a:off x="6601193" y="2615778"/>
-            <a:ext cx="1223690" cy="370475"/>
+            <a:off x="904874" y="5841999"/>
+            <a:ext cx="2635249" cy="492124"/>
           </a:xfrm>
           <a:prstGeom prst="roundRect">
             <a:avLst>
-              <a:gd name="adj" fmla="val 9090"/>
+              <a:gd name="adj" fmla="val 9677"/>
             </a:avLst>
           </a:prstGeom>
           <a:solidFill>
             <a:srgbClr val="F7F9FB"/>
           </a:solidFill>
-          <a:ln w="6735">
+          <a:ln w="9524">
             <a:solidFill>
               <a:srgbClr val="CBD3DA"/>
             </a:solidFill>
@@ -6214,8 +6214,8 @@
         </p:nvSpPr>
         <p:spPr>
           <a:xfrm>
-            <a:off x="6640486" y="2638231"/>
-            <a:ext cx="1145104" cy="325569"/>
+            <a:off x="960437" y="5873749"/>
+            <a:ext cx="2524124" cy="428624"/>
           </a:xfrm>
           <a:prstGeom prst="rect">
             <a:avLst/>
@@ -6231,7 +6231,7 @@
           <a:p>
             <a:pPr algn="ctr" fontAlgn="base">
               <a:lnSpc>
-                <a:spcPts val="928"/>
+                <a:spcPts val="1609"/>
               </a:lnSpc>
               <a:spcBef>
                 <a:spcPts val="0"/>
@@ -6239,7 +6239,7 @@
               <a:spcAft>
                 <a:spcPts val="0"/>
               </a:spcAft>
-              <a:defRPr sz="795" b="0" i="0" lang="zh-CN" dirty="0">
+              <a:defRPr sz="1374" b="0" i="0" lang="zh-CN" dirty="0">
                 <a:solidFill>
                   <a:srgbClr val="3F4854"/>
                 </a:solidFill>
@@ -6249,7 +6249,7 @@
               </a:defRPr>
             </a:pPr>
             <a:r>
-              <a:rPr sz="795" b="0" i="0" lang="zh-CN" dirty="0">
+              <a:rPr sz="1374" b="0" i="0" lang="zh-CN" dirty="0">
                 <a:solidFill>
                   <a:srgbClr val="3F4854"/>
                 </a:solidFill>
@@ -6270,18 +6270,18 @@
         </p:nvSpPr>
         <p:spPr>
           <a:xfrm>
-            <a:off x="8532154" y="819535"/>
-            <a:ext cx="1403314" cy="2469834"/>
+            <a:off x="4683124" y="4206874"/>
+            <a:ext cx="3016249" cy="2301874"/>
           </a:xfrm>
           <a:prstGeom prst="roundRect">
             <a:avLst>
-              <a:gd name="adj" fmla="val 3599"/>
+              <a:gd name="adj" fmla="val 3103"/>
             </a:avLst>
           </a:prstGeom>
           <a:solidFill>
             <a:srgbClr val="FFFFFF"/>
           </a:solidFill>
-          <a:ln w="7858">
+          <a:ln w="11112">
             <a:solidFill>
               <a:srgbClr val="C48A24"/>
             </a:solidFill>
@@ -6318,8 +6318,8 @@
         </p:nvSpPr>
         <p:spPr>
           <a:xfrm>
-            <a:off x="8532154" y="819535"/>
-            <a:ext cx="1403314" cy="33679"/>
+            <a:off x="4683124" y="4206874"/>
+            <a:ext cx="3016249" cy="47624"/>
           </a:xfrm>
           <a:prstGeom prst="roundRect">
             <a:avLst>
@@ -6364,8 +6364,8 @@
         </p:nvSpPr>
         <p:spPr>
           <a:xfrm>
-            <a:off x="8633193" y="1291049"/>
-            <a:ext cx="1201237" cy="218917"/>
+            <a:off x="4857749" y="4540249"/>
+            <a:ext cx="2666999" cy="341312"/>
           </a:xfrm>
           <a:prstGeom prst="rect">
             <a:avLst/>
@@ -6381,7 +6381,7 @@
           <a:p>
             <a:pPr algn="ctr" fontAlgn="base">
               <a:lnSpc>
-                <a:spcPts val="1701"/>
+                <a:spcPts val="2656"/>
               </a:lnSpc>
               <a:spcBef>
                 <a:spcPts val="0"/>
@@ -6389,7 +6389,7 @@
               <a:spcAft>
                 <a:spcPts val="0"/>
               </a:spcAft>
-              <a:defRPr sz="1171" b="1" i="0" lang="zh-CN" dirty="0">
+              <a:defRPr sz="1832" b="1" i="0" lang="zh-CN" dirty="0">
                 <a:solidFill>
                   <a:srgbClr val="7A5410"/>
                 </a:solidFill>
@@ -6399,7 +6399,7 @@
               </a:defRPr>
             </a:pPr>
             <a:r>
-              <a:rPr sz="1171" b="1" i="0" lang="zh-CN" dirty="0">
+              <a:rPr sz="1832" b="1" i="0" lang="zh-CN" dirty="0">
                 <a:solidFill>
                   <a:srgbClr val="7A5410"/>
                 </a:solidFill>
@@ -6420,8 +6420,8 @@
         </p:nvSpPr>
         <p:spPr>
           <a:xfrm>
-            <a:off x="8633193" y="931801"/>
-            <a:ext cx="303116" cy="157171"/>
+            <a:off x="4857749" y="4317999"/>
+            <a:ext cx="428624" cy="206374"/>
           </a:xfrm>
           <a:prstGeom prst="rect">
             <a:avLst/>
@@ -6437,7 +6437,7 @@
           <a:p>
             <a:pPr algn="l" fontAlgn="base">
               <a:lnSpc>
-                <a:spcPts val="928"/>
+                <a:spcPts val="1468"/>
               </a:lnSpc>
               <a:spcBef>
                 <a:spcPts val="0"/>
@@ -6445,7 +6445,7 @@
               <a:spcAft>
                 <a:spcPts val="0"/>
               </a:spcAft>
-              <a:defRPr sz="795" b="1" i="0" lang="zh-CN" dirty="0">
+              <a:defRPr sz="1249" b="1" i="0" lang="zh-CN" dirty="0">
                 <a:solidFill>
                   <a:srgbClr val="97A3AE"/>
                 </a:solidFill>
@@ -6455,7 +6455,7 @@
               </a:defRPr>
             </a:pPr>
             <a:r>
-              <a:rPr sz="795" b="1" i="0" lang="zh-CN" dirty="0">
+              <a:rPr sz="1249" b="1" i="0" lang="zh-CN" dirty="0">
                 <a:solidFill>
                   <a:srgbClr val="97A3AE"/>
                 </a:solidFill>
@@ -6476,13 +6476,13 @@
         </p:nvCxnSpPr>
         <p:spPr>
           <a:xfrm>
-            <a:off x="9233811" y="1975867"/>
-            <a:ext cx="0" cy="319956"/>
+            <a:off x="6191249" y="5103812"/>
+            <a:ext cx="0" cy="468312"/>
           </a:xfrm>
           <a:prstGeom prst="line">
             <a:avLst/>
           </a:prstGeom>
-          <a:ln w="9879">
+          <a:ln w="14604">
             <a:solidFill>
               <a:srgbClr val="1F2937"/>
             </a:solidFill>
@@ -6512,13 +6512,13 @@
         </p:nvCxnSpPr>
         <p:spPr>
           <a:xfrm>
-            <a:off x="9065414" y="2048839"/>
-            <a:ext cx="336795" cy="0"/>
+            <a:off x="5945187" y="5206999"/>
+            <a:ext cx="492125" cy="0"/>
           </a:xfrm>
           <a:prstGeom prst="line">
             <a:avLst/>
           </a:prstGeom>
-          <a:ln w="9879">
+          <a:ln w="14604">
             <a:solidFill>
               <a:srgbClr val="1F2937"/>
             </a:solidFill>
@@ -6548,13 +6548,13 @@
         </p:nvCxnSpPr>
         <p:spPr>
           <a:xfrm flipH="1">
-            <a:off x="9014894" y="2048839"/>
-            <a:ext cx="50520" cy="106652"/>
+            <a:off x="5873749" y="5206999"/>
+            <a:ext cx="71438" cy="158750"/>
           </a:xfrm>
           <a:prstGeom prst="line">
             <a:avLst/>
           </a:prstGeom>
-          <a:ln w="9879">
+          <a:ln w="14604">
             <a:solidFill>
               <a:srgbClr val="1F2937"/>
             </a:solidFill>
@@ -6584,13 +6584,13 @@
         </p:nvCxnSpPr>
         <p:spPr>
           <a:xfrm>
-            <a:off x="9014894" y="2155491"/>
-            <a:ext cx="101039" cy="0"/>
+            <a:off x="5873749" y="5365749"/>
+            <a:ext cx="142875" cy="0"/>
           </a:xfrm>
           <a:prstGeom prst="line">
             <a:avLst/>
           </a:prstGeom>
-          <a:ln w="9879">
+          <a:ln w="14604">
             <a:solidFill>
               <a:srgbClr val="1F2937"/>
             </a:solidFill>
@@ -6620,13 +6620,13 @@
         </p:nvCxnSpPr>
         <p:spPr>
           <a:xfrm flipH="1" flipV="1">
-            <a:off x="9065414" y="2048839"/>
-            <a:ext cx="50519" cy="106652"/>
+            <a:off x="5945187" y="5206999"/>
+            <a:ext cx="71437" cy="158750"/>
           </a:xfrm>
           <a:prstGeom prst="line">
             <a:avLst/>
           </a:prstGeom>
-          <a:ln w="9879">
+          <a:ln w="14604">
             <a:solidFill>
               <a:srgbClr val="1F2937"/>
             </a:solidFill>
@@ -6656,13 +6656,13 @@
         </p:nvCxnSpPr>
         <p:spPr>
           <a:xfrm flipH="1">
-            <a:off x="9351690" y="2048839"/>
-            <a:ext cx="50519" cy="106652"/>
+            <a:off x="6365874" y="5206999"/>
+            <a:ext cx="71438" cy="158750"/>
           </a:xfrm>
           <a:prstGeom prst="line">
             <a:avLst/>
           </a:prstGeom>
-          <a:ln w="9879">
+          <a:ln w="14604">
             <a:solidFill>
               <a:srgbClr val="1F2937"/>
             </a:solidFill>
@@ -6692,13 +6692,13 @@
         </p:nvCxnSpPr>
         <p:spPr>
           <a:xfrm>
-            <a:off x="9351690" y="2155491"/>
-            <a:ext cx="101039" cy="0"/>
+            <a:off x="6365874" y="5365749"/>
+            <a:ext cx="142875" cy="0"/>
           </a:xfrm>
           <a:prstGeom prst="line">
             <a:avLst/>
           </a:prstGeom>
-          <a:ln w="9879">
+          <a:ln w="14604">
             <a:solidFill>
               <a:srgbClr val="1F2937"/>
             </a:solidFill>
@@ -6728,13 +6728,13 @@
         </p:nvCxnSpPr>
         <p:spPr>
           <a:xfrm flipH="1" flipV="1">
-            <a:off x="9402209" y="2048839"/>
-            <a:ext cx="50520" cy="106652"/>
+            <a:off x="6437312" y="5206999"/>
+            <a:ext cx="71437" cy="158750"/>
           </a:xfrm>
           <a:prstGeom prst="line">
             <a:avLst/>
           </a:prstGeom>
-          <a:ln w="9879">
+          <a:ln w="14604">
             <a:solidFill>
               <a:srgbClr val="1F2937"/>
             </a:solidFill>
@@ -6764,13 +6764,13 @@
         </p:nvCxnSpPr>
         <p:spPr>
           <a:xfrm>
-            <a:off x="9132773" y="2335115"/>
-            <a:ext cx="202077" cy="0"/>
+            <a:off x="6048374" y="5627687"/>
+            <a:ext cx="285750" cy="0"/>
           </a:xfrm>
           <a:prstGeom prst="line">
             <a:avLst/>
           </a:prstGeom>
-          <a:ln w="9879">
+          <a:ln w="14604">
             <a:solidFill>
               <a:srgbClr val="1F2937"/>
             </a:solidFill>
@@ -6800,18 +6800,18 @@
         </p:nvSpPr>
         <p:spPr>
           <a:xfrm>
-            <a:off x="8621966" y="2615778"/>
-            <a:ext cx="1223690" cy="370475"/>
+            <a:off x="4873624" y="5841999"/>
+            <a:ext cx="2635249" cy="492124"/>
           </a:xfrm>
           <a:prstGeom prst="roundRect">
             <a:avLst>
-              <a:gd name="adj" fmla="val 9090"/>
+              <a:gd name="adj" fmla="val 9677"/>
             </a:avLst>
           </a:prstGeom>
           <a:solidFill>
             <a:srgbClr val="F7F9FB"/>
           </a:solidFill>
-          <a:ln w="6735">
+          <a:ln w="9524">
             <a:solidFill>
               <a:srgbClr val="CBD3DA"/>
             </a:solidFill>
@@ -6848,8 +6848,8 @@
         </p:nvSpPr>
         <p:spPr>
           <a:xfrm>
-            <a:off x="8661259" y="2638231"/>
-            <a:ext cx="1145104" cy="325569"/>
+            <a:off x="4929187" y="5873749"/>
+            <a:ext cx="2524124" cy="428624"/>
           </a:xfrm>
           <a:prstGeom prst="rect">
             <a:avLst/>
@@ -6865,7 +6865,7 @@
           <a:p>
             <a:pPr algn="ctr" fontAlgn="base">
               <a:lnSpc>
-                <a:spcPts val="928"/>
+                <a:spcPts val="1609"/>
               </a:lnSpc>
               <a:spcBef>
                 <a:spcPts val="0"/>
@@ -6873,7 +6873,7 @@
               <a:spcAft>
                 <a:spcPts val="0"/>
               </a:spcAft>
-              <a:defRPr sz="795" b="0" i="0" lang="zh-CN" dirty="0">
+              <a:defRPr sz="1374" b="0" i="0" lang="zh-CN" dirty="0">
                 <a:solidFill>
                   <a:srgbClr val="3F4854"/>
                 </a:solidFill>
@@ -6883,7 +6883,7 @@
               </a:defRPr>
             </a:pPr>
             <a:r>
-              <a:rPr sz="795" b="0" i="0" lang="zh-CN" dirty="0">
+              <a:rPr sz="1374" b="0" i="0" lang="zh-CN" dirty="0">
                 <a:solidFill>
                   <a:srgbClr val="3F4854"/>
                 </a:solidFill>
@@ -6904,18 +6904,18 @@
         </p:nvSpPr>
         <p:spPr>
           <a:xfrm>
-            <a:off x="10552927" y="819535"/>
-            <a:ext cx="1403314" cy="2469834"/>
+            <a:off x="8651874" y="4206874"/>
+            <a:ext cx="3016249" cy="2301874"/>
           </a:xfrm>
           <a:prstGeom prst="roundRect">
             <a:avLst>
-              <a:gd name="adj" fmla="val 3599"/>
+              <a:gd name="adj" fmla="val 3103"/>
             </a:avLst>
           </a:prstGeom>
           <a:solidFill>
             <a:srgbClr val="FFFFFF"/>
           </a:solidFill>
-          <a:ln w="7858">
+          <a:ln w="11112">
             <a:solidFill>
               <a:srgbClr val="1F7F8C"/>
             </a:solidFill>
@@ -6952,8 +6952,8 @@
         </p:nvSpPr>
         <p:spPr>
           <a:xfrm>
-            <a:off x="10552927" y="819535"/>
-            <a:ext cx="1403314" cy="33679"/>
+            <a:off x="8651874" y="4206874"/>
+            <a:ext cx="3016249" cy="47624"/>
           </a:xfrm>
           <a:prstGeom prst="roundRect">
             <a:avLst>
@@ -6998,8 +6998,8 @@
         </p:nvSpPr>
         <p:spPr>
           <a:xfrm>
-            <a:off x="10653966" y="1291049"/>
-            <a:ext cx="1201237" cy="218917"/>
+            <a:off x="8826499" y="4540249"/>
+            <a:ext cx="2666999" cy="341312"/>
           </a:xfrm>
           <a:prstGeom prst="rect">
             <a:avLst/>
@@ -7015,7 +7015,7 @@
           <a:p>
             <a:pPr algn="ctr" fontAlgn="base">
               <a:lnSpc>
-                <a:spcPts val="1701"/>
+                <a:spcPts val="2656"/>
               </a:lnSpc>
               <a:spcBef>
                 <a:spcPts val="0"/>
@@ -7023,7 +7023,7 @@
               <a:spcAft>
                 <a:spcPts val="0"/>
               </a:spcAft>
-              <a:defRPr sz="1171" b="1" i="0" lang="zh-CN" dirty="0">
+              <a:defRPr sz="1832" b="1" i="0" lang="zh-CN" dirty="0">
                 <a:solidFill>
                   <a:srgbClr val="0F4F58"/>
                 </a:solidFill>
@@ -7033,7 +7033,7 @@
               </a:defRPr>
             </a:pPr>
             <a:r>
-              <a:rPr sz="1171" b="1" i="0" lang="zh-CN" dirty="0">
+              <a:rPr sz="1832" b="1" i="0" lang="zh-CN" dirty="0">
                 <a:solidFill>
                   <a:srgbClr val="0F4F58"/>
                 </a:solidFill>
@@ -7054,8 +7054,8 @@
         </p:nvSpPr>
         <p:spPr>
           <a:xfrm>
-            <a:off x="10653966" y="931801"/>
-            <a:ext cx="303116" cy="157171"/>
+            <a:off x="8826499" y="4317999"/>
+            <a:ext cx="428624" cy="206374"/>
           </a:xfrm>
           <a:prstGeom prst="rect">
             <a:avLst/>
@@ -7071,7 +7071,7 @@
           <a:p>
             <a:pPr algn="l" fontAlgn="base">
               <a:lnSpc>
-                <a:spcPts val="928"/>
+                <a:spcPts val="1468"/>
               </a:lnSpc>
               <a:spcBef>
                 <a:spcPts val="0"/>
@@ -7079,7 +7079,7 @@
               <a:spcAft>
                 <a:spcPts val="0"/>
               </a:spcAft>
-              <a:defRPr sz="795" b="1" i="0" lang="zh-CN" dirty="0">
+              <a:defRPr sz="1249" b="1" i="0" lang="zh-CN" dirty="0">
                 <a:solidFill>
                   <a:srgbClr val="97A3AE"/>
                 </a:solidFill>
@@ -7089,7 +7089,7 @@
               </a:defRPr>
             </a:pPr>
             <a:r>
-              <a:rPr sz="795" b="1" i="0" lang="zh-CN" dirty="0">
+              <a:rPr sz="1249" b="1" i="0" lang="zh-CN" dirty="0">
                 <a:solidFill>
                   <a:srgbClr val="97A3AE"/>
                 </a:solidFill>
@@ -7110,14 +7110,14 @@
         </p:nvSpPr>
         <p:spPr>
           <a:xfrm>
-            <a:off x="11069347" y="2009546"/>
-            <a:ext cx="101038" cy="101038"/>
+            <a:off x="9882187" y="5143499"/>
+            <a:ext cx="142874" cy="142874"/>
           </a:xfrm>
           <a:prstGeom prst="rect">
             <a:avLst/>
           </a:prstGeom>
           <a:noFill/>
-          <a:ln w="9879">
+          <a:ln w="14604">
             <a:solidFill>
               <a:srgbClr val="1F2937"/>
             </a:solidFill>
@@ -7154,13 +7154,13 @@
         </p:nvCxnSpPr>
         <p:spPr>
           <a:xfrm>
-            <a:off x="11226519" y="2054452"/>
-            <a:ext cx="224530" cy="0"/>
+            <a:off x="10112374" y="5222874"/>
+            <a:ext cx="341313" cy="0"/>
           </a:xfrm>
           <a:prstGeom prst="line">
             <a:avLst/>
           </a:prstGeom>
-          <a:ln w="9879">
+          <a:ln w="14604">
             <a:solidFill>
               <a:srgbClr val="1F2937"/>
             </a:solidFill>
@@ -7190,13 +7190,13 @@
         </p:nvCxnSpPr>
         <p:spPr>
           <a:xfrm>
-            <a:off x="11086187" y="2060066"/>
-            <a:ext cx="22453" cy="28066"/>
+            <a:off x="9913937" y="5230812"/>
+            <a:ext cx="31750" cy="31750"/>
           </a:xfrm>
           <a:prstGeom prst="line">
             <a:avLst/>
           </a:prstGeom>
-          <a:ln w="9879">
+          <a:ln w="14604">
             <a:solidFill>
               <a:srgbClr val="1F2937"/>
             </a:solidFill>
@@ -7226,13 +7226,13 @@
         </p:nvCxnSpPr>
         <p:spPr>
           <a:xfrm flipV="1">
-            <a:off x="11108640" y="2026386"/>
-            <a:ext cx="44906" cy="61746"/>
+            <a:off x="9945687" y="5175249"/>
+            <a:ext cx="71437" cy="87313"/>
           </a:xfrm>
           <a:prstGeom prst="line">
             <a:avLst/>
           </a:prstGeom>
-          <a:ln w="9879">
+          <a:ln w="14604">
             <a:solidFill>
               <a:srgbClr val="1F2937"/>
             </a:solidFill>
@@ -7262,14 +7262,14 @@
         </p:nvSpPr>
         <p:spPr>
           <a:xfrm>
-            <a:off x="11069347" y="2133038"/>
-            <a:ext cx="101038" cy="101038"/>
+            <a:off x="9882187" y="5333999"/>
+            <a:ext cx="142874" cy="142874"/>
           </a:xfrm>
           <a:prstGeom prst="rect">
             <a:avLst/>
           </a:prstGeom>
           <a:noFill/>
-          <a:ln w="9879">
+          <a:ln w="14604">
             <a:solidFill>
               <a:srgbClr val="1F2937"/>
             </a:solidFill>
@@ -7306,13 +7306,13 @@
         </p:nvCxnSpPr>
         <p:spPr>
           <a:xfrm>
-            <a:off x="11226519" y="2183557"/>
-            <a:ext cx="224530" cy="0"/>
+            <a:off x="10112374" y="5413374"/>
+            <a:ext cx="341313" cy="0"/>
           </a:xfrm>
           <a:prstGeom prst="line">
             <a:avLst/>
           </a:prstGeom>
-          <a:ln w="9879">
+          <a:ln w="14604">
             <a:solidFill>
               <a:srgbClr val="1F2937"/>
             </a:solidFill>
@@ -7342,13 +7342,13 @@
         </p:nvCxnSpPr>
         <p:spPr>
           <a:xfrm>
-            <a:off x="11086187" y="2189171"/>
-            <a:ext cx="22453" cy="28066"/>
+            <a:off x="9913937" y="5413374"/>
+            <a:ext cx="31750" cy="39688"/>
           </a:xfrm>
           <a:prstGeom prst="line">
             <a:avLst/>
           </a:prstGeom>
-          <a:ln w="9879">
+          <a:ln w="14604">
             <a:solidFill>
               <a:srgbClr val="1F2937"/>
             </a:solidFill>
@@ -7378,13 +7378,13 @@
         </p:nvCxnSpPr>
         <p:spPr>
           <a:xfrm flipV="1">
-            <a:off x="11108640" y="2155491"/>
-            <a:ext cx="44906" cy="61746"/>
+            <a:off x="9945687" y="5365749"/>
+            <a:ext cx="71437" cy="87313"/>
           </a:xfrm>
           <a:prstGeom prst="line">
             <a:avLst/>
           </a:prstGeom>
-          <a:ln w="9879">
+          <a:ln w="14604">
             <a:solidFill>
               <a:srgbClr val="1F2937"/>
             </a:solidFill>
@@ -7414,14 +7414,14 @@
         </p:nvSpPr>
         <p:spPr>
           <a:xfrm>
-            <a:off x="11069347" y="2262143"/>
-            <a:ext cx="101038" cy="101038"/>
+            <a:off x="9882187" y="5524499"/>
+            <a:ext cx="142874" cy="142874"/>
           </a:xfrm>
           <a:prstGeom prst="rect">
             <a:avLst/>
           </a:prstGeom>
           <a:noFill/>
-          <a:ln w="9879">
+          <a:ln w="14604">
             <a:solidFill>
               <a:srgbClr val="1F2937"/>
             </a:solidFill>
@@ -7458,13 +7458,13 @@
         </p:nvCxnSpPr>
         <p:spPr>
           <a:xfrm>
-            <a:off x="11226519" y="2312662"/>
-            <a:ext cx="224530" cy="0"/>
+            <a:off x="10112374" y="5595937"/>
+            <a:ext cx="341313" cy="0"/>
           </a:xfrm>
           <a:prstGeom prst="line">
             <a:avLst/>
           </a:prstGeom>
-          <a:ln w="9879">
+          <a:ln w="14604">
             <a:solidFill>
               <a:srgbClr val="1F2937"/>
             </a:solidFill>
@@ -7494,18 +7494,18 @@
         </p:nvSpPr>
         <p:spPr>
           <a:xfrm>
-            <a:off x="10642740" y="2615778"/>
-            <a:ext cx="1223690" cy="370475"/>
+            <a:off x="8842374" y="5841999"/>
+            <a:ext cx="2635249" cy="492124"/>
           </a:xfrm>
           <a:prstGeom prst="roundRect">
             <a:avLst>
-              <a:gd name="adj" fmla="val 9090"/>
+              <a:gd name="adj" fmla="val 9677"/>
             </a:avLst>
           </a:prstGeom>
           <a:solidFill>
             <a:srgbClr val="F7F9FB"/>
           </a:solidFill>
-          <a:ln w="6735">
+          <a:ln w="9524">
             <a:solidFill>
               <a:srgbClr val="CBD3DA"/>
             </a:solidFill>
@@ -7542,8 +7542,8 @@
         </p:nvSpPr>
         <p:spPr>
           <a:xfrm>
-            <a:off x="10682032" y="2638231"/>
-            <a:ext cx="1145104" cy="325569"/>
+            <a:off x="8897937" y="5873749"/>
+            <a:ext cx="2524124" cy="428624"/>
           </a:xfrm>
           <a:prstGeom prst="rect">
             <a:avLst/>
@@ -7559,7 +7559,7 @@
           <a:p>
             <a:pPr algn="ctr" fontAlgn="base">
               <a:lnSpc>
-                <a:spcPts val="1160"/>
+                <a:spcPts val="2015"/>
               </a:lnSpc>
               <a:spcBef>
                 <a:spcPts val="0"/>
@@ -7567,7 +7567,7 @@
               <a:spcAft>
                 <a:spcPts val="0"/>
               </a:spcAft>
-              <a:defRPr sz="795" b="0" i="0" lang="zh-CN" dirty="0">
+              <a:defRPr sz="1374" b="0" i="0" lang="zh-CN" dirty="0">
                 <a:solidFill>
                   <a:srgbClr val="3F4854"/>
                 </a:solidFill>
@@ -7577,7 +7577,7 @@
               </a:defRPr>
             </a:pPr>
             <a:r>
-              <a:rPr sz="795" b="0" i="0" lang="zh-CN" dirty="0">
+              <a:rPr sz="1374" b="0" i="0" lang="zh-CN" dirty="0">
                 <a:solidFill>
                   <a:srgbClr val="3F4854"/>
                 </a:solidFill>
@@ -7588,7 +7588,7 @@
               <a:t>相图</a:t>
             </a:r>
             <a:r>
-              <a:rPr sz="795" b="0" i="0" lang="zh-CN" dirty="0">
+              <a:rPr sz="1374" b="0" i="0" lang="zh-CN" dirty="0">
                 <a:solidFill>
                   <a:srgbClr val="3F4854"/>
                 </a:solidFill>
@@ -7599,7 +7599,7 @@
               <a:t> · </a:t>
             </a:r>
             <a:r>
-              <a:rPr sz="795" b="0" i="0" lang="zh-CN" dirty="0">
+              <a:rPr sz="1374" b="0" i="0" lang="zh-CN" dirty="0">
                 <a:solidFill>
                   <a:srgbClr val="3F4854"/>
                 </a:solidFill>
@@ -7610,7 +7610,7 @@
               <a:t>结构</a:t>
             </a:r>
             <a:r>
-              <a:rPr sz="795" b="0" i="0" lang="zh-CN" dirty="0">
+              <a:rPr sz="1374" b="0" i="0" lang="zh-CN" dirty="0">
                 <a:solidFill>
                   <a:srgbClr val="3F4854"/>
                 </a:solidFill>
@@ -7621,7 +7621,7 @@
               <a:t> · </a:t>
             </a:r>
             <a:r>
-              <a:rPr sz="795" b="0" i="0" lang="zh-CN" dirty="0">
+              <a:rPr sz="1374" b="0" i="0" lang="zh-CN" dirty="0">
                 <a:solidFill>
                   <a:srgbClr val="3F4854"/>
                 </a:solidFill>
@@ -7642,8 +7642,8 @@
         </p:nvSpPr>
         <p:spPr>
           <a:xfrm>
-            <a:off x="1785017" y="2026387"/>
-            <a:ext cx="527646" cy="56133"/>
+            <a:off x="3794125" y="1905000"/>
+            <a:ext cx="825500" cy="79375"/>
           </a:xfrm>
           <a:custGeom>
             <a:avLst/>
@@ -7652,24 +7652,24 @@
             <a:cxnLst/>
             <a:rect l="l" t="t" r="r" b="b"/>
             <a:pathLst>
-              <a:path w="94000" h="10000">
+              <a:path w="104000" h="10000">
                 <a:moveTo>
                   <a:pt x="0" y="4100"/>
                 </a:moveTo>
                 <a:lnTo>
-                  <a:pt x="82000" y="4100"/>
+                  <a:pt x="92000" y="4100"/>
                 </a:lnTo>
                 <a:lnTo>
-                  <a:pt x="82000" y="0"/>
+                  <a:pt x="92000" y="0"/>
                 </a:lnTo>
                 <a:lnTo>
-                  <a:pt x="94000" y="5000"/>
+                  <a:pt x="104000" y="5000"/>
                 </a:lnTo>
                 <a:lnTo>
-                  <a:pt x="82000" y="10000"/>
+                  <a:pt x="92000" y="10000"/>
                 </a:lnTo>
                 <a:lnTo>
-                  <a:pt x="82000" y="5900"/>
+                  <a:pt x="92000" y="5900"/>
                 </a:lnTo>
                 <a:lnTo>
                   <a:pt x="0" y="5900"/>
@@ -7716,8 +7716,8 @@
         </p:nvSpPr>
         <p:spPr>
           <a:xfrm>
-            <a:off x="1756950" y="527646"/>
-            <a:ext cx="583778" cy="207690"/>
+            <a:off x="3746499" y="388937"/>
+            <a:ext cx="920749" cy="333374"/>
           </a:xfrm>
           <a:prstGeom prst="roundRect">
             <a:avLst>
@@ -7727,7 +7727,7 @@
           <a:solidFill>
             <a:srgbClr val="FFFFFF"/>
           </a:solidFill>
-          <a:ln w="6174">
+          <a:ln w="8731">
             <a:solidFill>
               <a:srgbClr val="CBD3DA"/>
             </a:solidFill>
@@ -7764,8 +7764,8 @@
         </p:nvSpPr>
         <p:spPr>
           <a:xfrm>
-            <a:off x="1813082" y="550099"/>
-            <a:ext cx="471513" cy="162784"/>
+            <a:off x="3825874" y="420687"/>
+            <a:ext cx="761999" cy="269874"/>
           </a:xfrm>
           <a:prstGeom prst="rect">
             <a:avLst/>
@@ -7781,7 +7781,7 @@
           <a:p>
             <a:pPr algn="ctr" fontAlgn="base">
               <a:lnSpc>
-                <a:spcPts val="1093"/>
+                <a:spcPts val="1828"/>
               </a:lnSpc>
               <a:spcBef>
                 <a:spcPts val="0"/>
@@ -7789,7 +7789,7 @@
               <a:spcAft>
                 <a:spcPts val="0"/>
               </a:spcAft>
-              <a:defRPr sz="751" b="0" i="0" lang="zh-CN" dirty="0">
+              <a:defRPr sz="1249" b="0" i="0" lang="zh-CN" dirty="0">
                 <a:solidFill>
                   <a:srgbClr val="3F4854"/>
                 </a:solidFill>
@@ -7799,7 +7799,7 @@
               </a:defRPr>
             </a:pPr>
             <a:r>
-              <a:rPr sz="751" b="0" i="0" lang="zh-CN" dirty="0">
+              <a:rPr sz="1249" b="0" i="0" lang="zh-CN" dirty="0">
                 <a:solidFill>
                   <a:srgbClr val="3F4854"/>
                 </a:solidFill>
@@ -7820,8 +7820,8 @@
         </p:nvSpPr>
         <p:spPr>
           <a:xfrm>
-            <a:off x="3805790" y="2026387"/>
-            <a:ext cx="527646" cy="56133"/>
+            <a:off x="7762875" y="1905000"/>
+            <a:ext cx="825500" cy="79375"/>
           </a:xfrm>
           <a:custGeom>
             <a:avLst/>
@@ -7830,24 +7830,24 @@
             <a:cxnLst/>
             <a:rect l="l" t="t" r="r" b="b"/>
             <a:pathLst>
-              <a:path w="94000" h="10000">
+              <a:path w="104000" h="10000">
                 <a:moveTo>
                   <a:pt x="0" y="4100"/>
                 </a:moveTo>
                 <a:lnTo>
-                  <a:pt x="82000" y="4100"/>
+                  <a:pt x="92000" y="4100"/>
                 </a:lnTo>
                 <a:lnTo>
-                  <a:pt x="82000" y="0"/>
+                  <a:pt x="92000" y="0"/>
                 </a:lnTo>
                 <a:lnTo>
-                  <a:pt x="94000" y="5000"/>
+                  <a:pt x="104000" y="5000"/>
                 </a:lnTo>
                 <a:lnTo>
-                  <a:pt x="82000" y="10000"/>
+                  <a:pt x="92000" y="10000"/>
                 </a:lnTo>
                 <a:lnTo>
-                  <a:pt x="82000" y="5900"/>
+                  <a:pt x="92000" y="5900"/>
                 </a:lnTo>
                 <a:lnTo>
                   <a:pt x="0" y="5900"/>
@@ -7894,8 +7894,8 @@
         </p:nvSpPr>
         <p:spPr>
           <a:xfrm>
-            <a:off x="3777723" y="527646"/>
-            <a:ext cx="583778" cy="207690"/>
+            <a:off x="7715249" y="388937"/>
+            <a:ext cx="920749" cy="333374"/>
           </a:xfrm>
           <a:prstGeom prst="roundRect">
             <a:avLst>
@@ -7905,7 +7905,7 @@
           <a:solidFill>
             <a:srgbClr val="FFFFFF"/>
           </a:solidFill>
-          <a:ln w="6174">
+          <a:ln w="8731">
             <a:solidFill>
               <a:srgbClr val="CBD3DA"/>
             </a:solidFill>
@@ -7942,8 +7942,8 @@
         </p:nvSpPr>
         <p:spPr>
           <a:xfrm>
-            <a:off x="3833856" y="550099"/>
-            <a:ext cx="471513" cy="162784"/>
+            <a:off x="7794624" y="420687"/>
+            <a:ext cx="761999" cy="269874"/>
           </a:xfrm>
           <a:prstGeom prst="rect">
             <a:avLst/>
@@ -7959,7 +7959,7 @@
           <a:p>
             <a:pPr algn="ctr" fontAlgn="base">
               <a:lnSpc>
-                <a:spcPts val="1093"/>
+                <a:spcPts val="1828"/>
               </a:lnSpc>
               <a:spcBef>
                 <a:spcPts val="0"/>
@@ -7967,7 +7967,7 @@
               <a:spcAft>
                 <a:spcPts val="0"/>
               </a:spcAft>
-              <a:defRPr sz="751" b="0" i="0" lang="zh-CN" dirty="0">
+              <a:defRPr sz="1249" b="0" i="0" lang="zh-CN" dirty="0">
                 <a:solidFill>
                   <a:srgbClr val="3F4854"/>
                 </a:solidFill>
@@ -7977,7 +7977,7 @@
               </a:defRPr>
             </a:pPr>
             <a:r>
-              <a:rPr sz="751" b="0" i="0" lang="zh-CN" dirty="0">
+              <a:rPr sz="1249" b="0" i="0" lang="zh-CN" dirty="0">
                 <a:solidFill>
                   <a:srgbClr val="3F4854"/>
                 </a:solidFill>
@@ -7992,14 +7992,14 @@
       </p:sp>
       <p:sp>
         <p:nvSpPr>
-          <p:cNvPr id="99" name="e2_0" descr="Editable line; source id e2_0"/>
+          <p:cNvPr id="99" name="e3_0" descr="Editable line; source id e3_0"/>
           <p:cNvSpPr/>
           <p:nvPr/>
         </p:nvSpPr>
         <p:spPr>
           <a:xfrm>
-            <a:off x="5826563" y="2026387"/>
-            <a:ext cx="639912" cy="56133"/>
+            <a:off x="3794125" y="5318125"/>
+            <a:ext cx="825500" cy="79375"/>
           </a:xfrm>
           <a:custGeom>
             <a:avLst/>
@@ -8008,24 +8008,24 @@
             <a:cxnLst/>
             <a:rect l="l" t="t" r="r" b="b"/>
             <a:pathLst>
-              <a:path w="114000" h="10000">
+              <a:path w="104000" h="10000">
                 <a:moveTo>
                   <a:pt x="0" y="4100"/>
                 </a:moveTo>
                 <a:lnTo>
-                  <a:pt x="102000" y="4100"/>
+                  <a:pt x="92000" y="4100"/>
                 </a:lnTo>
                 <a:lnTo>
-                  <a:pt x="102000" y="0"/>
+                  <a:pt x="92000" y="0"/>
                 </a:lnTo>
                 <a:lnTo>
-                  <a:pt x="114000" y="5000"/>
+                  <a:pt x="104000" y="5000"/>
                 </a:lnTo>
                 <a:lnTo>
-                  <a:pt x="102000" y="10000"/>
+                  <a:pt x="92000" y="10000"/>
                 </a:lnTo>
                 <a:lnTo>
-                  <a:pt x="102000" y="5900"/>
+                  <a:pt x="92000" y="5900"/>
                 </a:lnTo>
                 <a:lnTo>
                   <a:pt x="0" y="5900"/>
@@ -8066,14 +8066,14 @@
       </p:sp>
       <p:sp>
         <p:nvSpPr>
-          <p:cNvPr id="100" name="e2_p" descr="Editable shape; source id e2_p"/>
+          <p:cNvPr id="100" name="e3_p" descr="Editable shape; source id e3_p"/>
           <p:cNvSpPr/>
           <p:nvPr/>
         </p:nvSpPr>
         <p:spPr>
           <a:xfrm>
-            <a:off x="5804110" y="527646"/>
-            <a:ext cx="679204" cy="207690"/>
+            <a:off x="3746499" y="3802062"/>
+            <a:ext cx="920749" cy="333374"/>
           </a:xfrm>
           <a:prstGeom prst="roundRect">
             <a:avLst>
@@ -8083,7 +8083,7 @@
           <a:solidFill>
             <a:srgbClr val="FFFFFF"/>
           </a:solidFill>
-          <a:ln w="6174">
+          <a:ln w="8731">
             <a:solidFill>
               <a:srgbClr val="CBD3DA"/>
             </a:solidFill>
@@ -8114,14 +8114,14 @@
       </p:sp>
       <p:sp>
         <p:nvSpPr>
-          <p:cNvPr id="101" name="e2_p_t" descr="Editable text; source id e2_p_t"/>
+          <p:cNvPr id="101" name="e3_p_t" descr="Editable text; source id e3_p_t"/>
           <p:cNvSpPr txBox="1"/>
           <p:nvPr/>
         </p:nvSpPr>
         <p:spPr>
           <a:xfrm>
-            <a:off x="5860242" y="550099"/>
-            <a:ext cx="566939" cy="162784"/>
+            <a:off x="3825874" y="3833812"/>
+            <a:ext cx="761999" cy="269874"/>
           </a:xfrm>
           <a:prstGeom prst="rect">
             <a:avLst/>
@@ -8137,7 +8137,7 @@
           <a:p>
             <a:pPr algn="ctr" fontAlgn="base">
               <a:lnSpc>
-                <a:spcPts val="1093"/>
+                <a:spcPts val="1828"/>
               </a:lnSpc>
               <a:spcBef>
                 <a:spcPts val="0"/>
@@ -8145,7 +8145,7 @@
               <a:spcAft>
                 <a:spcPts val="0"/>
               </a:spcAft>
-              <a:defRPr sz="751" b="0" i="0" lang="zh-CN" dirty="0">
+              <a:defRPr sz="1249" b="0" i="0" lang="zh-CN" dirty="0">
                 <a:solidFill>
                   <a:srgbClr val="3F4854"/>
                 </a:solidFill>
@@ -8155,7 +8155,7 @@
               </a:defRPr>
             </a:pPr>
             <a:r>
-              <a:rPr sz="751" b="0" i="0" lang="zh-CN" dirty="0">
+              <a:rPr sz="1249" b="0" i="0" lang="zh-CN" dirty="0">
                 <a:solidFill>
                   <a:srgbClr val="3F4854"/>
                 </a:solidFill>
@@ -8163,21 +8163,21 @@
                 <a:ea typeface="Noto Sans CJK SC"/>
                 <a:cs typeface="Noto Sans CJK SC"/>
               </a:rPr>
-              <a:t>可迁移变量</a:t>
-            </a:r>
-          </a:p>
-        </p:txBody>
-      </p:sp>
-      <p:sp>
-        <p:nvSpPr>
-          <p:cNvPr id="102" name="e3_0" descr="Editable line; source id e3_0"/>
+              <a:t>比较边界</a:t>
+            </a:r>
+          </a:p>
+        </p:txBody>
+      </p:sp>
+      <p:sp>
+        <p:nvSpPr>
+          <p:cNvPr id="102" name="e4_0" descr="Editable line; source id e4_0"/>
           <p:cNvSpPr/>
           <p:nvPr/>
         </p:nvSpPr>
         <p:spPr>
           <a:xfrm>
-            <a:off x="7959602" y="2026387"/>
-            <a:ext cx="527646" cy="56133"/>
+            <a:off x="7762875" y="5318125"/>
+            <a:ext cx="825500" cy="79375"/>
           </a:xfrm>
           <a:custGeom>
             <a:avLst/>
@@ -8186,24 +8186,24 @@
             <a:cxnLst/>
             <a:rect l="l" t="t" r="r" b="b"/>
             <a:pathLst>
-              <a:path w="94000" h="10000">
+              <a:path w="104000" h="10000">
                 <a:moveTo>
                   <a:pt x="0" y="4100"/>
                 </a:moveTo>
                 <a:lnTo>
-                  <a:pt x="82000" y="4100"/>
+                  <a:pt x="92000" y="4100"/>
                 </a:lnTo>
                 <a:lnTo>
-                  <a:pt x="82000" y="0"/>
+                  <a:pt x="92000" y="0"/>
                 </a:lnTo>
                 <a:lnTo>
-                  <a:pt x="94000" y="5000"/>
+                  <a:pt x="104000" y="5000"/>
                 </a:lnTo>
                 <a:lnTo>
-                  <a:pt x="82000" y="10000"/>
+                  <a:pt x="92000" y="10000"/>
                 </a:lnTo>
                 <a:lnTo>
-                  <a:pt x="82000" y="5900"/>
+                  <a:pt x="92000" y="5900"/>
                 </a:lnTo>
                 <a:lnTo>
                   <a:pt x="0" y="5900"/>
@@ -8244,14 +8244,14 @@
       </p:sp>
       <p:sp>
         <p:nvSpPr>
-          <p:cNvPr id="103" name="e3_p" descr="Editable shape; source id e3_p"/>
+          <p:cNvPr id="103" name="e4_p" descr="Editable shape; source id e4_p"/>
           <p:cNvSpPr/>
           <p:nvPr/>
         </p:nvSpPr>
         <p:spPr>
           <a:xfrm>
-            <a:off x="7931535" y="527646"/>
-            <a:ext cx="583778" cy="207690"/>
+            <a:off x="7715249" y="3802062"/>
+            <a:ext cx="920749" cy="333374"/>
           </a:xfrm>
           <a:prstGeom prst="roundRect">
             <a:avLst>
@@ -8261,7 +8261,7 @@
           <a:solidFill>
             <a:srgbClr val="FFFFFF"/>
           </a:solidFill>
-          <a:ln w="6174">
+          <a:ln w="8731">
             <a:solidFill>
               <a:srgbClr val="CBD3DA"/>
             </a:solidFill>
@@ -8292,14 +8292,14 @@
       </p:sp>
       <p:sp>
         <p:nvSpPr>
-          <p:cNvPr id="104" name="e3_p_t" descr="Editable text; source id e3_p_t"/>
+          <p:cNvPr id="104" name="e4_p_t" descr="Editable text; source id e4_p_t"/>
           <p:cNvSpPr txBox="1"/>
           <p:nvPr/>
         </p:nvSpPr>
         <p:spPr>
           <a:xfrm>
-            <a:off x="7987668" y="550099"/>
-            <a:ext cx="471513" cy="162784"/>
+            <a:off x="7794624" y="3833812"/>
+            <a:ext cx="761999" cy="269874"/>
           </a:xfrm>
           <a:prstGeom prst="rect">
             <a:avLst/>
@@ -8315,7 +8315,7 @@
           <a:p>
             <a:pPr algn="ctr" fontAlgn="base">
               <a:lnSpc>
-                <a:spcPts val="1093"/>
+                <a:spcPts val="1828"/>
               </a:lnSpc>
               <a:spcBef>
                 <a:spcPts val="0"/>
@@ -8323,7 +8323,7 @@
               <a:spcAft>
                 <a:spcPts val="0"/>
               </a:spcAft>
-              <a:defRPr sz="751" b="0" i="0" lang="zh-CN" dirty="0">
+              <a:defRPr sz="1249" b="0" i="0" lang="zh-CN" dirty="0">
                 <a:solidFill>
                   <a:srgbClr val="3F4854"/>
                 </a:solidFill>
@@ -8333,7 +8333,7 @@
               </a:defRPr>
             </a:pPr>
             <a:r>
-              <a:rPr sz="751" b="0" i="0" lang="zh-CN" dirty="0">
+              <a:rPr sz="1249" b="0" i="0" lang="zh-CN" dirty="0">
                 <a:solidFill>
                   <a:srgbClr val="3F4854"/>
                 </a:solidFill>
@@ -8341,21 +8341,93 @@
                 <a:ea typeface="Noto Sans CJK SC"/>
                 <a:cs typeface="Noto Sans CJK SC"/>
               </a:rPr>
-              <a:t>比较边界</a:t>
-            </a:r>
-          </a:p>
-        </p:txBody>
-      </p:sp>
-      <p:sp>
-        <p:nvSpPr>
-          <p:cNvPr id="105" name="e4_0" descr="Editable line; source id e4_0"/>
+              <a:t>缺口驱动</a:t>
+            </a:r>
+          </a:p>
+        </p:txBody>
+      </p:sp>
+      <p:cxnSp>
+        <p:nvCxnSpPr>
+          <p:cNvPr id="105" name="e2_0" descr="Editable line; source id e2_0"/>
+          <p:cNvCxnSpPr/>
+          <p:nvPr/>
+        </p:nvCxnSpPr>
+        <p:spPr>
+          <a:xfrm>
+            <a:off x="10159999" y="3127374"/>
+            <a:ext cx="0" cy="444500"/>
+          </a:xfrm>
+          <a:prstGeom prst="line">
+            <a:avLst/>
+          </a:prstGeom>
+          <a:ln w="14287">
+            <a:solidFill>
+              <a:srgbClr val="4B5563"/>
+            </a:solidFill>
+          </a:ln>
+          <a:effectLst/>
+        </p:spPr>
+        <p:style>
+          <a:lnRef idx="2">
+            <a:schemeClr val="accent1"/>
+          </a:lnRef>
+          <a:fillRef idx="0">
+            <a:schemeClr val="accent1"/>
+          </a:fillRef>
+          <a:effectRef idx="0">
+            <a:schemeClr val="accent1"/>
+          </a:effectRef>
+          <a:fontRef idx="minor">
+            <a:schemeClr val="tx1"/>
+          </a:fontRef>
+        </p:style>
+      </p:cxnSp>
+      <p:cxnSp>
+        <p:nvCxnSpPr>
+          <p:cNvPr id="106" name="e2_1" descr="Editable line; source id e2_1"/>
+          <p:cNvCxnSpPr/>
+          <p:nvPr/>
+        </p:nvCxnSpPr>
+        <p:spPr>
+          <a:xfrm flipH="1">
+            <a:off x="2222499" y="3571874"/>
+            <a:ext cx="7937500" cy="0"/>
+          </a:xfrm>
+          <a:prstGeom prst="line">
+            <a:avLst/>
+          </a:prstGeom>
+          <a:ln w="14287">
+            <a:solidFill>
+              <a:srgbClr val="4B5563"/>
+            </a:solidFill>
+          </a:ln>
+          <a:effectLst/>
+        </p:spPr>
+        <p:style>
+          <a:lnRef idx="2">
+            <a:schemeClr val="accent1"/>
+          </a:lnRef>
+          <a:fillRef idx="0">
+            <a:schemeClr val="accent1"/>
+          </a:fillRef>
+          <a:effectRef idx="0">
+            <a:schemeClr val="accent1"/>
+          </a:effectRef>
+          <a:fontRef idx="minor">
+            <a:schemeClr val="tx1"/>
+          </a:fontRef>
+        </p:style>
+      </p:cxnSp>
+      <p:sp>
+        <p:nvSpPr>
+          <p:cNvPr id="107" name="e2_2" descr="Editable line; source id e2_2"/>
           <p:cNvSpPr/>
           <p:nvPr/>
         </p:nvSpPr>
         <p:spPr>
           <a:xfrm>
-            <a:off x="9980375" y="2026387"/>
-            <a:ext cx="527646" cy="56133"/>
+            <a:off x="2182812" y="3571875"/>
+            <a:ext cx="79375" cy="603250"/>
           </a:xfrm>
           <a:custGeom>
             <a:avLst/>
@@ -8364,27 +8436,27 @@
             <a:cxnLst/>
             <a:rect l="l" t="t" r="r" b="b"/>
             <a:pathLst>
-              <a:path w="94000" h="10000">
+              <a:path w="10000" h="76000">
                 <a:moveTo>
-                  <a:pt x="0" y="4100"/>
+                  <a:pt x="5900" y="0"/>
                 </a:moveTo>
                 <a:lnTo>
-                  <a:pt x="82000" y="4100"/>
+                  <a:pt x="5900" y="64000"/>
                 </a:lnTo>
                 <a:lnTo>
-                  <a:pt x="82000" y="0"/>
+                  <a:pt x="10000" y="64000"/>
                 </a:lnTo>
                 <a:lnTo>
-                  <a:pt x="94000" y="5000"/>
+                  <a:pt x="5000" y="76000"/>
                 </a:lnTo>
                 <a:lnTo>
-                  <a:pt x="82000" y="10000"/>
+                  <a:pt x="0" y="64000"/>
                 </a:lnTo>
                 <a:lnTo>
-                  <a:pt x="82000" y="5900"/>
+                  <a:pt x="4100" y="64000"/>
                 </a:lnTo>
                 <a:lnTo>
-                  <a:pt x="0" y="5900"/>
+                  <a:pt x="4100" y="0"/>
                 </a:lnTo>
                 <a:close/>
               </a:path>
@@ -8422,14 +8494,14 @@
       </p:sp>
       <p:sp>
         <p:nvSpPr>
-          <p:cNvPr id="106" name="e4_p" descr="Editable shape; source id e4_p"/>
+          <p:cNvPr id="108" name="e2_p" descr="Editable shape; source id e2_p"/>
           <p:cNvSpPr/>
           <p:nvPr/>
         </p:nvSpPr>
         <p:spPr>
           <a:xfrm>
-            <a:off x="9952309" y="527646"/>
-            <a:ext cx="583778" cy="207690"/>
+            <a:off x="5651499" y="3405187"/>
+            <a:ext cx="1079499" cy="333374"/>
           </a:xfrm>
           <a:prstGeom prst="roundRect">
             <a:avLst>
@@ -8439,7 +8511,7 @@
           <a:solidFill>
             <a:srgbClr val="FFFFFF"/>
           </a:solidFill>
-          <a:ln w="6174">
+          <a:ln w="8731">
             <a:solidFill>
               <a:srgbClr val="CBD3DA"/>
             </a:solidFill>
@@ -8470,14 +8542,14 @@
       </p:sp>
       <p:sp>
         <p:nvSpPr>
-          <p:cNvPr id="107" name="e4_p_t" descr="Editable text; source id e4_p_t"/>
+          <p:cNvPr id="109" name="e2_p_t" descr="Editable text; source id e2_p_t"/>
           <p:cNvSpPr txBox="1"/>
           <p:nvPr/>
         </p:nvSpPr>
         <p:spPr>
           <a:xfrm>
-            <a:off x="10008441" y="550099"/>
-            <a:ext cx="471513" cy="162784"/>
+            <a:off x="5730874" y="3436937"/>
+            <a:ext cx="920749" cy="269874"/>
           </a:xfrm>
           <a:prstGeom prst="rect">
             <a:avLst/>
@@ -8493,7 +8565,7 @@
           <a:p>
             <a:pPr algn="ctr" fontAlgn="base">
               <a:lnSpc>
-                <a:spcPts val="1093"/>
+                <a:spcPts val="1828"/>
               </a:lnSpc>
               <a:spcBef>
                 <a:spcPts val="0"/>
@@ -8501,7 +8573,7 @@
               <a:spcAft>
                 <a:spcPts val="0"/>
               </a:spcAft>
-              <a:defRPr sz="751" b="0" i="0" lang="zh-CN" dirty="0">
+              <a:defRPr sz="1249" b="0" i="0" lang="zh-CN" dirty="0">
                 <a:solidFill>
                   <a:srgbClr val="3F4854"/>
                 </a:solidFill>
@@ -8511,7 +8583,7 @@
               </a:defRPr>
             </a:pPr>
             <a:r>
-              <a:rPr sz="751" b="0" i="0" lang="zh-CN" dirty="0">
+              <a:rPr sz="1249" b="0" i="0" lang="zh-CN" dirty="0">
                 <a:solidFill>
                   <a:srgbClr val="3F4854"/>
                 </a:solidFill>
@@ -8519,7 +8591,7 @@
                 <a:ea typeface="Noto Sans CJK SC"/>
                 <a:cs typeface="Noto Sans CJK SC"/>
               </a:rPr>
-              <a:t>缺口驱动</a:t>
+              <a:t>可迁移变量</a:t>
             </a:r>
           </a:p>
         </p:txBody>

</xml_diff>

<commit_message>
dashboard: 2026-09-14 04:18 刷新
</commit_message>
<xml_diff>
--- a/media/figstudio/bzso_roadmap/roadmap_bazn2si2o7_editable.pptx
+++ b/media/figstudio/bzso_roadmap/roadmap_bazn2si2o7_editable.pptx
@@ -8406,8 +8406,8 @@
         </p:nvCxnSpPr>
         <p:spPr>
           <a:xfrm flipH="1">
-            <a:off x="2222499" y="3540124"/>
-            <a:ext cx="7937500" cy="0"/>
+            <a:off x="2857499" y="3540124"/>
+            <a:ext cx="7302500" cy="0"/>
           </a:xfrm>
           <a:prstGeom prst="line">
             <a:avLst/>
@@ -8442,7 +8442,7 @@
         </p:nvSpPr>
         <p:spPr>
           <a:xfrm>
-            <a:off x="2182812" y="3540125"/>
+            <a:off x="2817812" y="3540125"/>
             <a:ext cx="79375" cy="730250"/>
           </a:xfrm>
           <a:custGeom>
@@ -8516,7 +8516,7 @@
         </p:nvSpPr>
         <p:spPr>
           <a:xfrm>
-            <a:off x="5691187" y="3381374"/>
+            <a:off x="6008687" y="3381374"/>
             <a:ext cx="1000124" cy="309562"/>
           </a:xfrm>
           <a:prstGeom prst="roundRect">
@@ -8564,7 +8564,7 @@
         </p:nvSpPr>
         <p:spPr>
           <a:xfrm>
-            <a:off x="5770562" y="3413124"/>
+            <a:off x="6088062" y="3413124"/>
             <a:ext cx="841374" cy="246062"/>
           </a:xfrm>
           <a:prstGeom prst="rect">

</xml_diff>

<commit_message>
dashboard: 2026-09-14 17:04 刷新
</commit_message>
<xml_diff>
--- a/media/figstudio/bzso_roadmap/roadmap_bazn2si2o7_editable.pptx
+++ b/media/figstudio/bzso_roadmap/roadmap_bazn2si2o7_editable.pptx
@@ -3535,7 +3535,7 @@
           <a:solidFill>
             <a:srgbClr val="EEF2F7"/>
           </a:solidFill>
-          <a:ln w="9524">
+          <a:ln w="12699">
             <a:solidFill>
               <a:srgbClr val="5B7592"/>
             </a:solidFill>
@@ -3639,7 +3639,7 @@
           <a:solidFill>
             <a:srgbClr val="E6F2F3"/>
           </a:solidFill>
-          <a:ln w="9524">
+          <a:ln w="12699">
             <a:solidFill>
               <a:srgbClr val="1F7F8C"/>
             </a:solidFill>
@@ -3743,7 +3743,7 @@
           <a:solidFill>
             <a:srgbClr val="FFFFFF"/>
           </a:solidFill>
-          <a:ln w="11112">
+          <a:ln w="15081">
             <a:solidFill>
               <a:srgbClr val="5B7592"/>
             </a:solidFill>
@@ -3888,9 +3888,9 @@
           <a:prstGeom prst="line">
             <a:avLst/>
           </a:prstGeom>
-          <a:ln w="14604">
+          <a:ln w="19716">
             <a:solidFill>
-              <a:srgbClr val="1F2937"/>
+              <a:srgbClr val="111A24"/>
             </a:solidFill>
           </a:ln>
           <a:effectLst/>
@@ -3924,9 +3924,9 @@
           <a:prstGeom prst="line">
             <a:avLst/>
           </a:prstGeom>
-          <a:ln w="14604">
+          <a:ln w="19716">
             <a:solidFill>
-              <a:srgbClr val="1F2937"/>
+              <a:srgbClr val="111A24"/>
             </a:solidFill>
           </a:ln>
           <a:effectLst/>
@@ -3960,9 +3960,9 @@
           <a:prstGeom prst="line">
             <a:avLst/>
           </a:prstGeom>
-          <a:ln w="14604">
+          <a:ln w="19716">
             <a:solidFill>
-              <a:srgbClr val="1F2937"/>
+              <a:srgbClr val="111A24"/>
             </a:solidFill>
           </a:ln>
           <a:effectLst/>
@@ -3996,9 +3996,9 @@
           <a:prstGeom prst="line">
             <a:avLst/>
           </a:prstGeom>
-          <a:ln w="14604">
+          <a:ln w="19716">
             <a:solidFill>
-              <a:srgbClr val="1F2937"/>
+              <a:srgbClr val="111A24"/>
             </a:solidFill>
           </a:ln>
           <a:effectLst/>
@@ -4032,9 +4032,9 @@
           <a:prstGeom prst="line">
             <a:avLst/>
           </a:prstGeom>
-          <a:ln w="14604">
+          <a:ln w="19716">
             <a:solidFill>
-              <a:srgbClr val="1F2937"/>
+              <a:srgbClr val="111A24"/>
             </a:solidFill>
           </a:ln>
           <a:effectLst/>
@@ -4068,9 +4068,9 @@
           <a:prstGeom prst="line">
             <a:avLst/>
           </a:prstGeom>
-          <a:ln w="14604">
+          <a:ln w="19716">
             <a:solidFill>
-              <a:srgbClr val="1F2937"/>
+              <a:srgbClr val="111A24"/>
             </a:solidFill>
           </a:ln>
           <a:effectLst/>
@@ -4104,9 +4104,9 @@
           <a:prstGeom prst="line">
             <a:avLst/>
           </a:prstGeom>
-          <a:ln w="14604">
+          <a:ln w="19716">
             <a:solidFill>
-              <a:srgbClr val="1F2937"/>
+              <a:srgbClr val="111A24"/>
             </a:solidFill>
           </a:ln>
           <a:effectLst/>
@@ -4196,9 +4196,9 @@
           <a:prstGeom prst="line">
             <a:avLst/>
           </a:prstGeom>
-          <a:ln w="9524">
+          <a:ln w="12699">
             <a:solidFill>
-              <a:srgbClr val="E3E8ED"/>
+              <a:srgbClr val="CBD5DE"/>
             </a:solidFill>
           </a:ln>
           <a:effectLst/>
@@ -4235,11 +4235,11 @@
             </a:avLst>
           </a:prstGeom>
           <a:solidFill>
-            <a:srgbClr val="F7F9FB"/>
+            <a:srgbClr val="F4F7FA"/>
           </a:solidFill>
-          <a:ln w="9524">
+          <a:ln w="12699">
             <a:solidFill>
-              <a:srgbClr val="CBD3DA"/>
+              <a:srgbClr val="AEBBC7"/>
             </a:solidFill>
           </a:ln>
           <a:effectLst/>
@@ -4299,9 +4299,9 @@
               <a:spcAft>
                 <a:spcPts val="0"/>
               </a:spcAft>
-              <a:defRPr sz="1185" b="0" i="0" lang="zh-CN" dirty="0">
+              <a:defRPr sz="1185" b="1" i="0" lang="zh-CN" dirty="0">
                 <a:solidFill>
-                  <a:srgbClr val="3F4854"/>
+                  <a:srgbClr val="27303A"/>
                 </a:solidFill>
                 <a:latin typeface="Noto Sans CJK SC"/>
                 <a:ea typeface="Noto Sans CJK SC"/>
@@ -4309,9 +4309,9 @@
               </a:defRPr>
             </a:pPr>
             <a:r>
-              <a:rPr sz="1185" b="0" i="0" lang="zh-CN" dirty="0">
+              <a:rPr sz="1185" b="1" i="0" lang="zh-CN" dirty="0">
                 <a:solidFill>
-                  <a:srgbClr val="3F4854"/>
+                  <a:srgbClr val="27303A"/>
                 </a:solidFill>
                 <a:latin typeface="Noto Sans CJK SC"/>
                 <a:ea typeface="Noto Sans CJK SC"/>
@@ -4341,7 +4341,7 @@
           <a:solidFill>
             <a:srgbClr val="FFFFFF"/>
           </a:solidFill>
-          <a:ln w="11112">
+          <a:ln w="15081">
             <a:solidFill>
               <a:srgbClr val="5B7592"/>
             </a:solidFill>
@@ -4486,9 +4486,9 @@
           <a:prstGeom prst="line">
             <a:avLst/>
           </a:prstGeom>
-          <a:ln w="14604">
+          <a:ln w="19716">
             <a:solidFill>
-              <a:srgbClr val="1F2937"/>
+              <a:srgbClr val="111A24"/>
             </a:solidFill>
           </a:ln>
           <a:effectLst/>
@@ -4522,9 +4522,9 @@
           <a:prstGeom prst="line">
             <a:avLst/>
           </a:prstGeom>
-          <a:ln w="14604">
+          <a:ln w="19716">
             <a:solidFill>
-              <a:srgbClr val="1F2937"/>
+              <a:srgbClr val="111A24"/>
             </a:solidFill>
           </a:ln>
           <a:effectLst/>
@@ -4558,9 +4558,9 @@
           <a:prstGeom prst="line">
             <a:avLst/>
           </a:prstGeom>
-          <a:ln w="14604">
+          <a:ln w="19716">
             <a:solidFill>
-              <a:srgbClr val="1F2937"/>
+              <a:srgbClr val="111A24"/>
             </a:solidFill>
           </a:ln>
           <a:effectLst/>
@@ -4594,9 +4594,9 @@
           <a:prstGeom prst="line">
             <a:avLst/>
           </a:prstGeom>
-          <a:ln w="14604">
+          <a:ln w="19716">
             <a:solidFill>
-              <a:srgbClr val="1F2937"/>
+              <a:srgbClr val="111A24"/>
             </a:solidFill>
           </a:ln>
           <a:effectLst/>
@@ -4686,9 +4686,9 @@
           <a:prstGeom prst="line">
             <a:avLst/>
           </a:prstGeom>
-          <a:ln w="9524">
+          <a:ln w="12699">
             <a:solidFill>
-              <a:srgbClr val="E3E8ED"/>
+              <a:srgbClr val="CBD5DE"/>
             </a:solidFill>
           </a:ln>
           <a:effectLst/>
@@ -4725,11 +4725,11 @@
             </a:avLst>
           </a:prstGeom>
           <a:solidFill>
-            <a:srgbClr val="F7F9FB"/>
+            <a:srgbClr val="F4F7FA"/>
           </a:solidFill>
-          <a:ln w="9524">
+          <a:ln w="12699">
             <a:solidFill>
-              <a:srgbClr val="CBD3DA"/>
+              <a:srgbClr val="AEBBC7"/>
             </a:solidFill>
           </a:ln>
           <a:effectLst/>
@@ -4789,9 +4789,9 @@
               <a:spcAft>
                 <a:spcPts val="0"/>
               </a:spcAft>
-              <a:defRPr sz="1185" b="0" i="0" lang="zh-CN" dirty="0">
+              <a:defRPr sz="1185" b="1" i="0" lang="zh-CN" dirty="0">
                 <a:solidFill>
-                  <a:srgbClr val="3F4854"/>
+                  <a:srgbClr val="27303A"/>
                 </a:solidFill>
                 <a:latin typeface="Noto Sans CJK SC"/>
                 <a:ea typeface="Noto Sans CJK SC"/>
@@ -4799,9 +4799,9 @@
               </a:defRPr>
             </a:pPr>
             <a:r>
-              <a:rPr sz="1185" b="0" i="0" lang="zh-CN" dirty="0">
+              <a:rPr sz="1185" b="1" i="0" lang="zh-CN" dirty="0">
                 <a:solidFill>
-                  <a:srgbClr val="3F4854"/>
+                  <a:srgbClr val="27303A"/>
                 </a:solidFill>
                 <a:latin typeface="Noto Sans CJK SC"/>
                 <a:ea typeface="Noto Sans CJK SC"/>
@@ -4810,9 +4810,9 @@
               <a:t>固相</a:t>
             </a:r>
             <a:r>
-              <a:rPr sz="1185" b="0" i="0" lang="zh-CN" dirty="0">
+              <a:rPr sz="1185" b="1" i="0" lang="zh-CN" dirty="0">
                 <a:solidFill>
-                  <a:srgbClr val="3F4854"/>
+                  <a:srgbClr val="27303A"/>
                 </a:solidFill>
                 <a:latin typeface="DejaVu Sans"/>
                 <a:ea typeface="DejaVu Sans"/>
@@ -4821,9 +4821,9 @@
               <a:t> · </a:t>
             </a:r>
             <a:r>
-              <a:rPr sz="1185" b="0" i="0" lang="zh-CN" dirty="0">
+              <a:rPr sz="1185" b="1" i="0" lang="zh-CN" dirty="0">
                 <a:solidFill>
-                  <a:srgbClr val="3F4854"/>
+                  <a:srgbClr val="27303A"/>
                 </a:solidFill>
                 <a:latin typeface="Noto Sans CJK SC"/>
                 <a:ea typeface="Noto Sans CJK SC"/>
@@ -4832,9 +4832,9 @@
               <a:t>溶胶</a:t>
             </a:r>
             <a:r>
-              <a:rPr sz="1185" b="0" i="0" lang="zh-CN" dirty="0">
+              <a:rPr sz="1185" b="1" i="0" lang="zh-CN" dirty="0">
                 <a:solidFill>
-                  <a:srgbClr val="3F4854"/>
+                  <a:srgbClr val="27303A"/>
                 </a:solidFill>
                 <a:latin typeface="DejaVu Sans"/>
                 <a:ea typeface="DejaVu Sans"/>
@@ -4843,9 +4843,9 @@
               <a:t>—</a:t>
             </a:r>
             <a:r>
-              <a:rPr sz="1185" b="0" i="0" lang="zh-CN" dirty="0">
+              <a:rPr sz="1185" b="1" i="0" lang="zh-CN" dirty="0">
                 <a:solidFill>
-                  <a:srgbClr val="3F4854"/>
+                  <a:srgbClr val="27303A"/>
                 </a:solidFill>
                 <a:latin typeface="Noto Sans CJK SC"/>
                 <a:ea typeface="Noto Sans CJK SC"/>
@@ -4875,7 +4875,7 @@
           <a:solidFill>
             <a:srgbClr val="FFFFFF"/>
           </a:solidFill>
-          <a:ln w="11112">
+          <a:ln w="15081">
             <a:solidFill>
               <a:srgbClr val="5B7592"/>
             </a:solidFill>
@@ -5020,9 +5020,9 @@
           <a:prstGeom prst="line">
             <a:avLst/>
           </a:prstGeom>
-          <a:ln w="14604">
+          <a:ln w="19716">
             <a:solidFill>
-              <a:srgbClr val="1F2937"/>
+              <a:srgbClr val="111A24"/>
             </a:solidFill>
           </a:ln>
           <a:effectLst/>
@@ -5056,9 +5056,9 @@
           <a:prstGeom prst="line">
             <a:avLst/>
           </a:prstGeom>
-          <a:ln w="14604">
+          <a:ln w="19716">
             <a:solidFill>
-              <a:srgbClr val="1F2937"/>
+              <a:srgbClr val="111A24"/>
             </a:solidFill>
           </a:ln>
           <a:effectLst/>
@@ -5092,9 +5092,9 @@
           <a:prstGeom prst="line">
             <a:avLst/>
           </a:prstGeom>
-          <a:ln w="14604">
+          <a:ln w="19716">
             <a:solidFill>
-              <a:srgbClr val="1F2937"/>
+              <a:srgbClr val="111A24"/>
             </a:solidFill>
           </a:ln>
           <a:effectLst/>
@@ -5128,9 +5128,9 @@
           <a:prstGeom prst="line">
             <a:avLst/>
           </a:prstGeom>
-          <a:ln w="14604">
+          <a:ln w="19716">
             <a:solidFill>
-              <a:srgbClr val="1F2937"/>
+              <a:srgbClr val="111A24"/>
             </a:solidFill>
           </a:ln>
           <a:effectLst/>
@@ -5164,9 +5164,9 @@
           <a:prstGeom prst="line">
             <a:avLst/>
           </a:prstGeom>
-          <a:ln w="14604">
+          <a:ln w="19716">
             <a:solidFill>
-              <a:srgbClr val="1F2937"/>
+              <a:srgbClr val="111A24"/>
             </a:solidFill>
           </a:ln>
           <a:effectLst/>
@@ -5200,9 +5200,9 @@
           <a:prstGeom prst="line">
             <a:avLst/>
           </a:prstGeom>
-          <a:ln w="14604">
+          <a:ln w="19716">
             <a:solidFill>
-              <a:srgbClr val="1F2937"/>
+              <a:srgbClr val="111A24"/>
             </a:solidFill>
           </a:ln>
           <a:effectLst/>
@@ -5236,9 +5236,9 @@
           <a:prstGeom prst="line">
             <a:avLst/>
           </a:prstGeom>
-          <a:ln w="14604">
+          <a:ln w="19716">
             <a:solidFill>
-              <a:srgbClr val="1F2937"/>
+              <a:srgbClr val="111A24"/>
             </a:solidFill>
           </a:ln>
           <a:effectLst/>
@@ -5272,9 +5272,9 @@
           <a:prstGeom prst="line">
             <a:avLst/>
           </a:prstGeom>
-          <a:ln w="14604">
+          <a:ln w="19716">
             <a:solidFill>
-              <a:srgbClr val="1F2937"/>
+              <a:srgbClr val="111A24"/>
             </a:solidFill>
           </a:ln>
           <a:effectLst/>
@@ -5308,9 +5308,9 @@
           <a:prstGeom prst="line">
             <a:avLst/>
           </a:prstGeom>
-          <a:ln w="14604">
+          <a:ln w="19716">
             <a:solidFill>
-              <a:srgbClr val="1F2937"/>
+              <a:srgbClr val="111A24"/>
             </a:solidFill>
           </a:ln>
           <a:effectLst/>
@@ -5344,9 +5344,9 @@
           <a:prstGeom prst="line">
             <a:avLst/>
           </a:prstGeom>
-          <a:ln w="14604">
+          <a:ln w="19716">
             <a:solidFill>
-              <a:srgbClr val="1F2937"/>
+              <a:srgbClr val="111A24"/>
             </a:solidFill>
           </a:ln>
           <a:effectLst/>
@@ -5380,9 +5380,9 @@
           <a:prstGeom prst="line">
             <a:avLst/>
           </a:prstGeom>
-          <a:ln w="14604">
+          <a:ln w="19716">
             <a:solidFill>
-              <a:srgbClr val="1F2937"/>
+              <a:srgbClr val="111A24"/>
             </a:solidFill>
           </a:ln>
           <a:effectLst/>
@@ -5416,9 +5416,9 @@
           <a:prstGeom prst="line">
             <a:avLst/>
           </a:prstGeom>
-          <a:ln w="14604">
+          <a:ln w="19716">
             <a:solidFill>
-              <a:srgbClr val="1F2937"/>
+              <a:srgbClr val="111A24"/>
             </a:solidFill>
           </a:ln>
           <a:effectLst/>
@@ -5508,9 +5508,9 @@
           <a:prstGeom prst="line">
             <a:avLst/>
           </a:prstGeom>
-          <a:ln w="9524">
+          <a:ln w="12699">
             <a:solidFill>
-              <a:srgbClr val="E3E8ED"/>
+              <a:srgbClr val="CBD5DE"/>
             </a:solidFill>
           </a:ln>
           <a:effectLst/>
@@ -5547,11 +5547,11 @@
             </a:avLst>
           </a:prstGeom>
           <a:solidFill>
-            <a:srgbClr val="F7F9FB"/>
+            <a:srgbClr val="F4F7FA"/>
           </a:solidFill>
-          <a:ln w="9524">
+          <a:ln w="12699">
             <a:solidFill>
-              <a:srgbClr val="CBD3DA"/>
+              <a:srgbClr val="AEBBC7"/>
             </a:solidFill>
           </a:ln>
           <a:effectLst/>
@@ -5611,9 +5611,9 @@
               <a:spcAft>
                 <a:spcPts val="0"/>
               </a:spcAft>
-              <a:defRPr sz="1185" b="0" i="0" lang="zh-CN" dirty="0">
+              <a:defRPr sz="1185" b="1" i="0" lang="zh-CN" dirty="0">
                 <a:solidFill>
-                  <a:srgbClr val="3F4854"/>
+                  <a:srgbClr val="27303A"/>
                 </a:solidFill>
                 <a:latin typeface="Noto Sans CJK SC"/>
                 <a:ea typeface="Noto Sans CJK SC"/>
@@ -5621,9 +5621,9 @@
               </a:defRPr>
             </a:pPr>
             <a:r>
-              <a:rPr sz="1185" b="0" i="0" lang="zh-CN" dirty="0">
+              <a:rPr sz="1185" b="1" i="0" lang="zh-CN" dirty="0">
                 <a:solidFill>
-                  <a:srgbClr val="3F4854"/>
+                  <a:srgbClr val="27303A"/>
                 </a:solidFill>
                 <a:latin typeface="Noto Sans CJK SC"/>
                 <a:ea typeface="Noto Sans CJK SC"/>
@@ -5632,9 +5632,9 @@
               <a:t>组成</a:t>
             </a:r>
             <a:r>
-              <a:rPr sz="1185" b="0" i="0" lang="zh-CN" dirty="0">
+              <a:rPr sz="1185" b="1" i="0" lang="zh-CN" dirty="0">
                 <a:solidFill>
-                  <a:srgbClr val="3F4854"/>
+                  <a:srgbClr val="27303A"/>
                 </a:solidFill>
                 <a:latin typeface="DejaVu Sans"/>
                 <a:ea typeface="DejaVu Sans"/>
@@ -5643,9 +5643,9 @@
               <a:t> · </a:t>
             </a:r>
             <a:r>
-              <a:rPr sz="1185" b="0" i="0" lang="zh-CN" dirty="0">
+              <a:rPr sz="1185" b="1" i="0" lang="zh-CN" dirty="0">
                 <a:solidFill>
-                  <a:srgbClr val="3F4854"/>
+                  <a:srgbClr val="27303A"/>
                 </a:solidFill>
                 <a:latin typeface="Noto Sans CJK SC"/>
                 <a:ea typeface="Noto Sans CJK SC"/>
@@ -5675,7 +5675,7 @@
           <a:solidFill>
             <a:srgbClr val="FFFFFF"/>
           </a:solidFill>
-          <a:ln w="11112">
+          <a:ln w="15081">
             <a:solidFill>
               <a:srgbClr val="1F7F8C"/>
             </a:solidFill>
@@ -5821,9 +5821,9 @@
             <a:avLst/>
           </a:prstGeom>
           <a:noFill/>
-          <a:ln w="14604">
+          <a:ln w="19716">
             <a:solidFill>
-              <a:srgbClr val="1F2937"/>
+              <a:srgbClr val="111A24"/>
             </a:solidFill>
           </a:ln>
           <a:effectLst/>
@@ -5865,9 +5865,9 @@
             <a:avLst/>
           </a:prstGeom>
           <a:noFill/>
-          <a:ln w="14604">
+          <a:ln w="19716">
             <a:solidFill>
-              <a:srgbClr val="1F2937"/>
+              <a:srgbClr val="111A24"/>
             </a:solidFill>
           </a:ln>
           <a:effectLst/>
@@ -5909,9 +5909,9 @@
             <a:avLst/>
           </a:prstGeom>
           <a:noFill/>
-          <a:ln w="14604">
+          <a:ln w="19716">
             <a:solidFill>
-              <a:srgbClr val="1F2937"/>
+              <a:srgbClr val="111A24"/>
             </a:solidFill>
           </a:ln>
           <a:effectLst/>
@@ -5952,9 +5952,9 @@
           <a:prstGeom prst="line">
             <a:avLst/>
           </a:prstGeom>
-          <a:ln w="14604">
+          <a:ln w="19716">
             <a:solidFill>
-              <a:srgbClr val="1F2937"/>
+              <a:srgbClr val="111A24"/>
             </a:solidFill>
           </a:ln>
           <a:effectLst/>
@@ -5988,9 +5988,9 @@
           <a:prstGeom prst="line">
             <a:avLst/>
           </a:prstGeom>
-          <a:ln w="14604">
+          <a:ln w="19716">
             <a:solidFill>
-              <a:srgbClr val="1F2937"/>
+              <a:srgbClr val="111A24"/>
             </a:solidFill>
           </a:ln>
           <a:effectLst/>
@@ -6080,9 +6080,9 @@
           <a:prstGeom prst="line">
             <a:avLst/>
           </a:prstGeom>
-          <a:ln w="9524">
+          <a:ln w="12699">
             <a:solidFill>
-              <a:srgbClr val="E3E8ED"/>
+              <a:srgbClr val="CBD5DE"/>
             </a:solidFill>
           </a:ln>
           <a:effectLst/>
@@ -6119,11 +6119,11 @@
             </a:avLst>
           </a:prstGeom>
           <a:solidFill>
-            <a:srgbClr val="F7F9FB"/>
+            <a:srgbClr val="F4F7FA"/>
           </a:solidFill>
-          <a:ln w="9524">
+          <a:ln w="12699">
             <a:solidFill>
-              <a:srgbClr val="CBD3DA"/>
+              <a:srgbClr val="AEBBC7"/>
             </a:solidFill>
           </a:ln>
           <a:effectLst/>
@@ -6183,9 +6183,9 @@
               <a:spcAft>
                 <a:spcPts val="0"/>
               </a:spcAft>
-              <a:defRPr sz="1185" b="0" i="0" lang="zh-CN" dirty="0">
+              <a:defRPr sz="1185" b="1" i="0" lang="zh-CN" dirty="0">
                 <a:solidFill>
-                  <a:srgbClr val="3F4854"/>
+                  <a:srgbClr val="27303A"/>
                 </a:solidFill>
                 <a:latin typeface="DejaVu Sans"/>
                 <a:ea typeface="DejaVu Sans"/>
@@ -6193,9 +6193,9 @@
               </a:defRPr>
             </a:pPr>
             <a:r>
-              <a:rPr sz="1185" b="0" i="0" lang="zh-CN" dirty="0">
+              <a:rPr sz="1185" b="1" i="0" lang="zh-CN" dirty="0">
                 <a:solidFill>
-                  <a:srgbClr val="3F4854"/>
+                  <a:srgbClr val="27303A"/>
                 </a:solidFill>
                 <a:latin typeface="DejaVu Sans"/>
                 <a:ea typeface="DejaVu Sans"/>
@@ -6225,7 +6225,7 @@
           <a:solidFill>
             <a:srgbClr val="FFFAF0"/>
           </a:solidFill>
-          <a:ln w="11112">
+          <a:ln w="15081">
             <a:solidFill>
               <a:srgbClr val="C48A24"/>
             </a:solidFill>
@@ -6370,9 +6370,9 @@
           <a:prstGeom prst="line">
             <a:avLst/>
           </a:prstGeom>
-          <a:ln w="14604">
+          <a:ln w="19716">
             <a:solidFill>
-              <a:srgbClr val="1F2937"/>
+              <a:srgbClr val="111A24"/>
             </a:solidFill>
           </a:ln>
           <a:effectLst/>
@@ -6406,9 +6406,9 @@
           <a:prstGeom prst="line">
             <a:avLst/>
           </a:prstGeom>
-          <a:ln w="14604">
+          <a:ln w="19716">
             <a:solidFill>
-              <a:srgbClr val="1F2937"/>
+              <a:srgbClr val="111A24"/>
             </a:solidFill>
           </a:ln>
           <a:effectLst/>
@@ -6442,9 +6442,9 @@
           <a:prstGeom prst="line">
             <a:avLst/>
           </a:prstGeom>
-          <a:ln w="14604">
+          <a:ln w="19716">
             <a:solidFill>
-              <a:srgbClr val="1F2937"/>
+              <a:srgbClr val="111A24"/>
             </a:solidFill>
           </a:ln>
           <a:effectLst/>
@@ -6478,9 +6478,9 @@
           <a:prstGeom prst="line">
             <a:avLst/>
           </a:prstGeom>
-          <a:ln w="14604">
+          <a:ln w="19716">
             <a:solidFill>
-              <a:srgbClr val="1F2937"/>
+              <a:srgbClr val="111A24"/>
             </a:solidFill>
           </a:ln>
           <a:effectLst/>
@@ -6514,9 +6514,9 @@
           <a:prstGeom prst="line">
             <a:avLst/>
           </a:prstGeom>
-          <a:ln w="14604">
+          <a:ln w="19716">
             <a:solidFill>
-              <a:srgbClr val="1F2937"/>
+              <a:srgbClr val="111A24"/>
             </a:solidFill>
           </a:ln>
           <a:effectLst/>
@@ -6550,9 +6550,9 @@
           <a:prstGeom prst="line">
             <a:avLst/>
           </a:prstGeom>
-          <a:ln w="14604">
+          <a:ln w="19716">
             <a:solidFill>
-              <a:srgbClr val="1F2937"/>
+              <a:srgbClr val="111A24"/>
             </a:solidFill>
           </a:ln>
           <a:effectLst/>
@@ -6586,9 +6586,9 @@
           <a:prstGeom prst="line">
             <a:avLst/>
           </a:prstGeom>
-          <a:ln w="14604">
+          <a:ln w="19716">
             <a:solidFill>
-              <a:srgbClr val="1F2937"/>
+              <a:srgbClr val="111A24"/>
             </a:solidFill>
           </a:ln>
           <a:effectLst/>
@@ -6622,9 +6622,9 @@
           <a:prstGeom prst="line">
             <a:avLst/>
           </a:prstGeom>
-          <a:ln w="14604">
+          <a:ln w="19716">
             <a:solidFill>
-              <a:srgbClr val="1F2937"/>
+              <a:srgbClr val="111A24"/>
             </a:solidFill>
           </a:ln>
           <a:effectLst/>
@@ -6658,9 +6658,9 @@
           <a:prstGeom prst="line">
             <a:avLst/>
           </a:prstGeom>
-          <a:ln w="14604">
+          <a:ln w="19716">
             <a:solidFill>
-              <a:srgbClr val="1F2937"/>
+              <a:srgbClr val="111A24"/>
             </a:solidFill>
           </a:ln>
           <a:effectLst/>
@@ -6750,9 +6750,9 @@
           <a:prstGeom prst="line">
             <a:avLst/>
           </a:prstGeom>
-          <a:ln w="9524">
+          <a:ln w="12699">
             <a:solidFill>
-              <a:srgbClr val="E3E8ED"/>
+              <a:srgbClr val="CBD5DE"/>
             </a:solidFill>
           </a:ln>
           <a:effectLst/>
@@ -6789,11 +6789,11 @@
             </a:avLst>
           </a:prstGeom>
           <a:solidFill>
-            <a:srgbClr val="F7F9FB"/>
+            <a:srgbClr val="F4F7FA"/>
           </a:solidFill>
-          <a:ln w="9524">
+          <a:ln w="12699">
             <a:solidFill>
-              <a:srgbClr val="CBD3DA"/>
+              <a:srgbClr val="AEBBC7"/>
             </a:solidFill>
           </a:ln>
           <a:effectLst/>
@@ -6853,9 +6853,9 @@
               <a:spcAft>
                 <a:spcPts val="0"/>
               </a:spcAft>
-              <a:defRPr sz="1185" b="0" i="0" lang="zh-CN" dirty="0">
+              <a:defRPr sz="1185" b="1" i="0" lang="zh-CN" dirty="0">
                 <a:solidFill>
-                  <a:srgbClr val="3F4854"/>
+                  <a:srgbClr val="27303A"/>
                 </a:solidFill>
                 <a:latin typeface="DejaVu Sans"/>
                 <a:ea typeface="DejaVu Sans"/>
@@ -6863,9 +6863,9 @@
               </a:defRPr>
             </a:pPr>
             <a:r>
-              <a:rPr sz="1185" b="0" i="0" lang="zh-CN" dirty="0">
+              <a:rPr sz="1185" b="1" i="0" lang="zh-CN" dirty="0">
                 <a:solidFill>
-                  <a:srgbClr val="3F4854"/>
+                  <a:srgbClr val="27303A"/>
                 </a:solidFill>
                 <a:latin typeface="DejaVu Sans"/>
                 <a:ea typeface="DejaVu Sans"/>
@@ -6895,7 +6895,7 @@
           <a:solidFill>
             <a:srgbClr val="FFFFFF"/>
           </a:solidFill>
-          <a:ln w="11112">
+          <a:ln w="15081">
             <a:solidFill>
               <a:srgbClr val="1F7F8C"/>
             </a:solidFill>
@@ -7041,9 +7041,9 @@
             <a:avLst/>
           </a:prstGeom>
           <a:noFill/>
-          <a:ln w="14604">
+          <a:ln w="19716">
             <a:solidFill>
-              <a:srgbClr val="1F2937"/>
+              <a:srgbClr val="111A24"/>
             </a:solidFill>
           </a:ln>
           <a:effectLst/>
@@ -7084,9 +7084,9 @@
           <a:prstGeom prst="line">
             <a:avLst/>
           </a:prstGeom>
-          <a:ln w="14604">
+          <a:ln w="19716">
             <a:solidFill>
-              <a:srgbClr val="1F2937"/>
+              <a:srgbClr val="111A24"/>
             </a:solidFill>
           </a:ln>
           <a:effectLst/>
@@ -7120,9 +7120,9 @@
           <a:prstGeom prst="line">
             <a:avLst/>
           </a:prstGeom>
-          <a:ln w="14604">
+          <a:ln w="19716">
             <a:solidFill>
-              <a:srgbClr val="1F2937"/>
+              <a:srgbClr val="111A24"/>
             </a:solidFill>
           </a:ln>
           <a:effectLst/>
@@ -7156,9 +7156,9 @@
           <a:prstGeom prst="line">
             <a:avLst/>
           </a:prstGeom>
-          <a:ln w="14604">
+          <a:ln w="19716">
             <a:solidFill>
-              <a:srgbClr val="1F2937"/>
+              <a:srgbClr val="111A24"/>
             </a:solidFill>
           </a:ln>
           <a:effectLst/>
@@ -7193,9 +7193,9 @@
             <a:avLst/>
           </a:prstGeom>
           <a:noFill/>
-          <a:ln w="14604">
+          <a:ln w="19716">
             <a:solidFill>
-              <a:srgbClr val="1F2937"/>
+              <a:srgbClr val="111A24"/>
             </a:solidFill>
           </a:ln>
           <a:effectLst/>
@@ -7236,9 +7236,9 @@
           <a:prstGeom prst="line">
             <a:avLst/>
           </a:prstGeom>
-          <a:ln w="14604">
+          <a:ln w="19716">
             <a:solidFill>
-              <a:srgbClr val="1F2937"/>
+              <a:srgbClr val="111A24"/>
             </a:solidFill>
           </a:ln>
           <a:effectLst/>
@@ -7272,9 +7272,9 @@
           <a:prstGeom prst="line">
             <a:avLst/>
           </a:prstGeom>
-          <a:ln w="14604">
+          <a:ln w="19716">
             <a:solidFill>
-              <a:srgbClr val="1F2937"/>
+              <a:srgbClr val="111A24"/>
             </a:solidFill>
           </a:ln>
           <a:effectLst/>
@@ -7308,9 +7308,9 @@
           <a:prstGeom prst="line">
             <a:avLst/>
           </a:prstGeom>
-          <a:ln w="14604">
+          <a:ln w="19716">
             <a:solidFill>
-              <a:srgbClr val="1F2937"/>
+              <a:srgbClr val="111A24"/>
             </a:solidFill>
           </a:ln>
           <a:effectLst/>
@@ -7345,9 +7345,9 @@
             <a:avLst/>
           </a:prstGeom>
           <a:noFill/>
-          <a:ln w="14604">
+          <a:ln w="19716">
             <a:solidFill>
-              <a:srgbClr val="1F2937"/>
+              <a:srgbClr val="111A24"/>
             </a:solidFill>
           </a:ln>
           <a:effectLst/>
@@ -7388,9 +7388,9 @@
           <a:prstGeom prst="line">
             <a:avLst/>
           </a:prstGeom>
-          <a:ln w="14604">
+          <a:ln w="19716">
             <a:solidFill>
-              <a:srgbClr val="1F2937"/>
+              <a:srgbClr val="111A24"/>
             </a:solidFill>
           </a:ln>
           <a:effectLst/>
@@ -7480,9 +7480,9 @@
           <a:prstGeom prst="line">
             <a:avLst/>
           </a:prstGeom>
-          <a:ln w="9524">
+          <a:ln w="12699">
             <a:solidFill>
-              <a:srgbClr val="E3E8ED"/>
+              <a:srgbClr val="CBD5DE"/>
             </a:solidFill>
           </a:ln>
           <a:effectLst/>
@@ -7519,11 +7519,11 @@
             </a:avLst>
           </a:prstGeom>
           <a:solidFill>
-            <a:srgbClr val="F7F9FB"/>
+            <a:srgbClr val="F4F7FA"/>
           </a:solidFill>
-          <a:ln w="9524">
+          <a:ln w="12699">
             <a:solidFill>
-              <a:srgbClr val="CBD3DA"/>
+              <a:srgbClr val="AEBBC7"/>
             </a:solidFill>
           </a:ln>
           <a:effectLst/>
@@ -7583,9 +7583,9 @@
               <a:spcAft>
                 <a:spcPts val="0"/>
               </a:spcAft>
-              <a:defRPr sz="1185" b="0" i="0" lang="zh-CN" dirty="0">
+              <a:defRPr sz="1185" b="1" i="0" lang="zh-CN" dirty="0">
                 <a:solidFill>
-                  <a:srgbClr val="3F4854"/>
+                  <a:srgbClr val="27303A"/>
                 </a:solidFill>
                 <a:latin typeface="Noto Sans CJK SC"/>
                 <a:ea typeface="Noto Sans CJK SC"/>
@@ -7593,9 +7593,9 @@
               </a:defRPr>
             </a:pPr>
             <a:r>
-              <a:rPr sz="1185" b="0" i="0" lang="zh-CN" dirty="0">
+              <a:rPr sz="1185" b="1" i="0" lang="zh-CN" dirty="0">
                 <a:solidFill>
-                  <a:srgbClr val="3F4854"/>
+                  <a:srgbClr val="27303A"/>
                 </a:solidFill>
                 <a:latin typeface="Noto Sans CJK SC"/>
                 <a:ea typeface="Noto Sans CJK SC"/>
@@ -7604,9 +7604,9 @@
               <a:t>相图</a:t>
             </a:r>
             <a:r>
-              <a:rPr sz="1185" b="0" i="0" lang="zh-CN" dirty="0">
+              <a:rPr sz="1185" b="1" i="0" lang="zh-CN" dirty="0">
                 <a:solidFill>
-                  <a:srgbClr val="3F4854"/>
+                  <a:srgbClr val="27303A"/>
                 </a:solidFill>
                 <a:latin typeface="DejaVu Sans"/>
                 <a:ea typeface="DejaVu Sans"/>
@@ -7615,9 +7615,9 @@
               <a:t> · </a:t>
             </a:r>
             <a:r>
-              <a:rPr sz="1185" b="0" i="0" lang="zh-CN" dirty="0">
+              <a:rPr sz="1185" b="1" i="0" lang="zh-CN" dirty="0">
                 <a:solidFill>
-                  <a:srgbClr val="3F4854"/>
+                  <a:srgbClr val="27303A"/>
                 </a:solidFill>
                 <a:latin typeface="Noto Sans CJK SC"/>
                 <a:ea typeface="Noto Sans CJK SC"/>
@@ -7626,9 +7626,9 @@
               <a:t>结构</a:t>
             </a:r>
             <a:r>
-              <a:rPr sz="1185" b="0" i="0" lang="zh-CN" dirty="0">
+              <a:rPr sz="1185" b="1" i="0" lang="zh-CN" dirty="0">
                 <a:solidFill>
-                  <a:srgbClr val="3F4854"/>
+                  <a:srgbClr val="27303A"/>
                 </a:solidFill>
                 <a:latin typeface="DejaVu Sans"/>
                 <a:ea typeface="DejaVu Sans"/>
@@ -7637,9 +7637,9 @@
               <a:t> · </a:t>
             </a:r>
             <a:r>
-              <a:rPr sz="1185" b="0" i="0" lang="zh-CN" dirty="0">
+              <a:rPr sz="1185" b="1" i="0" lang="zh-CN" dirty="0">
                 <a:solidFill>
-                  <a:srgbClr val="3F4854"/>
+                  <a:srgbClr val="27303A"/>
                 </a:solidFill>
                 <a:latin typeface="Noto Sans CJK SC"/>
                 <a:ea typeface="Noto Sans CJK SC"/>
@@ -7658,8 +7658,8 @@
         </p:nvSpPr>
         <p:spPr>
           <a:xfrm>
-            <a:off x="3952875" y="1952625"/>
-            <a:ext cx="508000" cy="79375"/>
+            <a:off x="3952875" y="1944687"/>
+            <a:ext cx="508000" cy="95250"/>
           </a:xfrm>
           <a:custGeom>
             <a:avLst/>
@@ -7668,34 +7668,34 @@
             <a:cxnLst/>
             <a:rect l="l" t="t" r="r" b="b"/>
             <a:pathLst>
-              <a:path w="64000" h="10000">
+              <a:path w="64000" h="12000">
                 <a:moveTo>
-                  <a:pt x="0" y="4100"/>
+                  <a:pt x="0" y="4750"/>
                 </a:moveTo>
                 <a:lnTo>
-                  <a:pt x="52000" y="4100"/>
+                  <a:pt x="49000" y="4750"/>
                 </a:lnTo>
                 <a:lnTo>
-                  <a:pt x="52000" y="0"/>
+                  <a:pt x="49000" y="0"/>
                 </a:lnTo>
                 <a:lnTo>
-                  <a:pt x="64000" y="5000"/>
+                  <a:pt x="64000" y="6000"/>
                 </a:lnTo>
                 <a:lnTo>
-                  <a:pt x="52000" y="10000"/>
+                  <a:pt x="49000" y="12000"/>
                 </a:lnTo>
                 <a:lnTo>
-                  <a:pt x="52000" y="5900"/>
+                  <a:pt x="49000" y="7250"/>
                 </a:lnTo>
                 <a:lnTo>
-                  <a:pt x="0" y="5900"/>
+                  <a:pt x="0" y="7250"/>
                 </a:lnTo>
                 <a:close/>
               </a:path>
             </a:pathLst>
           </a:custGeom>
           <a:solidFill>
-            <a:srgbClr val="4B5563"/>
+            <a:srgbClr val="3C4753"/>
           </a:solidFill>
           <a:ln>
             <a:noFill/>
@@ -7732,7 +7732,7 @@
         </p:nvSpPr>
         <p:spPr>
           <a:xfrm>
-            <a:off x="3778249" y="1523999"/>
+            <a:off x="3778249" y="460374"/>
             <a:ext cx="857249" cy="309562"/>
           </a:xfrm>
           <a:prstGeom prst="roundRect">
@@ -7743,7 +7743,7 @@
           <a:solidFill>
             <a:srgbClr val="FFFFFF"/>
           </a:solidFill>
-          <a:ln w="8731">
+          <a:ln w="12699">
             <a:solidFill>
               <a:srgbClr val="CBD3DA"/>
             </a:solidFill>
@@ -7780,7 +7780,7 @@
         </p:nvSpPr>
         <p:spPr>
           <a:xfrm>
-            <a:off x="3857624" y="1555749"/>
+            <a:off x="3857624" y="492124"/>
             <a:ext cx="698499" cy="246062"/>
           </a:xfrm>
           <a:prstGeom prst="rect">
@@ -7805,9 +7805,9 @@
               <a:spcAft>
                 <a:spcPts val="0"/>
               </a:spcAft>
-              <a:defRPr sz="1124" b="0" i="0" lang="zh-CN" dirty="0">
+              <a:defRPr sz="1124" b="1" i="0" lang="zh-CN" dirty="0">
                 <a:solidFill>
-                  <a:srgbClr val="3F4854"/>
+                  <a:srgbClr val="27303A"/>
                 </a:solidFill>
                 <a:latin typeface="Noto Sans CJK SC"/>
                 <a:ea typeface="Noto Sans CJK SC"/>
@@ -7815,9 +7815,9 @@
               </a:defRPr>
             </a:pPr>
             <a:r>
-              <a:rPr sz="1124" b="0" i="0" lang="zh-CN" dirty="0">
+              <a:rPr sz="1124" b="1" i="0" lang="zh-CN" dirty="0">
                 <a:solidFill>
-                  <a:srgbClr val="3F4854"/>
+                  <a:srgbClr val="27303A"/>
                 </a:solidFill>
                 <a:latin typeface="Noto Sans CJK SC"/>
                 <a:ea typeface="Noto Sans CJK SC"/>
@@ -7836,8 +7836,8 @@
         </p:nvSpPr>
         <p:spPr>
           <a:xfrm>
-            <a:off x="7921625" y="1952625"/>
-            <a:ext cx="508000" cy="79375"/>
+            <a:off x="7921625" y="1944687"/>
+            <a:ext cx="508000" cy="95250"/>
           </a:xfrm>
           <a:custGeom>
             <a:avLst/>
@@ -7846,34 +7846,34 @@
             <a:cxnLst/>
             <a:rect l="l" t="t" r="r" b="b"/>
             <a:pathLst>
-              <a:path w="64000" h="10000">
+              <a:path w="64000" h="12000">
                 <a:moveTo>
-                  <a:pt x="0" y="4100"/>
+                  <a:pt x="0" y="4750"/>
                 </a:moveTo>
                 <a:lnTo>
-                  <a:pt x="52000" y="4100"/>
+                  <a:pt x="49000" y="4750"/>
                 </a:lnTo>
                 <a:lnTo>
-                  <a:pt x="52000" y="0"/>
+                  <a:pt x="49000" y="0"/>
                 </a:lnTo>
                 <a:lnTo>
-                  <a:pt x="64000" y="5000"/>
+                  <a:pt x="64000" y="6000"/>
                 </a:lnTo>
                 <a:lnTo>
-                  <a:pt x="52000" y="10000"/>
+                  <a:pt x="49000" y="12000"/>
                 </a:lnTo>
                 <a:lnTo>
-                  <a:pt x="52000" y="5900"/>
+                  <a:pt x="49000" y="7250"/>
                 </a:lnTo>
                 <a:lnTo>
-                  <a:pt x="0" y="5900"/>
+                  <a:pt x="0" y="7250"/>
                 </a:lnTo>
                 <a:close/>
               </a:path>
             </a:pathLst>
           </a:custGeom>
           <a:solidFill>
-            <a:srgbClr val="4B5563"/>
+            <a:srgbClr val="3C4753"/>
           </a:solidFill>
           <a:ln>
             <a:noFill/>
@@ -7910,7 +7910,7 @@
         </p:nvSpPr>
         <p:spPr>
           <a:xfrm>
-            <a:off x="7746999" y="1523999"/>
+            <a:off x="7746999" y="460374"/>
             <a:ext cx="857249" cy="309562"/>
           </a:xfrm>
           <a:prstGeom prst="roundRect">
@@ -7921,7 +7921,7 @@
           <a:solidFill>
             <a:srgbClr val="FFFFFF"/>
           </a:solidFill>
-          <a:ln w="8731">
+          <a:ln w="12699">
             <a:solidFill>
               <a:srgbClr val="CBD3DA"/>
             </a:solidFill>
@@ -7958,7 +7958,7 @@
         </p:nvSpPr>
         <p:spPr>
           <a:xfrm>
-            <a:off x="7826374" y="1555749"/>
+            <a:off x="7826374" y="492124"/>
             <a:ext cx="698499" cy="246062"/>
           </a:xfrm>
           <a:prstGeom prst="rect">
@@ -7983,9 +7983,9 @@
               <a:spcAft>
                 <a:spcPts val="0"/>
               </a:spcAft>
-              <a:defRPr sz="1124" b="0" i="0" lang="zh-CN" dirty="0">
+              <a:defRPr sz="1124" b="1" i="0" lang="zh-CN" dirty="0">
                 <a:solidFill>
-                  <a:srgbClr val="3F4854"/>
+                  <a:srgbClr val="27303A"/>
                 </a:solidFill>
                 <a:latin typeface="Noto Sans CJK SC"/>
                 <a:ea typeface="Noto Sans CJK SC"/>
@@ -7993,9 +7993,9 @@
               </a:defRPr>
             </a:pPr>
             <a:r>
-              <a:rPr sz="1124" b="0" i="0" lang="zh-CN" dirty="0">
+              <a:rPr sz="1124" b="1" i="0" lang="zh-CN" dirty="0">
                 <a:solidFill>
-                  <a:srgbClr val="3F4854"/>
+                  <a:srgbClr val="27303A"/>
                 </a:solidFill>
                 <a:latin typeface="Noto Sans CJK SC"/>
                 <a:ea typeface="Noto Sans CJK SC"/>
@@ -8014,8 +8014,8 @@
         </p:nvSpPr>
         <p:spPr>
           <a:xfrm>
-            <a:off x="3952875" y="5365750"/>
-            <a:ext cx="508000" cy="79375"/>
+            <a:off x="3952875" y="5357812"/>
+            <a:ext cx="508000" cy="95250"/>
           </a:xfrm>
           <a:custGeom>
             <a:avLst/>
@@ -8024,34 +8024,34 @@
             <a:cxnLst/>
             <a:rect l="l" t="t" r="r" b="b"/>
             <a:pathLst>
-              <a:path w="64000" h="10000">
+              <a:path w="64000" h="12000">
                 <a:moveTo>
-                  <a:pt x="0" y="4100"/>
+                  <a:pt x="0" y="4750"/>
                 </a:moveTo>
                 <a:lnTo>
-                  <a:pt x="52000" y="4100"/>
+                  <a:pt x="49000" y="4750"/>
                 </a:lnTo>
                 <a:lnTo>
-                  <a:pt x="52000" y="0"/>
+                  <a:pt x="49000" y="0"/>
                 </a:lnTo>
                 <a:lnTo>
-                  <a:pt x="64000" y="5000"/>
+                  <a:pt x="64000" y="6000"/>
                 </a:lnTo>
                 <a:lnTo>
-                  <a:pt x="52000" y="10000"/>
+                  <a:pt x="49000" y="12000"/>
                 </a:lnTo>
                 <a:lnTo>
-                  <a:pt x="52000" y="5900"/>
+                  <a:pt x="49000" y="7250"/>
                 </a:lnTo>
                 <a:lnTo>
-                  <a:pt x="0" y="5900"/>
+                  <a:pt x="0" y="7250"/>
                 </a:lnTo>
                 <a:close/>
               </a:path>
             </a:pathLst>
           </a:custGeom>
           <a:solidFill>
-            <a:srgbClr val="4B5563"/>
+            <a:srgbClr val="3C4753"/>
           </a:solidFill>
           <a:ln>
             <a:noFill/>
@@ -8088,7 +8088,7 @@
         </p:nvSpPr>
         <p:spPr>
           <a:xfrm>
-            <a:off x="3778249" y="4937124"/>
+            <a:off x="3778249" y="3873499"/>
             <a:ext cx="857249" cy="309562"/>
           </a:xfrm>
           <a:prstGeom prst="roundRect">
@@ -8099,7 +8099,7 @@
           <a:solidFill>
             <a:srgbClr val="FFFFFF"/>
           </a:solidFill>
-          <a:ln w="8731">
+          <a:ln w="12699">
             <a:solidFill>
               <a:srgbClr val="CBD3DA"/>
             </a:solidFill>
@@ -8136,7 +8136,7 @@
         </p:nvSpPr>
         <p:spPr>
           <a:xfrm>
-            <a:off x="3857624" y="4968874"/>
+            <a:off x="3857624" y="3905249"/>
             <a:ext cx="698499" cy="246062"/>
           </a:xfrm>
           <a:prstGeom prst="rect">
@@ -8161,9 +8161,9 @@
               <a:spcAft>
                 <a:spcPts val="0"/>
               </a:spcAft>
-              <a:defRPr sz="1124" b="0" i="0" lang="zh-CN" dirty="0">
+              <a:defRPr sz="1124" b="1" i="0" lang="zh-CN" dirty="0">
                 <a:solidFill>
-                  <a:srgbClr val="3F4854"/>
+                  <a:srgbClr val="27303A"/>
                 </a:solidFill>
                 <a:latin typeface="Noto Sans CJK SC"/>
                 <a:ea typeface="Noto Sans CJK SC"/>
@@ -8171,9 +8171,9 @@
               </a:defRPr>
             </a:pPr>
             <a:r>
-              <a:rPr sz="1124" b="0" i="0" lang="zh-CN" dirty="0">
+              <a:rPr sz="1124" b="1" i="0" lang="zh-CN" dirty="0">
                 <a:solidFill>
-                  <a:srgbClr val="3F4854"/>
+                  <a:srgbClr val="27303A"/>
                 </a:solidFill>
                 <a:latin typeface="Noto Sans CJK SC"/>
                 <a:ea typeface="Noto Sans CJK SC"/>
@@ -8192,8 +8192,8 @@
         </p:nvSpPr>
         <p:spPr>
           <a:xfrm>
-            <a:off x="7921625" y="5365750"/>
-            <a:ext cx="508000" cy="79375"/>
+            <a:off x="7921625" y="5357812"/>
+            <a:ext cx="508000" cy="95250"/>
           </a:xfrm>
           <a:custGeom>
             <a:avLst/>
@@ -8202,34 +8202,34 @@
             <a:cxnLst/>
             <a:rect l="l" t="t" r="r" b="b"/>
             <a:pathLst>
-              <a:path w="64000" h="10000">
+              <a:path w="64000" h="12000">
                 <a:moveTo>
-                  <a:pt x="0" y="4100"/>
+                  <a:pt x="0" y="4750"/>
                 </a:moveTo>
                 <a:lnTo>
-                  <a:pt x="52000" y="4100"/>
+                  <a:pt x="49000" y="4750"/>
                 </a:lnTo>
                 <a:lnTo>
-                  <a:pt x="52000" y="0"/>
+                  <a:pt x="49000" y="0"/>
                 </a:lnTo>
                 <a:lnTo>
-                  <a:pt x="64000" y="5000"/>
+                  <a:pt x="64000" y="6000"/>
                 </a:lnTo>
                 <a:lnTo>
-                  <a:pt x="52000" y="10000"/>
+                  <a:pt x="49000" y="12000"/>
                 </a:lnTo>
                 <a:lnTo>
-                  <a:pt x="52000" y="5900"/>
+                  <a:pt x="49000" y="7250"/>
                 </a:lnTo>
                 <a:lnTo>
-                  <a:pt x="0" y="5900"/>
+                  <a:pt x="0" y="7250"/>
                 </a:lnTo>
                 <a:close/>
               </a:path>
             </a:pathLst>
           </a:custGeom>
           <a:solidFill>
-            <a:srgbClr val="4B5563"/>
+            <a:srgbClr val="3C4753"/>
           </a:solidFill>
           <a:ln>
             <a:noFill/>
@@ -8266,7 +8266,7 @@
         </p:nvSpPr>
         <p:spPr>
           <a:xfrm>
-            <a:off x="7746999" y="4937124"/>
+            <a:off x="7746999" y="3873499"/>
             <a:ext cx="857249" cy="309562"/>
           </a:xfrm>
           <a:prstGeom prst="roundRect">
@@ -8277,7 +8277,7 @@
           <a:solidFill>
             <a:srgbClr val="FFFFFF"/>
           </a:solidFill>
-          <a:ln w="8731">
+          <a:ln w="12699">
             <a:solidFill>
               <a:srgbClr val="CBD3DA"/>
             </a:solidFill>
@@ -8314,7 +8314,7 @@
         </p:nvSpPr>
         <p:spPr>
           <a:xfrm>
-            <a:off x="7826374" y="4968874"/>
+            <a:off x="7826374" y="3905249"/>
             <a:ext cx="698499" cy="246062"/>
           </a:xfrm>
           <a:prstGeom prst="rect">
@@ -8339,9 +8339,9 @@
               <a:spcAft>
                 <a:spcPts val="0"/>
               </a:spcAft>
-              <a:defRPr sz="1124" b="0" i="0" lang="zh-CN" dirty="0">
+              <a:defRPr sz="1124" b="1" i="0" lang="zh-CN" dirty="0">
                 <a:solidFill>
-                  <a:srgbClr val="3F4854"/>
+                  <a:srgbClr val="27303A"/>
                 </a:solidFill>
                 <a:latin typeface="Noto Sans CJK SC"/>
                 <a:ea typeface="Noto Sans CJK SC"/>
@@ -8349,9 +8349,9 @@
               </a:defRPr>
             </a:pPr>
             <a:r>
-              <a:rPr sz="1124" b="0" i="0" lang="zh-CN" dirty="0">
+              <a:rPr sz="1124" b="1" i="0" lang="zh-CN" dirty="0">
                 <a:solidFill>
-                  <a:srgbClr val="3F4854"/>
+                  <a:srgbClr val="27303A"/>
                 </a:solidFill>
                 <a:latin typeface="Noto Sans CJK SC"/>
                 <a:ea typeface="Noto Sans CJK SC"/>
@@ -8376,9 +8376,9 @@
           <a:prstGeom prst="line">
             <a:avLst/>
           </a:prstGeom>
-          <a:ln w="14287">
+          <a:ln w="19843">
             <a:solidFill>
-              <a:srgbClr val="4B5563"/>
+              <a:srgbClr val="3C4753"/>
             </a:solidFill>
           </a:ln>
           <a:effectLst/>
@@ -8412,9 +8412,9 @@
           <a:prstGeom prst="line">
             <a:avLst/>
           </a:prstGeom>
-          <a:ln w="14287">
+          <a:ln w="19843">
             <a:solidFill>
-              <a:srgbClr val="4B5563"/>
+              <a:srgbClr val="3C4753"/>
             </a:solidFill>
           </a:ln>
           <a:effectLst/>
@@ -8442,8 +8442,8 @@
         </p:nvSpPr>
         <p:spPr>
           <a:xfrm>
-            <a:off x="2817812" y="3540125"/>
-            <a:ext cx="79375" cy="730250"/>
+            <a:off x="2809875" y="3540125"/>
+            <a:ext cx="95250" cy="730250"/>
           </a:xfrm>
           <a:custGeom>
             <a:avLst/>
@@ -8452,34 +8452,34 @@
             <a:cxnLst/>
             <a:rect l="l" t="t" r="r" b="b"/>
             <a:pathLst>
-              <a:path w="10000" h="92000">
+              <a:path w="12000" h="92000">
                 <a:moveTo>
-                  <a:pt x="5900" y="0"/>
+                  <a:pt x="7250" y="0"/>
                 </a:moveTo>
                 <a:lnTo>
-                  <a:pt x="5900" y="80000"/>
+                  <a:pt x="7250" y="77000"/>
                 </a:lnTo>
                 <a:lnTo>
-                  <a:pt x="10000" y="80000"/>
+                  <a:pt x="12000" y="77000"/>
                 </a:lnTo>
                 <a:lnTo>
-                  <a:pt x="5000" y="92000"/>
+                  <a:pt x="6000" y="92000"/>
                 </a:lnTo>
                 <a:lnTo>
-                  <a:pt x="0" y="80000"/>
+                  <a:pt x="0" y="77000"/>
                 </a:lnTo>
                 <a:lnTo>
-                  <a:pt x="4100" y="80000"/>
+                  <a:pt x="4750" y="77000"/>
                 </a:lnTo>
                 <a:lnTo>
-                  <a:pt x="4100" y="0"/>
+                  <a:pt x="4750" y="0"/>
                 </a:lnTo>
                 <a:close/>
               </a:path>
             </a:pathLst>
           </a:custGeom>
           <a:solidFill>
-            <a:srgbClr val="4B5563"/>
+            <a:srgbClr val="3C4753"/>
           </a:solidFill>
           <a:ln>
             <a:noFill/>
@@ -8516,7 +8516,7 @@
         </p:nvSpPr>
         <p:spPr>
           <a:xfrm>
-            <a:off x="6008687" y="3381374"/>
+            <a:off x="6008687" y="3873499"/>
             <a:ext cx="1000124" cy="309562"/>
           </a:xfrm>
           <a:prstGeom prst="roundRect">
@@ -8527,7 +8527,7 @@
           <a:solidFill>
             <a:srgbClr val="FFFFFF"/>
           </a:solidFill>
-          <a:ln w="8731">
+          <a:ln w="12699">
             <a:solidFill>
               <a:srgbClr val="CBD3DA"/>
             </a:solidFill>
@@ -8564,7 +8564,7 @@
         </p:nvSpPr>
         <p:spPr>
           <a:xfrm>
-            <a:off x="6088062" y="3413124"/>
+            <a:off x="6088062" y="3905249"/>
             <a:ext cx="841374" cy="246062"/>
           </a:xfrm>
           <a:prstGeom prst="rect">
@@ -8589,9 +8589,9 @@
               <a:spcAft>
                 <a:spcPts val="0"/>
               </a:spcAft>
-              <a:defRPr sz="1124" b="0" i="0" lang="zh-CN" dirty="0">
+              <a:defRPr sz="1124" b="1" i="0" lang="zh-CN" dirty="0">
                 <a:solidFill>
-                  <a:srgbClr val="3F4854"/>
+                  <a:srgbClr val="27303A"/>
                 </a:solidFill>
                 <a:latin typeface="Noto Sans CJK SC"/>
                 <a:ea typeface="Noto Sans CJK SC"/>
@@ -8599,9 +8599,9 @@
               </a:defRPr>
             </a:pPr>
             <a:r>
-              <a:rPr sz="1124" b="0" i="0" lang="zh-CN" dirty="0">
+              <a:rPr sz="1124" b="1" i="0" lang="zh-CN" dirty="0">
                 <a:solidFill>
-                  <a:srgbClr val="3F4854"/>
+                  <a:srgbClr val="27303A"/>
                 </a:solidFill>
                 <a:latin typeface="Noto Sans CJK SC"/>
                 <a:ea typeface="Noto Sans CJK SC"/>

</xml_diff>

<commit_message>
dashboard: 2026-09-16 18:33 刷新
</commit_message>
<xml_diff>
--- a/media/figstudio/bzso_roadmap/roadmap_bazn2si2o7_editable.pptx
+++ b/media/figstudio/bzso_roadmap/roadmap_bazn2si2o7_editable.pptx
@@ -7,7 +7,7 @@
   <p:sldIdLst>
     <p:sldId id="256" r:id="rId7"/>
   </p:sldIdLst>
-  <p:sldSz cx="12191999" cy="7143749" type="screen4x3"/>
+  <p:sldSz cx="12191999" cy="6334124" type="screen4x3"/>
   <p:notesSz cx="6858000" cy="9144000"/>
   <p:defaultTextStyle>
     <a:defPPr>
@@ -502,7 +502,7 @@
           <a:lstStyle/>
           <a:p>
             <a:r>
-              <a:t>BaZn2Si2O7 本文的行文路线图（第五轮 F02 → super_img2ppt 重建；3+3 两行，印刷可读优先）</a:t>
+              <a:t>BaZn2Si2O7 本文的行文路线图（第六轮：印刷字号 + 内容定尺寸；3+3 两行） [paper=bzso] [print_width_pt=435.2]</a:t>
             </a:r>
           </a:p>
         </p:txBody>
@@ -3524,12 +3524,12 @@
         </p:nvSpPr>
         <p:spPr>
           <a:xfrm>
-            <a:off x="238124" y="317499"/>
-            <a:ext cx="11715749" cy="3032124"/>
+            <a:off x="206374" y="206374"/>
+            <a:ext cx="11779249" cy="2651124"/>
           </a:xfrm>
           <a:prstGeom prst="roundRect">
             <a:avLst>
-              <a:gd name="adj" fmla="val 3664"/>
+              <a:gd name="adj" fmla="val 4191"/>
             </a:avLst>
           </a:prstGeom>
           <a:solidFill>
@@ -3572,8 +3572,8 @@
         </p:nvSpPr>
         <p:spPr>
           <a:xfrm>
-            <a:off x="380999" y="396874"/>
-            <a:ext cx="1063624" cy="357187"/>
+            <a:off x="349249" y="285749"/>
+            <a:ext cx="1285874" cy="444499"/>
           </a:xfrm>
           <a:prstGeom prst="rect">
             <a:avLst/>
@@ -3589,7 +3589,7 @@
           <a:p>
             <a:pPr algn="l" fontAlgn="base">
               <a:lnSpc>
-                <a:spcPts val="2359"/>
+                <a:spcPts val="3015"/>
               </a:lnSpc>
               <a:spcBef>
                 <a:spcPts val="0"/>
@@ -3597,7 +3597,7 @@
               <a:spcAft>
                 <a:spcPts val="0"/>
               </a:spcAft>
-              <a:defRPr sz="1624" b="1" i="0" lang="zh-CN" dirty="0">
+              <a:defRPr sz="2062" b="1" i="0" lang="zh-CN" dirty="0">
                 <a:solidFill>
                   <a:srgbClr val="2B3E57"/>
                 </a:solidFill>
@@ -3607,7 +3607,7 @@
               </a:defRPr>
             </a:pPr>
             <a:r>
-              <a:rPr sz="1624" b="1" i="0" lang="zh-CN" dirty="0">
+              <a:rPr sz="2062" b="1" i="0" lang="zh-CN" dirty="0">
                 <a:solidFill>
                   <a:srgbClr val="2B3E57"/>
                 </a:solidFill>
@@ -3628,12 +3628,12 @@
         </p:nvSpPr>
         <p:spPr>
           <a:xfrm>
-            <a:off x="238124" y="3730624"/>
-            <a:ext cx="11715749" cy="3095624"/>
+            <a:off x="206374" y="3476624"/>
+            <a:ext cx="11779249" cy="2651124"/>
           </a:xfrm>
           <a:prstGeom prst="roundRect">
             <a:avLst>
-              <a:gd name="adj" fmla="val 3589"/>
+              <a:gd name="adj" fmla="val 4191"/>
             </a:avLst>
           </a:prstGeom>
           <a:solidFill>
@@ -3676,8 +3676,8 @@
         </p:nvSpPr>
         <p:spPr>
           <a:xfrm>
-            <a:off x="380999" y="3809999"/>
-            <a:ext cx="1063624" cy="357187"/>
+            <a:off x="349249" y="3555999"/>
+            <a:ext cx="1285874" cy="444499"/>
           </a:xfrm>
           <a:prstGeom prst="rect">
             <a:avLst/>
@@ -3693,7 +3693,7 @@
           <a:p>
             <a:pPr algn="l" fontAlgn="base">
               <a:lnSpc>
-                <a:spcPts val="2359"/>
+                <a:spcPts val="3015"/>
               </a:lnSpc>
               <a:spcBef>
                 <a:spcPts val="0"/>
@@ -3701,7 +3701,7 @@
               <a:spcAft>
                 <a:spcPts val="0"/>
               </a:spcAft>
-              <a:defRPr sz="1624" b="1" i="0" lang="zh-CN" dirty="0">
+              <a:defRPr sz="2062" b="1" i="0" lang="zh-CN" dirty="0">
                 <a:solidFill>
                   <a:srgbClr val="0F4F58"/>
                 </a:solidFill>
@@ -3711,7 +3711,7 @@
               </a:defRPr>
             </a:pPr>
             <a:r>
-              <a:rPr sz="1624" b="1" i="0" lang="zh-CN" dirty="0">
+              <a:rPr sz="2062" b="1" i="0" lang="zh-CN" dirty="0">
                 <a:solidFill>
                   <a:srgbClr val="0F4F58"/>
                 </a:solidFill>
@@ -3732,12 +3732,12 @@
         </p:nvSpPr>
         <p:spPr>
           <a:xfrm>
-            <a:off x="555624" y="888999"/>
-            <a:ext cx="3333749" cy="2206624"/>
+            <a:off x="333374" y="809624"/>
+            <a:ext cx="3492499" cy="1904999"/>
           </a:xfrm>
           <a:prstGeom prst="roundRect">
             <a:avLst>
-              <a:gd name="adj" fmla="val 3237"/>
+              <a:gd name="adj" fmla="val 3750"/>
             </a:avLst>
           </a:prstGeom>
           <a:solidFill>
@@ -3780,8 +3780,8 @@
         </p:nvSpPr>
         <p:spPr>
           <a:xfrm>
-            <a:off x="555624" y="888999"/>
-            <a:ext cx="79374" cy="2206624"/>
+            <a:off x="333374" y="809624"/>
+            <a:ext cx="79374" cy="1904999"/>
           </a:xfrm>
           <a:prstGeom prst="roundRect">
             <a:avLst>
@@ -3826,8 +3826,8 @@
         </p:nvSpPr>
         <p:spPr>
           <a:xfrm>
-            <a:off x="777874" y="1031874"/>
-            <a:ext cx="730249" cy="484187"/>
+            <a:off x="555624" y="952499"/>
+            <a:ext cx="873124" cy="563562"/>
           </a:xfrm>
           <a:prstGeom prst="rect">
             <a:avLst/>
@@ -3843,7 +3843,7 @@
           <a:p>
             <a:pPr algn="l" fontAlgn="base">
               <a:lnSpc>
-                <a:spcPts val="2624"/>
+                <a:spcPts val="3062"/>
               </a:lnSpc>
               <a:spcBef>
                 <a:spcPts val="0"/>
@@ -3851,7 +3851,7 @@
               <a:spcAft>
                 <a:spcPts val="0"/>
               </a:spcAft>
-              <a:defRPr sz="2249" b="1" i="0" lang="zh-CN" dirty="0">
+              <a:defRPr sz="2624" b="1" i="0" lang="zh-CN" dirty="0">
                 <a:solidFill>
                   <a:srgbClr val="2B3E57"/>
                 </a:solidFill>
@@ -3861,7 +3861,7 @@
               </a:defRPr>
             </a:pPr>
             <a:r>
-              <a:rPr sz="2249" b="1" i="0" lang="zh-CN" dirty="0">
+              <a:rPr sz="2624" b="1" i="0" lang="zh-CN" dirty="0">
                 <a:solidFill>
                   <a:srgbClr val="2B3E57"/>
                 </a:solidFill>
@@ -3882,13 +3882,13 @@
         </p:nvCxnSpPr>
         <p:spPr>
           <a:xfrm>
-            <a:off x="3238499" y="1055687"/>
-            <a:ext cx="293688" cy="190500"/>
+            <a:off x="3428999" y="1023937"/>
+            <a:ext cx="206375" cy="127000"/>
           </a:xfrm>
           <a:prstGeom prst="line">
             <a:avLst/>
           </a:prstGeom>
-          <a:ln w="19716">
+          <a:ln w="18216">
             <a:solidFill>
               <a:srgbClr val="111A24"/>
             </a:solidFill>
@@ -3918,13 +3918,13 @@
         </p:nvCxnSpPr>
         <p:spPr>
           <a:xfrm flipH="1">
-            <a:off x="3397249" y="1246187"/>
-            <a:ext cx="134938" cy="396875"/>
+            <a:off x="3540124" y="1150937"/>
+            <a:ext cx="95250" cy="277812"/>
           </a:xfrm>
           <a:prstGeom prst="line">
             <a:avLst/>
           </a:prstGeom>
-          <a:ln w="19716">
+          <a:ln w="18216">
             <a:solidFill>
               <a:srgbClr val="111A24"/>
             </a:solidFill>
@@ -3954,13 +3954,13 @@
         </p:nvCxnSpPr>
         <p:spPr>
           <a:xfrm flipH="1">
-            <a:off x="3079749" y="1643062"/>
-            <a:ext cx="317500" cy="0"/>
+            <a:off x="3317874" y="1428749"/>
+            <a:ext cx="222250" cy="0"/>
           </a:xfrm>
           <a:prstGeom prst="line">
             <a:avLst/>
           </a:prstGeom>
-          <a:ln w="19716">
+          <a:ln w="18216">
             <a:solidFill>
               <a:srgbClr val="111A24"/>
             </a:solidFill>
@@ -3990,13 +3990,13 @@
         </p:nvCxnSpPr>
         <p:spPr>
           <a:xfrm flipH="1" flipV="1">
-            <a:off x="2944812" y="1246187"/>
-            <a:ext cx="134937" cy="396875"/>
+            <a:off x="3222624" y="1150937"/>
+            <a:ext cx="95250" cy="277812"/>
           </a:xfrm>
           <a:prstGeom prst="line">
             <a:avLst/>
           </a:prstGeom>
-          <a:ln w="19716">
+          <a:ln w="18216">
             <a:solidFill>
               <a:srgbClr val="111A24"/>
             </a:solidFill>
@@ -4026,13 +4026,13 @@
         </p:nvCxnSpPr>
         <p:spPr>
           <a:xfrm flipV="1">
-            <a:off x="2944812" y="1055687"/>
-            <a:ext cx="293687" cy="190500"/>
+            <a:off x="3222624" y="1023937"/>
+            <a:ext cx="206375" cy="127000"/>
           </a:xfrm>
           <a:prstGeom prst="line">
             <a:avLst/>
           </a:prstGeom>
-          <a:ln w="19716">
+          <a:ln w="18216">
             <a:solidFill>
               <a:srgbClr val="111A24"/>
             </a:solidFill>
@@ -4062,13 +4062,13 @@
         </p:nvCxnSpPr>
         <p:spPr>
           <a:xfrm>
-            <a:off x="3238499" y="1055687"/>
-            <a:ext cx="0" cy="587375"/>
+            <a:off x="3428999" y="1023937"/>
+            <a:ext cx="0" cy="404812"/>
           </a:xfrm>
           <a:prstGeom prst="line">
             <a:avLst/>
           </a:prstGeom>
-          <a:ln w="19716">
+          <a:ln w="18216">
             <a:solidFill>
               <a:srgbClr val="111A24"/>
             </a:solidFill>
@@ -4098,13 +4098,13 @@
         </p:nvCxnSpPr>
         <p:spPr>
           <a:xfrm>
-            <a:off x="2944812" y="1246187"/>
-            <a:ext cx="587375" cy="0"/>
+            <a:off x="3222624" y="1150937"/>
+            <a:ext cx="412750" cy="0"/>
           </a:xfrm>
           <a:prstGeom prst="line">
             <a:avLst/>
           </a:prstGeom>
-          <a:ln w="19716">
+          <a:ln w="18216">
             <a:solidFill>
               <a:srgbClr val="111A24"/>
             </a:solidFill>
@@ -4134,8 +4134,8 @@
         </p:nvSpPr>
         <p:spPr>
           <a:xfrm>
-            <a:off x="777874" y="1809749"/>
-            <a:ext cx="2968624" cy="341312"/>
+            <a:off x="555624" y="1579562"/>
+            <a:ext cx="3127374" cy="388937"/>
           </a:xfrm>
           <a:prstGeom prst="rect">
             <a:avLst/>
@@ -4151,7 +4151,7 @@
           <a:p>
             <a:pPr algn="ctr" fontAlgn="base">
               <a:lnSpc>
-                <a:spcPts val="2468"/>
+                <a:spcPts val="2812"/>
               </a:lnSpc>
               <a:spcBef>
                 <a:spcPts val="0"/>
@@ -4159,7 +4159,7 @@
               <a:spcAft>
                 <a:spcPts val="0"/>
               </a:spcAft>
-              <a:defRPr sz="1687" b="1" i="0" lang="zh-CN" dirty="0">
+              <a:defRPr sz="1937" b="1" i="0" lang="zh-CN" dirty="0">
                 <a:solidFill>
                   <a:srgbClr val="2B3E57"/>
                 </a:solidFill>
@@ -4169,7 +4169,7 @@
               </a:defRPr>
             </a:pPr>
             <a:r>
-              <a:rPr sz="1687" b="1" i="0" lang="zh-CN" dirty="0">
+              <a:rPr sz="1937" b="1" i="0" lang="zh-CN" dirty="0">
                 <a:solidFill>
                   <a:srgbClr val="2B3E57"/>
                 </a:solidFill>
@@ -4190,8 +4190,8 @@
         </p:nvCxnSpPr>
         <p:spPr>
           <a:xfrm>
-            <a:off x="825499" y="2262187"/>
-            <a:ext cx="2873375" cy="0"/>
+            <a:off x="603249" y="2063749"/>
+            <a:ext cx="3032125" cy="0"/>
           </a:xfrm>
           <a:prstGeom prst="line">
             <a:avLst/>
@@ -4226,12 +4226,12 @@
         </p:nvSpPr>
         <p:spPr>
           <a:xfrm>
-            <a:off x="777874" y="2666999"/>
-            <a:ext cx="2968624" cy="285749"/>
+            <a:off x="555624" y="2174874"/>
+            <a:ext cx="3127374" cy="396874"/>
           </a:xfrm>
           <a:prstGeom prst="roundRect">
             <a:avLst>
-              <a:gd name="adj" fmla="val 16666"/>
+              <a:gd name="adj" fmla="val 12000"/>
             </a:avLst>
           </a:prstGeom>
           <a:solidFill>
@@ -4274,8 +4274,8 @@
         </p:nvSpPr>
         <p:spPr>
           <a:xfrm>
-            <a:off x="833437" y="2698749"/>
-            <a:ext cx="2857499" cy="222249"/>
+            <a:off x="611187" y="2206624"/>
+            <a:ext cx="3016249" cy="333374"/>
           </a:xfrm>
           <a:prstGeom prst="rect">
             <a:avLst/>
@@ -4291,7 +4291,7 @@
           <a:p>
             <a:pPr algn="ctr" fontAlgn="base">
               <a:lnSpc>
-                <a:spcPts val="1718"/>
+                <a:spcPts val="2546"/>
               </a:lnSpc>
               <a:spcBef>
                 <a:spcPts val="0"/>
@@ -4299,7 +4299,7 @@
               <a:spcAft>
                 <a:spcPts val="0"/>
               </a:spcAft>
-              <a:defRPr sz="1185" b="1" i="0" lang="zh-CN" dirty="0">
+              <a:defRPr sz="1749" b="0" i="0" lang="zh-CN" dirty="0">
                 <a:solidFill>
                   <a:srgbClr val="27303A"/>
                 </a:solidFill>
@@ -4309,7 +4309,7 @@
               </a:defRPr>
             </a:pPr>
             <a:r>
-              <a:rPr sz="1185" b="1" i="0" lang="zh-CN" dirty="0">
+              <a:rPr sz="1749" b="0" i="0" lang="zh-CN" dirty="0">
                 <a:solidFill>
                   <a:srgbClr val="27303A"/>
                 </a:solidFill>
@@ -4330,12 +4330,12 @@
         </p:nvSpPr>
         <p:spPr>
           <a:xfrm>
-            <a:off x="4524374" y="888999"/>
-            <a:ext cx="3333749" cy="2206624"/>
+            <a:off x="4349749" y="809624"/>
+            <a:ext cx="3492499" cy="1904999"/>
           </a:xfrm>
           <a:prstGeom prst="roundRect">
             <a:avLst>
-              <a:gd name="adj" fmla="val 3237"/>
+              <a:gd name="adj" fmla="val 3750"/>
             </a:avLst>
           </a:prstGeom>
           <a:solidFill>
@@ -4378,8 +4378,8 @@
         </p:nvSpPr>
         <p:spPr>
           <a:xfrm>
-            <a:off x="4524374" y="888999"/>
-            <a:ext cx="79374" cy="2206624"/>
+            <a:off x="4349749" y="809624"/>
+            <a:ext cx="79374" cy="1904999"/>
           </a:xfrm>
           <a:prstGeom prst="roundRect">
             <a:avLst>
@@ -4424,8 +4424,8 @@
         </p:nvSpPr>
         <p:spPr>
           <a:xfrm>
-            <a:off x="4746624" y="1031874"/>
-            <a:ext cx="730249" cy="484187"/>
+            <a:off x="4571999" y="952499"/>
+            <a:ext cx="873124" cy="563562"/>
           </a:xfrm>
           <a:prstGeom prst="rect">
             <a:avLst/>
@@ -4441,7 +4441,7 @@
           <a:p>
             <a:pPr algn="l" fontAlgn="base">
               <a:lnSpc>
-                <a:spcPts val="2624"/>
+                <a:spcPts val="3062"/>
               </a:lnSpc>
               <a:spcBef>
                 <a:spcPts val="0"/>
@@ -4449,7 +4449,7 @@
               <a:spcAft>
                 <a:spcPts val="0"/>
               </a:spcAft>
-              <a:defRPr sz="2249" b="1" i="0" lang="zh-CN" dirty="0">
+              <a:defRPr sz="2624" b="1" i="0" lang="zh-CN" dirty="0">
                 <a:solidFill>
                   <a:srgbClr val="2B3E57"/>
                 </a:solidFill>
@@ -4459,7 +4459,7 @@
               </a:defRPr>
             </a:pPr>
             <a:r>
-              <a:rPr sz="2249" b="1" i="0" lang="zh-CN" dirty="0">
+              <a:rPr sz="2624" b="1" i="0" lang="zh-CN" dirty="0">
                 <a:solidFill>
                   <a:srgbClr val="2B3E57"/>
                 </a:solidFill>
@@ -4480,13 +4480,13 @@
         </p:nvCxnSpPr>
         <p:spPr>
           <a:xfrm>
-            <a:off x="7000874" y="1222374"/>
-            <a:ext cx="71438" cy="388938"/>
+            <a:off x="7302499" y="1135062"/>
+            <a:ext cx="47625" cy="269875"/>
           </a:xfrm>
           <a:prstGeom prst="line">
             <a:avLst/>
           </a:prstGeom>
-          <a:ln w="19716">
+          <a:ln w="18216">
             <a:solidFill>
               <a:srgbClr val="111A24"/>
             </a:solidFill>
@@ -4516,13 +4516,13 @@
         </p:nvCxnSpPr>
         <p:spPr>
           <a:xfrm>
-            <a:off x="7072312" y="1611312"/>
-            <a:ext cx="269875" cy="0"/>
+            <a:off x="7350124" y="1404937"/>
+            <a:ext cx="190500" cy="0"/>
           </a:xfrm>
           <a:prstGeom prst="line">
             <a:avLst/>
           </a:prstGeom>
-          <a:ln w="19716">
+          <a:ln w="18216">
             <a:solidFill>
               <a:srgbClr val="111A24"/>
             </a:solidFill>
@@ -4552,13 +4552,13 @@
         </p:nvCxnSpPr>
         <p:spPr>
           <a:xfrm flipV="1">
-            <a:off x="7342187" y="1222374"/>
-            <a:ext cx="71437" cy="388938"/>
+            <a:off x="7540624" y="1135062"/>
+            <a:ext cx="47625" cy="269875"/>
           </a:xfrm>
           <a:prstGeom prst="line">
             <a:avLst/>
           </a:prstGeom>
-          <a:ln w="19716">
+          <a:ln w="18216">
             <a:solidFill>
               <a:srgbClr val="111A24"/>
             </a:solidFill>
@@ -4588,13 +4588,13 @@
         </p:nvCxnSpPr>
         <p:spPr>
           <a:xfrm>
-            <a:off x="6961187" y="1222374"/>
-            <a:ext cx="492125" cy="0"/>
+            <a:off x="7270749" y="1135062"/>
+            <a:ext cx="349250" cy="0"/>
           </a:xfrm>
           <a:prstGeom prst="line">
             <a:avLst/>
           </a:prstGeom>
-          <a:ln w="19716">
+          <a:ln w="18216">
             <a:solidFill>
               <a:srgbClr val="111A24"/>
             </a:solidFill>
@@ -4624,8 +4624,8 @@
         </p:nvSpPr>
         <p:spPr>
           <a:xfrm>
-            <a:off x="4746624" y="1809749"/>
-            <a:ext cx="2968624" cy="341312"/>
+            <a:off x="4571999" y="1579562"/>
+            <a:ext cx="3127374" cy="388937"/>
           </a:xfrm>
           <a:prstGeom prst="rect">
             <a:avLst/>
@@ -4641,7 +4641,7 @@
           <a:p>
             <a:pPr algn="ctr" fontAlgn="base">
               <a:lnSpc>
-                <a:spcPts val="2468"/>
+                <a:spcPts val="2812"/>
               </a:lnSpc>
               <a:spcBef>
                 <a:spcPts val="0"/>
@@ -4649,7 +4649,7 @@
               <a:spcAft>
                 <a:spcPts val="0"/>
               </a:spcAft>
-              <a:defRPr sz="1687" b="1" i="0" lang="zh-CN" dirty="0">
+              <a:defRPr sz="1937" b="1" i="0" lang="zh-CN" dirty="0">
                 <a:solidFill>
                   <a:srgbClr val="2B3E57"/>
                 </a:solidFill>
@@ -4659,7 +4659,7 @@
               </a:defRPr>
             </a:pPr>
             <a:r>
-              <a:rPr sz="1687" b="1" i="0" lang="zh-CN" dirty="0">
+              <a:rPr sz="1937" b="1" i="0" lang="zh-CN" dirty="0">
                 <a:solidFill>
                   <a:srgbClr val="2B3E57"/>
                 </a:solidFill>
@@ -4680,8 +4680,8 @@
         </p:nvCxnSpPr>
         <p:spPr>
           <a:xfrm>
-            <a:off x="4794249" y="2262187"/>
-            <a:ext cx="2873375" cy="0"/>
+            <a:off x="4619624" y="2063749"/>
+            <a:ext cx="3032125" cy="0"/>
           </a:xfrm>
           <a:prstGeom prst="line">
             <a:avLst/>
@@ -4716,12 +4716,12 @@
         </p:nvSpPr>
         <p:spPr>
           <a:xfrm>
-            <a:off x="4746624" y="2666999"/>
-            <a:ext cx="2968624" cy="285749"/>
+            <a:off x="4571999" y="2174874"/>
+            <a:ext cx="3127374" cy="396874"/>
           </a:xfrm>
           <a:prstGeom prst="roundRect">
             <a:avLst>
-              <a:gd name="adj" fmla="val 16666"/>
+              <a:gd name="adj" fmla="val 12000"/>
             </a:avLst>
           </a:prstGeom>
           <a:solidFill>
@@ -4764,8 +4764,8 @@
         </p:nvSpPr>
         <p:spPr>
           <a:xfrm>
-            <a:off x="4802187" y="2698749"/>
-            <a:ext cx="2857499" cy="222249"/>
+            <a:off x="4627562" y="2206624"/>
+            <a:ext cx="3016249" cy="333374"/>
           </a:xfrm>
           <a:prstGeom prst="rect">
             <a:avLst/>
@@ -4781,7 +4781,7 @@
           <a:p>
             <a:pPr algn="ctr" fontAlgn="base">
               <a:lnSpc>
-                <a:spcPts val="1718"/>
+                <a:spcPts val="2546"/>
               </a:lnSpc>
               <a:spcBef>
                 <a:spcPts val="0"/>
@@ -4789,7 +4789,7 @@
               <a:spcAft>
                 <a:spcPts val="0"/>
               </a:spcAft>
-              <a:defRPr sz="1185" b="1" i="0" lang="zh-CN" dirty="0">
+              <a:defRPr sz="1749" b="0" i="0" lang="zh-CN" dirty="0">
                 <a:solidFill>
                   <a:srgbClr val="27303A"/>
                 </a:solidFill>
@@ -4799,7 +4799,7 @@
               </a:defRPr>
             </a:pPr>
             <a:r>
-              <a:rPr sz="1185" b="1" i="0" lang="zh-CN" dirty="0">
+              <a:rPr sz="1749" b="0" i="0" lang="zh-CN" dirty="0">
                 <a:solidFill>
                   <a:srgbClr val="27303A"/>
                 </a:solidFill>
@@ -4810,7 +4810,7 @@
               <a:t>固相</a:t>
             </a:r>
             <a:r>
-              <a:rPr sz="1185" b="1" i="0" lang="zh-CN" dirty="0">
+              <a:rPr sz="1749" b="0" i="0" lang="zh-CN" dirty="0">
                 <a:solidFill>
                   <a:srgbClr val="27303A"/>
                 </a:solidFill>
@@ -4821,7 +4821,7 @@
               <a:t> · </a:t>
             </a:r>
             <a:r>
-              <a:rPr sz="1185" b="1" i="0" lang="zh-CN" dirty="0">
+              <a:rPr sz="1749" b="0" i="0" lang="zh-CN" dirty="0">
                 <a:solidFill>
                   <a:srgbClr val="27303A"/>
                 </a:solidFill>
@@ -4832,7 +4832,7 @@
               <a:t>溶胶</a:t>
             </a:r>
             <a:r>
-              <a:rPr sz="1185" b="1" i="0" lang="zh-CN" dirty="0">
+              <a:rPr sz="1749" b="0" i="0" lang="zh-CN" dirty="0">
                 <a:solidFill>
                   <a:srgbClr val="27303A"/>
                 </a:solidFill>
@@ -4843,7 +4843,7 @@
               <a:t>—</a:t>
             </a:r>
             <a:r>
-              <a:rPr sz="1185" b="1" i="0" lang="zh-CN" dirty="0">
+              <a:rPr sz="1749" b="0" i="0" lang="zh-CN" dirty="0">
                 <a:solidFill>
                   <a:srgbClr val="27303A"/>
                 </a:solidFill>
@@ -4864,12 +4864,12 @@
         </p:nvSpPr>
         <p:spPr>
           <a:xfrm>
-            <a:off x="8493124" y="888999"/>
-            <a:ext cx="3333749" cy="2206624"/>
+            <a:off x="8366124" y="809624"/>
+            <a:ext cx="3492499" cy="1904999"/>
           </a:xfrm>
           <a:prstGeom prst="roundRect">
             <a:avLst>
-              <a:gd name="adj" fmla="val 3237"/>
+              <a:gd name="adj" fmla="val 3750"/>
             </a:avLst>
           </a:prstGeom>
           <a:solidFill>
@@ -4912,8 +4912,8 @@
         </p:nvSpPr>
         <p:spPr>
           <a:xfrm>
-            <a:off x="8493124" y="888999"/>
-            <a:ext cx="79374" cy="2206624"/>
+            <a:off x="8366124" y="809624"/>
+            <a:ext cx="79374" cy="1904999"/>
           </a:xfrm>
           <a:prstGeom prst="roundRect">
             <a:avLst>
@@ -4958,8 +4958,8 @@
         </p:nvSpPr>
         <p:spPr>
           <a:xfrm>
-            <a:off x="8715374" y="1031874"/>
-            <a:ext cx="730249" cy="484187"/>
+            <a:off x="8588374" y="952499"/>
+            <a:ext cx="873124" cy="563562"/>
           </a:xfrm>
           <a:prstGeom prst="rect">
             <a:avLst/>
@@ -4975,7 +4975,7 @@
           <a:p>
             <a:pPr algn="l" fontAlgn="base">
               <a:lnSpc>
-                <a:spcPts val="2624"/>
+                <a:spcPts val="3062"/>
               </a:lnSpc>
               <a:spcBef>
                 <a:spcPts val="0"/>
@@ -4983,7 +4983,7 @@
               <a:spcAft>
                 <a:spcPts val="0"/>
               </a:spcAft>
-              <a:defRPr sz="2249" b="1" i="0" lang="zh-CN" dirty="0">
+              <a:defRPr sz="2624" b="1" i="0" lang="zh-CN" dirty="0">
                 <a:solidFill>
                   <a:srgbClr val="2B3E57"/>
                 </a:solidFill>
@@ -4993,7 +4993,7 @@
               </a:defRPr>
             </a:pPr>
             <a:r>
-              <a:rPr sz="2249" b="1" i="0" lang="zh-CN" dirty="0">
+              <a:rPr sz="2624" b="1" i="0" lang="zh-CN" dirty="0">
                 <a:solidFill>
                   <a:srgbClr val="2B3E57"/>
                 </a:solidFill>
@@ -5014,13 +5014,13 @@
         </p:nvCxnSpPr>
         <p:spPr>
           <a:xfrm>
-            <a:off x="11175999" y="1103312"/>
-            <a:ext cx="277813" cy="127000"/>
+            <a:off x="11461749" y="1047749"/>
+            <a:ext cx="190500" cy="95250"/>
           </a:xfrm>
           <a:prstGeom prst="line">
             <a:avLst/>
           </a:prstGeom>
-          <a:ln w="19716">
+          <a:ln w="18216">
             <a:solidFill>
               <a:srgbClr val="111A24"/>
             </a:solidFill>
@@ -5050,13 +5050,13 @@
         </p:nvCxnSpPr>
         <p:spPr>
           <a:xfrm flipH="1">
-            <a:off x="11175999" y="1230312"/>
-            <a:ext cx="277813" cy="134937"/>
+            <a:off x="11461749" y="1142999"/>
+            <a:ext cx="190500" cy="95250"/>
           </a:xfrm>
           <a:prstGeom prst="line">
             <a:avLst/>
           </a:prstGeom>
-          <a:ln w="19716">
+          <a:ln w="18216">
             <a:solidFill>
               <a:srgbClr val="111A24"/>
             </a:solidFill>
@@ -5086,13 +5086,13 @@
         </p:nvCxnSpPr>
         <p:spPr>
           <a:xfrm flipH="1" flipV="1">
-            <a:off x="10898187" y="1230312"/>
-            <a:ext cx="277812" cy="134937"/>
+            <a:off x="11271249" y="1142999"/>
+            <a:ext cx="190500" cy="95250"/>
           </a:xfrm>
           <a:prstGeom prst="line">
             <a:avLst/>
           </a:prstGeom>
-          <a:ln w="19716">
+          <a:ln w="18216">
             <a:solidFill>
               <a:srgbClr val="111A24"/>
             </a:solidFill>
@@ -5122,13 +5122,13 @@
         </p:nvCxnSpPr>
         <p:spPr>
           <a:xfrm flipV="1">
-            <a:off x="10898187" y="1103312"/>
-            <a:ext cx="277812" cy="127000"/>
+            <a:off x="11271249" y="1047749"/>
+            <a:ext cx="190500" cy="95250"/>
           </a:xfrm>
           <a:prstGeom prst="line">
             <a:avLst/>
           </a:prstGeom>
-          <a:ln w="19716">
+          <a:ln w="18216">
             <a:solidFill>
               <a:srgbClr val="111A24"/>
             </a:solidFill>
@@ -5158,13 +5158,13 @@
         </p:nvCxnSpPr>
         <p:spPr>
           <a:xfrm>
-            <a:off x="11175999" y="1262062"/>
-            <a:ext cx="277813" cy="134937"/>
+            <a:off x="11461749" y="1166812"/>
+            <a:ext cx="190500" cy="87312"/>
           </a:xfrm>
           <a:prstGeom prst="line">
             <a:avLst/>
           </a:prstGeom>
-          <a:ln w="19716">
+          <a:ln w="18216">
             <a:solidFill>
               <a:srgbClr val="111A24"/>
             </a:solidFill>
@@ -5194,13 +5194,13 @@
         </p:nvCxnSpPr>
         <p:spPr>
           <a:xfrm flipH="1">
-            <a:off x="11175999" y="1396999"/>
-            <a:ext cx="277813" cy="127000"/>
+            <a:off x="11461749" y="1254124"/>
+            <a:ext cx="190500" cy="95250"/>
           </a:xfrm>
           <a:prstGeom prst="line">
             <a:avLst/>
           </a:prstGeom>
-          <a:ln w="19716">
+          <a:ln w="18216">
             <a:solidFill>
               <a:srgbClr val="111A24"/>
             </a:solidFill>
@@ -5230,13 +5230,13 @@
         </p:nvCxnSpPr>
         <p:spPr>
           <a:xfrm flipH="1" flipV="1">
-            <a:off x="10898187" y="1396999"/>
-            <a:ext cx="277812" cy="127000"/>
+            <a:off x="11271249" y="1254124"/>
+            <a:ext cx="190500" cy="95250"/>
           </a:xfrm>
           <a:prstGeom prst="line">
             <a:avLst/>
           </a:prstGeom>
-          <a:ln w="19716">
+          <a:ln w="18216">
             <a:solidFill>
               <a:srgbClr val="111A24"/>
             </a:solidFill>
@@ -5266,13 +5266,13 @@
         </p:nvCxnSpPr>
         <p:spPr>
           <a:xfrm flipV="1">
-            <a:off x="10898187" y="1262062"/>
-            <a:ext cx="277812" cy="134937"/>
+            <a:off x="11271249" y="1166812"/>
+            <a:ext cx="190500" cy="87312"/>
           </a:xfrm>
           <a:prstGeom prst="line">
             <a:avLst/>
           </a:prstGeom>
-          <a:ln w="19716">
+          <a:ln w="18216">
             <a:solidFill>
               <a:srgbClr val="111A24"/>
             </a:solidFill>
@@ -5302,13 +5302,13 @@
         </p:nvCxnSpPr>
         <p:spPr>
           <a:xfrm>
-            <a:off x="11175999" y="1420812"/>
-            <a:ext cx="277813" cy="134937"/>
+            <a:off x="11461749" y="1277937"/>
+            <a:ext cx="190500" cy="87312"/>
           </a:xfrm>
           <a:prstGeom prst="line">
             <a:avLst/>
           </a:prstGeom>
-          <a:ln w="19716">
+          <a:ln w="18216">
             <a:solidFill>
               <a:srgbClr val="111A24"/>
             </a:solidFill>
@@ -5338,13 +5338,13 @@
         </p:nvCxnSpPr>
         <p:spPr>
           <a:xfrm flipH="1">
-            <a:off x="11175999" y="1555749"/>
-            <a:ext cx="277813" cy="127000"/>
+            <a:off x="11461749" y="1365249"/>
+            <a:ext cx="190500" cy="95250"/>
           </a:xfrm>
           <a:prstGeom prst="line">
             <a:avLst/>
           </a:prstGeom>
-          <a:ln w="19716">
+          <a:ln w="18216">
             <a:solidFill>
               <a:srgbClr val="111A24"/>
             </a:solidFill>
@@ -5374,13 +5374,13 @@
         </p:nvCxnSpPr>
         <p:spPr>
           <a:xfrm flipH="1" flipV="1">
-            <a:off x="10898187" y="1555749"/>
-            <a:ext cx="277812" cy="127000"/>
+            <a:off x="11271249" y="1365249"/>
+            <a:ext cx="190500" cy="95250"/>
           </a:xfrm>
           <a:prstGeom prst="line">
             <a:avLst/>
           </a:prstGeom>
-          <a:ln w="19716">
+          <a:ln w="18216">
             <a:solidFill>
               <a:srgbClr val="111A24"/>
             </a:solidFill>
@@ -5410,13 +5410,13 @@
         </p:nvCxnSpPr>
         <p:spPr>
           <a:xfrm flipV="1">
-            <a:off x="10898187" y="1420812"/>
-            <a:ext cx="277812" cy="134937"/>
+            <a:off x="11271249" y="1277937"/>
+            <a:ext cx="190500" cy="87312"/>
           </a:xfrm>
           <a:prstGeom prst="line">
             <a:avLst/>
           </a:prstGeom>
-          <a:ln w="19716">
+          <a:ln w="18216">
             <a:solidFill>
               <a:srgbClr val="111A24"/>
             </a:solidFill>
@@ -5446,8 +5446,8 @@
         </p:nvSpPr>
         <p:spPr>
           <a:xfrm>
-            <a:off x="8715374" y="1809749"/>
-            <a:ext cx="2968624" cy="341312"/>
+            <a:off x="8588374" y="1579562"/>
+            <a:ext cx="3127374" cy="388937"/>
           </a:xfrm>
           <a:prstGeom prst="rect">
             <a:avLst/>
@@ -5463,7 +5463,7 @@
           <a:p>
             <a:pPr algn="ctr" fontAlgn="base">
               <a:lnSpc>
-                <a:spcPts val="2468"/>
+                <a:spcPts val="2812"/>
               </a:lnSpc>
               <a:spcBef>
                 <a:spcPts val="0"/>
@@ -5471,7 +5471,7 @@
               <a:spcAft>
                 <a:spcPts val="0"/>
               </a:spcAft>
-              <a:defRPr sz="1687" b="1" i="0" lang="zh-CN" dirty="0">
+              <a:defRPr sz="1937" b="1" i="0" lang="zh-CN" dirty="0">
                 <a:solidFill>
                   <a:srgbClr val="2B3E57"/>
                 </a:solidFill>
@@ -5481,7 +5481,7 @@
               </a:defRPr>
             </a:pPr>
             <a:r>
-              <a:rPr sz="1687" b="1" i="0" lang="zh-CN" dirty="0">
+              <a:rPr sz="1937" b="1" i="0" lang="zh-CN" dirty="0">
                 <a:solidFill>
                   <a:srgbClr val="2B3E57"/>
                 </a:solidFill>
@@ -5502,8 +5502,8 @@
         </p:nvCxnSpPr>
         <p:spPr>
           <a:xfrm>
-            <a:off x="8762999" y="2262187"/>
-            <a:ext cx="2873375" cy="0"/>
+            <a:off x="8635999" y="2063749"/>
+            <a:ext cx="3032125" cy="0"/>
           </a:xfrm>
           <a:prstGeom prst="line">
             <a:avLst/>
@@ -5538,12 +5538,12 @@
         </p:nvSpPr>
         <p:spPr>
           <a:xfrm>
-            <a:off x="8715374" y="2666999"/>
-            <a:ext cx="2968624" cy="285749"/>
+            <a:off x="8588374" y="2174874"/>
+            <a:ext cx="3127374" cy="396874"/>
           </a:xfrm>
           <a:prstGeom prst="roundRect">
             <a:avLst>
-              <a:gd name="adj" fmla="val 16666"/>
+              <a:gd name="adj" fmla="val 12000"/>
             </a:avLst>
           </a:prstGeom>
           <a:solidFill>
@@ -5586,8 +5586,8 @@
         </p:nvSpPr>
         <p:spPr>
           <a:xfrm>
-            <a:off x="8770937" y="2698749"/>
-            <a:ext cx="2857499" cy="222249"/>
+            <a:off x="8643937" y="2206624"/>
+            <a:ext cx="3016249" cy="333374"/>
           </a:xfrm>
           <a:prstGeom prst="rect">
             <a:avLst/>
@@ -5603,7 +5603,7 @@
           <a:p>
             <a:pPr algn="ctr" fontAlgn="base">
               <a:lnSpc>
-                <a:spcPts val="1718"/>
+                <a:spcPts val="2546"/>
               </a:lnSpc>
               <a:spcBef>
                 <a:spcPts val="0"/>
@@ -5611,7 +5611,7 @@
               <a:spcAft>
                 <a:spcPts val="0"/>
               </a:spcAft>
-              <a:defRPr sz="1185" b="1" i="0" lang="zh-CN" dirty="0">
+              <a:defRPr sz="1749" b="0" i="0" lang="zh-CN" dirty="0">
                 <a:solidFill>
                   <a:srgbClr val="27303A"/>
                 </a:solidFill>
@@ -5621,7 +5621,7 @@
               </a:defRPr>
             </a:pPr>
             <a:r>
-              <a:rPr sz="1185" b="1" i="0" lang="zh-CN" dirty="0">
+              <a:rPr sz="1749" b="0" i="0" lang="zh-CN" dirty="0">
                 <a:solidFill>
                   <a:srgbClr val="27303A"/>
                 </a:solidFill>
@@ -5632,7 +5632,7 @@
               <a:t>组成</a:t>
             </a:r>
             <a:r>
-              <a:rPr sz="1185" b="1" i="0" lang="zh-CN" dirty="0">
+              <a:rPr sz="1749" b="0" i="0" lang="zh-CN" dirty="0">
                 <a:solidFill>
                   <a:srgbClr val="27303A"/>
                 </a:solidFill>
@@ -5643,7 +5643,7 @@
               <a:t> · </a:t>
             </a:r>
             <a:r>
-              <a:rPr sz="1185" b="1" i="0" lang="zh-CN" dirty="0">
+              <a:rPr sz="1749" b="0" i="0" lang="zh-CN" dirty="0">
                 <a:solidFill>
                   <a:srgbClr val="27303A"/>
                 </a:solidFill>
@@ -5664,12 +5664,12 @@
         </p:nvSpPr>
         <p:spPr>
           <a:xfrm>
-            <a:off x="555624" y="4302124"/>
-            <a:ext cx="3333749" cy="2206624"/>
+            <a:off x="333374" y="4079874"/>
+            <a:ext cx="3492499" cy="1904999"/>
           </a:xfrm>
           <a:prstGeom prst="roundRect">
             <a:avLst>
-              <a:gd name="adj" fmla="val 3237"/>
+              <a:gd name="adj" fmla="val 3750"/>
             </a:avLst>
           </a:prstGeom>
           <a:solidFill>
@@ -5712,8 +5712,8 @@
         </p:nvSpPr>
         <p:spPr>
           <a:xfrm>
-            <a:off x="555624" y="4302124"/>
-            <a:ext cx="79374" cy="2206624"/>
+            <a:off x="333374" y="4079874"/>
+            <a:ext cx="79374" cy="1904999"/>
           </a:xfrm>
           <a:prstGeom prst="roundRect">
             <a:avLst>
@@ -5758,8 +5758,8 @@
         </p:nvSpPr>
         <p:spPr>
           <a:xfrm>
-            <a:off x="777874" y="4444999"/>
-            <a:ext cx="730249" cy="484187"/>
+            <a:off x="555624" y="4222749"/>
+            <a:ext cx="873124" cy="563562"/>
           </a:xfrm>
           <a:prstGeom prst="rect">
             <a:avLst/>
@@ -5775,7 +5775,7 @@
           <a:p>
             <a:pPr algn="l" fontAlgn="base">
               <a:lnSpc>
-                <a:spcPts val="2624"/>
+                <a:spcPts val="3062"/>
               </a:lnSpc>
               <a:spcBef>
                 <a:spcPts val="0"/>
@@ -5783,7 +5783,7 @@
               <a:spcAft>
                 <a:spcPts val="0"/>
               </a:spcAft>
-              <a:defRPr sz="2249" b="1" i="0" lang="zh-CN" dirty="0">
+              <a:defRPr sz="2624" b="1" i="0" lang="zh-CN" dirty="0">
                 <a:solidFill>
                   <a:srgbClr val="0F4F58"/>
                 </a:solidFill>
@@ -5793,7 +5793,7 @@
               </a:defRPr>
             </a:pPr>
             <a:r>
-              <a:rPr sz="2249" b="1" i="0" lang="zh-CN" dirty="0">
+              <a:rPr sz="2624" b="1" i="0" lang="zh-CN" dirty="0">
                 <a:solidFill>
                   <a:srgbClr val="0F4F58"/>
                 </a:solidFill>
@@ -5814,14 +5814,14 @@
         </p:nvSpPr>
         <p:spPr>
           <a:xfrm>
-            <a:off x="3135312" y="4468812"/>
-            <a:ext cx="206374" cy="206374"/>
+            <a:off x="3357562" y="4294187"/>
+            <a:ext cx="142874" cy="142874"/>
           </a:xfrm>
           <a:prstGeom prst="rect">
             <a:avLst/>
           </a:prstGeom>
           <a:noFill/>
-          <a:ln w="19716">
+          <a:ln w="18216">
             <a:solidFill>
               <a:srgbClr val="111A24"/>
             </a:solidFill>
@@ -5858,14 +5858,14 @@
         </p:nvSpPr>
         <p:spPr>
           <a:xfrm>
-            <a:off x="2920999" y="4849812"/>
-            <a:ext cx="206374" cy="206374"/>
+            <a:off x="3206749" y="4556124"/>
+            <a:ext cx="142874" cy="142874"/>
           </a:xfrm>
           <a:prstGeom prst="rect">
             <a:avLst/>
           </a:prstGeom>
           <a:noFill/>
-          <a:ln w="19716">
+          <a:ln w="18216">
             <a:solidFill>
               <a:srgbClr val="111A24"/>
             </a:solidFill>
@@ -5902,14 +5902,14 @@
         </p:nvSpPr>
         <p:spPr>
           <a:xfrm>
-            <a:off x="3357562" y="4849812"/>
-            <a:ext cx="206374" cy="206374"/>
+            <a:off x="3508374" y="4556124"/>
+            <a:ext cx="142874" cy="142874"/>
           </a:xfrm>
           <a:prstGeom prst="rect">
             <a:avLst/>
           </a:prstGeom>
           <a:noFill/>
-          <a:ln w="19716">
+          <a:ln w="18216">
             <a:solidFill>
               <a:srgbClr val="111A24"/>
             </a:solidFill>
@@ -5946,13 +5946,13 @@
         </p:nvCxnSpPr>
         <p:spPr>
           <a:xfrm flipH="1">
-            <a:off x="3016249" y="4675187"/>
-            <a:ext cx="222250" cy="174625"/>
+            <a:off x="3278187" y="4437062"/>
+            <a:ext cx="150812" cy="119062"/>
           </a:xfrm>
           <a:prstGeom prst="line">
             <a:avLst/>
           </a:prstGeom>
-          <a:ln w="19716">
+          <a:ln w="18216">
             <a:solidFill>
               <a:srgbClr val="111A24"/>
             </a:solidFill>
@@ -5982,13 +5982,13 @@
         </p:nvCxnSpPr>
         <p:spPr>
           <a:xfrm>
-            <a:off x="3238499" y="4675187"/>
-            <a:ext cx="222250" cy="174625"/>
+            <a:off x="3428999" y="4437062"/>
+            <a:ext cx="150813" cy="119062"/>
           </a:xfrm>
           <a:prstGeom prst="line">
             <a:avLst/>
           </a:prstGeom>
-          <a:ln w="19716">
+          <a:ln w="18216">
             <a:solidFill>
               <a:srgbClr val="111A24"/>
             </a:solidFill>
@@ -6018,8 +6018,8 @@
         </p:nvSpPr>
         <p:spPr>
           <a:xfrm>
-            <a:off x="777874" y="5222874"/>
-            <a:ext cx="2968624" cy="341312"/>
+            <a:off x="555624" y="4849812"/>
+            <a:ext cx="3127374" cy="388937"/>
           </a:xfrm>
           <a:prstGeom prst="rect">
             <a:avLst/>
@@ -6035,7 +6035,7 @@
           <a:p>
             <a:pPr algn="ctr" fontAlgn="base">
               <a:lnSpc>
-                <a:spcPts val="2468"/>
+                <a:spcPts val="2812"/>
               </a:lnSpc>
               <a:spcBef>
                 <a:spcPts val="0"/>
@@ -6043,7 +6043,7 @@
               <a:spcAft>
                 <a:spcPts val="0"/>
               </a:spcAft>
-              <a:defRPr sz="1687" b="1" i="0" lang="zh-CN" dirty="0">
+              <a:defRPr sz="1937" b="1" i="0" lang="zh-CN" dirty="0">
                 <a:solidFill>
                   <a:srgbClr val="0F4F58"/>
                 </a:solidFill>
@@ -6053,7 +6053,7 @@
               </a:defRPr>
             </a:pPr>
             <a:r>
-              <a:rPr sz="1687" b="1" i="0" lang="zh-CN" dirty="0">
+              <a:rPr sz="1937" b="1" i="0" lang="zh-CN" dirty="0">
                 <a:solidFill>
                   <a:srgbClr val="0F4F58"/>
                 </a:solidFill>
@@ -6074,8 +6074,8 @@
         </p:nvCxnSpPr>
         <p:spPr>
           <a:xfrm>
-            <a:off x="825499" y="5675312"/>
-            <a:ext cx="2873375" cy="0"/>
+            <a:off x="603249" y="5333999"/>
+            <a:ext cx="3032125" cy="0"/>
           </a:xfrm>
           <a:prstGeom prst="line">
             <a:avLst/>
@@ -6110,12 +6110,12 @@
         </p:nvSpPr>
         <p:spPr>
           <a:xfrm>
-            <a:off x="777874" y="6080124"/>
-            <a:ext cx="2968624" cy="285749"/>
+            <a:off x="555624" y="5445124"/>
+            <a:ext cx="3127374" cy="396874"/>
           </a:xfrm>
           <a:prstGeom prst="roundRect">
             <a:avLst>
-              <a:gd name="adj" fmla="val 16666"/>
+              <a:gd name="adj" fmla="val 12000"/>
             </a:avLst>
           </a:prstGeom>
           <a:solidFill>
@@ -6158,8 +6158,8 @@
         </p:nvSpPr>
         <p:spPr>
           <a:xfrm>
-            <a:off x="833437" y="6111874"/>
-            <a:ext cx="2857499" cy="222249"/>
+            <a:off x="611187" y="5476874"/>
+            <a:ext cx="3016249" cy="333374"/>
           </a:xfrm>
           <a:prstGeom prst="rect">
             <a:avLst/>
@@ -6175,7 +6175,7 @@
           <a:p>
             <a:pPr algn="ctr" fontAlgn="base">
               <a:lnSpc>
-                <a:spcPts val="1390"/>
+                <a:spcPts val="2046"/>
               </a:lnSpc>
               <a:spcBef>
                 <a:spcPts val="0"/>
@@ -6183,7 +6183,7 @@
               <a:spcAft>
                 <a:spcPts val="0"/>
               </a:spcAft>
-              <a:defRPr sz="1185" b="1" i="0" lang="zh-CN" dirty="0">
+              <a:defRPr sz="1749" b="0" i="0" lang="zh-CN" dirty="0">
                 <a:solidFill>
                   <a:srgbClr val="27303A"/>
                 </a:solidFill>
@@ -6193,7 +6193,7 @@
               </a:defRPr>
             </a:pPr>
             <a:r>
-              <a:rPr sz="1185" b="1" i="0" lang="zh-CN" dirty="0">
+              <a:rPr sz="1749" b="0" i="0" lang="zh-CN" dirty="0">
                 <a:solidFill>
                   <a:srgbClr val="27303A"/>
                 </a:solidFill>
@@ -6214,12 +6214,12 @@
         </p:nvSpPr>
         <p:spPr>
           <a:xfrm>
-            <a:off x="4524374" y="4302124"/>
-            <a:ext cx="3333749" cy="2206624"/>
+            <a:off x="4349749" y="4079874"/>
+            <a:ext cx="3492499" cy="1904999"/>
           </a:xfrm>
           <a:prstGeom prst="roundRect">
             <a:avLst>
-              <a:gd name="adj" fmla="val 3237"/>
+              <a:gd name="adj" fmla="val 3750"/>
             </a:avLst>
           </a:prstGeom>
           <a:solidFill>
@@ -6262,8 +6262,8 @@
         </p:nvSpPr>
         <p:spPr>
           <a:xfrm>
-            <a:off x="4524374" y="4302124"/>
-            <a:ext cx="79374" cy="2206624"/>
+            <a:off x="4349749" y="4079874"/>
+            <a:ext cx="79374" cy="1904999"/>
           </a:xfrm>
           <a:prstGeom prst="roundRect">
             <a:avLst>
@@ -6308,8 +6308,8 @@
         </p:nvSpPr>
         <p:spPr>
           <a:xfrm>
-            <a:off x="4746624" y="4444999"/>
-            <a:ext cx="730249" cy="484187"/>
+            <a:off x="4571999" y="4222749"/>
+            <a:ext cx="873124" cy="563562"/>
           </a:xfrm>
           <a:prstGeom prst="rect">
             <a:avLst/>
@@ -6325,7 +6325,7 @@
           <a:p>
             <a:pPr algn="l" fontAlgn="base">
               <a:lnSpc>
-                <a:spcPts val="2624"/>
+                <a:spcPts val="3062"/>
               </a:lnSpc>
               <a:spcBef>
                 <a:spcPts val="0"/>
@@ -6333,7 +6333,7 @@
               <a:spcAft>
                 <a:spcPts val="0"/>
               </a:spcAft>
-              <a:defRPr sz="2249" b="1" i="0" lang="zh-CN" dirty="0">
+              <a:defRPr sz="2624" b="1" i="0" lang="zh-CN" dirty="0">
                 <a:solidFill>
                   <a:srgbClr val="7A5410"/>
                 </a:solidFill>
@@ -6343,7 +6343,7 @@
               </a:defRPr>
             </a:pPr>
             <a:r>
-              <a:rPr sz="2249" b="1" i="0" lang="zh-CN" dirty="0">
+              <a:rPr sz="2624" b="1" i="0" lang="zh-CN" dirty="0">
                 <a:solidFill>
                   <a:srgbClr val="7A5410"/>
                 </a:solidFill>
@@ -6364,13 +6364,13 @@
         </p:nvCxnSpPr>
         <p:spPr>
           <a:xfrm>
-            <a:off x="7207249" y="4516437"/>
-            <a:ext cx="0" cy="468312"/>
+            <a:off x="7445374" y="4317999"/>
+            <a:ext cx="0" cy="325438"/>
           </a:xfrm>
           <a:prstGeom prst="line">
             <a:avLst/>
           </a:prstGeom>
-          <a:ln w="19716">
+          <a:ln w="18216">
             <a:solidFill>
               <a:srgbClr val="111A24"/>
             </a:solidFill>
@@ -6400,13 +6400,13 @@
         </p:nvCxnSpPr>
         <p:spPr>
           <a:xfrm>
-            <a:off x="6961187" y="4619624"/>
-            <a:ext cx="492125" cy="0"/>
+            <a:off x="7270749" y="4389437"/>
+            <a:ext cx="349250" cy="0"/>
           </a:xfrm>
           <a:prstGeom prst="line">
             <a:avLst/>
           </a:prstGeom>
-          <a:ln w="19716">
+          <a:ln w="18216">
             <a:solidFill>
               <a:srgbClr val="111A24"/>
             </a:solidFill>
@@ -6436,13 +6436,13 @@
         </p:nvCxnSpPr>
         <p:spPr>
           <a:xfrm flipH="1">
-            <a:off x="6889749" y="4619624"/>
-            <a:ext cx="71438" cy="158750"/>
+            <a:off x="7223124" y="4389437"/>
+            <a:ext cx="47625" cy="119062"/>
           </a:xfrm>
           <a:prstGeom prst="line">
             <a:avLst/>
           </a:prstGeom>
-          <a:ln w="19716">
+          <a:ln w="18216">
             <a:solidFill>
               <a:srgbClr val="111A24"/>
             </a:solidFill>
@@ -6472,13 +6472,13 @@
         </p:nvCxnSpPr>
         <p:spPr>
           <a:xfrm>
-            <a:off x="6889749" y="4778374"/>
-            <a:ext cx="142875" cy="0"/>
+            <a:off x="7223124" y="4508499"/>
+            <a:ext cx="103188" cy="0"/>
           </a:xfrm>
           <a:prstGeom prst="line">
             <a:avLst/>
           </a:prstGeom>
-          <a:ln w="19716">
+          <a:ln w="18216">
             <a:solidFill>
               <a:srgbClr val="111A24"/>
             </a:solidFill>
@@ -6508,13 +6508,13 @@
         </p:nvCxnSpPr>
         <p:spPr>
           <a:xfrm flipH="1" flipV="1">
-            <a:off x="6961187" y="4619624"/>
-            <a:ext cx="71437" cy="158750"/>
+            <a:off x="7270749" y="4389437"/>
+            <a:ext cx="55563" cy="119062"/>
           </a:xfrm>
           <a:prstGeom prst="line">
             <a:avLst/>
           </a:prstGeom>
-          <a:ln w="19716">
+          <a:ln w="18216">
             <a:solidFill>
               <a:srgbClr val="111A24"/>
             </a:solidFill>
@@ -6544,13 +6544,13 @@
         </p:nvCxnSpPr>
         <p:spPr>
           <a:xfrm flipH="1">
-            <a:off x="7381874" y="4619624"/>
-            <a:ext cx="71438" cy="158750"/>
+            <a:off x="7564437" y="4389437"/>
+            <a:ext cx="55562" cy="119062"/>
           </a:xfrm>
           <a:prstGeom prst="line">
             <a:avLst/>
           </a:prstGeom>
-          <a:ln w="19716">
+          <a:ln w="18216">
             <a:solidFill>
               <a:srgbClr val="111A24"/>
             </a:solidFill>
@@ -6580,13 +6580,13 @@
         </p:nvCxnSpPr>
         <p:spPr>
           <a:xfrm>
-            <a:off x="7381874" y="4778374"/>
-            <a:ext cx="142875" cy="0"/>
+            <a:off x="7564437" y="4508499"/>
+            <a:ext cx="103187" cy="0"/>
           </a:xfrm>
           <a:prstGeom prst="line">
             <a:avLst/>
           </a:prstGeom>
-          <a:ln w="19716">
+          <a:ln w="18216">
             <a:solidFill>
               <a:srgbClr val="111A24"/>
             </a:solidFill>
@@ -6616,13 +6616,13 @@
         </p:nvCxnSpPr>
         <p:spPr>
           <a:xfrm flipH="1" flipV="1">
-            <a:off x="7453312" y="4619624"/>
-            <a:ext cx="71437" cy="158750"/>
+            <a:off x="7619999" y="4389437"/>
+            <a:ext cx="47625" cy="119062"/>
           </a:xfrm>
           <a:prstGeom prst="line">
             <a:avLst/>
           </a:prstGeom>
-          <a:ln w="19716">
+          <a:ln w="18216">
             <a:solidFill>
               <a:srgbClr val="111A24"/>
             </a:solidFill>
@@ -6652,13 +6652,13 @@
         </p:nvCxnSpPr>
         <p:spPr>
           <a:xfrm>
-            <a:off x="7064374" y="5040312"/>
-            <a:ext cx="285750" cy="0"/>
+            <a:off x="7342187" y="4691062"/>
+            <a:ext cx="206375" cy="0"/>
           </a:xfrm>
           <a:prstGeom prst="line">
             <a:avLst/>
           </a:prstGeom>
-          <a:ln w="19716">
+          <a:ln w="18216">
             <a:solidFill>
               <a:srgbClr val="111A24"/>
             </a:solidFill>
@@ -6688,8 +6688,8 @@
         </p:nvSpPr>
         <p:spPr>
           <a:xfrm>
-            <a:off x="4746624" y="5222874"/>
-            <a:ext cx="2968624" cy="341312"/>
+            <a:off x="4571999" y="4849812"/>
+            <a:ext cx="3127374" cy="388937"/>
           </a:xfrm>
           <a:prstGeom prst="rect">
             <a:avLst/>
@@ -6705,7 +6705,7 @@
           <a:p>
             <a:pPr algn="ctr" fontAlgn="base">
               <a:lnSpc>
-                <a:spcPts val="2468"/>
+                <a:spcPts val="2812"/>
               </a:lnSpc>
               <a:spcBef>
                 <a:spcPts val="0"/>
@@ -6713,7 +6713,7 @@
               <a:spcAft>
                 <a:spcPts val="0"/>
               </a:spcAft>
-              <a:defRPr sz="1687" b="1" i="0" lang="zh-CN" dirty="0">
+              <a:defRPr sz="1937" b="1" i="0" lang="zh-CN" dirty="0">
                 <a:solidFill>
                   <a:srgbClr val="7A5410"/>
                 </a:solidFill>
@@ -6723,7 +6723,7 @@
               </a:defRPr>
             </a:pPr>
             <a:r>
-              <a:rPr sz="1687" b="1" i="0" lang="zh-CN" dirty="0">
+              <a:rPr sz="1937" b="1" i="0" lang="zh-CN" dirty="0">
                 <a:solidFill>
                   <a:srgbClr val="7A5410"/>
                 </a:solidFill>
@@ -6744,8 +6744,8 @@
         </p:nvCxnSpPr>
         <p:spPr>
           <a:xfrm>
-            <a:off x="4794249" y="5675312"/>
-            <a:ext cx="2873375" cy="0"/>
+            <a:off x="4619624" y="5333999"/>
+            <a:ext cx="3032125" cy="0"/>
           </a:xfrm>
           <a:prstGeom prst="line">
             <a:avLst/>
@@ -6780,12 +6780,12 @@
         </p:nvSpPr>
         <p:spPr>
           <a:xfrm>
-            <a:off x="4746624" y="6080124"/>
-            <a:ext cx="2968624" cy="285749"/>
+            <a:off x="4571999" y="5445124"/>
+            <a:ext cx="3127374" cy="396874"/>
           </a:xfrm>
           <a:prstGeom prst="roundRect">
             <a:avLst>
-              <a:gd name="adj" fmla="val 16666"/>
+              <a:gd name="adj" fmla="val 12000"/>
             </a:avLst>
           </a:prstGeom>
           <a:solidFill>
@@ -6828,8 +6828,8 @@
         </p:nvSpPr>
         <p:spPr>
           <a:xfrm>
-            <a:off x="4802187" y="6111874"/>
-            <a:ext cx="2857499" cy="222249"/>
+            <a:off x="4627562" y="5476874"/>
+            <a:ext cx="3016249" cy="333374"/>
           </a:xfrm>
           <a:prstGeom prst="rect">
             <a:avLst/>
@@ -6845,7 +6845,7 @@
           <a:p>
             <a:pPr algn="ctr" fontAlgn="base">
               <a:lnSpc>
-                <a:spcPts val="1390"/>
+                <a:spcPts val="2046"/>
               </a:lnSpc>
               <a:spcBef>
                 <a:spcPts val="0"/>
@@ -6853,7 +6853,7 @@
               <a:spcAft>
                 <a:spcPts val="0"/>
               </a:spcAft>
-              <a:defRPr sz="1185" b="1" i="0" lang="zh-CN" dirty="0">
+              <a:defRPr sz="1749" b="0" i="0" lang="zh-CN" dirty="0">
                 <a:solidFill>
                   <a:srgbClr val="27303A"/>
                 </a:solidFill>
@@ -6863,7 +6863,7 @@
               </a:defRPr>
             </a:pPr>
             <a:r>
-              <a:rPr sz="1185" b="1" i="0" lang="zh-CN" dirty="0">
+              <a:rPr sz="1749" b="0" i="0" lang="zh-CN" dirty="0">
                 <a:solidFill>
                   <a:srgbClr val="27303A"/>
                 </a:solidFill>
@@ -6884,12 +6884,12 @@
         </p:nvSpPr>
         <p:spPr>
           <a:xfrm>
-            <a:off x="8493124" y="4302124"/>
-            <a:ext cx="3333749" cy="2206624"/>
+            <a:off x="8366124" y="4079874"/>
+            <a:ext cx="3492499" cy="1904999"/>
           </a:xfrm>
           <a:prstGeom prst="roundRect">
             <a:avLst>
-              <a:gd name="adj" fmla="val 3237"/>
+              <a:gd name="adj" fmla="val 3750"/>
             </a:avLst>
           </a:prstGeom>
           <a:solidFill>
@@ -6932,8 +6932,8 @@
         </p:nvSpPr>
         <p:spPr>
           <a:xfrm>
-            <a:off x="8493124" y="4302124"/>
-            <a:ext cx="79374" cy="2206624"/>
+            <a:off x="8366124" y="4079874"/>
+            <a:ext cx="79374" cy="1904999"/>
           </a:xfrm>
           <a:prstGeom prst="roundRect">
             <a:avLst>
@@ -6978,8 +6978,8 @@
         </p:nvSpPr>
         <p:spPr>
           <a:xfrm>
-            <a:off x="8715374" y="4444999"/>
-            <a:ext cx="730249" cy="484187"/>
+            <a:off x="8588374" y="4222749"/>
+            <a:ext cx="873124" cy="563562"/>
           </a:xfrm>
           <a:prstGeom prst="rect">
             <a:avLst/>
@@ -6995,7 +6995,7 @@
           <a:p>
             <a:pPr algn="l" fontAlgn="base">
               <a:lnSpc>
-                <a:spcPts val="2624"/>
+                <a:spcPts val="3062"/>
               </a:lnSpc>
               <a:spcBef>
                 <a:spcPts val="0"/>
@@ -7003,7 +7003,7 @@
               <a:spcAft>
                 <a:spcPts val="0"/>
               </a:spcAft>
-              <a:defRPr sz="2249" b="1" i="0" lang="zh-CN" dirty="0">
+              <a:defRPr sz="2624" b="1" i="0" lang="zh-CN" dirty="0">
                 <a:solidFill>
                   <a:srgbClr val="0F4F58"/>
                 </a:solidFill>
@@ -7013,7 +7013,7 @@
               </a:defRPr>
             </a:pPr>
             <a:r>
-              <a:rPr sz="2249" b="1" i="0" lang="zh-CN" dirty="0">
+              <a:rPr sz="2624" b="1" i="0" lang="zh-CN" dirty="0">
                 <a:solidFill>
                   <a:srgbClr val="0F4F58"/>
                 </a:solidFill>
@@ -7034,14 +7034,14 @@
         </p:nvSpPr>
         <p:spPr>
           <a:xfrm>
-            <a:off x="10898187" y="4556124"/>
-            <a:ext cx="142874" cy="142874"/>
+            <a:off x="11271249" y="4349749"/>
+            <a:ext cx="103187" cy="103187"/>
           </a:xfrm>
           <a:prstGeom prst="rect">
             <a:avLst/>
           </a:prstGeom>
           <a:noFill/>
-          <a:ln w="19716">
+          <a:ln w="18216">
             <a:solidFill>
               <a:srgbClr val="111A24"/>
             </a:solidFill>
@@ -7078,13 +7078,13 @@
         </p:nvCxnSpPr>
         <p:spPr>
           <a:xfrm>
-            <a:off x="11128374" y="4635499"/>
-            <a:ext cx="341313" cy="0"/>
+            <a:off x="11429999" y="4405312"/>
+            <a:ext cx="238125" cy="0"/>
           </a:xfrm>
           <a:prstGeom prst="line">
             <a:avLst/>
           </a:prstGeom>
-          <a:ln w="19716">
+          <a:ln w="18216">
             <a:solidFill>
               <a:srgbClr val="111A24"/>
             </a:solidFill>
@@ -7114,13 +7114,13 @@
         </p:nvCxnSpPr>
         <p:spPr>
           <a:xfrm>
-            <a:off x="10929937" y="4643437"/>
-            <a:ext cx="31750" cy="31750"/>
+            <a:off x="11287124" y="4405312"/>
+            <a:ext cx="23813" cy="31750"/>
           </a:xfrm>
           <a:prstGeom prst="line">
             <a:avLst/>
           </a:prstGeom>
-          <a:ln w="19716">
+          <a:ln w="18216">
             <a:solidFill>
               <a:srgbClr val="111A24"/>
             </a:solidFill>
@@ -7150,13 +7150,13 @@
         </p:nvCxnSpPr>
         <p:spPr>
           <a:xfrm flipV="1">
-            <a:off x="10961687" y="4587874"/>
-            <a:ext cx="71437" cy="87313"/>
+            <a:off x="11310937" y="4373562"/>
+            <a:ext cx="47625" cy="63500"/>
           </a:xfrm>
           <a:prstGeom prst="line">
             <a:avLst/>
           </a:prstGeom>
-          <a:ln w="19716">
+          <a:ln w="18216">
             <a:solidFill>
               <a:srgbClr val="111A24"/>
             </a:solidFill>
@@ -7186,14 +7186,14 @@
         </p:nvSpPr>
         <p:spPr>
           <a:xfrm>
-            <a:off x="10898187" y="4746624"/>
-            <a:ext cx="142874" cy="142874"/>
+            <a:off x="11271249" y="4484687"/>
+            <a:ext cx="103187" cy="103187"/>
           </a:xfrm>
           <a:prstGeom prst="rect">
             <a:avLst/>
           </a:prstGeom>
           <a:noFill/>
-          <a:ln w="19716">
+          <a:ln w="18216">
             <a:solidFill>
               <a:srgbClr val="111A24"/>
             </a:solidFill>
@@ -7230,13 +7230,13 @@
         </p:nvCxnSpPr>
         <p:spPr>
           <a:xfrm>
-            <a:off x="11128374" y="4825999"/>
-            <a:ext cx="341313" cy="0"/>
+            <a:off x="11429999" y="4532312"/>
+            <a:ext cx="238125" cy="0"/>
           </a:xfrm>
           <a:prstGeom prst="line">
             <a:avLst/>
           </a:prstGeom>
-          <a:ln w="19716">
+          <a:ln w="18216">
             <a:solidFill>
               <a:srgbClr val="111A24"/>
             </a:solidFill>
@@ -7266,13 +7266,13 @@
         </p:nvCxnSpPr>
         <p:spPr>
           <a:xfrm>
-            <a:off x="10929937" y="4825999"/>
-            <a:ext cx="31750" cy="39688"/>
+            <a:off x="11287124" y="4540249"/>
+            <a:ext cx="23813" cy="23813"/>
           </a:xfrm>
           <a:prstGeom prst="line">
             <a:avLst/>
           </a:prstGeom>
-          <a:ln w="19716">
+          <a:ln w="18216">
             <a:solidFill>
               <a:srgbClr val="111A24"/>
             </a:solidFill>
@@ -7302,13 +7302,13 @@
         </p:nvCxnSpPr>
         <p:spPr>
           <a:xfrm flipV="1">
-            <a:off x="10961687" y="4778374"/>
-            <a:ext cx="71437" cy="87313"/>
+            <a:off x="11310937" y="4508499"/>
+            <a:ext cx="47625" cy="55563"/>
           </a:xfrm>
           <a:prstGeom prst="line">
             <a:avLst/>
           </a:prstGeom>
-          <a:ln w="19716">
+          <a:ln w="18216">
             <a:solidFill>
               <a:srgbClr val="111A24"/>
             </a:solidFill>
@@ -7338,14 +7338,14 @@
         </p:nvSpPr>
         <p:spPr>
           <a:xfrm>
-            <a:off x="10898187" y="4937124"/>
-            <a:ext cx="142874" cy="142874"/>
+            <a:off x="11271249" y="4619624"/>
+            <a:ext cx="103187" cy="103187"/>
           </a:xfrm>
           <a:prstGeom prst="rect">
             <a:avLst/>
           </a:prstGeom>
           <a:noFill/>
-          <a:ln w="19716">
+          <a:ln w="18216">
             <a:solidFill>
               <a:srgbClr val="111A24"/>
             </a:solidFill>
@@ -7382,13 +7382,13 @@
         </p:nvCxnSpPr>
         <p:spPr>
           <a:xfrm>
-            <a:off x="11128374" y="5008562"/>
-            <a:ext cx="341313" cy="0"/>
+            <a:off x="11429999" y="4667249"/>
+            <a:ext cx="238125" cy="0"/>
           </a:xfrm>
           <a:prstGeom prst="line">
             <a:avLst/>
           </a:prstGeom>
-          <a:ln w="19716">
+          <a:ln w="18216">
             <a:solidFill>
               <a:srgbClr val="111A24"/>
             </a:solidFill>
@@ -7418,8 +7418,8 @@
         </p:nvSpPr>
         <p:spPr>
           <a:xfrm>
-            <a:off x="8715374" y="5222874"/>
-            <a:ext cx="2968624" cy="341312"/>
+            <a:off x="8588374" y="4849812"/>
+            <a:ext cx="3127374" cy="388937"/>
           </a:xfrm>
           <a:prstGeom prst="rect">
             <a:avLst/>
@@ -7435,7 +7435,7 @@
           <a:p>
             <a:pPr algn="ctr" fontAlgn="base">
               <a:lnSpc>
-                <a:spcPts val="2468"/>
+                <a:spcPts val="2812"/>
               </a:lnSpc>
               <a:spcBef>
                 <a:spcPts val="0"/>
@@ -7443,7 +7443,7 @@
               <a:spcAft>
                 <a:spcPts val="0"/>
               </a:spcAft>
-              <a:defRPr sz="1687" b="1" i="0" lang="zh-CN" dirty="0">
+              <a:defRPr sz="1937" b="1" i="0" lang="zh-CN" dirty="0">
                 <a:solidFill>
                   <a:srgbClr val="0F4F58"/>
                 </a:solidFill>
@@ -7453,7 +7453,7 @@
               </a:defRPr>
             </a:pPr>
             <a:r>
-              <a:rPr sz="1687" b="1" i="0" lang="zh-CN" dirty="0">
+              <a:rPr sz="1937" b="1" i="0" lang="zh-CN" dirty="0">
                 <a:solidFill>
                   <a:srgbClr val="0F4F58"/>
                 </a:solidFill>
@@ -7474,8 +7474,8 @@
         </p:nvCxnSpPr>
         <p:spPr>
           <a:xfrm>
-            <a:off x="8762999" y="5675312"/>
-            <a:ext cx="2873375" cy="0"/>
+            <a:off x="8635999" y="5333999"/>
+            <a:ext cx="3032125" cy="0"/>
           </a:xfrm>
           <a:prstGeom prst="line">
             <a:avLst/>
@@ -7510,12 +7510,12 @@
         </p:nvSpPr>
         <p:spPr>
           <a:xfrm>
-            <a:off x="8715374" y="6080124"/>
-            <a:ext cx="2968624" cy="285749"/>
+            <a:off x="8588374" y="5445124"/>
+            <a:ext cx="3127374" cy="396874"/>
           </a:xfrm>
           <a:prstGeom prst="roundRect">
             <a:avLst>
-              <a:gd name="adj" fmla="val 16666"/>
+              <a:gd name="adj" fmla="val 12000"/>
             </a:avLst>
           </a:prstGeom>
           <a:solidFill>
@@ -7558,8 +7558,8 @@
         </p:nvSpPr>
         <p:spPr>
           <a:xfrm>
-            <a:off x="8770937" y="6111874"/>
-            <a:ext cx="2857499" cy="222249"/>
+            <a:off x="8643937" y="5476874"/>
+            <a:ext cx="3016249" cy="333374"/>
           </a:xfrm>
           <a:prstGeom prst="rect">
             <a:avLst/>
@@ -7575,7 +7575,7 @@
           <a:p>
             <a:pPr algn="ctr" fontAlgn="base">
               <a:lnSpc>
-                <a:spcPts val="1718"/>
+                <a:spcPts val="2546"/>
               </a:lnSpc>
               <a:spcBef>
                 <a:spcPts val="0"/>
@@ -7583,7 +7583,7 @@
               <a:spcAft>
                 <a:spcPts val="0"/>
               </a:spcAft>
-              <a:defRPr sz="1185" b="1" i="0" lang="zh-CN" dirty="0">
+              <a:defRPr sz="1749" b="0" i="0" lang="zh-CN" dirty="0">
                 <a:solidFill>
                   <a:srgbClr val="27303A"/>
                 </a:solidFill>
@@ -7593,7 +7593,7 @@
               </a:defRPr>
             </a:pPr>
             <a:r>
-              <a:rPr sz="1185" b="1" i="0" lang="zh-CN" dirty="0">
+              <a:rPr sz="1749" b="0" i="0" lang="zh-CN" dirty="0">
                 <a:solidFill>
                   <a:srgbClr val="27303A"/>
                 </a:solidFill>
@@ -7604,7 +7604,7 @@
               <a:t>相图</a:t>
             </a:r>
             <a:r>
-              <a:rPr sz="1185" b="1" i="0" lang="zh-CN" dirty="0">
+              <a:rPr sz="1749" b="0" i="0" lang="zh-CN" dirty="0">
                 <a:solidFill>
                   <a:srgbClr val="27303A"/>
                 </a:solidFill>
@@ -7615,7 +7615,7 @@
               <a:t> · </a:t>
             </a:r>
             <a:r>
-              <a:rPr sz="1185" b="1" i="0" lang="zh-CN" dirty="0">
+              <a:rPr sz="1749" b="0" i="0" lang="zh-CN" dirty="0">
                 <a:solidFill>
                   <a:srgbClr val="27303A"/>
                 </a:solidFill>
@@ -7626,7 +7626,7 @@
               <a:t>结构</a:t>
             </a:r>
             <a:r>
-              <a:rPr sz="1185" b="1" i="0" lang="zh-CN" dirty="0">
+              <a:rPr sz="1749" b="0" i="0" lang="zh-CN" dirty="0">
                 <a:solidFill>
                   <a:srgbClr val="27303A"/>
                 </a:solidFill>
@@ -7637,7 +7637,7 @@
               <a:t> · </a:t>
             </a:r>
             <a:r>
-              <a:rPr sz="1185" b="1" i="0" lang="zh-CN" dirty="0">
+              <a:rPr sz="1749" b="0" i="0" lang="zh-CN" dirty="0">
                 <a:solidFill>
                   <a:srgbClr val="27303A"/>
                 </a:solidFill>
@@ -7658,8 +7658,8 @@
         </p:nvSpPr>
         <p:spPr>
           <a:xfrm>
-            <a:off x="3952875" y="1944687"/>
-            <a:ext cx="508000" cy="95250"/>
+            <a:off x="3873500" y="1714500"/>
+            <a:ext cx="428625" cy="95250"/>
           </a:xfrm>
           <a:custGeom>
             <a:avLst/>
@@ -7668,24 +7668,24 @@
             <a:cxnLst/>
             <a:rect l="l" t="t" r="r" b="b"/>
             <a:pathLst>
-              <a:path w="64000" h="12000">
+              <a:path w="54000" h="12000">
                 <a:moveTo>
                   <a:pt x="0" y="4750"/>
                 </a:moveTo>
                 <a:lnTo>
-                  <a:pt x="49000" y="4750"/>
+                  <a:pt x="39000" y="4750"/>
                 </a:lnTo>
                 <a:lnTo>
-                  <a:pt x="49000" y="0"/>
+                  <a:pt x="39000" y="0"/>
                 </a:lnTo>
                 <a:lnTo>
-                  <a:pt x="64000" y="6000"/>
+                  <a:pt x="54000" y="6000"/>
                 </a:lnTo>
                 <a:lnTo>
-                  <a:pt x="49000" y="12000"/>
+                  <a:pt x="39000" y="12000"/>
                 </a:lnTo>
                 <a:lnTo>
-                  <a:pt x="49000" y="7250"/>
+                  <a:pt x="39000" y="7250"/>
                 </a:lnTo>
                 <a:lnTo>
                   <a:pt x="0" y="7250"/>
@@ -7732,8 +7732,8 @@
         </p:nvSpPr>
         <p:spPr>
           <a:xfrm>
-            <a:off x="3778249" y="460374"/>
-            <a:ext cx="857249" cy="309562"/>
+            <a:off x="3532187" y="301624"/>
+            <a:ext cx="1111249" cy="404812"/>
           </a:xfrm>
           <a:prstGeom prst="roundRect">
             <a:avLst>
@@ -7780,8 +7780,8 @@
         </p:nvSpPr>
         <p:spPr>
           <a:xfrm>
-            <a:off x="3857624" y="492124"/>
-            <a:ext cx="698499" cy="246062"/>
+            <a:off x="3611562" y="333374"/>
+            <a:ext cx="952499" cy="341312"/>
           </a:xfrm>
           <a:prstGeom prst="rect">
             <a:avLst/>
@@ -7797,7 +7797,7 @@
           <a:p>
             <a:pPr algn="ctr" fontAlgn="base">
               <a:lnSpc>
-                <a:spcPts val="1640"/>
+                <a:spcPts val="2359"/>
               </a:lnSpc>
               <a:spcBef>
                 <a:spcPts val="0"/>
@@ -7805,7 +7805,7 @@
               <a:spcAft>
                 <a:spcPts val="0"/>
               </a:spcAft>
-              <a:defRPr sz="1124" b="1" i="0" lang="zh-CN" dirty="0">
+              <a:defRPr sz="1624" b="0" i="0" lang="zh-CN" dirty="0">
                 <a:solidFill>
                   <a:srgbClr val="27303A"/>
                 </a:solidFill>
@@ -7815,7 +7815,7 @@
               </a:defRPr>
             </a:pPr>
             <a:r>
-              <a:rPr sz="1124" b="1" i="0" lang="zh-CN" dirty="0">
+              <a:rPr sz="1624" b="0" i="0" lang="zh-CN" dirty="0">
                 <a:solidFill>
                   <a:srgbClr val="27303A"/>
                 </a:solidFill>
@@ -7836,8 +7836,8 @@
         </p:nvSpPr>
         <p:spPr>
           <a:xfrm>
-            <a:off x="7921625" y="1944687"/>
-            <a:ext cx="508000" cy="95250"/>
+            <a:off x="7889875" y="1714500"/>
+            <a:ext cx="428625" cy="95250"/>
           </a:xfrm>
           <a:custGeom>
             <a:avLst/>
@@ -7846,24 +7846,24 @@
             <a:cxnLst/>
             <a:rect l="l" t="t" r="r" b="b"/>
             <a:pathLst>
-              <a:path w="64000" h="12000">
+              <a:path w="54000" h="12000">
                 <a:moveTo>
                   <a:pt x="0" y="4750"/>
                 </a:moveTo>
                 <a:lnTo>
-                  <a:pt x="49000" y="4750"/>
+                  <a:pt x="39000" y="4750"/>
                 </a:lnTo>
                 <a:lnTo>
-                  <a:pt x="49000" y="0"/>
+                  <a:pt x="39000" y="0"/>
                 </a:lnTo>
                 <a:lnTo>
-                  <a:pt x="64000" y="6000"/>
+                  <a:pt x="54000" y="6000"/>
                 </a:lnTo>
                 <a:lnTo>
-                  <a:pt x="49000" y="12000"/>
+                  <a:pt x="39000" y="12000"/>
                 </a:lnTo>
                 <a:lnTo>
-                  <a:pt x="49000" y="7250"/>
+                  <a:pt x="39000" y="7250"/>
                 </a:lnTo>
                 <a:lnTo>
                   <a:pt x="0" y="7250"/>
@@ -7910,8 +7910,8 @@
         </p:nvSpPr>
         <p:spPr>
           <a:xfrm>
-            <a:off x="7746999" y="460374"/>
-            <a:ext cx="857249" cy="309562"/>
+            <a:off x="7548562" y="301624"/>
+            <a:ext cx="1111249" cy="404812"/>
           </a:xfrm>
           <a:prstGeom prst="roundRect">
             <a:avLst>
@@ -7958,8 +7958,8 @@
         </p:nvSpPr>
         <p:spPr>
           <a:xfrm>
-            <a:off x="7826374" y="492124"/>
-            <a:ext cx="698499" cy="246062"/>
+            <a:off x="7627937" y="333374"/>
+            <a:ext cx="952499" cy="341312"/>
           </a:xfrm>
           <a:prstGeom prst="rect">
             <a:avLst/>
@@ -7975,7 +7975,7 @@
           <a:p>
             <a:pPr algn="ctr" fontAlgn="base">
               <a:lnSpc>
-                <a:spcPts val="1640"/>
+                <a:spcPts val="2359"/>
               </a:lnSpc>
               <a:spcBef>
                 <a:spcPts val="0"/>
@@ -7983,7 +7983,7 @@
               <a:spcAft>
                 <a:spcPts val="0"/>
               </a:spcAft>
-              <a:defRPr sz="1124" b="1" i="0" lang="zh-CN" dirty="0">
+              <a:defRPr sz="1624" b="0" i="0" lang="zh-CN" dirty="0">
                 <a:solidFill>
                   <a:srgbClr val="27303A"/>
                 </a:solidFill>
@@ -7993,7 +7993,7 @@
               </a:defRPr>
             </a:pPr>
             <a:r>
-              <a:rPr sz="1124" b="1" i="0" lang="zh-CN" dirty="0">
+              <a:rPr sz="1624" b="0" i="0" lang="zh-CN" dirty="0">
                 <a:solidFill>
                   <a:srgbClr val="27303A"/>
                 </a:solidFill>
@@ -8014,8 +8014,8 @@
         </p:nvSpPr>
         <p:spPr>
           <a:xfrm>
-            <a:off x="3952875" y="5357812"/>
-            <a:ext cx="508000" cy="95250"/>
+            <a:off x="3873500" y="4984750"/>
+            <a:ext cx="428625" cy="95250"/>
           </a:xfrm>
           <a:custGeom>
             <a:avLst/>
@@ -8024,24 +8024,24 @@
             <a:cxnLst/>
             <a:rect l="l" t="t" r="r" b="b"/>
             <a:pathLst>
-              <a:path w="64000" h="12000">
+              <a:path w="54000" h="12000">
                 <a:moveTo>
                   <a:pt x="0" y="4750"/>
                 </a:moveTo>
                 <a:lnTo>
-                  <a:pt x="49000" y="4750"/>
+                  <a:pt x="39000" y="4750"/>
                 </a:lnTo>
                 <a:lnTo>
-                  <a:pt x="49000" y="0"/>
+                  <a:pt x="39000" y="0"/>
                 </a:lnTo>
                 <a:lnTo>
-                  <a:pt x="64000" y="6000"/>
+                  <a:pt x="54000" y="6000"/>
                 </a:lnTo>
                 <a:lnTo>
-                  <a:pt x="49000" y="12000"/>
+                  <a:pt x="39000" y="12000"/>
                 </a:lnTo>
                 <a:lnTo>
-                  <a:pt x="49000" y="7250"/>
+                  <a:pt x="39000" y="7250"/>
                 </a:lnTo>
                 <a:lnTo>
                   <a:pt x="0" y="7250"/>
@@ -8088,8 +8088,8 @@
         </p:nvSpPr>
         <p:spPr>
           <a:xfrm>
-            <a:off x="3778249" y="3873499"/>
-            <a:ext cx="857249" cy="309562"/>
+            <a:off x="3532187" y="3571874"/>
+            <a:ext cx="1111249" cy="404812"/>
           </a:xfrm>
           <a:prstGeom prst="roundRect">
             <a:avLst>
@@ -8136,8 +8136,8 @@
         </p:nvSpPr>
         <p:spPr>
           <a:xfrm>
-            <a:off x="3857624" y="3905249"/>
-            <a:ext cx="698499" cy="246062"/>
+            <a:off x="3611562" y="3603624"/>
+            <a:ext cx="952499" cy="341312"/>
           </a:xfrm>
           <a:prstGeom prst="rect">
             <a:avLst/>
@@ -8153,7 +8153,7 @@
           <a:p>
             <a:pPr algn="ctr" fontAlgn="base">
               <a:lnSpc>
-                <a:spcPts val="1640"/>
+                <a:spcPts val="2359"/>
               </a:lnSpc>
               <a:spcBef>
                 <a:spcPts val="0"/>
@@ -8161,7 +8161,7 @@
               <a:spcAft>
                 <a:spcPts val="0"/>
               </a:spcAft>
-              <a:defRPr sz="1124" b="1" i="0" lang="zh-CN" dirty="0">
+              <a:defRPr sz="1624" b="0" i="0" lang="zh-CN" dirty="0">
                 <a:solidFill>
                   <a:srgbClr val="27303A"/>
                 </a:solidFill>
@@ -8171,7 +8171,7 @@
               </a:defRPr>
             </a:pPr>
             <a:r>
-              <a:rPr sz="1124" b="1" i="0" lang="zh-CN" dirty="0">
+              <a:rPr sz="1624" b="0" i="0" lang="zh-CN" dirty="0">
                 <a:solidFill>
                   <a:srgbClr val="27303A"/>
                 </a:solidFill>
@@ -8192,8 +8192,8 @@
         </p:nvSpPr>
         <p:spPr>
           <a:xfrm>
-            <a:off x="7921625" y="5357812"/>
-            <a:ext cx="508000" cy="95250"/>
+            <a:off x="7889875" y="4984750"/>
+            <a:ext cx="428625" cy="95250"/>
           </a:xfrm>
           <a:custGeom>
             <a:avLst/>
@@ -8202,24 +8202,24 @@
             <a:cxnLst/>
             <a:rect l="l" t="t" r="r" b="b"/>
             <a:pathLst>
-              <a:path w="64000" h="12000">
+              <a:path w="54000" h="12000">
                 <a:moveTo>
                   <a:pt x="0" y="4750"/>
                 </a:moveTo>
                 <a:lnTo>
-                  <a:pt x="49000" y="4750"/>
+                  <a:pt x="39000" y="4750"/>
                 </a:lnTo>
                 <a:lnTo>
-                  <a:pt x="49000" y="0"/>
+                  <a:pt x="39000" y="0"/>
                 </a:lnTo>
                 <a:lnTo>
-                  <a:pt x="64000" y="6000"/>
+                  <a:pt x="54000" y="6000"/>
                 </a:lnTo>
                 <a:lnTo>
-                  <a:pt x="49000" y="12000"/>
+                  <a:pt x="39000" y="12000"/>
                 </a:lnTo>
                 <a:lnTo>
-                  <a:pt x="49000" y="7250"/>
+                  <a:pt x="39000" y="7250"/>
                 </a:lnTo>
                 <a:lnTo>
                   <a:pt x="0" y="7250"/>
@@ -8266,8 +8266,8 @@
         </p:nvSpPr>
         <p:spPr>
           <a:xfrm>
-            <a:off x="7746999" y="3873499"/>
-            <a:ext cx="857249" cy="309562"/>
+            <a:off x="7548562" y="3571874"/>
+            <a:ext cx="1111249" cy="404812"/>
           </a:xfrm>
           <a:prstGeom prst="roundRect">
             <a:avLst>
@@ -8314,8 +8314,8 @@
         </p:nvSpPr>
         <p:spPr>
           <a:xfrm>
-            <a:off x="7826374" y="3905249"/>
-            <a:ext cx="698499" cy="246062"/>
+            <a:off x="7627937" y="3603624"/>
+            <a:ext cx="952499" cy="341312"/>
           </a:xfrm>
           <a:prstGeom prst="rect">
             <a:avLst/>
@@ -8331,7 +8331,7 @@
           <a:p>
             <a:pPr algn="ctr" fontAlgn="base">
               <a:lnSpc>
-                <a:spcPts val="1640"/>
+                <a:spcPts val="2359"/>
               </a:lnSpc>
               <a:spcBef>
                 <a:spcPts val="0"/>
@@ -8339,7 +8339,7 @@
               <a:spcAft>
                 <a:spcPts val="0"/>
               </a:spcAft>
-              <a:defRPr sz="1124" b="1" i="0" lang="zh-CN" dirty="0">
+              <a:defRPr sz="1624" b="0" i="0" lang="zh-CN" dirty="0">
                 <a:solidFill>
                   <a:srgbClr val="27303A"/>
                 </a:solidFill>
@@ -8349,7 +8349,7 @@
               </a:defRPr>
             </a:pPr>
             <a:r>
-              <a:rPr sz="1124" b="1" i="0" lang="zh-CN" dirty="0">
+              <a:rPr sz="1624" b="0" i="0" lang="zh-CN" dirty="0">
                 <a:solidFill>
                   <a:srgbClr val="27303A"/>
                 </a:solidFill>
@@ -8370,8 +8370,8 @@
         </p:nvCxnSpPr>
         <p:spPr>
           <a:xfrm>
-            <a:off x="10159999" y="3127374"/>
-            <a:ext cx="0" cy="412750"/>
+            <a:off x="10112374" y="2746374"/>
+            <a:ext cx="0" cy="420688"/>
           </a:xfrm>
           <a:prstGeom prst="line">
             <a:avLst/>
@@ -8406,8 +8406,8 @@
         </p:nvCxnSpPr>
         <p:spPr>
           <a:xfrm flipH="1">
-            <a:off x="2857499" y="3540124"/>
-            <a:ext cx="7302500" cy="0"/>
+            <a:off x="2079624" y="3167062"/>
+            <a:ext cx="8032750" cy="0"/>
           </a:xfrm>
           <a:prstGeom prst="line">
             <a:avLst/>
@@ -8442,8 +8442,8 @@
         </p:nvSpPr>
         <p:spPr>
           <a:xfrm>
-            <a:off x="2809875" y="3540125"/>
-            <a:ext cx="95250" cy="730250"/>
+            <a:off x="2032000" y="3167062"/>
+            <a:ext cx="95250" cy="881062"/>
           </a:xfrm>
           <a:custGeom>
             <a:avLst/>
@@ -8452,24 +8452,24 @@
             <a:cxnLst/>
             <a:rect l="l" t="t" r="r" b="b"/>
             <a:pathLst>
-              <a:path w="12000" h="92000">
+              <a:path w="12000" h="111000">
                 <a:moveTo>
                   <a:pt x="7250" y="0"/>
                 </a:moveTo>
                 <a:lnTo>
-                  <a:pt x="7250" y="77000"/>
+                  <a:pt x="7250" y="96000"/>
                 </a:lnTo>
                 <a:lnTo>
-                  <a:pt x="12000" y="77000"/>
+                  <a:pt x="12000" y="96000"/>
                 </a:lnTo>
                 <a:lnTo>
-                  <a:pt x="6000" y="92000"/>
+                  <a:pt x="6000" y="111000"/>
                 </a:lnTo>
                 <a:lnTo>
-                  <a:pt x="0" y="77000"/>
+                  <a:pt x="0" y="96000"/>
                 </a:lnTo>
                 <a:lnTo>
-                  <a:pt x="4750" y="77000"/>
+                  <a:pt x="4750" y="96000"/>
                 </a:lnTo>
                 <a:lnTo>
                   <a:pt x="4750" y="0"/>
@@ -8516,8 +8516,8 @@
         </p:nvSpPr>
         <p:spPr>
           <a:xfrm>
-            <a:off x="6008687" y="3873499"/>
-            <a:ext cx="1000124" cy="309562"/>
+            <a:off x="5437187" y="2968624"/>
+            <a:ext cx="1317624" cy="404812"/>
           </a:xfrm>
           <a:prstGeom prst="roundRect">
             <a:avLst>
@@ -8564,8 +8564,8 @@
         </p:nvSpPr>
         <p:spPr>
           <a:xfrm>
-            <a:off x="6088062" y="3905249"/>
-            <a:ext cx="841374" cy="246062"/>
+            <a:off x="5516562" y="3000374"/>
+            <a:ext cx="1158874" cy="341312"/>
           </a:xfrm>
           <a:prstGeom prst="rect">
             <a:avLst/>
@@ -8581,7 +8581,7 @@
           <a:p>
             <a:pPr algn="ctr" fontAlgn="base">
               <a:lnSpc>
-                <a:spcPts val="1640"/>
+                <a:spcPts val="2359"/>
               </a:lnSpc>
               <a:spcBef>
                 <a:spcPts val="0"/>
@@ -8589,7 +8589,7 @@
               <a:spcAft>
                 <a:spcPts val="0"/>
               </a:spcAft>
-              <a:defRPr sz="1124" b="1" i="0" lang="zh-CN" dirty="0">
+              <a:defRPr sz="1624" b="0" i="0" lang="zh-CN" dirty="0">
                 <a:solidFill>
                   <a:srgbClr val="27303A"/>
                 </a:solidFill>
@@ -8599,7 +8599,7 @@
               </a:defRPr>
             </a:pPr>
             <a:r>
-              <a:rPr sz="1124" b="1" i="0" lang="zh-CN" dirty="0">
+              <a:rPr sz="1624" b="0" i="0" lang="zh-CN" dirty="0">
                 <a:solidFill>
                   <a:srgbClr val="27303A"/>
                 </a:solidFill>

</xml_diff>